<commit_message>
update Fri 07/17/2026  0:37:19.71
</commit_message>
<xml_diff>
--- a/GITA/Pre-Acceleration/2026-5h-AI-for-Startups/day1-slides.pptx
+++ b/GITA/Pre-Acceleration/2026-5h-AI-for-Startups/day1-slides.pptx
@@ -7422,7 +7422,7 @@
         <p:spPr>
           <a:xfrm>
             <a:off x="457200" y="1737360"/>
-            <a:ext cx="54864" cy="3008376"/>
+            <a:ext cx="54864" cy="3113532"/>
           </a:xfrm>
           <a:prstGeom prst="rect">
             <a:avLst/>
@@ -7466,7 +7466,7 @@
         <p:spPr>
           <a:xfrm>
             <a:off x="512064" y="1737360"/>
-            <a:ext cx="8174736" cy="3008376"/>
+            <a:ext cx="3991356" cy="3113532"/>
           </a:xfrm>
           <a:prstGeom prst="roundRect">
             <a:avLst>
@@ -7476,7 +7476,7 @@
           <a:solidFill>
             <a:srgbClr val="F8FAFC"/>
           </a:solidFill>
-          <a:ln w="9525">
+          <a:ln w="6350">
             <a:solidFill>
               <a:srgbClr val="E2E8F0"/>
             </a:solidFill>
@@ -7514,7 +7514,7 @@
         <p:spPr>
           <a:xfrm>
             <a:off x="621792" y="1810512"/>
-            <a:ext cx="7955279" cy="320040"/>
+            <a:ext cx="3771900" cy="320040"/>
           </a:xfrm>
           <a:prstGeom prst="rect">
             <a:avLst/>
@@ -7555,7 +7555,7 @@
         <p:spPr>
           <a:xfrm>
             <a:off x="621792" y="2203704"/>
-            <a:ext cx="7955279" cy="2414016"/>
+            <a:ext cx="3771900" cy="2574035"/>
           </a:xfrm>
           <a:prstGeom prst="rect">
             <a:avLst/>
@@ -7693,6 +7693,1006 @@
         </p:nvSpPr>
         <p:spPr>
           <a:xfrm>
+            <a:off x="4640580" y="1737360"/>
+            <a:ext cx="54864" cy="3113532"/>
+          </a:xfrm>
+          <a:prstGeom prst="rect">
+            <a:avLst/>
+          </a:prstGeom>
+          <a:solidFill>
+            <a:srgbClr val="3730A3"/>
+          </a:solidFill>
+          <a:ln>
+            <a:noFill/>
+          </a:ln>
+          <a:effectLst/>
+        </p:spPr>
+        <p:style>
+          <a:lnRef idx="1">
+            <a:schemeClr val="accent1"/>
+          </a:lnRef>
+          <a:fillRef idx="3">
+            <a:schemeClr val="accent1"/>
+          </a:fillRef>
+          <a:effectRef idx="2">
+            <a:schemeClr val="accent1"/>
+          </a:effectRef>
+          <a:fontRef idx="minor">
+            <a:schemeClr val="lt1"/>
+          </a:fontRef>
+        </p:style>
+        <p:txBody>
+          <a:bodyPr rtlCol="0" anchor="ctr"/>
+          <a:lstStyle/>
+          <a:p>
+            <a:pPr algn="ctr"/>
+          </a:p>
+        </p:txBody>
+      </p:sp>
+      <p:sp>
+        <p:nvSpPr>
+          <p:cNvPr id="14" name="Rounded Rectangle 13"/>
+          <p:cNvSpPr/>
+          <p:nvPr/>
+        </p:nvSpPr>
+        <p:spPr>
+          <a:xfrm>
+            <a:off x="4695444" y="1737360"/>
+            <a:ext cx="3991356" cy="3113532"/>
+          </a:xfrm>
+          <a:prstGeom prst="roundRect">
+            <a:avLst>
+              <a:gd name="adj" fmla="val 4000"/>
+            </a:avLst>
+          </a:prstGeom>
+          <a:solidFill>
+            <a:srgbClr val="F8FAFC"/>
+          </a:solidFill>
+          <a:ln w="6350">
+            <a:solidFill>
+              <a:srgbClr val="3730A3"/>
+            </a:solidFill>
+          </a:ln>
+          <a:effectLst/>
+        </p:spPr>
+        <p:style>
+          <a:lnRef idx="1">
+            <a:schemeClr val="accent1"/>
+          </a:lnRef>
+          <a:fillRef idx="3">
+            <a:schemeClr val="accent1"/>
+          </a:fillRef>
+          <a:effectRef idx="2">
+            <a:schemeClr val="accent1"/>
+          </a:effectRef>
+          <a:fontRef idx="minor">
+            <a:schemeClr val="lt1"/>
+          </a:fontRef>
+        </p:style>
+        <p:txBody>
+          <a:bodyPr rtlCol="0" anchor="ctr"/>
+          <a:lstStyle/>
+          <a:p>
+            <a:pPr algn="ctr"/>
+          </a:p>
+        </p:txBody>
+      </p:sp>
+      <p:sp>
+        <p:nvSpPr>
+          <p:cNvPr id="15" name="Rectangle 14"/>
+          <p:cNvSpPr/>
+          <p:nvPr/>
+        </p:nvSpPr>
+        <p:spPr>
+          <a:xfrm>
+            <a:off x="4805172" y="1810512"/>
+            <a:ext cx="54864" cy="292608"/>
+          </a:xfrm>
+          <a:prstGeom prst="rect">
+            <a:avLst/>
+          </a:prstGeom>
+          <a:solidFill>
+            <a:srgbClr val="3730A3"/>
+          </a:solidFill>
+          <a:ln>
+            <a:noFill/>
+          </a:ln>
+          <a:effectLst/>
+        </p:spPr>
+        <p:style>
+          <a:lnRef idx="1">
+            <a:schemeClr val="accent1"/>
+          </a:lnRef>
+          <a:fillRef idx="3">
+            <a:schemeClr val="accent1"/>
+          </a:fillRef>
+          <a:effectRef idx="2">
+            <a:schemeClr val="accent1"/>
+          </a:effectRef>
+          <a:fontRef idx="minor">
+            <a:schemeClr val="lt1"/>
+          </a:fontRef>
+        </p:style>
+        <p:txBody>
+          <a:bodyPr rtlCol="0" anchor="ctr"/>
+          <a:lstStyle/>
+          <a:p>
+            <a:pPr algn="ctr"/>
+          </a:p>
+        </p:txBody>
+      </p:sp>
+      <p:sp>
+        <p:nvSpPr>
+          <p:cNvPr id="16" name="Rounded Rectangle 15"/>
+          <p:cNvSpPr/>
+          <p:nvPr/>
+        </p:nvSpPr>
+        <p:spPr>
+          <a:xfrm>
+            <a:off x="4860036" y="1810512"/>
+            <a:ext cx="3717036" cy="292608"/>
+          </a:xfrm>
+          <a:prstGeom prst="roundRect">
+            <a:avLst>
+              <a:gd name="adj" fmla="val 4000"/>
+            </a:avLst>
+          </a:prstGeom>
+          <a:solidFill>
+            <a:srgbClr val="F8FAFC"/>
+          </a:solidFill>
+          <a:ln w="9525">
+            <a:solidFill>
+              <a:srgbClr val="E2E8F0"/>
+            </a:solidFill>
+          </a:ln>
+          <a:effectLst/>
+        </p:spPr>
+        <p:style>
+          <a:lnRef idx="1">
+            <a:schemeClr val="accent1"/>
+          </a:lnRef>
+          <a:fillRef idx="3">
+            <a:schemeClr val="accent1"/>
+          </a:fillRef>
+          <a:effectRef idx="2">
+            <a:schemeClr val="accent1"/>
+          </a:effectRef>
+          <a:fontRef idx="minor">
+            <a:schemeClr val="lt1"/>
+          </a:fontRef>
+        </p:style>
+        <p:txBody>
+          <a:bodyPr rtlCol="0" anchor="ctr"/>
+          <a:lstStyle/>
+          <a:p>
+            <a:pPr algn="ctr"/>
+          </a:p>
+        </p:txBody>
+      </p:sp>
+      <p:sp>
+        <p:nvSpPr>
+          <p:cNvPr id="17" name="Rectangle 16"/>
+          <p:cNvSpPr/>
+          <p:nvPr/>
+        </p:nvSpPr>
+        <p:spPr>
+          <a:xfrm>
+            <a:off x="4914900" y="1865376"/>
+            <a:ext cx="3552444" cy="201168"/>
+          </a:xfrm>
+          <a:prstGeom prst="rect">
+            <a:avLst/>
+          </a:prstGeom>
+          <a:solidFill>
+            <a:srgbClr val="FFFFFF"/>
+          </a:solidFill>
+          <a:ln w="6350">
+            <a:solidFill>
+              <a:srgbClr val="E2E8F0"/>
+            </a:solidFill>
+          </a:ln>
+          <a:effectLst/>
+        </p:spPr>
+        <p:style>
+          <a:lnRef idx="1">
+            <a:schemeClr val="accent1"/>
+          </a:lnRef>
+          <a:fillRef idx="3">
+            <a:schemeClr val="accent1"/>
+          </a:fillRef>
+          <a:effectRef idx="2">
+            <a:schemeClr val="accent1"/>
+          </a:effectRef>
+          <a:fontRef idx="minor">
+            <a:schemeClr val="lt1"/>
+          </a:fontRef>
+        </p:style>
+        <p:txBody>
+          <a:bodyPr rtlCol="0" anchor="ctr"/>
+          <a:lstStyle/>
+          <a:p>
+            <a:pPr algn="ctr"/>
+          </a:p>
+        </p:txBody>
+      </p:sp>
+      <p:sp>
+        <p:nvSpPr>
+          <p:cNvPr id="18" name="TextBox 17"/>
+          <p:cNvSpPr txBox="1"/>
+          <p:nvPr/>
+        </p:nvSpPr>
+        <p:spPr>
+          <a:xfrm>
+            <a:off x="4969764" y="1892807"/>
+            <a:ext cx="3442716" cy="146304"/>
+          </a:xfrm>
+          <a:prstGeom prst="rect">
+            <a:avLst/>
+          </a:prstGeom>
+          <a:noFill/>
+        </p:spPr>
+        <p:txBody>
+          <a:bodyPr wrap="square" anchor="t" lIns="54864" rIns="54864" tIns="54864" bIns="54864">
+            <a:spAutoFit/>
+          </a:bodyPr>
+          <a:lstStyle/>
+          <a:p>
+            <a:pPr>
+              <a:spcAft>
+                <a:spcPts val="0"/>
+              </a:spcAft>
+            </a:pPr>
+            <a:r>
+              <a:rPr sz="800">
+                <a:solidFill>
+                  <a:srgbClr val="0F172A"/>
+                </a:solidFill>
+                <a:ea typeface="Consolas"/>
+                <a:cs typeface="Consolas"/>
+                <a:latin typeface="Consolas"/>
+              </a:rPr>
+              <a:t>C.R.E.A.T.E. სავარჯიშო</a:t>
+            </a:r>
+          </a:p>
+          <a:p>
+            <a:pPr>
+              <a:spcAft>
+                <a:spcPts val="0"/>
+              </a:spcAft>
+            </a:pPr>
+            <a:r>
+              <a:rPr sz="800">
+                <a:solidFill>
+                  <a:srgbClr val="0F172A"/>
+                </a:solidFill>
+                <a:ea typeface="Consolas"/>
+                <a:cs typeface="Consolas"/>
+                <a:latin typeface="Consolas"/>
+              </a:rPr>
+              <a:t>შაბლონი:</a:t>
+            </a:r>
+          </a:p>
+        </p:txBody>
+      </p:sp>
+      <p:sp>
+        <p:nvSpPr>
+          <p:cNvPr id="19" name="Rounded Rectangle 18"/>
+          <p:cNvSpPr/>
+          <p:nvPr/>
+        </p:nvSpPr>
+        <p:spPr>
+          <a:xfrm>
+            <a:off x="4805172" y="2176272"/>
+            <a:ext cx="3771900" cy="2601468"/>
+          </a:xfrm>
+          <a:prstGeom prst="roundRect">
+            <a:avLst>
+              <a:gd name="adj" fmla="val 4000"/>
+            </a:avLst>
+          </a:prstGeom>
+          <a:solidFill>
+            <a:srgbClr val="F8FAFC"/>
+          </a:solidFill>
+          <a:ln w="9525">
+            <a:solidFill>
+              <a:srgbClr val="E2E8F0"/>
+            </a:solidFill>
+          </a:ln>
+          <a:effectLst/>
+        </p:spPr>
+        <p:style>
+          <a:lnRef idx="1">
+            <a:schemeClr val="accent1"/>
+          </a:lnRef>
+          <a:fillRef idx="3">
+            <a:schemeClr val="accent1"/>
+          </a:fillRef>
+          <a:effectRef idx="2">
+            <a:schemeClr val="accent1"/>
+          </a:effectRef>
+          <a:fontRef idx="minor">
+            <a:schemeClr val="lt1"/>
+          </a:fontRef>
+        </p:style>
+        <p:txBody>
+          <a:bodyPr rtlCol="0" anchor="ctr"/>
+          <a:lstStyle/>
+          <a:p>
+            <a:pPr algn="ctr"/>
+          </a:p>
+        </p:txBody>
+      </p:sp>
+      <p:sp>
+        <p:nvSpPr>
+          <p:cNvPr id="20" name="Rectangle 19"/>
+          <p:cNvSpPr/>
+          <p:nvPr/>
+        </p:nvSpPr>
+        <p:spPr>
+          <a:xfrm>
+            <a:off x="4860036" y="2221991"/>
+            <a:ext cx="3662172" cy="2510027"/>
+          </a:xfrm>
+          <a:prstGeom prst="rect">
+            <a:avLst/>
+          </a:prstGeom>
+          <a:solidFill>
+            <a:srgbClr val="FFFFFF"/>
+          </a:solidFill>
+          <a:ln w="6350">
+            <a:solidFill>
+              <a:srgbClr val="E2E8F0"/>
+            </a:solidFill>
+          </a:ln>
+          <a:effectLst/>
+        </p:spPr>
+        <p:style>
+          <a:lnRef idx="1">
+            <a:schemeClr val="accent1"/>
+          </a:lnRef>
+          <a:fillRef idx="3">
+            <a:schemeClr val="accent1"/>
+          </a:fillRef>
+          <a:effectRef idx="2">
+            <a:schemeClr val="accent1"/>
+          </a:effectRef>
+          <a:fontRef idx="minor">
+            <a:schemeClr val="lt1"/>
+          </a:fontRef>
+        </p:style>
+        <p:txBody>
+          <a:bodyPr rtlCol="0" anchor="ctr"/>
+          <a:lstStyle/>
+          <a:p>
+            <a:pPr algn="ctr"/>
+          </a:p>
+        </p:txBody>
+      </p:sp>
+      <p:sp>
+        <p:nvSpPr>
+          <p:cNvPr id="21" name="TextBox 20"/>
+          <p:cNvSpPr txBox="1"/>
+          <p:nvPr/>
+        </p:nvSpPr>
+        <p:spPr>
+          <a:xfrm>
+            <a:off x="4914900" y="2240279"/>
+            <a:ext cx="3552444" cy="2473451"/>
+          </a:xfrm>
+          <a:prstGeom prst="rect">
+            <a:avLst/>
+          </a:prstGeom>
+          <a:noFill/>
+        </p:spPr>
+        <p:txBody>
+          <a:bodyPr wrap="square" anchor="t" lIns="54864" rIns="54864" tIns="54864" bIns="54864">
+            <a:spAutoFit/>
+          </a:bodyPr>
+          <a:lstStyle/>
+          <a:p>
+            <a:pPr>
+              <a:spcAft>
+                <a:spcPts val="0"/>
+              </a:spcAft>
+            </a:pPr>
+            <a:r>
+              <a:rPr sz="1000">
+                <a:solidFill>
+                  <a:srgbClr val="0F172A"/>
+                </a:solidFill>
+                <a:ea typeface="Consolas"/>
+                <a:cs typeface="Consolas"/>
+                <a:latin typeface="Consolas"/>
+              </a:rPr>
+              <a:t>[Context] მე ვარ სტარტაპის</a:t>
+            </a:r>
+          </a:p>
+          <a:p>
+            <a:pPr>
+              <a:spcAft>
+                <a:spcPts val="0"/>
+              </a:spcAft>
+            </a:pPr>
+            <a:r>
+              <a:rPr sz="1000">
+                <a:solidFill>
+                  <a:srgbClr val="0F172A"/>
+                </a:solidFill>
+                <a:ea typeface="Consolas"/>
+                <a:cs typeface="Consolas"/>
+                <a:latin typeface="Consolas"/>
+              </a:rPr>
+              <a:t>დამფუძნებელი. ჩემი</a:t>
+            </a:r>
+          </a:p>
+          <a:p>
+            <a:pPr>
+              <a:spcAft>
+                <a:spcPts val="0"/>
+              </a:spcAft>
+            </a:pPr>
+            <a:r>
+              <a:rPr sz="1000">
+                <a:solidFill>
+                  <a:srgbClr val="0F172A"/>
+                </a:solidFill>
+                <a:ea typeface="Consolas"/>
+                <a:cs typeface="Consolas"/>
+                <a:latin typeface="Consolas"/>
+              </a:rPr>
+              <a:t>პროდუქტია: [მაგ:</a:t>
+            </a:r>
+          </a:p>
+          <a:p>
+            <a:pPr>
+              <a:spcAft>
+                <a:spcPts val="0"/>
+              </a:spcAft>
+            </a:pPr>
+            <a:r>
+              <a:rPr sz="1000">
+                <a:solidFill>
+                  <a:srgbClr val="0F172A"/>
+                </a:solidFill>
+                <a:ea typeface="Consolas"/>
+                <a:cs typeface="Consolas"/>
+                <a:latin typeface="Consolas"/>
+              </a:rPr>
+              <a:t>მცენარეების ჭკვიანი</a:t>
+            </a:r>
+          </a:p>
+          <a:p>
+            <a:pPr>
+              <a:spcAft>
+                <a:spcPts val="0"/>
+              </a:spcAft>
+            </a:pPr>
+            <a:r>
+              <a:rPr sz="1000">
+                <a:solidFill>
+                  <a:srgbClr val="0F172A"/>
+                </a:solidFill>
+                <a:ea typeface="Consolas"/>
+                <a:cs typeface="Consolas"/>
+                <a:latin typeface="Consolas"/>
+              </a:rPr>
+              <a:t>სარწყავი სისტემა]. ჩემი</a:t>
+            </a:r>
+          </a:p>
+          <a:p>
+            <a:pPr>
+              <a:spcAft>
+                <a:spcPts val="0"/>
+              </a:spcAft>
+            </a:pPr>
+            <a:r>
+              <a:rPr sz="1000">
+                <a:solidFill>
+                  <a:srgbClr val="0F172A"/>
+                </a:solidFill>
+                <a:ea typeface="Consolas"/>
+                <a:cs typeface="Consolas"/>
+                <a:latin typeface="Consolas"/>
+              </a:rPr>
+              <a:t>სამიზნე ICP არის [მაგ:</a:t>
+            </a:r>
+          </a:p>
+          <a:p>
+            <a:pPr>
+              <a:spcAft>
+                <a:spcPts val="0"/>
+              </a:spcAft>
+            </a:pPr>
+            <a:r>
+              <a:rPr sz="1000">
+                <a:solidFill>
+                  <a:srgbClr val="0F172A"/>
+                </a:solidFill>
+                <a:ea typeface="Consolas"/>
+                <a:cs typeface="Consolas"/>
+                <a:latin typeface="Consolas"/>
+              </a:rPr>
+              <a:t>დაკავებული ურბანული</a:t>
+            </a:r>
+          </a:p>
+          <a:p>
+            <a:pPr>
+              <a:spcAft>
+                <a:spcPts val="0"/>
+              </a:spcAft>
+            </a:pPr>
+            <a:r>
+              <a:rPr sz="1000">
+                <a:solidFill>
+                  <a:srgbClr val="0F172A"/>
+                </a:solidFill>
+                <a:ea typeface="Consolas"/>
+                <a:cs typeface="Consolas"/>
+                <a:latin typeface="Consolas"/>
+              </a:rPr>
+              <a:t>მაცხოვრებლები].</a:t>
+            </a:r>
+          </a:p>
+          <a:p>
+            <a:pPr>
+              <a:spcAft>
+                <a:spcPts val="0"/>
+              </a:spcAft>
+            </a:pPr>
+            <a:r>
+              <a:rPr sz="1000">
+                <a:solidFill>
+                  <a:srgbClr val="0F172A"/>
+                </a:solidFill>
+                <a:ea typeface="Consolas"/>
+                <a:cs typeface="Consolas"/>
+                <a:latin typeface="Consolas"/>
+              </a:rPr>
+              <a:t>[Request] შემომთავაზე 3</a:t>
+            </a:r>
+          </a:p>
+          <a:p>
+            <a:pPr>
+              <a:spcAft>
+                <a:spcPts val="0"/>
+              </a:spcAft>
+            </a:pPr>
+            <a:r>
+              <a:rPr sz="1000">
+                <a:solidFill>
+                  <a:srgbClr val="0F172A"/>
+                </a:solidFill>
+                <a:ea typeface="Consolas"/>
+                <a:cs typeface="Consolas"/>
+                <a:latin typeface="Consolas"/>
+              </a:rPr>
+              <a:t>განსხვავებული ფასწარმოების</a:t>
+            </a:r>
+          </a:p>
+          <a:p>
+            <a:pPr>
+              <a:spcAft>
+                <a:spcPts val="0"/>
+              </a:spcAft>
+            </a:pPr>
+            <a:r>
+              <a:rPr sz="1000">
+                <a:solidFill>
+                  <a:srgbClr val="0F172A"/>
+                </a:solidFill>
+                <a:ea typeface="Consolas"/>
+                <a:cs typeface="Consolas"/>
+                <a:latin typeface="Consolas"/>
+              </a:rPr>
+              <a:t>მოდელი ჩემი</a:t>
+            </a:r>
+          </a:p>
+          <a:p>
+            <a:pPr>
+              <a:spcAft>
+                <a:spcPts val="0"/>
+              </a:spcAft>
+            </a:pPr>
+            <a:r>
+              <a:rPr sz="1000">
+                <a:solidFill>
+                  <a:srgbClr val="0F172A"/>
+                </a:solidFill>
+                <a:ea typeface="Consolas"/>
+                <a:cs typeface="Consolas"/>
+                <a:latin typeface="Consolas"/>
+              </a:rPr>
+              <a:t>პლატფორმისთვის.</a:t>
+            </a:r>
+          </a:p>
+          <a:p>
+            <a:pPr>
+              <a:spcAft>
+                <a:spcPts val="0"/>
+              </a:spcAft>
+            </a:pPr>
+            <a:r>
+              <a:rPr sz="1000">
+                <a:solidFill>
+                  <a:srgbClr val="0F172A"/>
+                </a:solidFill>
+                <a:ea typeface="Consolas"/>
+                <a:cs typeface="Consolas"/>
+                <a:latin typeface="Consolas"/>
+              </a:rPr>
+              <a:t>[Explanation] მინდა</a:t>
+            </a:r>
+          </a:p>
+          <a:p>
+            <a:pPr>
+              <a:spcAft>
+                <a:spcPts val="0"/>
+              </a:spcAft>
+            </a:pPr>
+            <a:r>
+              <a:rPr sz="1000">
+                <a:solidFill>
+                  <a:srgbClr val="0F172A"/>
+                </a:solidFill>
+                <a:ea typeface="Consolas"/>
+                <a:cs typeface="Consolas"/>
+                <a:latin typeface="Consolas"/>
+              </a:rPr>
+              <a:t>დავინახო, რომელი მოდელი</a:t>
+            </a:r>
+          </a:p>
+          <a:p>
+            <a:pPr>
+              <a:spcAft>
+                <a:spcPts val="0"/>
+              </a:spcAft>
+            </a:pPr>
+            <a:r>
+              <a:rPr sz="1000">
+                <a:solidFill>
+                  <a:srgbClr val="0F172A"/>
+                </a:solidFill>
+                <a:ea typeface="Consolas"/>
+                <a:cs typeface="Consolas"/>
+                <a:latin typeface="Consolas"/>
+              </a:rPr>
+              <a:t>იქნება ყველაზე</a:t>
+            </a:r>
+          </a:p>
+          <a:p>
+            <a:pPr>
+              <a:spcAft>
+                <a:spcPts val="0"/>
+              </a:spcAft>
+            </a:pPr>
+            <a:r>
+              <a:rPr sz="1000">
+                <a:solidFill>
+                  <a:srgbClr val="0F172A"/>
+                </a:solidFill>
+                <a:ea typeface="Consolas"/>
+                <a:cs typeface="Consolas"/>
+                <a:latin typeface="Consolas"/>
+              </a:rPr>
+              <a:t>ხელმისაწვდომი</a:t>
+            </a:r>
+          </a:p>
+          <a:p>
+            <a:pPr>
+              <a:spcAft>
+                <a:spcPts val="0"/>
+              </a:spcAft>
+            </a:pPr>
+            <a:r>
+              <a:rPr sz="1000">
+                <a:solidFill>
+                  <a:srgbClr val="0F172A"/>
+                </a:solidFill>
+                <a:ea typeface="Consolas"/>
+                <a:cs typeface="Consolas"/>
+                <a:latin typeface="Consolas"/>
+              </a:rPr>
+              <a:t>მომხმარებლისთვის საწყის</a:t>
+            </a:r>
+          </a:p>
+          <a:p>
+            <a:pPr>
+              <a:spcAft>
+                <a:spcPts val="0"/>
+              </a:spcAft>
+            </a:pPr>
+            <a:r>
+              <a:rPr sz="1000">
+                <a:solidFill>
+                  <a:srgbClr val="0F172A"/>
+                </a:solidFill>
+                <a:ea typeface="Consolas"/>
+                <a:cs typeface="Consolas"/>
+                <a:latin typeface="Consolas"/>
+              </a:rPr>
+              <a:t>ეტაპზე და ამავდროულად</a:t>
+            </a:r>
+          </a:p>
+          <a:p>
+            <a:pPr>
+              <a:spcAft>
+                <a:spcPts val="0"/>
+              </a:spcAft>
+            </a:pPr>
+            <a:r>
+              <a:rPr sz="1000">
+                <a:solidFill>
+                  <a:srgbClr val="0F172A"/>
+                </a:solidFill>
+                <a:ea typeface="Consolas"/>
+                <a:cs typeface="Consolas"/>
+                <a:latin typeface="Consolas"/>
+              </a:rPr>
+              <a:t>მოგვცემს მყარ განმეორებად</a:t>
+            </a:r>
+          </a:p>
+          <a:p>
+            <a:pPr>
+              <a:spcAft>
+                <a:spcPts val="0"/>
+              </a:spcAft>
+            </a:pPr>
+            <a:r>
+              <a:rPr sz="1000">
+                <a:solidFill>
+                  <a:srgbClr val="0F172A"/>
+                </a:solidFill>
+                <a:ea typeface="Consolas"/>
+                <a:cs typeface="Consolas"/>
+                <a:latin typeface="Consolas"/>
+              </a:rPr>
+              <a:t>შემოსავალს (MRR).</a:t>
+            </a:r>
+          </a:p>
+          <a:p>
+            <a:pPr>
+              <a:spcAft>
+                <a:spcPts val="0"/>
+              </a:spcAft>
+            </a:pPr>
+            <a:r>
+              <a:rPr sz="1000">
+                <a:solidFill>
+                  <a:srgbClr val="0F172A"/>
+                </a:solidFill>
+                <a:ea typeface="Consolas"/>
+                <a:cs typeface="Consolas"/>
+                <a:latin typeface="Consolas"/>
+              </a:rPr>
+              <a:t>[Action] შეადარე</a:t>
+            </a:r>
+          </a:p>
+          <a:p>
+            <a:pPr>
+              <a:spcAft>
+                <a:spcPts val="0"/>
+              </a:spcAft>
+            </a:pPr>
+            <a:r>
+              <a:rPr sz="1000">
+                <a:solidFill>
+                  <a:srgbClr val="0F172A"/>
+                </a:solidFill>
+                <a:ea typeface="Consolas"/>
+                <a:cs typeface="Consolas"/>
+                <a:latin typeface="Consolas"/>
+              </a:rPr>
+              <a:t>ერთმანეთს: ერთჯერადი</a:t>
+            </a:r>
+          </a:p>
+          <a:p>
+            <a:pPr>
+              <a:spcAft>
+                <a:spcPts val="0"/>
+              </a:spcAft>
+            </a:pPr>
+            <a:r>
+              <a:rPr sz="1000">
+                <a:solidFill>
+                  <a:srgbClr val="0F172A"/>
+                </a:solidFill>
+                <a:ea typeface="Consolas"/>
+                <a:cs typeface="Consolas"/>
+                <a:latin typeface="Consolas"/>
+              </a:rPr>
+              <a:t>გაყიდვის, ყოველთვიური</a:t>
+            </a:r>
+          </a:p>
+          <a:p>
+            <a:pPr>
+              <a:spcAft>
+                <a:spcPts val="0"/>
+              </a:spcAft>
+            </a:pPr>
+            <a:r>
+              <a:rPr sz="1000">
+                <a:solidFill>
+                  <a:srgbClr val="0F172A"/>
+                </a:solidFill>
+                <a:ea typeface="Consolas"/>
+                <a:cs typeface="Consolas"/>
+                <a:latin typeface="Consolas"/>
+              </a:rPr>
+              <a:t>გამომწერის (SaaS) და</a:t>
+            </a:r>
+          </a:p>
+          <a:p>
+            <a:pPr>
+              <a:spcAft>
+                <a:spcPts val="0"/>
+              </a:spcAft>
+            </a:pPr>
+            <a:r>
+              <a:rPr sz="1000">
+                <a:solidFill>
+                  <a:srgbClr val="0F172A"/>
+                </a:solidFill>
+                <a:ea typeface="Consolas"/>
+                <a:cs typeface="Consolas"/>
+                <a:latin typeface="Consolas"/>
+              </a:rPr>
+              <a:t>ჰიბრიდული მოდელები.</a:t>
+            </a:r>
+          </a:p>
+          <a:p>
+            <a:pPr>
+              <a:spcAft>
+                <a:spcPts val="0"/>
+              </a:spcAft>
+            </a:pPr>
+            <a:r>
+              <a:rPr sz="1000">
+                <a:solidFill>
+                  <a:srgbClr val="0F172A"/>
+                </a:solidFill>
+                <a:ea typeface="Consolas"/>
+                <a:cs typeface="Consolas"/>
+                <a:latin typeface="Consolas"/>
+              </a:rPr>
+              <a:t>[Target] წარმოადგინე ეს</a:t>
+            </a:r>
+          </a:p>
+          <a:p>
+            <a:pPr>
+              <a:spcAft>
+                <a:spcPts val="0"/>
+              </a:spcAft>
+            </a:pPr>
+            <a:r>
+              <a:rPr sz="1000">
+                <a:solidFill>
+                  <a:srgbClr val="0F172A"/>
+                </a:solidFill>
+                <a:ea typeface="Consolas"/>
+                <a:cs typeface="Consolas"/>
+                <a:latin typeface="Consolas"/>
+              </a:rPr>
+              <a:t>ყველაფერი ცხრილის სახით:</a:t>
+            </a:r>
+          </a:p>
+          <a:p>
+            <a:pPr>
+              <a:spcAft>
+                <a:spcPts val="0"/>
+              </a:spcAft>
+            </a:pPr>
+            <a:r>
+              <a:rPr sz="1000">
+                <a:solidFill>
+                  <a:srgbClr val="0F172A"/>
+                </a:solidFill>
+                <a:ea typeface="Consolas"/>
+                <a:cs typeface="Consolas"/>
+                <a:latin typeface="Consolas"/>
+              </a:rPr>
+              <a:t>პლიუსები, მინუსები და</a:t>
+            </a:r>
+          </a:p>
+          <a:p>
+            <a:pPr>
+              <a:spcAft>
+                <a:spcPts val="0"/>
+              </a:spcAft>
+            </a:pPr>
+            <a:r>
+              <a:rPr sz="1000">
+                <a:solidFill>
+                  <a:srgbClr val="0F172A"/>
+                </a:solidFill>
+                <a:ea typeface="Consolas"/>
+                <a:cs typeface="Consolas"/>
+                <a:latin typeface="Consolas"/>
+              </a:rPr>
+              <a:t>სავარაუდო ფასი.</a:t>
+            </a:r>
+          </a:p>
+          <a:p>
+            <a:pPr>
+              <a:spcAft>
+                <a:spcPts val="0"/>
+              </a:spcAft>
+            </a:pPr>
+            <a:r>
+              <a:rPr sz="1000">
+                <a:solidFill>
+                  <a:srgbClr val="0F172A"/>
+                </a:solidFill>
+                <a:ea typeface="Consolas"/>
+                <a:cs typeface="Consolas"/>
+                <a:latin typeface="Consolas"/>
+              </a:rPr>
+              <a:t>[Extras] თითოეული</a:t>
+            </a:r>
+          </a:p>
+          <a:p>
+            <a:pPr>
+              <a:spcAft>
+                <a:spcPts val="0"/>
+              </a:spcAft>
+            </a:pPr>
+            <a:r>
+              <a:rPr sz="1000">
+                <a:solidFill>
+                  <a:srgbClr val="0F172A"/>
+                </a:solidFill>
+                <a:ea typeface="Consolas"/>
+                <a:cs typeface="Consolas"/>
+                <a:latin typeface="Consolas"/>
+              </a:rPr>
+              <a:t>მოდელისთვის დაწერე 1</a:t>
+            </a:r>
+          </a:p>
+          <a:p>
+            <a:pPr>
+              <a:spcAft>
+                <a:spcPts val="0"/>
+              </a:spcAft>
+            </a:pPr>
+            <a:r>
+              <a:rPr sz="1000">
+                <a:solidFill>
+                  <a:srgbClr val="0F172A"/>
+                </a:solidFill>
+                <a:ea typeface="Consolas"/>
+                <a:cs typeface="Consolas"/>
+                <a:latin typeface="Consolas"/>
+              </a:rPr>
+              <a:t>ძირითადი რისკი. ტონი</a:t>
+            </a:r>
+          </a:p>
+          <a:p>
+            <a:pPr>
+              <a:spcAft>
+                <a:spcPts val="0"/>
+              </a:spcAft>
+            </a:pPr>
+            <a:r>
+              <a:rPr sz="1000">
+                <a:solidFill>
+                  <a:srgbClr val="0F172A"/>
+                </a:solidFill>
+                <a:ea typeface="Consolas"/>
+                <a:cs typeface="Consolas"/>
+                <a:latin typeface="Consolas"/>
+              </a:rPr>
+              <a:t>შეინარჩუნე საქმიანი.</a:t>
+            </a:r>
+          </a:p>
+        </p:txBody>
+      </p:sp>
+      <p:sp>
+        <p:nvSpPr>
+          <p:cNvPr id="22" name="Rectangle 21"/>
+          <p:cNvSpPr/>
+          <p:nvPr/>
+        </p:nvSpPr>
+        <p:spPr>
+          <a:xfrm>
             <a:off x="457200" y="4850892"/>
             <a:ext cx="8229600" cy="13716"/>
           </a:xfrm>
@@ -7731,7 +8731,7 @@
       </p:sp>
       <p:sp>
         <p:nvSpPr>
-          <p:cNvPr id="14" name="TextBox 13"/>
+          <p:cNvPr id="23" name="TextBox 22"/>
           <p:cNvSpPr txBox="1"/>
           <p:nvPr/>
         </p:nvSpPr>

</xml_diff>

<commit_message>
update Fri 07/17/2026  0:40:31.91
</commit_message>
<xml_diff>
--- a/GITA/Pre-Acceleration/2026-5h-AI-for-Startups/day1-slides.pptx
+++ b/GITA/Pre-Acceleration/2026-5h-AI-for-Startups/day1-slides.pptx
@@ -20685,7 +20685,7 @@
         <p:spPr>
           <a:xfrm>
             <a:off x="457200" y="1737360"/>
-            <a:ext cx="54864" cy="2587752"/>
+            <a:ext cx="54864" cy="3113532"/>
           </a:xfrm>
           <a:prstGeom prst="rect">
             <a:avLst/>
@@ -20729,7 +20729,7 @@
         <p:spPr>
           <a:xfrm>
             <a:off x="512064" y="1737360"/>
-            <a:ext cx="8174736" cy="2587752"/>
+            <a:ext cx="3991356" cy="3113532"/>
           </a:xfrm>
           <a:prstGeom prst="roundRect">
             <a:avLst>
@@ -20739,6 +20739,341 @@
           <a:solidFill>
             <a:srgbClr val="F8FAFC"/>
           </a:solidFill>
+          <a:ln w="6350">
+            <a:solidFill>
+              <a:srgbClr val="E2E8F0"/>
+            </a:solidFill>
+          </a:ln>
+          <a:effectLst/>
+        </p:spPr>
+        <p:style>
+          <a:lnRef idx="1">
+            <a:schemeClr val="accent1"/>
+          </a:lnRef>
+          <a:fillRef idx="3">
+            <a:schemeClr val="accent1"/>
+          </a:fillRef>
+          <a:effectRef idx="2">
+            <a:schemeClr val="accent1"/>
+          </a:effectRef>
+          <a:fontRef idx="minor">
+            <a:schemeClr val="lt1"/>
+          </a:fontRef>
+        </p:style>
+        <p:txBody>
+          <a:bodyPr rtlCol="0" anchor="ctr"/>
+          <a:lstStyle/>
+          <a:p>
+            <a:pPr algn="ctr"/>
+          </a:p>
+        </p:txBody>
+      </p:sp>
+      <p:sp>
+        <p:nvSpPr>
+          <p:cNvPr id="11" name="TextBox 10"/>
+          <p:cNvSpPr txBox="1"/>
+          <p:nvPr/>
+        </p:nvSpPr>
+        <p:spPr>
+          <a:xfrm>
+            <a:off x="621792" y="1810512"/>
+            <a:ext cx="3771900" cy="320040"/>
+          </a:xfrm>
+          <a:prstGeom prst="rect">
+            <a:avLst/>
+          </a:prstGeom>
+          <a:noFill/>
+        </p:spPr>
+        <p:txBody>
+          <a:bodyPr wrap="square" anchor="t" lIns="54864" rIns="54864" tIns="54864" bIns="54864">
+            <a:spAutoFit/>
+          </a:bodyPr>
+          <a:lstStyle/>
+          <a:p>
+            <a:pPr>
+              <a:spcAft>
+                <a:spcPts val="400"/>
+              </a:spcAft>
+            </a:pPr>
+            <a:r>
+              <a:rPr sz="1400" b="1" i="0">
+                <a:solidFill>
+                  <a:srgbClr val="0F172A"/>
+                </a:solidFill>
+                <a:ea typeface="Sylfaen"/>
+                <a:cs typeface="Sylfaen"/>
+                <a:latin typeface="Sylfaen"/>
+              </a:rPr>
+              <a:t>📋 ინსტრუქცია:</a:t>
+            </a:r>
+          </a:p>
+        </p:txBody>
+      </p:sp>
+      <p:sp>
+        <p:nvSpPr>
+          <p:cNvPr id="12" name="TextBox 11"/>
+          <p:cNvSpPr txBox="1"/>
+          <p:nvPr/>
+        </p:nvSpPr>
+        <p:spPr>
+          <a:xfrm>
+            <a:off x="621792" y="2203704"/>
+            <a:ext cx="3771900" cy="2574035"/>
+          </a:xfrm>
+          <a:prstGeom prst="rect">
+            <a:avLst/>
+          </a:prstGeom>
+          <a:noFill/>
+        </p:spPr>
+        <p:txBody>
+          <a:bodyPr wrap="square" anchor="t" lIns="54864" rIns="54864" tIns="54864" bIns="54864">
+            <a:spAutoFit/>
+          </a:bodyPr>
+          <a:lstStyle/>
+          <a:p>
+            <a:pPr algn="l">
+              <a:spcAft>
+                <a:spcPts val="300"/>
+              </a:spcAft>
+            </a:pPr>
+            <a:r>
+              <a:rPr sz="1300" b="1">
+                <a:solidFill>
+                  <a:srgbClr val="3730A3"/>
+                </a:solidFill>
+                <a:ea typeface="Sylfaen"/>
+                <a:cs typeface="Sylfaen"/>
+                <a:latin typeface="Sylfaen"/>
+              </a:rPr>
+              <a:t>▸  </a:t>
+            </a:r>
+            <a:r>
+              <a:rPr sz="1300">
+                <a:solidFill>
+                  <a:srgbClr val="0F172A"/>
+                </a:solidFill>
+                <a:ea typeface="Sylfaen"/>
+                <a:cs typeface="Sylfaen"/>
+                <a:latin typeface="Sylfaen"/>
+              </a:rPr>
+              <a:t>აირჩიეთ ტრადიციული ბიზნესი (მაგ: საოჯახო მარანი, საცხობი, ხილ-ბოსტნის მაღაზია);</a:t>
+            </a:r>
+          </a:p>
+          <a:p>
+            <a:pPr algn="l">
+              <a:spcAft>
+                <a:spcPts val="300"/>
+              </a:spcAft>
+            </a:pPr>
+            <a:r>
+              <a:rPr sz="1300" b="1">
+                <a:solidFill>
+                  <a:srgbClr val="3730A3"/>
+                </a:solidFill>
+                <a:ea typeface="Sylfaen"/>
+                <a:cs typeface="Sylfaen"/>
+                <a:latin typeface="Sylfaen"/>
+              </a:rPr>
+              <a:t>▸  </a:t>
+            </a:r>
+            <a:r>
+              <a:rPr sz="1300">
+                <a:solidFill>
+                  <a:srgbClr val="0F172A"/>
+                </a:solidFill>
+                <a:ea typeface="Sylfaen"/>
+                <a:cs typeface="Sylfaen"/>
+                <a:latin typeface="Sylfaen"/>
+              </a:rPr>
+              <a:t>გახსენით Claude ან ChatGPT და სთხოვეთ SCAMPER-ის მინიმუმ 3 ასოს (მაგ: Combine, Adapt, Eliminate) გამოყენებით ამ ბიზნესის ინოვაციური გარდაქმნა;</a:t>
+            </a:r>
+          </a:p>
+          <a:p>
+            <a:pPr algn="l">
+              <a:spcAft>
+                <a:spcPts val="300"/>
+              </a:spcAft>
+            </a:pPr>
+            <a:r>
+              <a:rPr sz="1300" b="1">
+                <a:solidFill>
+                  <a:srgbClr val="3730A3"/>
+                </a:solidFill>
+                <a:ea typeface="Sylfaen"/>
+                <a:cs typeface="Sylfaen"/>
+                <a:latin typeface="Sylfaen"/>
+              </a:rPr>
+              <a:t>▸  </a:t>
+            </a:r>
+            <a:r>
+              <a:rPr sz="1300">
+                <a:solidFill>
+                  <a:srgbClr val="0F172A"/>
+                </a:solidFill>
+                <a:ea typeface="Sylfaen"/>
+                <a:cs typeface="Sylfaen"/>
+                <a:latin typeface="Sylfaen"/>
+              </a:rPr>
+              <a:t>შეარჩიეთ 1 ყველაზე საინტერესო იდეა და მოინიშნეთ.</a:t>
+            </a:r>
+          </a:p>
+        </p:txBody>
+      </p:sp>
+      <p:sp>
+        <p:nvSpPr>
+          <p:cNvPr id="13" name="Rectangle 12"/>
+          <p:cNvSpPr/>
+          <p:nvPr/>
+        </p:nvSpPr>
+        <p:spPr>
+          <a:xfrm>
+            <a:off x="4640580" y="1737360"/>
+            <a:ext cx="54864" cy="3113532"/>
+          </a:xfrm>
+          <a:prstGeom prst="rect">
+            <a:avLst/>
+          </a:prstGeom>
+          <a:solidFill>
+            <a:srgbClr val="3730A3"/>
+          </a:solidFill>
+          <a:ln>
+            <a:noFill/>
+          </a:ln>
+          <a:effectLst/>
+        </p:spPr>
+        <p:style>
+          <a:lnRef idx="1">
+            <a:schemeClr val="accent1"/>
+          </a:lnRef>
+          <a:fillRef idx="3">
+            <a:schemeClr val="accent1"/>
+          </a:fillRef>
+          <a:effectRef idx="2">
+            <a:schemeClr val="accent1"/>
+          </a:effectRef>
+          <a:fontRef idx="minor">
+            <a:schemeClr val="lt1"/>
+          </a:fontRef>
+        </p:style>
+        <p:txBody>
+          <a:bodyPr rtlCol="0" anchor="ctr"/>
+          <a:lstStyle/>
+          <a:p>
+            <a:pPr algn="ctr"/>
+          </a:p>
+        </p:txBody>
+      </p:sp>
+      <p:sp>
+        <p:nvSpPr>
+          <p:cNvPr id="14" name="Rounded Rectangle 13"/>
+          <p:cNvSpPr/>
+          <p:nvPr/>
+        </p:nvSpPr>
+        <p:spPr>
+          <a:xfrm>
+            <a:off x="4695444" y="1737360"/>
+            <a:ext cx="3991356" cy="3113532"/>
+          </a:xfrm>
+          <a:prstGeom prst="roundRect">
+            <a:avLst>
+              <a:gd name="adj" fmla="val 4000"/>
+            </a:avLst>
+          </a:prstGeom>
+          <a:solidFill>
+            <a:srgbClr val="F8FAFC"/>
+          </a:solidFill>
+          <a:ln w="6350">
+            <a:solidFill>
+              <a:srgbClr val="3730A3"/>
+            </a:solidFill>
+          </a:ln>
+          <a:effectLst/>
+        </p:spPr>
+        <p:style>
+          <a:lnRef idx="1">
+            <a:schemeClr val="accent1"/>
+          </a:lnRef>
+          <a:fillRef idx="3">
+            <a:schemeClr val="accent1"/>
+          </a:fillRef>
+          <a:effectRef idx="2">
+            <a:schemeClr val="accent1"/>
+          </a:effectRef>
+          <a:fontRef idx="minor">
+            <a:schemeClr val="lt1"/>
+          </a:fontRef>
+        </p:style>
+        <p:txBody>
+          <a:bodyPr rtlCol="0" anchor="ctr"/>
+          <a:lstStyle/>
+          <a:p>
+            <a:pPr algn="ctr"/>
+          </a:p>
+        </p:txBody>
+      </p:sp>
+      <p:sp>
+        <p:nvSpPr>
+          <p:cNvPr id="15" name="Rectangle 14"/>
+          <p:cNvSpPr/>
+          <p:nvPr/>
+        </p:nvSpPr>
+        <p:spPr>
+          <a:xfrm>
+            <a:off x="4805172" y="1810512"/>
+            <a:ext cx="54864" cy="292608"/>
+          </a:xfrm>
+          <a:prstGeom prst="rect">
+            <a:avLst/>
+          </a:prstGeom>
+          <a:solidFill>
+            <a:srgbClr val="3730A3"/>
+          </a:solidFill>
+          <a:ln>
+            <a:noFill/>
+          </a:ln>
+          <a:effectLst/>
+        </p:spPr>
+        <p:style>
+          <a:lnRef idx="1">
+            <a:schemeClr val="accent1"/>
+          </a:lnRef>
+          <a:fillRef idx="3">
+            <a:schemeClr val="accent1"/>
+          </a:fillRef>
+          <a:effectRef idx="2">
+            <a:schemeClr val="accent1"/>
+          </a:effectRef>
+          <a:fontRef idx="minor">
+            <a:schemeClr val="lt1"/>
+          </a:fontRef>
+        </p:style>
+        <p:txBody>
+          <a:bodyPr rtlCol="0" anchor="ctr"/>
+          <a:lstStyle/>
+          <a:p>
+            <a:pPr algn="ctr"/>
+          </a:p>
+        </p:txBody>
+      </p:sp>
+      <p:sp>
+        <p:nvSpPr>
+          <p:cNvPr id="16" name="Rounded Rectangle 15"/>
+          <p:cNvSpPr/>
+          <p:nvPr/>
+        </p:nvSpPr>
+        <p:spPr>
+          <a:xfrm>
+            <a:off x="4860036" y="1810512"/>
+            <a:ext cx="3717036" cy="292608"/>
+          </a:xfrm>
+          <a:prstGeom prst="roundRect">
+            <a:avLst>
+              <a:gd name="adj" fmla="val 4000"/>
+            </a:avLst>
+          </a:prstGeom>
+          <a:solidFill>
+            <a:srgbClr val="F8FAFC"/>
+          </a:solidFill>
           <a:ln w="9525">
             <a:solidFill>
               <a:srgbClr val="E2E8F0"/>
@@ -20770,14 +21105,60 @@
       </p:sp>
       <p:sp>
         <p:nvSpPr>
-          <p:cNvPr id="11" name="TextBox 10"/>
+          <p:cNvPr id="17" name="Rectangle 16"/>
+          <p:cNvSpPr/>
+          <p:nvPr/>
+        </p:nvSpPr>
+        <p:spPr>
+          <a:xfrm>
+            <a:off x="4914900" y="1865376"/>
+            <a:ext cx="3552444" cy="201168"/>
+          </a:xfrm>
+          <a:prstGeom prst="rect">
+            <a:avLst/>
+          </a:prstGeom>
+          <a:solidFill>
+            <a:srgbClr val="FFFFFF"/>
+          </a:solidFill>
+          <a:ln w="6350">
+            <a:solidFill>
+              <a:srgbClr val="E2E8F0"/>
+            </a:solidFill>
+          </a:ln>
+          <a:effectLst/>
+        </p:spPr>
+        <p:style>
+          <a:lnRef idx="1">
+            <a:schemeClr val="accent1"/>
+          </a:lnRef>
+          <a:fillRef idx="3">
+            <a:schemeClr val="accent1"/>
+          </a:fillRef>
+          <a:effectRef idx="2">
+            <a:schemeClr val="accent1"/>
+          </a:effectRef>
+          <a:fontRef idx="minor">
+            <a:schemeClr val="lt1"/>
+          </a:fontRef>
+        </p:style>
+        <p:txBody>
+          <a:bodyPr rtlCol="0" anchor="ctr"/>
+          <a:lstStyle/>
+          <a:p>
+            <a:pPr algn="ctr"/>
+          </a:p>
+        </p:txBody>
+      </p:sp>
+      <p:sp>
+        <p:nvSpPr>
+          <p:cNvPr id="18" name="TextBox 17"/>
           <p:cNvSpPr txBox="1"/>
           <p:nvPr/>
         </p:nvSpPr>
         <p:spPr>
           <a:xfrm>
-            <a:off x="621792" y="1810512"/>
-            <a:ext cx="7955279" cy="320040"/>
+            <a:off x="4969764" y="1892807"/>
+            <a:ext cx="3442716" cy="146304"/>
           </a:xfrm>
           <a:prstGeom prst="rect">
             <a:avLst/>
@@ -20792,33 +21173,127 @@
           <a:p>
             <a:pPr>
               <a:spcAft>
-                <a:spcPts val="400"/>
-              </a:spcAft>
-            </a:pPr>
-            <a:r>
-              <a:rPr sz="1400" b="1" i="0">
+                <a:spcPts val="0"/>
+              </a:spcAft>
+            </a:pPr>
+            <a:r>
+              <a:rPr sz="1200">
                 <a:solidFill>
                   <a:srgbClr val="0F172A"/>
                 </a:solidFill>
-                <a:ea typeface="Sylfaen"/>
-                <a:cs typeface="Sylfaen"/>
-                <a:latin typeface="Sylfaen"/>
-              </a:rPr>
-              <a:t>📋 ინსტრუქცია:</a:t>
-            </a:r>
-          </a:p>
-        </p:txBody>
-      </p:sp>
-      <p:sp>
-        <p:nvSpPr>
-          <p:cNvPr id="12" name="TextBox 11"/>
+                <a:ea typeface="Consolas"/>
+                <a:cs typeface="Consolas"/>
+                <a:latin typeface="Consolas"/>
+              </a:rPr>
+              <a:t>SCAMPER სავარჯიშო შაბლონი:</a:t>
+            </a:r>
+          </a:p>
+        </p:txBody>
+      </p:sp>
+      <p:sp>
+        <p:nvSpPr>
+          <p:cNvPr id="19" name="Rounded Rectangle 18"/>
+          <p:cNvSpPr/>
+          <p:nvPr/>
+        </p:nvSpPr>
+        <p:spPr>
+          <a:xfrm>
+            <a:off x="4805172" y="2176272"/>
+            <a:ext cx="3771900" cy="2601468"/>
+          </a:xfrm>
+          <a:prstGeom prst="roundRect">
+            <a:avLst>
+              <a:gd name="adj" fmla="val 4000"/>
+            </a:avLst>
+          </a:prstGeom>
+          <a:solidFill>
+            <a:srgbClr val="F8FAFC"/>
+          </a:solidFill>
+          <a:ln w="9525">
+            <a:solidFill>
+              <a:srgbClr val="E2E8F0"/>
+            </a:solidFill>
+          </a:ln>
+          <a:effectLst/>
+        </p:spPr>
+        <p:style>
+          <a:lnRef idx="1">
+            <a:schemeClr val="accent1"/>
+          </a:lnRef>
+          <a:fillRef idx="3">
+            <a:schemeClr val="accent1"/>
+          </a:fillRef>
+          <a:effectRef idx="2">
+            <a:schemeClr val="accent1"/>
+          </a:effectRef>
+          <a:fontRef idx="minor">
+            <a:schemeClr val="lt1"/>
+          </a:fontRef>
+        </p:style>
+        <p:txBody>
+          <a:bodyPr rtlCol="0" anchor="ctr"/>
+          <a:lstStyle/>
+          <a:p>
+            <a:pPr algn="ctr"/>
+          </a:p>
+        </p:txBody>
+      </p:sp>
+      <p:sp>
+        <p:nvSpPr>
+          <p:cNvPr id="20" name="Rectangle 19"/>
+          <p:cNvSpPr/>
+          <p:nvPr/>
+        </p:nvSpPr>
+        <p:spPr>
+          <a:xfrm>
+            <a:off x="4860036" y="2221991"/>
+            <a:ext cx="3662172" cy="2510027"/>
+          </a:xfrm>
+          <a:prstGeom prst="rect">
+            <a:avLst/>
+          </a:prstGeom>
+          <a:solidFill>
+            <a:srgbClr val="FFFFFF"/>
+          </a:solidFill>
+          <a:ln w="6350">
+            <a:solidFill>
+              <a:srgbClr val="E2E8F0"/>
+            </a:solidFill>
+          </a:ln>
+          <a:effectLst/>
+        </p:spPr>
+        <p:style>
+          <a:lnRef idx="1">
+            <a:schemeClr val="accent1"/>
+          </a:lnRef>
+          <a:fillRef idx="3">
+            <a:schemeClr val="accent1"/>
+          </a:fillRef>
+          <a:effectRef idx="2">
+            <a:schemeClr val="accent1"/>
+          </a:effectRef>
+          <a:fontRef idx="minor">
+            <a:schemeClr val="lt1"/>
+          </a:fontRef>
+        </p:style>
+        <p:txBody>
+          <a:bodyPr rtlCol="0" anchor="ctr"/>
+          <a:lstStyle/>
+          <a:p>
+            <a:pPr algn="ctr"/>
+          </a:p>
+        </p:txBody>
+      </p:sp>
+      <p:sp>
+        <p:nvSpPr>
+          <p:cNvPr id="21" name="TextBox 20"/>
           <p:cNvSpPr txBox="1"/>
           <p:nvPr/>
         </p:nvSpPr>
         <p:spPr>
           <a:xfrm>
-            <a:off x="621792" y="2203704"/>
-            <a:ext cx="7955279" cy="1993392"/>
+            <a:off x="4914900" y="2240279"/>
+            <a:ext cx="3552444" cy="2473451"/>
           </a:xfrm>
           <a:prstGeom prst="rect">
             <a:avLst/>
@@ -20831,97 +21306,370 @@
           </a:bodyPr>
           <a:lstStyle/>
           <a:p>
-            <a:pPr algn="l">
-              <a:spcAft>
-                <a:spcPts val="300"/>
-              </a:spcAft>
-            </a:pPr>
-            <a:r>
-              <a:rPr sz="1300" b="1">
-                <a:solidFill>
-                  <a:srgbClr val="3730A3"/>
-                </a:solidFill>
-                <a:ea typeface="Sylfaen"/>
-                <a:cs typeface="Sylfaen"/>
-                <a:latin typeface="Sylfaen"/>
-              </a:rPr>
-              <a:t>▸  </a:t>
-            </a:r>
-            <a:r>
-              <a:rPr sz="1300">
+            <a:pPr>
+              <a:spcAft>
+                <a:spcPts val="0"/>
+              </a:spcAft>
+            </a:pPr>
+            <a:r>
+              <a:rPr sz="1000">
                 <a:solidFill>
                   <a:srgbClr val="0F172A"/>
                 </a:solidFill>
-                <a:ea typeface="Sylfaen"/>
-                <a:cs typeface="Sylfaen"/>
-                <a:latin typeface="Sylfaen"/>
-              </a:rPr>
-              <a:t>აირჩიეთ ტრადიციული ბიზნესი (მაგ: საოჯახო მარანი, საცხობი, ხილ-ბოსტნის მაღაზია);</a:t>
-            </a:r>
-          </a:p>
-          <a:p>
-            <a:pPr algn="l">
-              <a:spcAft>
-                <a:spcPts val="300"/>
-              </a:spcAft>
-            </a:pPr>
-            <a:r>
-              <a:rPr sz="1300" b="1">
-                <a:solidFill>
-                  <a:srgbClr val="3730A3"/>
-                </a:solidFill>
-                <a:ea typeface="Sylfaen"/>
-                <a:cs typeface="Sylfaen"/>
-                <a:latin typeface="Sylfaen"/>
-              </a:rPr>
-              <a:t>▸  </a:t>
-            </a:r>
-            <a:r>
-              <a:rPr sz="1300">
+                <a:ea typeface="Consolas"/>
+                <a:cs typeface="Consolas"/>
+                <a:latin typeface="Consolas"/>
+              </a:rPr>
+              <a:t>მე მაქვს ტრადიციული</a:t>
+            </a:r>
+          </a:p>
+          <a:p>
+            <a:pPr>
+              <a:spcAft>
+                <a:spcPts val="0"/>
+              </a:spcAft>
+            </a:pPr>
+            <a:r>
+              <a:rPr sz="1000">
                 <a:solidFill>
                   <a:srgbClr val="0F172A"/>
                 </a:solidFill>
-                <a:ea typeface="Sylfaen"/>
-                <a:cs typeface="Sylfaen"/>
-                <a:latin typeface="Sylfaen"/>
-              </a:rPr>
-              <a:t>გახსენით Claude ან ChatGPT და სთხოვეთ SCAMPER-ის მინიმუმ 3 ასოს (მაგ: Combine, Adapt, Eliminate) გამოყენებით ამ ბიზნესის ინოვაციური გარდაქმნა;</a:t>
-            </a:r>
-          </a:p>
-          <a:p>
-            <a:pPr algn="l">
-              <a:spcAft>
-                <a:spcPts val="300"/>
-              </a:spcAft>
-            </a:pPr>
-            <a:r>
-              <a:rPr sz="1300" b="1">
-                <a:solidFill>
-                  <a:srgbClr val="3730A3"/>
-                </a:solidFill>
-                <a:ea typeface="Sylfaen"/>
-                <a:cs typeface="Sylfaen"/>
-                <a:latin typeface="Sylfaen"/>
-              </a:rPr>
-              <a:t>▸  </a:t>
-            </a:r>
-            <a:r>
-              <a:rPr sz="1300">
+                <a:ea typeface="Consolas"/>
+                <a:cs typeface="Consolas"/>
+                <a:latin typeface="Consolas"/>
+              </a:rPr>
+              <a:t>ბიზნესი: [მაგ: საოჯახო</a:t>
+            </a:r>
+          </a:p>
+          <a:p>
+            <a:pPr>
+              <a:spcAft>
+                <a:spcPts val="0"/>
+              </a:spcAft>
+            </a:pPr>
+            <a:r>
+              <a:rPr sz="1000">
                 <a:solidFill>
                   <a:srgbClr val="0F172A"/>
                 </a:solidFill>
-                <a:ea typeface="Sylfaen"/>
-                <a:cs typeface="Sylfaen"/>
-                <a:latin typeface="Sylfaen"/>
-              </a:rPr>
-              <a:t>შეარჩიეთ 1 ყველაზე საინტერესო იდეა და მოინიშნეთ.</a:t>
-            </a:r>
-          </a:p>
-        </p:txBody>
-      </p:sp>
-      <p:sp>
-        <p:nvSpPr>
-          <p:cNvPr id="13" name="Rectangle 12"/>
+                <a:ea typeface="Consolas"/>
+                <a:cs typeface="Consolas"/>
+                <a:latin typeface="Consolas"/>
+              </a:rPr>
+              <a:t>მარანი კახეთში].</a:t>
+            </a:r>
+          </a:p>
+          <a:p>
+            <a:pPr>
+              <a:spcAft>
+                <a:spcPts val="0"/>
+              </a:spcAft>
+            </a:pPr>
+            <a:r>
+              <a:rPr sz="1000">
+                <a:solidFill>
+                  <a:srgbClr val="0F172A"/>
+                </a:solidFill>
+                <a:ea typeface="Consolas"/>
+                <a:cs typeface="Consolas"/>
+                <a:latin typeface="Consolas"/>
+              </a:rPr>
+              <a:t>დამეხმარე SCAMPER</a:t>
+            </a:r>
+          </a:p>
+          <a:p>
+            <a:pPr>
+              <a:spcAft>
+                <a:spcPts val="0"/>
+              </a:spcAft>
+            </a:pPr>
+            <a:r>
+              <a:rPr sz="1000">
+                <a:solidFill>
+                  <a:srgbClr val="0F172A"/>
+                </a:solidFill>
+                <a:ea typeface="Consolas"/>
+                <a:cs typeface="Consolas"/>
+                <a:latin typeface="Consolas"/>
+              </a:rPr>
+              <a:t>მეთოდოლოგიის გამოყენებით</a:t>
+            </a:r>
+          </a:p>
+          <a:p>
+            <a:pPr>
+              <a:spcAft>
+                <a:spcPts val="0"/>
+              </a:spcAft>
+            </a:pPr>
+            <a:r>
+              <a:rPr sz="1000">
+                <a:solidFill>
+                  <a:srgbClr val="0F172A"/>
+                </a:solidFill>
+                <a:ea typeface="Consolas"/>
+                <a:cs typeface="Consolas"/>
+                <a:latin typeface="Consolas"/>
+              </a:rPr>
+              <a:t>ამ ბიზნესის მოდერნიზაციასა</a:t>
+            </a:r>
+          </a:p>
+          <a:p>
+            <a:pPr>
+              <a:spcAft>
+                <a:spcPts val="0"/>
+              </a:spcAft>
+            </a:pPr>
+            <a:r>
+              <a:rPr sz="1000">
+                <a:solidFill>
+                  <a:srgbClr val="0F172A"/>
+                </a:solidFill>
+                <a:ea typeface="Consolas"/>
+                <a:cs typeface="Consolas"/>
+                <a:latin typeface="Consolas"/>
+              </a:rPr>
+              <a:t>და ინოვაციური კუთხის</a:t>
+            </a:r>
+          </a:p>
+          <a:p>
+            <a:pPr>
+              <a:spcAft>
+                <a:spcPts val="0"/>
+              </a:spcAft>
+            </a:pPr>
+            <a:r>
+              <a:rPr sz="1000">
+                <a:solidFill>
+                  <a:srgbClr val="0F172A"/>
+                </a:solidFill>
+                <a:ea typeface="Consolas"/>
+                <a:cs typeface="Consolas"/>
+                <a:latin typeface="Consolas"/>
+              </a:rPr>
+              <a:t>მოძებნაში.</a:t>
+            </a:r>
+          </a:p>
+          <a:p>
+            <a:pPr>
+              <a:spcAft>
+                <a:spcPts val="0"/>
+              </a:spcAft>
+            </a:pPr>
+            <a:r>
+              <a:rPr sz="1000">
+                <a:solidFill>
+                  <a:srgbClr val="0F172A"/>
+                </a:solidFill>
+                <a:ea typeface="Consolas"/>
+                <a:cs typeface="Consolas"/>
+                <a:latin typeface="Consolas"/>
+              </a:rPr>
+              <a:t>შემომთავაზე 3 იდეა შემდეგი</a:t>
+            </a:r>
+          </a:p>
+          <a:p>
+            <a:pPr>
+              <a:spcAft>
+                <a:spcPts val="0"/>
+              </a:spcAft>
+            </a:pPr>
+            <a:r>
+              <a:rPr sz="1000">
+                <a:solidFill>
+                  <a:srgbClr val="0F172A"/>
+                </a:solidFill>
+                <a:ea typeface="Consolas"/>
+                <a:cs typeface="Consolas"/>
+                <a:latin typeface="Consolas"/>
+              </a:rPr>
+              <a:t>ასოების მიხედვით:</a:t>
+            </a:r>
+          </a:p>
+          <a:p>
+            <a:pPr>
+              <a:spcAft>
+                <a:spcPts val="0"/>
+              </a:spcAft>
+            </a:pPr>
+            <a:r>
+              <a:rPr sz="1000">
+                <a:solidFill>
+                  <a:srgbClr val="0F172A"/>
+                </a:solidFill>
+                <a:ea typeface="Consolas"/>
+                <a:cs typeface="Consolas"/>
+                <a:latin typeface="Consolas"/>
+              </a:rPr>
+              <a:t>1. Combine (გაერთიანება) -</a:t>
+            </a:r>
+          </a:p>
+          <a:p>
+            <a:pPr>
+              <a:spcAft>
+                <a:spcPts val="0"/>
+              </a:spcAft>
+            </a:pPr>
+            <a:r>
+              <a:rPr sz="1000">
+                <a:solidFill>
+                  <a:srgbClr val="0F172A"/>
+                </a:solidFill>
+                <a:ea typeface="Consolas"/>
+                <a:cs typeface="Consolas"/>
+                <a:latin typeface="Consolas"/>
+              </a:rPr>
+              <a:t>რასთან შეგვიძლია მისი</a:t>
+            </a:r>
+          </a:p>
+          <a:p>
+            <a:pPr>
+              <a:spcAft>
+                <a:spcPts val="0"/>
+              </a:spcAft>
+            </a:pPr>
+            <a:r>
+              <a:rPr sz="1000">
+                <a:solidFill>
+                  <a:srgbClr val="0F172A"/>
+                </a:solidFill>
+                <a:ea typeface="Consolas"/>
+                <a:cs typeface="Consolas"/>
+                <a:latin typeface="Consolas"/>
+              </a:rPr>
+              <a:t>გაერთიანება?</a:t>
+            </a:r>
+          </a:p>
+          <a:p>
+            <a:pPr>
+              <a:spcAft>
+                <a:spcPts val="0"/>
+              </a:spcAft>
+            </a:pPr>
+            <a:r>
+              <a:rPr sz="1000">
+                <a:solidFill>
+                  <a:srgbClr val="0F172A"/>
+                </a:solidFill>
+                <a:ea typeface="Consolas"/>
+                <a:cs typeface="Consolas"/>
+                <a:latin typeface="Consolas"/>
+              </a:rPr>
+              <a:t>2. Adapt (ადაპტაცია) -</a:t>
+            </a:r>
+          </a:p>
+          <a:p>
+            <a:pPr>
+              <a:spcAft>
+                <a:spcPts val="0"/>
+              </a:spcAft>
+            </a:pPr>
+            <a:r>
+              <a:rPr sz="1000">
+                <a:solidFill>
+                  <a:srgbClr val="0F172A"/>
+                </a:solidFill>
+                <a:ea typeface="Consolas"/>
+                <a:cs typeface="Consolas"/>
+                <a:latin typeface="Consolas"/>
+              </a:rPr>
+              <a:t>სხვა სფეროდან რა მოდელი</a:t>
+            </a:r>
+          </a:p>
+          <a:p>
+            <a:pPr>
+              <a:spcAft>
+                <a:spcPts val="0"/>
+              </a:spcAft>
+            </a:pPr>
+            <a:r>
+              <a:rPr sz="1000">
+                <a:solidFill>
+                  <a:srgbClr val="0F172A"/>
+                </a:solidFill>
+                <a:ea typeface="Consolas"/>
+                <a:cs typeface="Consolas"/>
+                <a:latin typeface="Consolas"/>
+              </a:rPr>
+              <a:t>შეგვიძლია გადმოვიტანოთ?</a:t>
+            </a:r>
+          </a:p>
+          <a:p>
+            <a:pPr>
+              <a:spcAft>
+                <a:spcPts val="0"/>
+              </a:spcAft>
+            </a:pPr>
+            <a:r>
+              <a:rPr sz="1000">
+                <a:solidFill>
+                  <a:srgbClr val="0F172A"/>
+                </a:solidFill>
+                <a:ea typeface="Consolas"/>
+                <a:cs typeface="Consolas"/>
+                <a:latin typeface="Consolas"/>
+              </a:rPr>
+              <a:t>3. Eliminate (მოცილება) -</a:t>
+            </a:r>
+          </a:p>
+          <a:p>
+            <a:pPr>
+              <a:spcAft>
+                <a:spcPts val="0"/>
+              </a:spcAft>
+            </a:pPr>
+            <a:r>
+              <a:rPr sz="1000">
+                <a:solidFill>
+                  <a:srgbClr val="0F172A"/>
+                </a:solidFill>
+                <a:ea typeface="Consolas"/>
+                <a:cs typeface="Consolas"/>
+                <a:latin typeface="Consolas"/>
+              </a:rPr>
+              <a:t>რა ტრადიციული კომპონენტის</a:t>
+            </a:r>
+          </a:p>
+          <a:p>
+            <a:pPr>
+              <a:spcAft>
+                <a:spcPts val="0"/>
+              </a:spcAft>
+            </a:pPr>
+            <a:r>
+              <a:rPr sz="1000">
+                <a:solidFill>
+                  <a:srgbClr val="0F172A"/>
+                </a:solidFill>
+                <a:ea typeface="Consolas"/>
+                <a:cs typeface="Consolas"/>
+                <a:latin typeface="Consolas"/>
+              </a:rPr>
+              <a:t>ამოღება შეგვიძლია პროცესის</a:t>
+            </a:r>
+          </a:p>
+          <a:p>
+            <a:pPr>
+              <a:spcAft>
+                <a:spcPts val="0"/>
+              </a:spcAft>
+            </a:pPr>
+            <a:r>
+              <a:rPr sz="1000">
+                <a:solidFill>
+                  <a:srgbClr val="0F172A"/>
+                </a:solidFill>
+                <a:ea typeface="Consolas"/>
+                <a:cs typeface="Consolas"/>
+                <a:latin typeface="Consolas"/>
+              </a:rPr>
+              <a:t>გასამარტივებლად?</a:t>
+            </a:r>
+          </a:p>
+        </p:txBody>
+      </p:sp>
+      <p:sp>
+        <p:nvSpPr>
+          <p:cNvPr id="22" name="Rectangle 21"/>
           <p:cNvSpPr/>
           <p:nvPr/>
         </p:nvSpPr>
@@ -20965,7 +21713,7 @@
       </p:sp>
       <p:sp>
         <p:nvSpPr>
-          <p:cNvPr id="14" name="TextBox 13"/>
+          <p:cNvPr id="23" name="TextBox 22"/>
           <p:cNvSpPr txBox="1"/>
           <p:nvPr/>
         </p:nvSpPr>
@@ -27568,7 +28316,7 @@
         <p:spPr>
           <a:xfrm>
             <a:off x="457200" y="1737360"/>
-            <a:ext cx="54864" cy="2587752"/>
+            <a:ext cx="54864" cy="3113532"/>
           </a:xfrm>
           <a:prstGeom prst="rect">
             <a:avLst/>
@@ -27612,7 +28360,7 @@
         <p:spPr>
           <a:xfrm>
             <a:off x="512064" y="1737360"/>
-            <a:ext cx="8174736" cy="2587752"/>
+            <a:ext cx="3991356" cy="3113532"/>
           </a:xfrm>
           <a:prstGeom prst="roundRect">
             <a:avLst>
@@ -27622,6 +28370,341 @@
           <a:solidFill>
             <a:srgbClr val="F8FAFC"/>
           </a:solidFill>
+          <a:ln w="6350">
+            <a:solidFill>
+              <a:srgbClr val="E2E8F0"/>
+            </a:solidFill>
+          </a:ln>
+          <a:effectLst/>
+        </p:spPr>
+        <p:style>
+          <a:lnRef idx="1">
+            <a:schemeClr val="accent1"/>
+          </a:lnRef>
+          <a:fillRef idx="3">
+            <a:schemeClr val="accent1"/>
+          </a:fillRef>
+          <a:effectRef idx="2">
+            <a:schemeClr val="accent1"/>
+          </a:effectRef>
+          <a:fontRef idx="minor">
+            <a:schemeClr val="lt1"/>
+          </a:fontRef>
+        </p:style>
+        <p:txBody>
+          <a:bodyPr rtlCol="0" anchor="ctr"/>
+          <a:lstStyle/>
+          <a:p>
+            <a:pPr algn="ctr"/>
+          </a:p>
+        </p:txBody>
+      </p:sp>
+      <p:sp>
+        <p:nvSpPr>
+          <p:cNvPr id="11" name="TextBox 10"/>
+          <p:cNvSpPr txBox="1"/>
+          <p:nvPr/>
+        </p:nvSpPr>
+        <p:spPr>
+          <a:xfrm>
+            <a:off x="621792" y="1810512"/>
+            <a:ext cx="3771900" cy="320040"/>
+          </a:xfrm>
+          <a:prstGeom prst="rect">
+            <a:avLst/>
+          </a:prstGeom>
+          <a:noFill/>
+        </p:spPr>
+        <p:txBody>
+          <a:bodyPr wrap="square" anchor="t" lIns="54864" rIns="54864" tIns="54864" bIns="54864">
+            <a:spAutoFit/>
+          </a:bodyPr>
+          <a:lstStyle/>
+          <a:p>
+            <a:pPr>
+              <a:spcAft>
+                <a:spcPts val="400"/>
+              </a:spcAft>
+            </a:pPr>
+            <a:r>
+              <a:rPr sz="1400" b="1" i="0">
+                <a:solidFill>
+                  <a:srgbClr val="0F172A"/>
+                </a:solidFill>
+                <a:ea typeface="Sylfaen"/>
+                <a:cs typeface="Sylfaen"/>
+                <a:latin typeface="Sylfaen"/>
+              </a:rPr>
+              <a:t>📋 ინსტრუქცია:</a:t>
+            </a:r>
+          </a:p>
+        </p:txBody>
+      </p:sp>
+      <p:sp>
+        <p:nvSpPr>
+          <p:cNvPr id="12" name="TextBox 11"/>
+          <p:cNvSpPr txBox="1"/>
+          <p:nvPr/>
+        </p:nvSpPr>
+        <p:spPr>
+          <a:xfrm>
+            <a:off x="621792" y="2203704"/>
+            <a:ext cx="3771900" cy="2542032"/>
+          </a:xfrm>
+          <a:prstGeom prst="rect">
+            <a:avLst/>
+          </a:prstGeom>
+          <a:noFill/>
+        </p:spPr>
+        <p:txBody>
+          <a:bodyPr wrap="square" anchor="t" lIns="54864" rIns="54864" tIns="54864" bIns="54864">
+            <a:spAutoFit/>
+          </a:bodyPr>
+          <a:lstStyle/>
+          <a:p>
+            <a:pPr algn="l">
+              <a:spcAft>
+                <a:spcPts val="300"/>
+              </a:spcAft>
+            </a:pPr>
+            <a:r>
+              <a:rPr sz="1300" b="1">
+                <a:solidFill>
+                  <a:srgbClr val="3730A3"/>
+                </a:solidFill>
+                <a:ea typeface="Sylfaen"/>
+                <a:cs typeface="Sylfaen"/>
+                <a:latin typeface="Sylfaen"/>
+              </a:rPr>
+              <a:t>▸  </a:t>
+            </a:r>
+            <a:r>
+              <a:rPr sz="1300">
+                <a:solidFill>
+                  <a:srgbClr val="0F172A"/>
+                </a:solidFill>
+                <a:ea typeface="Sylfaen"/>
+                <a:cs typeface="Sylfaen"/>
+                <a:latin typeface="Sylfaen"/>
+              </a:rPr>
+              <a:t>გახსენით Claude ან ChatGPT ;</a:t>
+            </a:r>
+          </a:p>
+          <a:p>
+            <a:pPr algn="l">
+              <a:spcAft>
+                <a:spcPts val="300"/>
+              </a:spcAft>
+            </a:pPr>
+            <a:r>
+              <a:rPr sz="1300" b="1">
+                <a:solidFill>
+                  <a:srgbClr val="3730A3"/>
+                </a:solidFill>
+                <a:ea typeface="Sylfaen"/>
+                <a:cs typeface="Sylfaen"/>
+                <a:latin typeface="Sylfaen"/>
+              </a:rPr>
+              <a:t>▸  </a:t>
+            </a:r>
+            <a:r>
+              <a:rPr sz="1300">
+                <a:solidFill>
+                  <a:srgbClr val="0F172A"/>
+                </a:solidFill>
+                <a:ea typeface="Sylfaen"/>
+                <a:cs typeface="Sylfaen"/>
+                <a:latin typeface="Sylfaen"/>
+              </a:rPr>
+              <a:t>დაწერეთ თქვენი სტარტაპის JTBD ფორმულა: „როდესაც [სიტუაცია], მინდა [აქტივობა], რათა [სასურველი შედეგი]“ ;</a:t>
+            </a:r>
+          </a:p>
+          <a:p>
+            <a:pPr algn="l">
+              <a:spcAft>
+                <a:spcPts val="300"/>
+              </a:spcAft>
+            </a:pPr>
+            <a:r>
+              <a:rPr sz="1300" b="1">
+                <a:solidFill>
+                  <a:srgbClr val="3730A3"/>
+                </a:solidFill>
+                <a:ea typeface="Sylfaen"/>
+                <a:cs typeface="Sylfaen"/>
+                <a:latin typeface="Sylfaen"/>
+              </a:rPr>
+              <a:t>▸  </a:t>
+            </a:r>
+            <a:r>
+              <a:rPr sz="1300">
+                <a:solidFill>
+                  <a:srgbClr val="0F172A"/>
+                </a:solidFill>
+                <a:ea typeface="Sylfaen"/>
+                <a:cs typeface="Sylfaen"/>
+                <a:latin typeface="Sylfaen"/>
+              </a:rPr>
+              <a:t>სთხოვეთ AI-ს, გაუკეთოს კრიტიკა ამ ფორმულას და შემოგთავაზოთ 2 უფრო ზუსტი და სპეციფიკური ალტერნატივა.</a:t>
+            </a:r>
+          </a:p>
+        </p:txBody>
+      </p:sp>
+      <p:sp>
+        <p:nvSpPr>
+          <p:cNvPr id="13" name="Rectangle 12"/>
+          <p:cNvSpPr/>
+          <p:nvPr/>
+        </p:nvSpPr>
+        <p:spPr>
+          <a:xfrm>
+            <a:off x="4640580" y="1737360"/>
+            <a:ext cx="54864" cy="3113532"/>
+          </a:xfrm>
+          <a:prstGeom prst="rect">
+            <a:avLst/>
+          </a:prstGeom>
+          <a:solidFill>
+            <a:srgbClr val="3730A3"/>
+          </a:solidFill>
+          <a:ln>
+            <a:noFill/>
+          </a:ln>
+          <a:effectLst/>
+        </p:spPr>
+        <p:style>
+          <a:lnRef idx="1">
+            <a:schemeClr val="accent1"/>
+          </a:lnRef>
+          <a:fillRef idx="3">
+            <a:schemeClr val="accent1"/>
+          </a:fillRef>
+          <a:effectRef idx="2">
+            <a:schemeClr val="accent1"/>
+          </a:effectRef>
+          <a:fontRef idx="minor">
+            <a:schemeClr val="lt1"/>
+          </a:fontRef>
+        </p:style>
+        <p:txBody>
+          <a:bodyPr rtlCol="0" anchor="ctr"/>
+          <a:lstStyle/>
+          <a:p>
+            <a:pPr algn="ctr"/>
+          </a:p>
+        </p:txBody>
+      </p:sp>
+      <p:sp>
+        <p:nvSpPr>
+          <p:cNvPr id="14" name="Rounded Rectangle 13"/>
+          <p:cNvSpPr/>
+          <p:nvPr/>
+        </p:nvSpPr>
+        <p:spPr>
+          <a:xfrm>
+            <a:off x="4695444" y="1737360"/>
+            <a:ext cx="3991356" cy="3113532"/>
+          </a:xfrm>
+          <a:prstGeom prst="roundRect">
+            <a:avLst>
+              <a:gd name="adj" fmla="val 4000"/>
+            </a:avLst>
+          </a:prstGeom>
+          <a:solidFill>
+            <a:srgbClr val="F8FAFC"/>
+          </a:solidFill>
+          <a:ln w="6350">
+            <a:solidFill>
+              <a:srgbClr val="3730A3"/>
+            </a:solidFill>
+          </a:ln>
+          <a:effectLst/>
+        </p:spPr>
+        <p:style>
+          <a:lnRef idx="1">
+            <a:schemeClr val="accent1"/>
+          </a:lnRef>
+          <a:fillRef idx="3">
+            <a:schemeClr val="accent1"/>
+          </a:fillRef>
+          <a:effectRef idx="2">
+            <a:schemeClr val="accent1"/>
+          </a:effectRef>
+          <a:fontRef idx="minor">
+            <a:schemeClr val="lt1"/>
+          </a:fontRef>
+        </p:style>
+        <p:txBody>
+          <a:bodyPr rtlCol="0" anchor="ctr"/>
+          <a:lstStyle/>
+          <a:p>
+            <a:pPr algn="ctr"/>
+          </a:p>
+        </p:txBody>
+      </p:sp>
+      <p:sp>
+        <p:nvSpPr>
+          <p:cNvPr id="15" name="Rectangle 14"/>
+          <p:cNvSpPr/>
+          <p:nvPr/>
+        </p:nvSpPr>
+        <p:spPr>
+          <a:xfrm>
+            <a:off x="4805172" y="1810512"/>
+            <a:ext cx="54864" cy="292608"/>
+          </a:xfrm>
+          <a:prstGeom prst="rect">
+            <a:avLst/>
+          </a:prstGeom>
+          <a:solidFill>
+            <a:srgbClr val="3730A3"/>
+          </a:solidFill>
+          <a:ln>
+            <a:noFill/>
+          </a:ln>
+          <a:effectLst/>
+        </p:spPr>
+        <p:style>
+          <a:lnRef idx="1">
+            <a:schemeClr val="accent1"/>
+          </a:lnRef>
+          <a:fillRef idx="3">
+            <a:schemeClr val="accent1"/>
+          </a:fillRef>
+          <a:effectRef idx="2">
+            <a:schemeClr val="accent1"/>
+          </a:effectRef>
+          <a:fontRef idx="minor">
+            <a:schemeClr val="lt1"/>
+          </a:fontRef>
+        </p:style>
+        <p:txBody>
+          <a:bodyPr rtlCol="0" anchor="ctr"/>
+          <a:lstStyle/>
+          <a:p>
+            <a:pPr algn="ctr"/>
+          </a:p>
+        </p:txBody>
+      </p:sp>
+      <p:sp>
+        <p:nvSpPr>
+          <p:cNvPr id="16" name="Rounded Rectangle 15"/>
+          <p:cNvSpPr/>
+          <p:nvPr/>
+        </p:nvSpPr>
+        <p:spPr>
+          <a:xfrm>
+            <a:off x="4860036" y="1810512"/>
+            <a:ext cx="3717036" cy="292608"/>
+          </a:xfrm>
+          <a:prstGeom prst="roundRect">
+            <a:avLst>
+              <a:gd name="adj" fmla="val 4000"/>
+            </a:avLst>
+          </a:prstGeom>
+          <a:solidFill>
+            <a:srgbClr val="F8FAFC"/>
+          </a:solidFill>
           <a:ln w="9525">
             <a:solidFill>
               <a:srgbClr val="E2E8F0"/>
@@ -27653,14 +28736,60 @@
       </p:sp>
       <p:sp>
         <p:nvSpPr>
-          <p:cNvPr id="11" name="TextBox 10"/>
+          <p:cNvPr id="17" name="Rectangle 16"/>
+          <p:cNvSpPr/>
+          <p:nvPr/>
+        </p:nvSpPr>
+        <p:spPr>
+          <a:xfrm>
+            <a:off x="4914900" y="1865376"/>
+            <a:ext cx="3552444" cy="201168"/>
+          </a:xfrm>
+          <a:prstGeom prst="rect">
+            <a:avLst/>
+          </a:prstGeom>
+          <a:solidFill>
+            <a:srgbClr val="FFFFFF"/>
+          </a:solidFill>
+          <a:ln w="6350">
+            <a:solidFill>
+              <a:srgbClr val="E2E8F0"/>
+            </a:solidFill>
+          </a:ln>
+          <a:effectLst/>
+        </p:spPr>
+        <p:style>
+          <a:lnRef idx="1">
+            <a:schemeClr val="accent1"/>
+          </a:lnRef>
+          <a:fillRef idx="3">
+            <a:schemeClr val="accent1"/>
+          </a:fillRef>
+          <a:effectRef idx="2">
+            <a:schemeClr val="accent1"/>
+          </a:effectRef>
+          <a:fontRef idx="minor">
+            <a:schemeClr val="lt1"/>
+          </a:fontRef>
+        </p:style>
+        <p:txBody>
+          <a:bodyPr rtlCol="0" anchor="ctr"/>
+          <a:lstStyle/>
+          <a:p>
+            <a:pPr algn="ctr"/>
+          </a:p>
+        </p:txBody>
+      </p:sp>
+      <p:sp>
+        <p:nvSpPr>
+          <p:cNvPr id="18" name="TextBox 17"/>
           <p:cNvSpPr txBox="1"/>
           <p:nvPr/>
         </p:nvSpPr>
         <p:spPr>
           <a:xfrm>
-            <a:off x="621792" y="1810512"/>
-            <a:ext cx="7955279" cy="320040"/>
+            <a:off x="4969764" y="1892807"/>
+            <a:ext cx="3442716" cy="146304"/>
           </a:xfrm>
           <a:prstGeom prst="rect">
             <a:avLst/>
@@ -27675,33 +28804,127 @@
           <a:p>
             <a:pPr>
               <a:spcAft>
-                <a:spcPts val="400"/>
-              </a:spcAft>
-            </a:pPr>
-            <a:r>
-              <a:rPr sz="1400" b="1" i="0">
+                <a:spcPts val="0"/>
+              </a:spcAft>
+            </a:pPr>
+            <a:r>
+              <a:rPr sz="1200">
                 <a:solidFill>
                   <a:srgbClr val="0F172A"/>
                 </a:solidFill>
-                <a:ea typeface="Sylfaen"/>
-                <a:cs typeface="Sylfaen"/>
-                <a:latin typeface="Sylfaen"/>
-              </a:rPr>
-              <a:t>📋 ინსტრუქცია:</a:t>
-            </a:r>
-          </a:p>
-        </p:txBody>
-      </p:sp>
-      <p:sp>
-        <p:nvSpPr>
-          <p:cNvPr id="12" name="TextBox 11"/>
+                <a:ea typeface="Consolas"/>
+                <a:cs typeface="Consolas"/>
+                <a:latin typeface="Consolas"/>
+              </a:rPr>
+              <a:t>JTBD სავარჯიშო შაბლონი:</a:t>
+            </a:r>
+          </a:p>
+        </p:txBody>
+      </p:sp>
+      <p:sp>
+        <p:nvSpPr>
+          <p:cNvPr id="19" name="Rounded Rectangle 18"/>
+          <p:cNvSpPr/>
+          <p:nvPr/>
+        </p:nvSpPr>
+        <p:spPr>
+          <a:xfrm>
+            <a:off x="4805172" y="2176272"/>
+            <a:ext cx="3771900" cy="2601468"/>
+          </a:xfrm>
+          <a:prstGeom prst="roundRect">
+            <a:avLst>
+              <a:gd name="adj" fmla="val 4000"/>
+            </a:avLst>
+          </a:prstGeom>
+          <a:solidFill>
+            <a:srgbClr val="F8FAFC"/>
+          </a:solidFill>
+          <a:ln w="9525">
+            <a:solidFill>
+              <a:srgbClr val="E2E8F0"/>
+            </a:solidFill>
+          </a:ln>
+          <a:effectLst/>
+        </p:spPr>
+        <p:style>
+          <a:lnRef idx="1">
+            <a:schemeClr val="accent1"/>
+          </a:lnRef>
+          <a:fillRef idx="3">
+            <a:schemeClr val="accent1"/>
+          </a:fillRef>
+          <a:effectRef idx="2">
+            <a:schemeClr val="accent1"/>
+          </a:effectRef>
+          <a:fontRef idx="minor">
+            <a:schemeClr val="lt1"/>
+          </a:fontRef>
+        </p:style>
+        <p:txBody>
+          <a:bodyPr rtlCol="0" anchor="ctr"/>
+          <a:lstStyle/>
+          <a:p>
+            <a:pPr algn="ctr"/>
+          </a:p>
+        </p:txBody>
+      </p:sp>
+      <p:sp>
+        <p:nvSpPr>
+          <p:cNvPr id="20" name="Rectangle 19"/>
+          <p:cNvSpPr/>
+          <p:nvPr/>
+        </p:nvSpPr>
+        <p:spPr>
+          <a:xfrm>
+            <a:off x="4860036" y="2221991"/>
+            <a:ext cx="3662172" cy="2510027"/>
+          </a:xfrm>
+          <a:prstGeom prst="rect">
+            <a:avLst/>
+          </a:prstGeom>
+          <a:solidFill>
+            <a:srgbClr val="FFFFFF"/>
+          </a:solidFill>
+          <a:ln w="6350">
+            <a:solidFill>
+              <a:srgbClr val="E2E8F0"/>
+            </a:solidFill>
+          </a:ln>
+          <a:effectLst/>
+        </p:spPr>
+        <p:style>
+          <a:lnRef idx="1">
+            <a:schemeClr val="accent1"/>
+          </a:lnRef>
+          <a:fillRef idx="3">
+            <a:schemeClr val="accent1"/>
+          </a:fillRef>
+          <a:effectRef idx="2">
+            <a:schemeClr val="accent1"/>
+          </a:effectRef>
+          <a:fontRef idx="minor">
+            <a:schemeClr val="lt1"/>
+          </a:fontRef>
+        </p:style>
+        <p:txBody>
+          <a:bodyPr rtlCol="0" anchor="ctr"/>
+          <a:lstStyle/>
+          <a:p>
+            <a:pPr algn="ctr"/>
+          </a:p>
+        </p:txBody>
+      </p:sp>
+      <p:sp>
+        <p:nvSpPr>
+          <p:cNvPr id="21" name="TextBox 20"/>
           <p:cNvSpPr txBox="1"/>
           <p:nvPr/>
         </p:nvSpPr>
         <p:spPr>
           <a:xfrm>
-            <a:off x="621792" y="2203704"/>
-            <a:ext cx="7955279" cy="1993392"/>
+            <a:off x="4914900" y="2240279"/>
+            <a:ext cx="3552444" cy="2473451"/>
           </a:xfrm>
           <a:prstGeom prst="rect">
             <a:avLst/>
@@ -27714,97 +28937,370 @@
           </a:bodyPr>
           <a:lstStyle/>
           <a:p>
-            <a:pPr algn="l">
-              <a:spcAft>
-                <a:spcPts val="300"/>
-              </a:spcAft>
-            </a:pPr>
-            <a:r>
-              <a:rPr sz="1300" b="1">
-                <a:solidFill>
-                  <a:srgbClr val="3730A3"/>
-                </a:solidFill>
-                <a:ea typeface="Sylfaen"/>
-                <a:cs typeface="Sylfaen"/>
-                <a:latin typeface="Sylfaen"/>
-              </a:rPr>
-              <a:t>▸  </a:t>
-            </a:r>
-            <a:r>
-              <a:rPr sz="1300">
+            <a:pPr>
+              <a:spcAft>
+                <a:spcPts val="0"/>
+              </a:spcAft>
+            </a:pPr>
+            <a:r>
+              <a:rPr sz="1000">
                 <a:solidFill>
                   <a:srgbClr val="0F172A"/>
                 </a:solidFill>
-                <a:ea typeface="Sylfaen"/>
-                <a:cs typeface="Sylfaen"/>
-                <a:latin typeface="Sylfaen"/>
-              </a:rPr>
-              <a:t>გახსენით Claude ან ChatGPT ;</a:t>
-            </a:r>
-          </a:p>
-          <a:p>
-            <a:pPr algn="l">
-              <a:spcAft>
-                <a:spcPts val="300"/>
-              </a:spcAft>
-            </a:pPr>
-            <a:r>
-              <a:rPr sz="1300" b="1">
-                <a:solidFill>
-                  <a:srgbClr val="3730A3"/>
-                </a:solidFill>
-                <a:ea typeface="Sylfaen"/>
-                <a:cs typeface="Sylfaen"/>
-                <a:latin typeface="Sylfaen"/>
-              </a:rPr>
-              <a:t>▸  </a:t>
-            </a:r>
-            <a:r>
-              <a:rPr sz="1300">
+                <a:ea typeface="Consolas"/>
+                <a:cs typeface="Consolas"/>
+                <a:latin typeface="Consolas"/>
+              </a:rPr>
+              <a:t>მე ვავითარებ სტარტაპს:</a:t>
+            </a:r>
+          </a:p>
+          <a:p>
+            <a:pPr>
+              <a:spcAft>
+                <a:spcPts val="0"/>
+              </a:spcAft>
+            </a:pPr>
+            <a:r>
+              <a:rPr sz="1000">
                 <a:solidFill>
                   <a:srgbClr val="0F172A"/>
                 </a:solidFill>
-                <a:ea typeface="Sylfaen"/>
-                <a:cs typeface="Sylfaen"/>
-                <a:latin typeface="Sylfaen"/>
-              </a:rPr>
-              <a:t>დაწერეთ თქვენი სტარტაპის JTBD ფორმულა: „როდესაც [სიტუაცია], მინდა [აქტივობა], რათა [სასურველი შედეგი]“ ;</a:t>
-            </a:r>
-          </a:p>
-          <a:p>
-            <a:pPr algn="l">
-              <a:spcAft>
-                <a:spcPts val="300"/>
-              </a:spcAft>
-            </a:pPr>
-            <a:r>
-              <a:rPr sz="1300" b="1">
-                <a:solidFill>
-                  <a:srgbClr val="3730A3"/>
-                </a:solidFill>
-                <a:ea typeface="Sylfaen"/>
-                <a:cs typeface="Sylfaen"/>
-                <a:latin typeface="Sylfaen"/>
-              </a:rPr>
-              <a:t>▸  </a:t>
-            </a:r>
-            <a:r>
-              <a:rPr sz="1300">
+                <a:ea typeface="Consolas"/>
+                <a:cs typeface="Consolas"/>
+                <a:latin typeface="Consolas"/>
+              </a:rPr>
+              <a:t>[მაგ: პლატფორმა ძაღლის</a:t>
+            </a:r>
+          </a:p>
+          <a:p>
+            <a:pPr>
+              <a:spcAft>
+                <a:spcPts val="0"/>
+              </a:spcAft>
+            </a:pPr>
+            <a:r>
+              <a:rPr sz="1000">
                 <a:solidFill>
                   <a:srgbClr val="0F172A"/>
                 </a:solidFill>
-                <a:ea typeface="Sylfaen"/>
-                <a:cs typeface="Sylfaen"/>
-                <a:latin typeface="Sylfaen"/>
-              </a:rPr>
-              <a:t>სთხოვეთ AI-ს, გაუკეთოს კრიტიკა ამ ფორმულას და შემოგთავაზოთ 2 უფრო ზუსტი და სპეციფიკური ალტერნატივა.</a:t>
-            </a:r>
-          </a:p>
-        </p:txBody>
-      </p:sp>
-      <p:sp>
-        <p:nvSpPr>
-          <p:cNvPr id="13" name="Rectangle 12"/>
+                <a:ea typeface="Consolas"/>
+                <a:cs typeface="Consolas"/>
+                <a:latin typeface="Consolas"/>
+              </a:rPr>
+              <a:t>მომვლელების საპოვნელად].</a:t>
+            </a:r>
+          </a:p>
+          <a:p>
+            <a:pPr>
+              <a:spcAft>
+                <a:spcPts val="0"/>
+              </a:spcAft>
+            </a:pPr>
+            <a:r>
+              <a:rPr sz="1000">
+                <a:solidFill>
+                  <a:srgbClr val="0F172A"/>
+                </a:solidFill>
+                <a:ea typeface="Consolas"/>
+                <a:cs typeface="Consolas"/>
+                <a:latin typeface="Consolas"/>
+              </a:rPr>
+              <a:t>ჩემი მომხმარებლისთვის</a:t>
+            </a:r>
+          </a:p>
+          <a:p>
+            <a:pPr>
+              <a:spcAft>
+                <a:spcPts val="0"/>
+              </a:spcAft>
+            </a:pPr>
+            <a:r>
+              <a:rPr sz="1000">
+                <a:solidFill>
+                  <a:srgbClr val="0F172A"/>
+                </a:solidFill>
+                <a:ea typeface="Consolas"/>
+                <a:cs typeface="Consolas"/>
+                <a:latin typeface="Consolas"/>
+              </a:rPr>
+              <a:t>ჩამოვაყალიბე შემდეგი JTBD</a:t>
+            </a:r>
+          </a:p>
+          <a:p>
+            <a:pPr>
+              <a:spcAft>
+                <a:spcPts val="0"/>
+              </a:spcAft>
+            </a:pPr>
+            <a:r>
+              <a:rPr sz="1000">
+                <a:solidFill>
+                  <a:srgbClr val="0F172A"/>
+                </a:solidFill>
+                <a:ea typeface="Consolas"/>
+                <a:cs typeface="Consolas"/>
+                <a:latin typeface="Consolas"/>
+              </a:rPr>
+              <a:t>განაცხადი:</a:t>
+            </a:r>
+          </a:p>
+          <a:p>
+            <a:pPr>
+              <a:spcAft>
+                <a:spcPts val="0"/>
+              </a:spcAft>
+            </a:pPr>
+            <a:r>
+              <a:rPr sz="1000">
+                <a:solidFill>
+                  <a:srgbClr val="0F172A"/>
+                </a:solidFill>
+                <a:ea typeface="Consolas"/>
+                <a:cs typeface="Consolas"/>
+                <a:latin typeface="Consolas"/>
+              </a:rPr>
+              <a:t>„როდესაც მივდივარ</a:t>
+            </a:r>
+          </a:p>
+          <a:p>
+            <a:pPr>
+              <a:spcAft>
+                <a:spcPts val="0"/>
+              </a:spcAft>
+            </a:pPr>
+            <a:r>
+              <a:rPr sz="1000">
+                <a:solidFill>
+                  <a:srgbClr val="0F172A"/>
+                </a:solidFill>
+                <a:ea typeface="Consolas"/>
+                <a:cs typeface="Consolas"/>
+                <a:latin typeface="Consolas"/>
+              </a:rPr>
+              <a:t>მივლინებაში და სახლში</a:t>
+            </a:r>
+          </a:p>
+          <a:p>
+            <a:pPr>
+              <a:spcAft>
+                <a:spcPts val="0"/>
+              </a:spcAft>
+            </a:pPr>
+            <a:r>
+              <a:rPr sz="1000">
+                <a:solidFill>
+                  <a:srgbClr val="0F172A"/>
+                </a:solidFill>
+                <a:ea typeface="Consolas"/>
+                <a:cs typeface="Consolas"/>
+                <a:latin typeface="Consolas"/>
+              </a:rPr>
+              <a:t>მრჩება ძაღლი, მინდა ვიპოვო</a:t>
+            </a:r>
+          </a:p>
+          <a:p>
+            <a:pPr>
+              <a:spcAft>
+                <a:spcPts val="0"/>
+              </a:spcAft>
+            </a:pPr>
+            <a:r>
+              <a:rPr sz="1000">
+                <a:solidFill>
+                  <a:srgbClr val="0F172A"/>
+                </a:solidFill>
+                <a:ea typeface="Consolas"/>
+                <a:cs typeface="Consolas"/>
+                <a:latin typeface="Consolas"/>
+              </a:rPr>
+              <a:t>სანდო ადამიანი, რომელიც</a:t>
+            </a:r>
+          </a:p>
+          <a:p>
+            <a:pPr>
+              <a:spcAft>
+                <a:spcPts val="0"/>
+              </a:spcAft>
+            </a:pPr>
+            <a:r>
+              <a:rPr sz="1000">
+                <a:solidFill>
+                  <a:srgbClr val="0F172A"/>
+                </a:solidFill>
+                <a:ea typeface="Consolas"/>
+                <a:cs typeface="Consolas"/>
+                <a:latin typeface="Consolas"/>
+              </a:rPr>
+              <a:t>ჩემს ძაღლს მიხედავს, რათა</a:t>
+            </a:r>
+          </a:p>
+          <a:p>
+            <a:pPr>
+              <a:spcAft>
+                <a:spcPts val="0"/>
+              </a:spcAft>
+            </a:pPr>
+            <a:r>
+              <a:rPr sz="1000">
+                <a:solidFill>
+                  <a:srgbClr val="0F172A"/>
+                </a:solidFill>
+                <a:ea typeface="Consolas"/>
+                <a:cs typeface="Consolas"/>
+                <a:latin typeface="Consolas"/>
+              </a:rPr>
+              <a:t>მშვიდად ვიყო.“</a:t>
+            </a:r>
+          </a:p>
+          <a:p>
+            <a:pPr>
+              <a:spcAft>
+                <a:spcPts val="0"/>
+              </a:spcAft>
+            </a:pPr>
+            <a:r>
+              <a:rPr sz="1000">
+                <a:solidFill>
+                  <a:srgbClr val="0F172A"/>
+                </a:solidFill>
+                <a:ea typeface="Consolas"/>
+                <a:cs typeface="Consolas"/>
+                <a:latin typeface="Consolas"/>
+              </a:rPr>
+              <a:t>გააანალიზე ეს ფორმულირება:</a:t>
+            </a:r>
+          </a:p>
+          <a:p>
+            <a:pPr>
+              <a:spcAft>
+                <a:spcPts val="0"/>
+              </a:spcAft>
+            </a:pPr>
+            <a:r>
+              <a:rPr sz="1000">
+                <a:solidFill>
+                  <a:srgbClr val="0F172A"/>
+                </a:solidFill>
+                <a:ea typeface="Consolas"/>
+                <a:cs typeface="Consolas"/>
+                <a:latin typeface="Consolas"/>
+              </a:rPr>
+              <a:t>1. რამდენად ზუსტად</a:t>
+            </a:r>
+          </a:p>
+          <a:p>
+            <a:pPr>
+              <a:spcAft>
+                <a:spcPts val="0"/>
+              </a:spcAft>
+            </a:pPr>
+            <a:r>
+              <a:rPr sz="1000">
+                <a:solidFill>
+                  <a:srgbClr val="0F172A"/>
+                </a:solidFill>
+                <a:ea typeface="Consolas"/>
+                <a:cs typeface="Consolas"/>
+                <a:latin typeface="Consolas"/>
+              </a:rPr>
+              <a:t>გადმოსცემს ის მომხმარებლის</a:t>
+            </a:r>
+          </a:p>
+          <a:p>
+            <a:pPr>
+              <a:spcAft>
+                <a:spcPts val="0"/>
+              </a:spcAft>
+            </a:pPr>
+            <a:r>
+              <a:rPr sz="1000">
+                <a:solidFill>
+                  <a:srgbClr val="0F172A"/>
+                </a:solidFill>
+                <a:ea typeface="Consolas"/>
+                <a:cs typeface="Consolas"/>
+                <a:latin typeface="Consolas"/>
+              </a:rPr>
+              <a:t>რეალურ ამოცანას, სიტუაციას</a:t>
+            </a:r>
+          </a:p>
+          <a:p>
+            <a:pPr>
+              <a:spcAft>
+                <a:spcPts val="0"/>
+              </a:spcAft>
+            </a:pPr>
+            <a:r>
+              <a:rPr sz="1000">
+                <a:solidFill>
+                  <a:srgbClr val="0F172A"/>
+                </a:solidFill>
+                <a:ea typeface="Consolas"/>
+                <a:cs typeface="Consolas"/>
+                <a:latin typeface="Consolas"/>
+              </a:rPr>
+              <a:t>და ემოციურ მოტივაციას?</a:t>
+            </a:r>
+          </a:p>
+          <a:p>
+            <a:pPr>
+              <a:spcAft>
+                <a:spcPts val="0"/>
+              </a:spcAft>
+            </a:pPr>
+            <a:r>
+              <a:rPr sz="1000">
+                <a:solidFill>
+                  <a:srgbClr val="0F172A"/>
+                </a:solidFill>
+                <a:ea typeface="Consolas"/>
+                <a:cs typeface="Consolas"/>
+                <a:latin typeface="Consolas"/>
+              </a:rPr>
+              <a:t>2. შემომთავაზე 2 უფრო</a:t>
+            </a:r>
+          </a:p>
+          <a:p>
+            <a:pPr>
+              <a:spcAft>
+                <a:spcPts val="0"/>
+              </a:spcAft>
+            </a:pPr>
+            <a:r>
+              <a:rPr sz="1000">
+                <a:solidFill>
+                  <a:srgbClr val="0F172A"/>
+                </a:solidFill>
+                <a:ea typeface="Consolas"/>
+                <a:cs typeface="Consolas"/>
+                <a:latin typeface="Consolas"/>
+              </a:rPr>
+              <a:t>გაუმჯობესებული JTBD</a:t>
+            </a:r>
+          </a:p>
+          <a:p>
+            <a:pPr>
+              <a:spcAft>
+                <a:spcPts val="0"/>
+              </a:spcAft>
+            </a:pPr>
+            <a:r>
+              <a:rPr sz="1000">
+                <a:solidFill>
+                  <a:srgbClr val="0F172A"/>
+                </a:solidFill>
+                <a:ea typeface="Consolas"/>
+                <a:cs typeface="Consolas"/>
+                <a:latin typeface="Consolas"/>
+              </a:rPr>
+              <a:t>ალტერნატივა.</a:t>
+            </a:r>
+          </a:p>
+        </p:txBody>
+      </p:sp>
+      <p:sp>
+        <p:nvSpPr>
+          <p:cNvPr id="22" name="Rectangle 21"/>
           <p:cNvSpPr/>
           <p:nvPr/>
         </p:nvSpPr>
@@ -27848,7 +29344,7 @@
       </p:sp>
       <p:sp>
         <p:nvSpPr>
-          <p:cNvPr id="14" name="TextBox 13"/>
+          <p:cNvPr id="23" name="TextBox 22"/>
           <p:cNvSpPr txBox="1"/>
           <p:nvPr/>
         </p:nvSpPr>
@@ -31823,7 +33319,7 @@
         <p:spPr>
           <a:xfrm>
             <a:off x="457200" y="1737360"/>
-            <a:ext cx="54864" cy="2862072"/>
+            <a:ext cx="54864" cy="3113532"/>
           </a:xfrm>
           <a:prstGeom prst="rect">
             <a:avLst/>
@@ -31867,7 +33363,7 @@
         <p:spPr>
           <a:xfrm>
             <a:off x="512064" y="1737360"/>
-            <a:ext cx="8174736" cy="2862072"/>
+            <a:ext cx="3991356" cy="3113532"/>
           </a:xfrm>
           <a:prstGeom prst="roundRect">
             <a:avLst>
@@ -31877,6 +33373,341 @@
           <a:solidFill>
             <a:srgbClr val="F8FAFC"/>
           </a:solidFill>
+          <a:ln w="6350">
+            <a:solidFill>
+              <a:srgbClr val="E2E8F0"/>
+            </a:solidFill>
+          </a:ln>
+          <a:effectLst/>
+        </p:spPr>
+        <p:style>
+          <a:lnRef idx="1">
+            <a:schemeClr val="accent1"/>
+          </a:lnRef>
+          <a:fillRef idx="3">
+            <a:schemeClr val="accent1"/>
+          </a:fillRef>
+          <a:effectRef idx="2">
+            <a:schemeClr val="accent1"/>
+          </a:effectRef>
+          <a:fontRef idx="minor">
+            <a:schemeClr val="lt1"/>
+          </a:fontRef>
+        </p:style>
+        <p:txBody>
+          <a:bodyPr rtlCol="0" anchor="ctr"/>
+          <a:lstStyle/>
+          <a:p>
+            <a:pPr algn="ctr"/>
+          </a:p>
+        </p:txBody>
+      </p:sp>
+      <p:sp>
+        <p:nvSpPr>
+          <p:cNvPr id="11" name="TextBox 10"/>
+          <p:cNvSpPr txBox="1"/>
+          <p:nvPr/>
+        </p:nvSpPr>
+        <p:spPr>
+          <a:xfrm>
+            <a:off x="621792" y="1810512"/>
+            <a:ext cx="3771900" cy="320040"/>
+          </a:xfrm>
+          <a:prstGeom prst="rect">
+            <a:avLst/>
+          </a:prstGeom>
+          <a:noFill/>
+        </p:spPr>
+        <p:txBody>
+          <a:bodyPr wrap="square" anchor="t" lIns="54864" rIns="54864" tIns="54864" bIns="54864">
+            <a:spAutoFit/>
+          </a:bodyPr>
+          <a:lstStyle/>
+          <a:p>
+            <a:pPr>
+              <a:spcAft>
+                <a:spcPts val="400"/>
+              </a:spcAft>
+            </a:pPr>
+            <a:r>
+              <a:rPr sz="1400" b="1" i="0">
+                <a:solidFill>
+                  <a:srgbClr val="0F172A"/>
+                </a:solidFill>
+                <a:ea typeface="Sylfaen"/>
+                <a:cs typeface="Sylfaen"/>
+                <a:latin typeface="Sylfaen"/>
+              </a:rPr>
+              <a:t>📋 ინსტრუქცია:</a:t>
+            </a:r>
+          </a:p>
+        </p:txBody>
+      </p:sp>
+      <p:sp>
+        <p:nvSpPr>
+          <p:cNvPr id="12" name="TextBox 11"/>
+          <p:cNvSpPr txBox="1"/>
+          <p:nvPr/>
+        </p:nvSpPr>
+        <p:spPr>
+          <a:xfrm>
+            <a:off x="621792" y="2203704"/>
+            <a:ext cx="3771900" cy="2574035"/>
+          </a:xfrm>
+          <a:prstGeom prst="rect">
+            <a:avLst/>
+          </a:prstGeom>
+          <a:noFill/>
+        </p:spPr>
+        <p:txBody>
+          <a:bodyPr wrap="square" anchor="t" lIns="54864" rIns="54864" tIns="54864" bIns="54864">
+            <a:spAutoFit/>
+          </a:bodyPr>
+          <a:lstStyle/>
+          <a:p>
+            <a:pPr algn="l">
+              <a:spcAft>
+                <a:spcPts val="300"/>
+              </a:spcAft>
+            </a:pPr>
+            <a:r>
+              <a:rPr sz="1300" b="1">
+                <a:solidFill>
+                  <a:srgbClr val="3730A3"/>
+                </a:solidFill>
+                <a:ea typeface="Sylfaen"/>
+                <a:cs typeface="Sylfaen"/>
+                <a:latin typeface="Sylfaen"/>
+              </a:rPr>
+              <a:t>▸  </a:t>
+            </a:r>
+            <a:r>
+              <a:rPr sz="1300">
+                <a:solidFill>
+                  <a:srgbClr val="0F172A"/>
+                </a:solidFill>
+                <a:ea typeface="Sylfaen"/>
+                <a:cs typeface="Sylfaen"/>
+                <a:latin typeface="Sylfaen"/>
+              </a:rPr>
+              <a:t>გახსენით Claude ან ChatGPT ;</a:t>
+            </a:r>
+          </a:p>
+          <a:p>
+            <a:pPr algn="l">
+              <a:spcAft>
+                <a:spcPts val="300"/>
+              </a:spcAft>
+            </a:pPr>
+            <a:r>
+              <a:rPr sz="1300" b="1">
+                <a:solidFill>
+                  <a:srgbClr val="3730A3"/>
+                </a:solidFill>
+                <a:ea typeface="Sylfaen"/>
+                <a:cs typeface="Sylfaen"/>
+                <a:latin typeface="Sylfaen"/>
+              </a:rPr>
+              <a:t>▸  </a:t>
+            </a:r>
+            <a:r>
+              <a:rPr sz="1300">
+                <a:solidFill>
+                  <a:srgbClr val="0F172A"/>
+                </a:solidFill>
+                <a:ea typeface="Sylfaen"/>
+                <a:cs typeface="Sylfaen"/>
+                <a:latin typeface="Sylfaen"/>
+              </a:rPr>
+              <a:t>სთხოვეთ AI-ს: „მოირგე [თქვენი ICP პროფილის] როლი. მე დაგისვამ კითხვებს ჩემი სტარტაპის ვალიდაციისთვის. ილაპარაკე მოკლედ და ნუ იქნები ზედმეტად დამყოლი.“ ;</a:t>
+            </a:r>
+          </a:p>
+          <a:p>
+            <a:pPr algn="l">
+              <a:spcAft>
+                <a:spcPts val="300"/>
+              </a:spcAft>
+            </a:pPr>
+            <a:r>
+              <a:rPr sz="1300" b="1">
+                <a:solidFill>
+                  <a:srgbClr val="3730A3"/>
+                </a:solidFill>
+                <a:ea typeface="Sylfaen"/>
+                <a:cs typeface="Sylfaen"/>
+                <a:latin typeface="Sylfaen"/>
+              </a:rPr>
+              <a:t>▸  </a:t>
+            </a:r>
+            <a:r>
+              <a:rPr sz="1300">
+                <a:solidFill>
+                  <a:srgbClr val="0F172A"/>
+                </a:solidFill>
+                <a:ea typeface="Sylfaen"/>
+                <a:cs typeface="Sylfaen"/>
+                <a:latin typeface="Sylfaen"/>
+              </a:rPr>
+              <a:t>დაუსვით 3 კითხვა The Mom Test-ის წესების (წარსული გამოცდილების შესახებ) დაცვით და შეაფასეთ მიღებული პასუხები.</a:t>
+            </a:r>
+          </a:p>
+        </p:txBody>
+      </p:sp>
+      <p:sp>
+        <p:nvSpPr>
+          <p:cNvPr id="13" name="Rectangle 12"/>
+          <p:cNvSpPr/>
+          <p:nvPr/>
+        </p:nvSpPr>
+        <p:spPr>
+          <a:xfrm>
+            <a:off x="4640580" y="1737360"/>
+            <a:ext cx="54864" cy="3113532"/>
+          </a:xfrm>
+          <a:prstGeom prst="rect">
+            <a:avLst/>
+          </a:prstGeom>
+          <a:solidFill>
+            <a:srgbClr val="3730A3"/>
+          </a:solidFill>
+          <a:ln>
+            <a:noFill/>
+          </a:ln>
+          <a:effectLst/>
+        </p:spPr>
+        <p:style>
+          <a:lnRef idx="1">
+            <a:schemeClr val="accent1"/>
+          </a:lnRef>
+          <a:fillRef idx="3">
+            <a:schemeClr val="accent1"/>
+          </a:fillRef>
+          <a:effectRef idx="2">
+            <a:schemeClr val="accent1"/>
+          </a:effectRef>
+          <a:fontRef idx="minor">
+            <a:schemeClr val="lt1"/>
+          </a:fontRef>
+        </p:style>
+        <p:txBody>
+          <a:bodyPr rtlCol="0" anchor="ctr"/>
+          <a:lstStyle/>
+          <a:p>
+            <a:pPr algn="ctr"/>
+          </a:p>
+        </p:txBody>
+      </p:sp>
+      <p:sp>
+        <p:nvSpPr>
+          <p:cNvPr id="14" name="Rounded Rectangle 13"/>
+          <p:cNvSpPr/>
+          <p:nvPr/>
+        </p:nvSpPr>
+        <p:spPr>
+          <a:xfrm>
+            <a:off x="4695444" y="1737360"/>
+            <a:ext cx="3991356" cy="3113532"/>
+          </a:xfrm>
+          <a:prstGeom prst="roundRect">
+            <a:avLst>
+              <a:gd name="adj" fmla="val 4000"/>
+            </a:avLst>
+          </a:prstGeom>
+          <a:solidFill>
+            <a:srgbClr val="F8FAFC"/>
+          </a:solidFill>
+          <a:ln w="6350">
+            <a:solidFill>
+              <a:srgbClr val="3730A3"/>
+            </a:solidFill>
+          </a:ln>
+          <a:effectLst/>
+        </p:spPr>
+        <p:style>
+          <a:lnRef idx="1">
+            <a:schemeClr val="accent1"/>
+          </a:lnRef>
+          <a:fillRef idx="3">
+            <a:schemeClr val="accent1"/>
+          </a:fillRef>
+          <a:effectRef idx="2">
+            <a:schemeClr val="accent1"/>
+          </a:effectRef>
+          <a:fontRef idx="minor">
+            <a:schemeClr val="lt1"/>
+          </a:fontRef>
+        </p:style>
+        <p:txBody>
+          <a:bodyPr rtlCol="0" anchor="ctr"/>
+          <a:lstStyle/>
+          <a:p>
+            <a:pPr algn="ctr"/>
+          </a:p>
+        </p:txBody>
+      </p:sp>
+      <p:sp>
+        <p:nvSpPr>
+          <p:cNvPr id="15" name="Rectangle 14"/>
+          <p:cNvSpPr/>
+          <p:nvPr/>
+        </p:nvSpPr>
+        <p:spPr>
+          <a:xfrm>
+            <a:off x="4805172" y="1810512"/>
+            <a:ext cx="54864" cy="292608"/>
+          </a:xfrm>
+          <a:prstGeom prst="rect">
+            <a:avLst/>
+          </a:prstGeom>
+          <a:solidFill>
+            <a:srgbClr val="3730A3"/>
+          </a:solidFill>
+          <a:ln>
+            <a:noFill/>
+          </a:ln>
+          <a:effectLst/>
+        </p:spPr>
+        <p:style>
+          <a:lnRef idx="1">
+            <a:schemeClr val="accent1"/>
+          </a:lnRef>
+          <a:fillRef idx="3">
+            <a:schemeClr val="accent1"/>
+          </a:fillRef>
+          <a:effectRef idx="2">
+            <a:schemeClr val="accent1"/>
+          </a:effectRef>
+          <a:fontRef idx="minor">
+            <a:schemeClr val="lt1"/>
+          </a:fontRef>
+        </p:style>
+        <p:txBody>
+          <a:bodyPr rtlCol="0" anchor="ctr"/>
+          <a:lstStyle/>
+          <a:p>
+            <a:pPr algn="ctr"/>
+          </a:p>
+        </p:txBody>
+      </p:sp>
+      <p:sp>
+        <p:nvSpPr>
+          <p:cNvPr id="16" name="Rounded Rectangle 15"/>
+          <p:cNvSpPr/>
+          <p:nvPr/>
+        </p:nvSpPr>
+        <p:spPr>
+          <a:xfrm>
+            <a:off x="4860036" y="1810512"/>
+            <a:ext cx="3717036" cy="292608"/>
+          </a:xfrm>
+          <a:prstGeom prst="roundRect">
+            <a:avLst>
+              <a:gd name="adj" fmla="val 4000"/>
+            </a:avLst>
+          </a:prstGeom>
+          <a:solidFill>
+            <a:srgbClr val="F8FAFC"/>
+          </a:solidFill>
           <a:ln w="9525">
             <a:solidFill>
               <a:srgbClr val="E2E8F0"/>
@@ -31908,14 +33739,60 @@
       </p:sp>
       <p:sp>
         <p:nvSpPr>
-          <p:cNvPr id="11" name="TextBox 10"/>
+          <p:cNvPr id="17" name="Rectangle 16"/>
+          <p:cNvSpPr/>
+          <p:nvPr/>
+        </p:nvSpPr>
+        <p:spPr>
+          <a:xfrm>
+            <a:off x="4914900" y="1865376"/>
+            <a:ext cx="3552444" cy="201168"/>
+          </a:xfrm>
+          <a:prstGeom prst="rect">
+            <a:avLst/>
+          </a:prstGeom>
+          <a:solidFill>
+            <a:srgbClr val="FFFFFF"/>
+          </a:solidFill>
+          <a:ln w="6350">
+            <a:solidFill>
+              <a:srgbClr val="E2E8F0"/>
+            </a:solidFill>
+          </a:ln>
+          <a:effectLst/>
+        </p:spPr>
+        <p:style>
+          <a:lnRef idx="1">
+            <a:schemeClr val="accent1"/>
+          </a:lnRef>
+          <a:fillRef idx="3">
+            <a:schemeClr val="accent1"/>
+          </a:fillRef>
+          <a:effectRef idx="2">
+            <a:schemeClr val="accent1"/>
+          </a:effectRef>
+          <a:fontRef idx="minor">
+            <a:schemeClr val="lt1"/>
+          </a:fontRef>
+        </p:style>
+        <p:txBody>
+          <a:bodyPr rtlCol="0" anchor="ctr"/>
+          <a:lstStyle/>
+          <a:p>
+            <a:pPr algn="ctr"/>
+          </a:p>
+        </p:txBody>
+      </p:sp>
+      <p:sp>
+        <p:nvSpPr>
+          <p:cNvPr id="18" name="TextBox 17"/>
           <p:cNvSpPr txBox="1"/>
           <p:nvPr/>
         </p:nvSpPr>
         <p:spPr>
           <a:xfrm>
-            <a:off x="621792" y="1810512"/>
-            <a:ext cx="7955279" cy="320040"/>
+            <a:off x="4969764" y="1892807"/>
+            <a:ext cx="3442716" cy="146304"/>
           </a:xfrm>
           <a:prstGeom prst="rect">
             <a:avLst/>
@@ -31930,33 +33807,145 @@
           <a:p>
             <a:pPr>
               <a:spcAft>
-                <a:spcPts val="400"/>
-              </a:spcAft>
-            </a:pPr>
-            <a:r>
-              <a:rPr sz="1400" b="1" i="0">
+                <a:spcPts val="0"/>
+              </a:spcAft>
+            </a:pPr>
+            <a:r>
+              <a:rPr sz="800">
                 <a:solidFill>
                   <a:srgbClr val="0F172A"/>
                 </a:solidFill>
-                <a:ea typeface="Sylfaen"/>
-                <a:cs typeface="Sylfaen"/>
-                <a:latin typeface="Sylfaen"/>
-              </a:rPr>
-              <a:t>📋 ინსტრუქცია:</a:t>
-            </a:r>
-          </a:p>
-        </p:txBody>
-      </p:sp>
-      <p:sp>
-        <p:nvSpPr>
-          <p:cNvPr id="12" name="TextBox 11"/>
+                <a:ea typeface="Consolas"/>
+                <a:cs typeface="Consolas"/>
+                <a:latin typeface="Consolas"/>
+              </a:rPr>
+              <a:t>The Mom Test როლური</a:t>
+            </a:r>
+          </a:p>
+          <a:p>
+            <a:pPr>
+              <a:spcAft>
+                <a:spcPts val="0"/>
+              </a:spcAft>
+            </a:pPr>
+            <a:r>
+              <a:rPr sz="800">
+                <a:solidFill>
+                  <a:srgbClr val="0F172A"/>
+                </a:solidFill>
+                <a:ea typeface="Consolas"/>
+                <a:cs typeface="Consolas"/>
+                <a:latin typeface="Consolas"/>
+              </a:rPr>
+              <a:t>თამაშის პრომპტი:</a:t>
+            </a:r>
+          </a:p>
+        </p:txBody>
+      </p:sp>
+      <p:sp>
+        <p:nvSpPr>
+          <p:cNvPr id="19" name="Rounded Rectangle 18"/>
+          <p:cNvSpPr/>
+          <p:nvPr/>
+        </p:nvSpPr>
+        <p:spPr>
+          <a:xfrm>
+            <a:off x="4805172" y="2176272"/>
+            <a:ext cx="3771900" cy="2601468"/>
+          </a:xfrm>
+          <a:prstGeom prst="roundRect">
+            <a:avLst>
+              <a:gd name="adj" fmla="val 4000"/>
+            </a:avLst>
+          </a:prstGeom>
+          <a:solidFill>
+            <a:srgbClr val="F8FAFC"/>
+          </a:solidFill>
+          <a:ln w="9525">
+            <a:solidFill>
+              <a:srgbClr val="E2E8F0"/>
+            </a:solidFill>
+          </a:ln>
+          <a:effectLst/>
+        </p:spPr>
+        <p:style>
+          <a:lnRef idx="1">
+            <a:schemeClr val="accent1"/>
+          </a:lnRef>
+          <a:fillRef idx="3">
+            <a:schemeClr val="accent1"/>
+          </a:fillRef>
+          <a:effectRef idx="2">
+            <a:schemeClr val="accent1"/>
+          </a:effectRef>
+          <a:fontRef idx="minor">
+            <a:schemeClr val="lt1"/>
+          </a:fontRef>
+        </p:style>
+        <p:txBody>
+          <a:bodyPr rtlCol="0" anchor="ctr"/>
+          <a:lstStyle/>
+          <a:p>
+            <a:pPr algn="ctr"/>
+          </a:p>
+        </p:txBody>
+      </p:sp>
+      <p:sp>
+        <p:nvSpPr>
+          <p:cNvPr id="20" name="Rectangle 19"/>
+          <p:cNvSpPr/>
+          <p:nvPr/>
+        </p:nvSpPr>
+        <p:spPr>
+          <a:xfrm>
+            <a:off x="4860036" y="2221991"/>
+            <a:ext cx="3662172" cy="2510027"/>
+          </a:xfrm>
+          <a:prstGeom prst="rect">
+            <a:avLst/>
+          </a:prstGeom>
+          <a:solidFill>
+            <a:srgbClr val="FFFFFF"/>
+          </a:solidFill>
+          <a:ln w="6350">
+            <a:solidFill>
+              <a:srgbClr val="E2E8F0"/>
+            </a:solidFill>
+          </a:ln>
+          <a:effectLst/>
+        </p:spPr>
+        <p:style>
+          <a:lnRef idx="1">
+            <a:schemeClr val="accent1"/>
+          </a:lnRef>
+          <a:fillRef idx="3">
+            <a:schemeClr val="accent1"/>
+          </a:fillRef>
+          <a:effectRef idx="2">
+            <a:schemeClr val="accent1"/>
+          </a:effectRef>
+          <a:fontRef idx="minor">
+            <a:schemeClr val="lt1"/>
+          </a:fontRef>
+        </p:style>
+        <p:txBody>
+          <a:bodyPr rtlCol="0" anchor="ctr"/>
+          <a:lstStyle/>
+          <a:p>
+            <a:pPr algn="ctr"/>
+          </a:p>
+        </p:txBody>
+      </p:sp>
+      <p:sp>
+        <p:nvSpPr>
+          <p:cNvPr id="21" name="TextBox 20"/>
           <p:cNvSpPr txBox="1"/>
           <p:nvPr/>
         </p:nvSpPr>
         <p:spPr>
           <a:xfrm>
-            <a:off x="621792" y="2203704"/>
-            <a:ext cx="7955279" cy="2267712"/>
+            <a:off x="4914900" y="2240279"/>
+            <a:ext cx="3552444" cy="2473451"/>
           </a:xfrm>
           <a:prstGeom prst="rect">
             <a:avLst/>
@@ -31969,97 +33958,388 @@
           </a:bodyPr>
           <a:lstStyle/>
           <a:p>
-            <a:pPr algn="l">
-              <a:spcAft>
-                <a:spcPts val="300"/>
-              </a:spcAft>
-            </a:pPr>
-            <a:r>
-              <a:rPr sz="1300" b="1">
-                <a:solidFill>
-                  <a:srgbClr val="3730A3"/>
-                </a:solidFill>
-                <a:ea typeface="Sylfaen"/>
-                <a:cs typeface="Sylfaen"/>
-                <a:latin typeface="Sylfaen"/>
-              </a:rPr>
-              <a:t>▸  </a:t>
-            </a:r>
-            <a:r>
-              <a:rPr sz="1300">
+            <a:pPr>
+              <a:spcAft>
+                <a:spcPts val="0"/>
+              </a:spcAft>
+            </a:pPr>
+            <a:r>
+              <a:rPr sz="1000">
                 <a:solidFill>
                   <a:srgbClr val="0F172A"/>
                 </a:solidFill>
-                <a:ea typeface="Sylfaen"/>
-                <a:cs typeface="Sylfaen"/>
-                <a:latin typeface="Sylfaen"/>
-              </a:rPr>
-              <a:t>გახსენით Claude ან ChatGPT ;</a:t>
-            </a:r>
-          </a:p>
-          <a:p>
-            <a:pPr algn="l">
-              <a:spcAft>
-                <a:spcPts val="300"/>
-              </a:spcAft>
-            </a:pPr>
-            <a:r>
-              <a:rPr sz="1300" b="1">
-                <a:solidFill>
-                  <a:srgbClr val="3730A3"/>
-                </a:solidFill>
-                <a:ea typeface="Sylfaen"/>
-                <a:cs typeface="Sylfaen"/>
-                <a:latin typeface="Sylfaen"/>
-              </a:rPr>
-              <a:t>▸  </a:t>
-            </a:r>
-            <a:r>
-              <a:rPr sz="1300">
+                <a:ea typeface="Consolas"/>
+                <a:cs typeface="Consolas"/>
+                <a:latin typeface="Consolas"/>
+              </a:rPr>
+              <a:t>შენ ხარ ჩემი სტარტაპის</a:t>
+            </a:r>
+          </a:p>
+          <a:p>
+            <a:pPr>
+              <a:spcAft>
+                <a:spcPts val="0"/>
+              </a:spcAft>
+            </a:pPr>
+            <a:r>
+              <a:rPr sz="1000">
                 <a:solidFill>
                   <a:srgbClr val="0F172A"/>
                 </a:solidFill>
-                <a:ea typeface="Sylfaen"/>
-                <a:cs typeface="Sylfaen"/>
-                <a:latin typeface="Sylfaen"/>
-              </a:rPr>
-              <a:t>სთხოვეთ AI-ს: „მოირგე [თქვენი ICP პროფილის] როლი. მე დაგისვამ კითხვებს ჩემი სტარტაპის ვალიდაციისთვის. ილაპარაკე მოკლედ და ნუ იქნები ზედმეტად დამყოლი ან მეგობრული.“ ;</a:t>
-            </a:r>
-          </a:p>
-          <a:p>
-            <a:pPr algn="l">
-              <a:spcAft>
-                <a:spcPts val="300"/>
-              </a:spcAft>
-            </a:pPr>
-            <a:r>
-              <a:rPr sz="1300" b="1">
-                <a:solidFill>
-                  <a:srgbClr val="3730A3"/>
-                </a:solidFill>
-                <a:ea typeface="Sylfaen"/>
-                <a:cs typeface="Sylfaen"/>
-                <a:latin typeface="Sylfaen"/>
-              </a:rPr>
-              <a:t>▸  </a:t>
-            </a:r>
-            <a:r>
-              <a:rPr sz="1300">
+                <a:ea typeface="Consolas"/>
+                <a:cs typeface="Consolas"/>
+                <a:latin typeface="Consolas"/>
+              </a:rPr>
+              <a:t>სამიზნე მომხმარებელი</a:t>
+            </a:r>
+          </a:p>
+          <a:p>
+            <a:pPr>
+              <a:spcAft>
+                <a:spcPts val="0"/>
+              </a:spcAft>
+            </a:pPr>
+            <a:r>
+              <a:rPr sz="1000">
                 <a:solidFill>
                   <a:srgbClr val="0F172A"/>
                 </a:solidFill>
-                <a:ea typeface="Sylfaen"/>
-                <a:cs typeface="Sylfaen"/>
-                <a:latin typeface="Sylfaen"/>
-              </a:rPr>
-              <a:t>დაუსვით 3 კითხვა The Mom Test-ის წესების (წარსული გამოცდილების შესახებ) დაცვით და შეაფასეთ მიღებული პასუხები.</a:t>
-            </a:r>
-          </a:p>
-        </p:txBody>
-      </p:sp>
-      <p:sp>
-        <p:nvSpPr>
-          <p:cNvPr id="13" name="Rectangle 12"/>
+                <a:ea typeface="Consolas"/>
+                <a:cs typeface="Consolas"/>
+                <a:latin typeface="Consolas"/>
+              </a:rPr>
+              <a:t>(ICP): [მაგ: მცირე</a:t>
+            </a:r>
+          </a:p>
+          <a:p>
+            <a:pPr>
+              <a:spcAft>
+                <a:spcPts val="0"/>
+              </a:spcAft>
+            </a:pPr>
+            <a:r>
+              <a:rPr sz="1000">
+                <a:solidFill>
+                  <a:srgbClr val="0F172A"/>
+                </a:solidFill>
+                <a:ea typeface="Consolas"/>
+                <a:cs typeface="Consolas"/>
+                <a:latin typeface="Consolas"/>
+              </a:rPr>
+              <a:t>რესტორნის მფლობელი,</a:t>
+            </a:r>
+          </a:p>
+          <a:p>
+            <a:pPr>
+              <a:spcAft>
+                <a:spcPts val="0"/>
+              </a:spcAft>
+            </a:pPr>
+            <a:r>
+              <a:rPr sz="1000">
+                <a:solidFill>
+                  <a:srgbClr val="0F172A"/>
+                </a:solidFill>
+                <a:ea typeface="Consolas"/>
+                <a:cs typeface="Consolas"/>
+                <a:latin typeface="Consolas"/>
+              </a:rPr>
+              <a:t>რომელიც თავად უმკლავდება</a:t>
+            </a:r>
+          </a:p>
+          <a:p>
+            <a:pPr>
+              <a:spcAft>
+                <a:spcPts val="0"/>
+              </a:spcAft>
+            </a:pPr>
+            <a:r>
+              <a:rPr sz="1000">
+                <a:solidFill>
+                  <a:srgbClr val="0F172A"/>
+                </a:solidFill>
+                <a:ea typeface="Consolas"/>
+                <a:cs typeface="Consolas"/>
+                <a:latin typeface="Consolas"/>
+              </a:rPr>
+              <a:t>პროდუქტების შესყიდვას].</a:t>
+            </a:r>
+          </a:p>
+          <a:p>
+            <a:pPr>
+              <a:spcAft>
+                <a:spcPts val="0"/>
+              </a:spcAft>
+            </a:pPr>
+            <a:r>
+              <a:rPr sz="1000">
+                <a:solidFill>
+                  <a:srgbClr val="0F172A"/>
+                </a:solidFill>
+                <a:ea typeface="Consolas"/>
+                <a:cs typeface="Consolas"/>
+                <a:latin typeface="Consolas"/>
+              </a:rPr>
+              <a:t>მინდა ჩაგიტარო ინტერვიუ.</a:t>
+            </a:r>
+          </a:p>
+          <a:p>
+            <a:pPr>
+              <a:spcAft>
+                <a:spcPts val="0"/>
+              </a:spcAft>
+            </a:pPr>
+            <a:r>
+              <a:rPr sz="1000">
+                <a:solidFill>
+                  <a:srgbClr val="0F172A"/>
+                </a:solidFill>
+                <a:ea typeface="Consolas"/>
+                <a:cs typeface="Consolas"/>
+                <a:latin typeface="Consolas"/>
+              </a:rPr>
+              <a:t>წესები შენთვის:</a:t>
+            </a:r>
+          </a:p>
+          <a:p>
+            <a:pPr>
+              <a:spcAft>
+                <a:spcPts val="0"/>
+              </a:spcAft>
+            </a:pPr>
+            <a:r>
+              <a:rPr sz="1000">
+                <a:solidFill>
+                  <a:srgbClr val="0F172A"/>
+                </a:solidFill>
+                <a:ea typeface="Consolas"/>
+                <a:cs typeface="Consolas"/>
+                <a:latin typeface="Consolas"/>
+              </a:rPr>
+              <a:t>1. ილაპარაკე მოკლედ, 1-2</a:t>
+            </a:r>
+          </a:p>
+          <a:p>
+            <a:pPr>
+              <a:spcAft>
+                <a:spcPts val="0"/>
+              </a:spcAft>
+            </a:pPr>
+            <a:r>
+              <a:rPr sz="1000">
+                <a:solidFill>
+                  <a:srgbClr val="0F172A"/>
+                </a:solidFill>
+                <a:ea typeface="Consolas"/>
+                <a:cs typeface="Consolas"/>
+                <a:latin typeface="Consolas"/>
+              </a:rPr>
+              <a:t>წინადადებით, როგორც</a:t>
+            </a:r>
+          </a:p>
+          <a:p>
+            <a:pPr>
+              <a:spcAft>
+                <a:spcPts val="0"/>
+              </a:spcAft>
+            </a:pPr>
+            <a:r>
+              <a:rPr sz="1000">
+                <a:solidFill>
+                  <a:srgbClr val="0F172A"/>
+                </a:solidFill>
+                <a:ea typeface="Consolas"/>
+                <a:cs typeface="Consolas"/>
+                <a:latin typeface="Consolas"/>
+              </a:rPr>
+              <a:t>დაკავებულმა ადამიანმა.</a:t>
+            </a:r>
+          </a:p>
+          <a:p>
+            <a:pPr>
+              <a:spcAft>
+                <a:spcPts val="0"/>
+              </a:spcAft>
+            </a:pPr>
+            <a:r>
+              <a:rPr sz="1000">
+                <a:solidFill>
+                  <a:srgbClr val="0F172A"/>
+                </a:solidFill>
+                <a:ea typeface="Consolas"/>
+                <a:cs typeface="Consolas"/>
+                <a:latin typeface="Consolas"/>
+              </a:rPr>
+              <a:t>2. ნუ იქნები ზედმეტად</a:t>
+            </a:r>
+          </a:p>
+          <a:p>
+            <a:pPr>
+              <a:spcAft>
+                <a:spcPts val="0"/>
+              </a:spcAft>
+            </a:pPr>
+            <a:r>
+              <a:rPr sz="1000">
+                <a:solidFill>
+                  <a:srgbClr val="0F172A"/>
+                </a:solidFill>
+                <a:ea typeface="Consolas"/>
+                <a:cs typeface="Consolas"/>
+                <a:latin typeface="Consolas"/>
+              </a:rPr>
+              <a:t>დამყოლი ან თავაზიანი. თუ</a:t>
+            </a:r>
+          </a:p>
+          <a:p>
+            <a:pPr>
+              <a:spcAft>
+                <a:spcPts val="0"/>
+              </a:spcAft>
+            </a:pPr>
+            <a:r>
+              <a:rPr sz="1000">
+                <a:solidFill>
+                  <a:srgbClr val="0F172A"/>
+                </a:solidFill>
+                <a:ea typeface="Consolas"/>
+                <a:cs typeface="Consolas"/>
+                <a:latin typeface="Consolas"/>
+              </a:rPr>
+              <a:t>რამე პრობლემა არ გაწუხებს</a:t>
+            </a:r>
+          </a:p>
+          <a:p>
+            <a:pPr>
+              <a:spcAft>
+                <a:spcPts val="0"/>
+              </a:spcAft>
+            </a:pPr>
+            <a:r>
+              <a:rPr sz="1000">
+                <a:solidFill>
+                  <a:srgbClr val="0F172A"/>
+                </a:solidFill>
+                <a:ea typeface="Consolas"/>
+                <a:cs typeface="Consolas"/>
+                <a:latin typeface="Consolas"/>
+              </a:rPr>
+              <a:t>რეალურად, პირდაპირ</a:t>
+            </a:r>
+          </a:p>
+          <a:p>
+            <a:pPr>
+              <a:spcAft>
+                <a:spcPts val="0"/>
+              </a:spcAft>
+            </a:pPr>
+            <a:r>
+              <a:rPr sz="1000">
+                <a:solidFill>
+                  <a:srgbClr val="0F172A"/>
+                </a:solidFill>
+                <a:ea typeface="Consolas"/>
+                <a:cs typeface="Consolas"/>
+                <a:latin typeface="Consolas"/>
+              </a:rPr>
+              <a:t>მითხარი.</a:t>
+            </a:r>
+          </a:p>
+          <a:p>
+            <a:pPr>
+              <a:spcAft>
+                <a:spcPts val="0"/>
+              </a:spcAft>
+            </a:pPr>
+            <a:r>
+              <a:rPr sz="1000">
+                <a:solidFill>
+                  <a:srgbClr val="0F172A"/>
+                </a:solidFill>
+                <a:ea typeface="Consolas"/>
+                <a:cs typeface="Consolas"/>
+                <a:latin typeface="Consolas"/>
+              </a:rPr>
+              <a:t>3. უპასუხე მხოლოდ შენს</a:t>
+            </a:r>
+          </a:p>
+          <a:p>
+            <a:pPr>
+              <a:spcAft>
+                <a:spcPts val="0"/>
+              </a:spcAft>
+            </a:pPr>
+            <a:r>
+              <a:rPr sz="1000">
+                <a:solidFill>
+                  <a:srgbClr val="0F172A"/>
+                </a:solidFill>
+                <a:ea typeface="Consolas"/>
+                <a:cs typeface="Consolas"/>
+                <a:latin typeface="Consolas"/>
+              </a:rPr>
+              <a:t>წარსულ გამოცდილებაზე</a:t>
+            </a:r>
+          </a:p>
+          <a:p>
+            <a:pPr>
+              <a:spcAft>
+                <a:spcPts val="0"/>
+              </a:spcAft>
+            </a:pPr>
+            <a:r>
+              <a:rPr sz="1000">
+                <a:solidFill>
+                  <a:srgbClr val="0F172A"/>
+                </a:solidFill>
+                <a:ea typeface="Consolas"/>
+                <a:cs typeface="Consolas"/>
+                <a:latin typeface="Consolas"/>
+              </a:rPr>
+              <a:t>დაყრდნობით.</a:t>
+            </a:r>
+          </a:p>
+          <a:p>
+            <a:pPr>
+              <a:spcAft>
+                <a:spcPts val="0"/>
+              </a:spcAft>
+            </a:pPr>
+            <a:r>
+              <a:rPr sz="1000">
+                <a:solidFill>
+                  <a:srgbClr val="0F172A"/>
+                </a:solidFill>
+                <a:ea typeface="Consolas"/>
+                <a:cs typeface="Consolas"/>
+                <a:latin typeface="Consolas"/>
+              </a:rPr>
+              <a:t>თუ მზად ხარ, მომესალმე და</a:t>
+            </a:r>
+          </a:p>
+          <a:p>
+            <a:pPr>
+              <a:spcAft>
+                <a:spcPts val="0"/>
+              </a:spcAft>
+            </a:pPr>
+            <a:r>
+              <a:rPr sz="1000">
+                <a:solidFill>
+                  <a:srgbClr val="0F172A"/>
+                </a:solidFill>
+                <a:ea typeface="Consolas"/>
+                <a:cs typeface="Consolas"/>
+                <a:latin typeface="Consolas"/>
+              </a:rPr>
+              <a:t>დავიწყოთ.</a:t>
+            </a:r>
+          </a:p>
+        </p:txBody>
+      </p:sp>
+      <p:sp>
+        <p:nvSpPr>
+          <p:cNvPr id="22" name="Rectangle 21"/>
           <p:cNvSpPr/>
           <p:nvPr/>
         </p:nvSpPr>
@@ -32103,7 +34383,7 @@
       </p:sp>
       <p:sp>
         <p:nvSpPr>
-          <p:cNvPr id="14" name="TextBox 13"/>
+          <p:cNvPr id="23" name="TextBox 22"/>
           <p:cNvSpPr txBox="1"/>
           <p:nvPr/>
         </p:nvSpPr>
@@ -39016,7 +41296,7 @@
         <p:spPr>
           <a:xfrm>
             <a:off x="457200" y="1737360"/>
-            <a:ext cx="54864" cy="2313432"/>
+            <a:ext cx="54864" cy="3113532"/>
           </a:xfrm>
           <a:prstGeom prst="rect">
             <a:avLst/>
@@ -39060,7 +41340,7 @@
         <p:spPr>
           <a:xfrm>
             <a:off x="512064" y="1737360"/>
-            <a:ext cx="8174736" cy="2313432"/>
+            <a:ext cx="3991356" cy="3113532"/>
           </a:xfrm>
           <a:prstGeom prst="roundRect">
             <a:avLst>
@@ -39070,6 +41350,341 @@
           <a:solidFill>
             <a:srgbClr val="F8FAFC"/>
           </a:solidFill>
+          <a:ln w="6350">
+            <a:solidFill>
+              <a:srgbClr val="E2E8F0"/>
+            </a:solidFill>
+          </a:ln>
+          <a:effectLst/>
+        </p:spPr>
+        <p:style>
+          <a:lnRef idx="1">
+            <a:schemeClr val="accent1"/>
+          </a:lnRef>
+          <a:fillRef idx="3">
+            <a:schemeClr val="accent1"/>
+          </a:fillRef>
+          <a:effectRef idx="2">
+            <a:schemeClr val="accent1"/>
+          </a:effectRef>
+          <a:fontRef idx="minor">
+            <a:schemeClr val="lt1"/>
+          </a:fontRef>
+        </p:style>
+        <p:txBody>
+          <a:bodyPr rtlCol="0" anchor="ctr"/>
+          <a:lstStyle/>
+          <a:p>
+            <a:pPr algn="ctr"/>
+          </a:p>
+        </p:txBody>
+      </p:sp>
+      <p:sp>
+        <p:nvSpPr>
+          <p:cNvPr id="11" name="TextBox 10"/>
+          <p:cNvSpPr txBox="1"/>
+          <p:nvPr/>
+        </p:nvSpPr>
+        <p:spPr>
+          <a:xfrm>
+            <a:off x="621792" y="1810512"/>
+            <a:ext cx="3771900" cy="320040"/>
+          </a:xfrm>
+          <a:prstGeom prst="rect">
+            <a:avLst/>
+          </a:prstGeom>
+          <a:noFill/>
+        </p:spPr>
+        <p:txBody>
+          <a:bodyPr wrap="square" anchor="t" lIns="54864" rIns="54864" tIns="54864" bIns="54864">
+            <a:spAutoFit/>
+          </a:bodyPr>
+          <a:lstStyle/>
+          <a:p>
+            <a:pPr>
+              <a:spcAft>
+                <a:spcPts val="400"/>
+              </a:spcAft>
+            </a:pPr>
+            <a:r>
+              <a:rPr sz="1400" b="1" i="0">
+                <a:solidFill>
+                  <a:srgbClr val="0F172A"/>
+                </a:solidFill>
+                <a:ea typeface="Sylfaen"/>
+                <a:cs typeface="Sylfaen"/>
+                <a:latin typeface="Sylfaen"/>
+              </a:rPr>
+              <a:t>📋 ინსტრუქცია:</a:t>
+            </a:r>
+          </a:p>
+        </p:txBody>
+      </p:sp>
+      <p:sp>
+        <p:nvSpPr>
+          <p:cNvPr id="12" name="TextBox 11"/>
+          <p:cNvSpPr txBox="1"/>
+          <p:nvPr/>
+        </p:nvSpPr>
+        <p:spPr>
+          <a:xfrm>
+            <a:off x="621792" y="2203704"/>
+            <a:ext cx="3771900" cy="2542032"/>
+          </a:xfrm>
+          <a:prstGeom prst="rect">
+            <a:avLst/>
+          </a:prstGeom>
+          <a:noFill/>
+        </p:spPr>
+        <p:txBody>
+          <a:bodyPr wrap="square" anchor="t" lIns="54864" rIns="54864" tIns="54864" bIns="54864">
+            <a:spAutoFit/>
+          </a:bodyPr>
+          <a:lstStyle/>
+          <a:p>
+            <a:pPr algn="l">
+              <a:spcAft>
+                <a:spcPts val="300"/>
+              </a:spcAft>
+            </a:pPr>
+            <a:r>
+              <a:rPr sz="1300" b="1">
+                <a:solidFill>
+                  <a:srgbClr val="3730A3"/>
+                </a:solidFill>
+                <a:ea typeface="Sylfaen"/>
+                <a:cs typeface="Sylfaen"/>
+                <a:latin typeface="Sylfaen"/>
+              </a:rPr>
+              <a:t>▸  </a:t>
+            </a:r>
+            <a:r>
+              <a:rPr sz="1300">
+                <a:solidFill>
+                  <a:srgbClr val="0F172A"/>
+                </a:solidFill>
+                <a:ea typeface="Sylfaen"/>
+                <a:cs typeface="Sylfaen"/>
+                <a:latin typeface="Sylfaen"/>
+              </a:rPr>
+              <a:t>გახსენით Perplexity ;</a:t>
+            </a:r>
+          </a:p>
+          <a:p>
+            <a:pPr algn="l">
+              <a:spcAft>
+                <a:spcPts val="300"/>
+              </a:spcAft>
+            </a:pPr>
+            <a:r>
+              <a:rPr sz="1300" b="1">
+                <a:solidFill>
+                  <a:srgbClr val="3730A3"/>
+                </a:solidFill>
+                <a:ea typeface="Sylfaen"/>
+                <a:cs typeface="Sylfaen"/>
+                <a:latin typeface="Sylfaen"/>
+              </a:rPr>
+              <a:t>▸  </a:t>
+            </a:r>
+            <a:r>
+              <a:rPr sz="1300">
+                <a:solidFill>
+                  <a:srgbClr val="0F172A"/>
+                </a:solidFill>
+                <a:ea typeface="Sylfaen"/>
+                <a:cs typeface="Sylfaen"/>
+                <a:latin typeface="Sylfaen"/>
+              </a:rPr>
+              <a:t>მოიძიეთ თქვენი იდეის მინიმუმ 2 გლობალური და 1 ლოკალური კონკურენტი;</a:t>
+            </a:r>
+          </a:p>
+          <a:p>
+            <a:pPr algn="l">
+              <a:spcAft>
+                <a:spcPts val="300"/>
+              </a:spcAft>
+            </a:pPr>
+            <a:r>
+              <a:rPr sz="1300" b="1">
+                <a:solidFill>
+                  <a:srgbClr val="3730A3"/>
+                </a:solidFill>
+                <a:ea typeface="Sylfaen"/>
+                <a:cs typeface="Sylfaen"/>
+                <a:latin typeface="Sylfaen"/>
+              </a:rPr>
+              <a:t>▸  </a:t>
+            </a:r>
+            <a:r>
+              <a:rPr sz="1300">
+                <a:solidFill>
+                  <a:srgbClr val="0F172A"/>
+                </a:solidFill>
+                <a:ea typeface="Sylfaen"/>
+                <a:cs typeface="Sylfaen"/>
+                <a:latin typeface="Sylfaen"/>
+              </a:rPr>
+              <a:t>სთხოვეთ Perplexity-ს, შემოგთავაზოთ შედარებითი Feature Matrix ცხრილი, სადაც ნაჩვენები იქნება თქვენი სტარტაპის უპირატესობა.</a:t>
+            </a:r>
+          </a:p>
+        </p:txBody>
+      </p:sp>
+      <p:sp>
+        <p:nvSpPr>
+          <p:cNvPr id="13" name="Rectangle 12"/>
+          <p:cNvSpPr/>
+          <p:nvPr/>
+        </p:nvSpPr>
+        <p:spPr>
+          <a:xfrm>
+            <a:off x="4640580" y="1737360"/>
+            <a:ext cx="54864" cy="3113532"/>
+          </a:xfrm>
+          <a:prstGeom prst="rect">
+            <a:avLst/>
+          </a:prstGeom>
+          <a:solidFill>
+            <a:srgbClr val="3730A3"/>
+          </a:solidFill>
+          <a:ln>
+            <a:noFill/>
+          </a:ln>
+          <a:effectLst/>
+        </p:spPr>
+        <p:style>
+          <a:lnRef idx="1">
+            <a:schemeClr val="accent1"/>
+          </a:lnRef>
+          <a:fillRef idx="3">
+            <a:schemeClr val="accent1"/>
+          </a:fillRef>
+          <a:effectRef idx="2">
+            <a:schemeClr val="accent1"/>
+          </a:effectRef>
+          <a:fontRef idx="minor">
+            <a:schemeClr val="lt1"/>
+          </a:fontRef>
+        </p:style>
+        <p:txBody>
+          <a:bodyPr rtlCol="0" anchor="ctr"/>
+          <a:lstStyle/>
+          <a:p>
+            <a:pPr algn="ctr"/>
+          </a:p>
+        </p:txBody>
+      </p:sp>
+      <p:sp>
+        <p:nvSpPr>
+          <p:cNvPr id="14" name="Rounded Rectangle 13"/>
+          <p:cNvSpPr/>
+          <p:nvPr/>
+        </p:nvSpPr>
+        <p:spPr>
+          <a:xfrm>
+            <a:off x="4695444" y="1737360"/>
+            <a:ext cx="3991356" cy="3113532"/>
+          </a:xfrm>
+          <a:prstGeom prst="roundRect">
+            <a:avLst>
+              <a:gd name="adj" fmla="val 4000"/>
+            </a:avLst>
+          </a:prstGeom>
+          <a:solidFill>
+            <a:srgbClr val="F8FAFC"/>
+          </a:solidFill>
+          <a:ln w="6350">
+            <a:solidFill>
+              <a:srgbClr val="3730A3"/>
+            </a:solidFill>
+          </a:ln>
+          <a:effectLst/>
+        </p:spPr>
+        <p:style>
+          <a:lnRef idx="1">
+            <a:schemeClr val="accent1"/>
+          </a:lnRef>
+          <a:fillRef idx="3">
+            <a:schemeClr val="accent1"/>
+          </a:fillRef>
+          <a:effectRef idx="2">
+            <a:schemeClr val="accent1"/>
+          </a:effectRef>
+          <a:fontRef idx="minor">
+            <a:schemeClr val="lt1"/>
+          </a:fontRef>
+        </p:style>
+        <p:txBody>
+          <a:bodyPr rtlCol="0" anchor="ctr"/>
+          <a:lstStyle/>
+          <a:p>
+            <a:pPr algn="ctr"/>
+          </a:p>
+        </p:txBody>
+      </p:sp>
+      <p:sp>
+        <p:nvSpPr>
+          <p:cNvPr id="15" name="Rectangle 14"/>
+          <p:cNvSpPr/>
+          <p:nvPr/>
+        </p:nvSpPr>
+        <p:spPr>
+          <a:xfrm>
+            <a:off x="4805172" y="1810512"/>
+            <a:ext cx="54864" cy="292608"/>
+          </a:xfrm>
+          <a:prstGeom prst="rect">
+            <a:avLst/>
+          </a:prstGeom>
+          <a:solidFill>
+            <a:srgbClr val="3730A3"/>
+          </a:solidFill>
+          <a:ln>
+            <a:noFill/>
+          </a:ln>
+          <a:effectLst/>
+        </p:spPr>
+        <p:style>
+          <a:lnRef idx="1">
+            <a:schemeClr val="accent1"/>
+          </a:lnRef>
+          <a:fillRef idx="3">
+            <a:schemeClr val="accent1"/>
+          </a:fillRef>
+          <a:effectRef idx="2">
+            <a:schemeClr val="accent1"/>
+          </a:effectRef>
+          <a:fontRef idx="minor">
+            <a:schemeClr val="lt1"/>
+          </a:fontRef>
+        </p:style>
+        <p:txBody>
+          <a:bodyPr rtlCol="0" anchor="ctr"/>
+          <a:lstStyle/>
+          <a:p>
+            <a:pPr algn="ctr"/>
+          </a:p>
+        </p:txBody>
+      </p:sp>
+      <p:sp>
+        <p:nvSpPr>
+          <p:cNvPr id="16" name="Rounded Rectangle 15"/>
+          <p:cNvSpPr/>
+          <p:nvPr/>
+        </p:nvSpPr>
+        <p:spPr>
+          <a:xfrm>
+            <a:off x="4860036" y="1810512"/>
+            <a:ext cx="3717036" cy="292608"/>
+          </a:xfrm>
+          <a:prstGeom prst="roundRect">
+            <a:avLst>
+              <a:gd name="adj" fmla="val 4000"/>
+            </a:avLst>
+          </a:prstGeom>
+          <a:solidFill>
+            <a:srgbClr val="F8FAFC"/>
+          </a:solidFill>
           <a:ln w="9525">
             <a:solidFill>
               <a:srgbClr val="E2E8F0"/>
@@ -39101,14 +41716,60 @@
       </p:sp>
       <p:sp>
         <p:nvSpPr>
-          <p:cNvPr id="11" name="TextBox 10"/>
+          <p:cNvPr id="17" name="Rectangle 16"/>
+          <p:cNvSpPr/>
+          <p:nvPr/>
+        </p:nvSpPr>
+        <p:spPr>
+          <a:xfrm>
+            <a:off x="4914900" y="1865376"/>
+            <a:ext cx="3552444" cy="201168"/>
+          </a:xfrm>
+          <a:prstGeom prst="rect">
+            <a:avLst/>
+          </a:prstGeom>
+          <a:solidFill>
+            <a:srgbClr val="FFFFFF"/>
+          </a:solidFill>
+          <a:ln w="6350">
+            <a:solidFill>
+              <a:srgbClr val="E2E8F0"/>
+            </a:solidFill>
+          </a:ln>
+          <a:effectLst/>
+        </p:spPr>
+        <p:style>
+          <a:lnRef idx="1">
+            <a:schemeClr val="accent1"/>
+          </a:lnRef>
+          <a:fillRef idx="3">
+            <a:schemeClr val="accent1"/>
+          </a:fillRef>
+          <a:effectRef idx="2">
+            <a:schemeClr val="accent1"/>
+          </a:effectRef>
+          <a:fontRef idx="minor">
+            <a:schemeClr val="lt1"/>
+          </a:fontRef>
+        </p:style>
+        <p:txBody>
+          <a:bodyPr rtlCol="0" anchor="ctr"/>
+          <a:lstStyle/>
+          <a:p>
+            <a:pPr algn="ctr"/>
+          </a:p>
+        </p:txBody>
+      </p:sp>
+      <p:sp>
+        <p:nvSpPr>
+          <p:cNvPr id="18" name="TextBox 17"/>
           <p:cNvSpPr txBox="1"/>
           <p:nvPr/>
         </p:nvSpPr>
         <p:spPr>
           <a:xfrm>
-            <a:off x="621792" y="1810512"/>
-            <a:ext cx="7955279" cy="320040"/>
+            <a:off x="4969764" y="1892807"/>
+            <a:ext cx="3442716" cy="146304"/>
           </a:xfrm>
           <a:prstGeom prst="rect">
             <a:avLst/>
@@ -39123,33 +41784,145 @@
           <a:p>
             <a:pPr>
               <a:spcAft>
-                <a:spcPts val="400"/>
-              </a:spcAft>
-            </a:pPr>
-            <a:r>
-              <a:rPr sz="1400" b="1" i="0">
+                <a:spcPts val="0"/>
+              </a:spcAft>
+            </a:pPr>
+            <a:r>
+              <a:rPr sz="800">
                 <a:solidFill>
                   <a:srgbClr val="0F172A"/>
                 </a:solidFill>
-                <a:ea typeface="Sylfaen"/>
-                <a:cs typeface="Sylfaen"/>
-                <a:latin typeface="Sylfaen"/>
-              </a:rPr>
-              <a:t>📋 ინსტრუქცია:</a:t>
-            </a:r>
-          </a:p>
-        </p:txBody>
-      </p:sp>
-      <p:sp>
-        <p:nvSpPr>
-          <p:cNvPr id="12" name="TextBox 11"/>
+                <a:ea typeface="Consolas"/>
+                <a:cs typeface="Consolas"/>
+                <a:latin typeface="Consolas"/>
+              </a:rPr>
+              <a:t>Perplexity კონკურენტების</a:t>
+            </a:r>
+          </a:p>
+          <a:p>
+            <a:pPr>
+              <a:spcAft>
+                <a:spcPts val="0"/>
+              </a:spcAft>
+            </a:pPr>
+            <a:r>
+              <a:rPr sz="800">
+                <a:solidFill>
+                  <a:srgbClr val="0F172A"/>
+                </a:solidFill>
+                <a:ea typeface="Consolas"/>
+                <a:cs typeface="Consolas"/>
+                <a:latin typeface="Consolas"/>
+              </a:rPr>
+              <a:t>ძიების პრომპტი:</a:t>
+            </a:r>
+          </a:p>
+        </p:txBody>
+      </p:sp>
+      <p:sp>
+        <p:nvSpPr>
+          <p:cNvPr id="19" name="Rounded Rectangle 18"/>
+          <p:cNvSpPr/>
+          <p:nvPr/>
+        </p:nvSpPr>
+        <p:spPr>
+          <a:xfrm>
+            <a:off x="4805172" y="2176272"/>
+            <a:ext cx="3771900" cy="2601468"/>
+          </a:xfrm>
+          <a:prstGeom prst="roundRect">
+            <a:avLst>
+              <a:gd name="adj" fmla="val 4000"/>
+            </a:avLst>
+          </a:prstGeom>
+          <a:solidFill>
+            <a:srgbClr val="F8FAFC"/>
+          </a:solidFill>
+          <a:ln w="9525">
+            <a:solidFill>
+              <a:srgbClr val="E2E8F0"/>
+            </a:solidFill>
+          </a:ln>
+          <a:effectLst/>
+        </p:spPr>
+        <p:style>
+          <a:lnRef idx="1">
+            <a:schemeClr val="accent1"/>
+          </a:lnRef>
+          <a:fillRef idx="3">
+            <a:schemeClr val="accent1"/>
+          </a:fillRef>
+          <a:effectRef idx="2">
+            <a:schemeClr val="accent1"/>
+          </a:effectRef>
+          <a:fontRef idx="minor">
+            <a:schemeClr val="lt1"/>
+          </a:fontRef>
+        </p:style>
+        <p:txBody>
+          <a:bodyPr rtlCol="0" anchor="ctr"/>
+          <a:lstStyle/>
+          <a:p>
+            <a:pPr algn="ctr"/>
+          </a:p>
+        </p:txBody>
+      </p:sp>
+      <p:sp>
+        <p:nvSpPr>
+          <p:cNvPr id="20" name="Rectangle 19"/>
+          <p:cNvSpPr/>
+          <p:nvPr/>
+        </p:nvSpPr>
+        <p:spPr>
+          <a:xfrm>
+            <a:off x="4860036" y="2221991"/>
+            <a:ext cx="3662172" cy="2510027"/>
+          </a:xfrm>
+          <a:prstGeom prst="rect">
+            <a:avLst/>
+          </a:prstGeom>
+          <a:solidFill>
+            <a:srgbClr val="FFFFFF"/>
+          </a:solidFill>
+          <a:ln w="6350">
+            <a:solidFill>
+              <a:srgbClr val="E2E8F0"/>
+            </a:solidFill>
+          </a:ln>
+          <a:effectLst/>
+        </p:spPr>
+        <p:style>
+          <a:lnRef idx="1">
+            <a:schemeClr val="accent1"/>
+          </a:lnRef>
+          <a:fillRef idx="3">
+            <a:schemeClr val="accent1"/>
+          </a:fillRef>
+          <a:effectRef idx="2">
+            <a:schemeClr val="accent1"/>
+          </a:effectRef>
+          <a:fontRef idx="minor">
+            <a:schemeClr val="lt1"/>
+          </a:fontRef>
+        </p:style>
+        <p:txBody>
+          <a:bodyPr rtlCol="0" anchor="ctr"/>
+          <a:lstStyle/>
+          <a:p>
+            <a:pPr algn="ctr"/>
+          </a:p>
+        </p:txBody>
+      </p:sp>
+      <p:sp>
+        <p:nvSpPr>
+          <p:cNvPr id="21" name="TextBox 20"/>
           <p:cNvSpPr txBox="1"/>
           <p:nvPr/>
         </p:nvSpPr>
         <p:spPr>
           <a:xfrm>
-            <a:off x="621792" y="2203704"/>
-            <a:ext cx="7955279" cy="1719072"/>
+            <a:off x="4914900" y="2240279"/>
+            <a:ext cx="3552444" cy="2473451"/>
           </a:xfrm>
           <a:prstGeom prst="rect">
             <a:avLst/>
@@ -39162,97 +41935,316 @@
           </a:bodyPr>
           <a:lstStyle/>
           <a:p>
-            <a:pPr algn="l">
-              <a:spcAft>
-                <a:spcPts val="300"/>
-              </a:spcAft>
-            </a:pPr>
-            <a:r>
-              <a:rPr sz="1300" b="1">
-                <a:solidFill>
-                  <a:srgbClr val="3730A3"/>
-                </a:solidFill>
-                <a:ea typeface="Sylfaen"/>
-                <a:cs typeface="Sylfaen"/>
-                <a:latin typeface="Sylfaen"/>
-              </a:rPr>
-              <a:t>▸  </a:t>
-            </a:r>
-            <a:r>
-              <a:rPr sz="1300">
+            <a:pPr>
+              <a:spcAft>
+                <a:spcPts val="0"/>
+              </a:spcAft>
+            </a:pPr>
+            <a:r>
+              <a:rPr sz="1000">
                 <a:solidFill>
                   <a:srgbClr val="0F172A"/>
                 </a:solidFill>
-                <a:ea typeface="Sylfaen"/>
-                <a:cs typeface="Sylfaen"/>
-                <a:latin typeface="Sylfaen"/>
-              </a:rPr>
-              <a:t>გახსენით Perplexity ;</a:t>
-            </a:r>
-          </a:p>
-          <a:p>
-            <a:pPr algn="l">
-              <a:spcAft>
-                <a:spcPts val="300"/>
-              </a:spcAft>
-            </a:pPr>
-            <a:r>
-              <a:rPr sz="1300" b="1">
-                <a:solidFill>
-                  <a:srgbClr val="3730A3"/>
-                </a:solidFill>
-                <a:ea typeface="Sylfaen"/>
-                <a:cs typeface="Sylfaen"/>
-                <a:latin typeface="Sylfaen"/>
-              </a:rPr>
-              <a:t>▸  </a:t>
-            </a:r>
-            <a:r>
-              <a:rPr sz="1300">
+                <a:ea typeface="Consolas"/>
+                <a:cs typeface="Consolas"/>
+                <a:latin typeface="Consolas"/>
+              </a:rPr>
+              <a:t>Search for 3 main</a:t>
+            </a:r>
+          </a:p>
+          <a:p>
+            <a:pPr>
+              <a:spcAft>
+                <a:spcPts val="0"/>
+              </a:spcAft>
+            </a:pPr>
+            <a:r>
+              <a:rPr sz="1000">
                 <a:solidFill>
                   <a:srgbClr val="0F172A"/>
                 </a:solidFill>
-                <a:ea typeface="Sylfaen"/>
-                <a:cs typeface="Sylfaen"/>
-                <a:latin typeface="Sylfaen"/>
-              </a:rPr>
-              <a:t>მოიძიეთ თქვენი იდეის მინიმუმ 2 გლობალური და 1 ლოკალური კონკურენტი;</a:t>
-            </a:r>
-          </a:p>
-          <a:p>
-            <a:pPr algn="l">
-              <a:spcAft>
-                <a:spcPts val="300"/>
-              </a:spcAft>
-            </a:pPr>
-            <a:r>
-              <a:rPr sz="1300" b="1">
-                <a:solidFill>
-                  <a:srgbClr val="3730A3"/>
-                </a:solidFill>
-                <a:ea typeface="Sylfaen"/>
-                <a:cs typeface="Sylfaen"/>
-                <a:latin typeface="Sylfaen"/>
-              </a:rPr>
-              <a:t>▸  </a:t>
-            </a:r>
-            <a:r>
-              <a:rPr sz="1300">
+                <a:ea typeface="Consolas"/>
+                <a:cs typeface="Consolas"/>
+                <a:latin typeface="Consolas"/>
+              </a:rPr>
+              <a:t>competitors (both global</a:t>
+            </a:r>
+          </a:p>
+          <a:p>
+            <a:pPr>
+              <a:spcAft>
+                <a:spcPts val="0"/>
+              </a:spcAft>
+            </a:pPr>
+            <a:r>
+              <a:rPr sz="1000">
                 <a:solidFill>
                   <a:srgbClr val="0F172A"/>
                 </a:solidFill>
-                <a:ea typeface="Sylfaen"/>
-                <a:cs typeface="Sylfaen"/>
-                <a:latin typeface="Sylfaen"/>
-              </a:rPr>
-              <a:t>სთხოვეთ Perplexity-ს, შემოგთავაზოთ შედარებითი Feature Matrix ცხრილი, სადაც ნაჩვენები იქნება თქვენი სტარტაპის უპირატესობა.</a:t>
-            </a:r>
-          </a:p>
-        </p:txBody>
-      </p:sp>
-      <p:sp>
-        <p:nvSpPr>
-          <p:cNvPr id="13" name="Rectangle 12"/>
+                <a:ea typeface="Consolas"/>
+                <a:cs typeface="Consolas"/>
+                <a:latin typeface="Consolas"/>
+              </a:rPr>
+              <a:t>and local in Georgia) for</a:t>
+            </a:r>
+          </a:p>
+          <a:p>
+            <a:pPr>
+              <a:spcAft>
+                <a:spcPts val="0"/>
+              </a:spcAft>
+            </a:pPr>
+            <a:r>
+              <a:rPr sz="1000">
+                <a:solidFill>
+                  <a:srgbClr val="0F172A"/>
+                </a:solidFill>
+                <a:ea typeface="Consolas"/>
+                <a:cs typeface="Consolas"/>
+                <a:latin typeface="Consolas"/>
+              </a:rPr>
+              <a:t>the following startup</a:t>
+            </a:r>
+          </a:p>
+          <a:p>
+            <a:pPr>
+              <a:spcAft>
+                <a:spcPts val="0"/>
+              </a:spcAft>
+            </a:pPr>
+            <a:r>
+              <a:rPr sz="1000">
+                <a:solidFill>
+                  <a:srgbClr val="0F172A"/>
+                </a:solidFill>
+                <a:ea typeface="Consolas"/>
+                <a:cs typeface="Consolas"/>
+                <a:latin typeface="Consolas"/>
+              </a:rPr>
+              <a:t>idea: [მაგ: მეორადი</a:t>
+            </a:r>
+          </a:p>
+          <a:p>
+            <a:pPr>
+              <a:spcAft>
+                <a:spcPts val="0"/>
+              </a:spcAft>
+            </a:pPr>
+            <a:r>
+              <a:rPr sz="1000">
+                <a:solidFill>
+                  <a:srgbClr val="0F172A"/>
+                </a:solidFill>
+                <a:ea typeface="Consolas"/>
+                <a:cs typeface="Consolas"/>
+                <a:latin typeface="Consolas"/>
+              </a:rPr>
+              <a:t>წიგნების გაცვლისა და</a:t>
+            </a:r>
+          </a:p>
+          <a:p>
+            <a:pPr>
+              <a:spcAft>
+                <a:spcPts val="0"/>
+              </a:spcAft>
+            </a:pPr>
+            <a:r>
+              <a:rPr sz="1000">
+                <a:solidFill>
+                  <a:srgbClr val="0F172A"/>
+                </a:solidFill>
+                <a:ea typeface="Consolas"/>
+                <a:cs typeface="Consolas"/>
+                <a:latin typeface="Consolas"/>
+              </a:rPr>
+              <a:t>გაყიდვის პლატფორმა].</a:t>
+            </a:r>
+          </a:p>
+          <a:p>
+            <a:pPr>
+              <a:spcAft>
+                <a:spcPts val="0"/>
+              </a:spcAft>
+            </a:pPr>
+            <a:r>
+              <a:rPr sz="1000">
+                <a:solidFill>
+                  <a:srgbClr val="0F172A"/>
+                </a:solidFill>
+                <a:ea typeface="Consolas"/>
+                <a:cs typeface="Consolas"/>
+                <a:latin typeface="Consolas"/>
+              </a:rPr>
+              <a:t>Provide a comparison table</a:t>
+            </a:r>
+          </a:p>
+          <a:p>
+            <a:pPr>
+              <a:spcAft>
+                <a:spcPts val="0"/>
+              </a:spcAft>
+            </a:pPr>
+            <a:r>
+              <a:rPr sz="1000">
+                <a:solidFill>
+                  <a:srgbClr val="0F172A"/>
+                </a:solidFill>
+                <a:ea typeface="Consolas"/>
+                <a:cs typeface="Consolas"/>
+                <a:latin typeface="Consolas"/>
+              </a:rPr>
+              <a:t>including:</a:t>
+            </a:r>
+          </a:p>
+          <a:p>
+            <a:pPr>
+              <a:spcAft>
+                <a:spcPts val="0"/>
+              </a:spcAft>
+            </a:pPr>
+            <a:r>
+              <a:rPr sz="1000">
+                <a:solidFill>
+                  <a:srgbClr val="0F172A"/>
+                </a:solidFill>
+                <a:ea typeface="Consolas"/>
+                <a:cs typeface="Consolas"/>
+                <a:latin typeface="Consolas"/>
+              </a:rPr>
+              <a:t>1. Pricing Model</a:t>
+            </a:r>
+          </a:p>
+          <a:p>
+            <a:pPr>
+              <a:spcAft>
+                <a:spcPts val="0"/>
+              </a:spcAft>
+            </a:pPr>
+            <a:r>
+              <a:rPr sz="1000">
+                <a:solidFill>
+                  <a:srgbClr val="0F172A"/>
+                </a:solidFill>
+                <a:ea typeface="Consolas"/>
+                <a:cs typeface="Consolas"/>
+                <a:latin typeface="Consolas"/>
+              </a:rPr>
+              <a:t>2. Key Features and USP</a:t>
+            </a:r>
+          </a:p>
+          <a:p>
+            <a:pPr>
+              <a:spcAft>
+                <a:spcPts val="0"/>
+              </a:spcAft>
+            </a:pPr>
+            <a:r>
+              <a:rPr sz="1000">
+                <a:solidFill>
+                  <a:srgbClr val="0F172A"/>
+                </a:solidFill>
+                <a:ea typeface="Consolas"/>
+                <a:cs typeface="Consolas"/>
+                <a:latin typeface="Consolas"/>
+              </a:rPr>
+              <a:t>3. Weaknesses / Customer</a:t>
+            </a:r>
+          </a:p>
+          <a:p>
+            <a:pPr>
+              <a:spcAft>
+                <a:spcPts val="0"/>
+              </a:spcAft>
+            </a:pPr>
+            <a:r>
+              <a:rPr sz="1000">
+                <a:solidFill>
+                  <a:srgbClr val="0F172A"/>
+                </a:solidFill>
+                <a:ea typeface="Consolas"/>
+                <a:cs typeface="Consolas"/>
+                <a:latin typeface="Consolas"/>
+              </a:rPr>
+              <a:t>Complaints</a:t>
+            </a:r>
+          </a:p>
+          <a:p>
+            <a:pPr>
+              <a:spcAft>
+                <a:spcPts val="0"/>
+              </a:spcAft>
+            </a:pPr>
+            <a:r>
+              <a:rPr sz="1000">
+                <a:solidFill>
+                  <a:srgbClr val="0F172A"/>
+                </a:solidFill>
+                <a:ea typeface="Consolas"/>
+                <a:cs typeface="Consolas"/>
+                <a:latin typeface="Consolas"/>
+              </a:rPr>
+              <a:t>Determine a potential</a:t>
+            </a:r>
+          </a:p>
+          <a:p>
+            <a:pPr>
+              <a:spcAft>
+                <a:spcPts val="0"/>
+              </a:spcAft>
+            </a:pPr>
+            <a:r>
+              <a:rPr sz="1000">
+                <a:solidFill>
+                  <a:srgbClr val="0F172A"/>
+                </a:solidFill>
+                <a:ea typeface="Consolas"/>
+                <a:cs typeface="Consolas"/>
+                <a:latin typeface="Consolas"/>
+              </a:rPr>
+              <a:t>"Unfair Advantage" for my</a:t>
+            </a:r>
+          </a:p>
+          <a:p>
+            <a:pPr>
+              <a:spcAft>
+                <a:spcPts val="0"/>
+              </a:spcAft>
+            </a:pPr>
+            <a:r>
+              <a:rPr sz="1000">
+                <a:solidFill>
+                  <a:srgbClr val="0F172A"/>
+                </a:solidFill>
+                <a:ea typeface="Consolas"/>
+                <a:cs typeface="Consolas"/>
+                <a:latin typeface="Consolas"/>
+              </a:rPr>
+              <a:t>startup based on their</a:t>
+            </a:r>
+          </a:p>
+          <a:p>
+            <a:pPr>
+              <a:spcAft>
+                <a:spcPts val="0"/>
+              </a:spcAft>
+            </a:pPr>
+            <a:r>
+              <a:rPr sz="1000">
+                <a:solidFill>
+                  <a:srgbClr val="0F172A"/>
+                </a:solidFill>
+                <a:ea typeface="Consolas"/>
+                <a:cs typeface="Consolas"/>
+                <a:latin typeface="Consolas"/>
+              </a:rPr>
+              <a:t>weaknesses.</a:t>
+            </a:r>
+          </a:p>
+        </p:txBody>
+      </p:sp>
+      <p:sp>
+        <p:nvSpPr>
+          <p:cNvPr id="22" name="Rectangle 21"/>
           <p:cNvSpPr/>
           <p:nvPr/>
         </p:nvSpPr>
@@ -39296,7 +42288,7 @@
       </p:sp>
       <p:sp>
         <p:nvSpPr>
-          <p:cNvPr id="14" name="TextBox 13"/>
+          <p:cNvPr id="23" name="TextBox 22"/>
           <p:cNvSpPr txBox="1"/>
           <p:nvPr/>
         </p:nvSpPr>

</xml_diff>

<commit_message>
update Fri 07/17/2026 12:12:45.13
</commit_message>
<xml_diff>
--- a/GITA/Pre-Acceleration/2026-5h-AI-for-Startups/day1-slides.pptx
+++ b/GITA/Pre-Acceleration/2026-5h-AI-for-Startups/day1-slides.pptx
@@ -24320,7 +24320,7 @@
                 <a:cs typeface="Consolas"/>
                 <a:latin typeface="Consolas"/>
               </a:rPr>
-              <a:t>მე ვარ ფერმერი/აგრონომი. ჩემი იდეაა ჭკვიანი სარწყავი</a:t>
+              <a:t>შენ ხარ სტარტაპ მენტორი და კოპირაიტერი.</a:t>
             </a:r>
           </a:p>
           <a:p>
@@ -24338,7 +24338,7 @@
                 <a:cs typeface="Consolas"/>
                 <a:latin typeface="Consolas"/>
               </a:rPr>
-              <a:t>სისტემა.</a:t>
+              <a:t>მე ვარ ფერმერი/აგრონომი. ჩემი იდეაა "ჭკვიანი ირიგაციის</a:t>
             </a:r>
           </a:p>
           <a:p>
@@ -24356,7 +24356,7 @@
                 <a:cs typeface="Consolas"/>
                 <a:latin typeface="Consolas"/>
               </a:rPr>
-              <a:t>დამიწერე 30-წამიანი პრეზენტაციის ტექსტი ქართულად, რომელიც</a:t>
+              <a:t>სისტემა" (ნიადაგის AI სენსორები, რომლებიც ზოგავს წყალს და</a:t>
             </a:r>
           </a:p>
           <a:p>
@@ -24374,7 +24374,7 @@
                 <a:cs typeface="Consolas"/>
                 <a:latin typeface="Consolas"/>
               </a:rPr>
-              <a:t>ნათლად გამოკვეთს პრობლემას და წყლის დაზოგვის ეკონომიკურ</a:t>
+              <a:t>იცავს მოსავალს გვალვისგან).</a:t>
             </a:r>
           </a:p>
           <a:p>
@@ -24392,7 +24392,79 @@
                 <a:cs typeface="Consolas"/>
                 <a:latin typeface="Consolas"/>
               </a:rPr>
-              <a:t>სარგებელს.</a:t>
+              <a:t>დამიწერე 30-წამიანი Elevator Pitch ქართულად:</a:t>
+            </a:r>
+          </a:p>
+          <a:p>
+            <a:pPr>
+              <a:spcAft>
+                <a:spcPts val="0"/>
+              </a:spcAft>
+            </a:pPr>
+            <a:r>
+              <a:rPr sz="800">
+                <a:solidFill>
+                  <a:srgbClr val="0F172A"/>
+                </a:solidFill>
+                <a:ea typeface="Consolas"/>
+                <a:cs typeface="Consolas"/>
+                <a:latin typeface="Consolas"/>
+              </a:rPr>
+              <a:t>- სტრუქტურა: Hook (პრობლემა) -&gt; Solution (გადაწყვეტა) -&gt;</a:t>
+            </a:r>
+          </a:p>
+          <a:p>
+            <a:pPr>
+              <a:spcAft>
+                <a:spcPts val="0"/>
+              </a:spcAft>
+            </a:pPr>
+            <a:r>
+              <a:rPr sz="800">
+                <a:solidFill>
+                  <a:srgbClr val="0F172A"/>
+                </a:solidFill>
+                <a:ea typeface="Consolas"/>
+                <a:cs typeface="Consolas"/>
+                <a:latin typeface="Consolas"/>
+              </a:rPr>
+              <a:t>Value/Ask (ეკონომიკური სარგებელი, წყლის 40%-იანი დაზოგვა).</a:t>
+            </a:r>
+          </a:p>
+          <a:p>
+            <a:pPr>
+              <a:spcAft>
+                <a:spcPts val="0"/>
+              </a:spcAft>
+            </a:pPr>
+            <a:r>
+              <a:rPr sz="800">
+                <a:solidFill>
+                  <a:srgbClr val="0F172A"/>
+                </a:solidFill>
+                <a:ea typeface="Consolas"/>
+                <a:cs typeface="Consolas"/>
+                <a:latin typeface="Consolas"/>
+              </a:rPr>
+              <a:t>- შეზღუდვა: მაქსიმუმ 70-80 სიტყვა (რათა 30 წამში ჩაეტიოს).</a:t>
+            </a:r>
+          </a:p>
+          <a:p>
+            <a:pPr>
+              <a:spcAft>
+                <a:spcPts val="0"/>
+              </a:spcAft>
+            </a:pPr>
+            <a:r>
+              <a:rPr sz="800">
+                <a:solidFill>
+                  <a:srgbClr val="0F172A"/>
+                </a:solidFill>
+                <a:ea typeface="Consolas"/>
+                <a:cs typeface="Consolas"/>
+                <a:latin typeface="Consolas"/>
+              </a:rPr>
+              <a:t>- ტონი: საქმიანი, ინოვაციური და დამაჯერებელი.</a:t>
             </a:r>
           </a:p>
         </p:txBody>
@@ -34795,7 +34867,7 @@
                 <a:cs typeface="Consolas"/>
                 <a:latin typeface="Consolas"/>
               </a:rPr>
-              <a:t>მე ვარ ფინანსისტი. ჩემი იდეაა AI ბუღალტერია მცირე</a:t>
+              <a:t>შენ ხარ სტარტაპ მენტორი და კოპირაიტერი.</a:t>
             </a:r>
           </a:p>
           <a:p>
@@ -34813,7 +34885,7 @@
                 <a:cs typeface="Consolas"/>
                 <a:latin typeface="Consolas"/>
               </a:rPr>
-              <a:t>ბიზნესისთვის.</a:t>
+              <a:t>მე ვარ ფინანსისტი. ჩემი იდეაა "AI ბუღალტერია მცირე</a:t>
             </a:r>
           </a:p>
           <a:p>
@@ -34831,7 +34903,7 @@
                 <a:cs typeface="Consolas"/>
                 <a:latin typeface="Consolas"/>
               </a:rPr>
-              <a:t>დამიწერე 30-წამიანი პრეზენტაციის ტექსტი ქართულად, რომელიც</a:t>
+              <a:t>ბიზნესისთვის" (აპლიკაცია, რომელიც საბანკო ამონაწერებიდან</a:t>
             </a:r>
           </a:p>
           <a:p>
@@ -34849,7 +34921,7 @@
                 <a:cs typeface="Consolas"/>
                 <a:latin typeface="Consolas"/>
               </a:rPr>
-              <a:t>აჩვენებს თუ როგორ ზოგავს მომხმარებელი დროსა და ჯარიმების</a:t>
+              <a:t>ავტომატურად აგენერირებს დეკლარაციებს ინდ. მეწარმეებისთვის).</a:t>
             </a:r>
           </a:p>
           <a:p>
@@ -34867,7 +34939,97 @@
                 <a:cs typeface="Consolas"/>
                 <a:latin typeface="Consolas"/>
               </a:rPr>
-              <a:t>რისკს.</a:t>
+              <a:t>დამიწერე 30-წამიანი Elevator Pitch ქართულად:</a:t>
+            </a:r>
+          </a:p>
+          <a:p>
+            <a:pPr>
+              <a:spcAft>
+                <a:spcPts val="0"/>
+              </a:spcAft>
+            </a:pPr>
+            <a:r>
+              <a:rPr sz="800">
+                <a:solidFill>
+                  <a:srgbClr val="0F172A"/>
+                </a:solidFill>
+                <a:ea typeface="Consolas"/>
+                <a:cs typeface="Consolas"/>
+                <a:latin typeface="Consolas"/>
+              </a:rPr>
+              <a:t>- სტრუქტურა: Hook (დროის კარგვა საგადასახადოზე) -&gt; Solution</a:t>
+            </a:r>
+          </a:p>
+          <a:p>
+            <a:pPr>
+              <a:spcAft>
+                <a:spcPts val="0"/>
+              </a:spcAft>
+            </a:pPr>
+            <a:r>
+              <a:rPr sz="800">
+                <a:solidFill>
+                  <a:srgbClr val="0F172A"/>
+                </a:solidFill>
+                <a:ea typeface="Consolas"/>
+                <a:cs typeface="Consolas"/>
+                <a:latin typeface="Consolas"/>
+              </a:rPr>
+              <a:t>(AI ავტომატიზაცია) -&gt; Value/Ask (დროის 90%-იანი დაზოგვა და</a:t>
+            </a:r>
+          </a:p>
+          <a:p>
+            <a:pPr>
+              <a:spcAft>
+                <a:spcPts val="0"/>
+              </a:spcAft>
+            </a:pPr>
+            <a:r>
+              <a:rPr sz="800">
+                <a:solidFill>
+                  <a:srgbClr val="0F172A"/>
+                </a:solidFill>
+                <a:ea typeface="Consolas"/>
+                <a:cs typeface="Consolas"/>
+                <a:latin typeface="Consolas"/>
+              </a:rPr>
+              <a:t>ჯარიმების 0% რისკი).</a:t>
+            </a:r>
+          </a:p>
+          <a:p>
+            <a:pPr>
+              <a:spcAft>
+                <a:spcPts val="0"/>
+              </a:spcAft>
+            </a:pPr>
+            <a:r>
+              <a:rPr sz="800">
+                <a:solidFill>
+                  <a:srgbClr val="0F172A"/>
+                </a:solidFill>
+                <a:ea typeface="Consolas"/>
+                <a:cs typeface="Consolas"/>
+                <a:latin typeface="Consolas"/>
+              </a:rPr>
+              <a:t>- შეზღუდვა: მაქსიმუმ 70-80 სიტყვა (რათა 30 წამში ჩაეტიოს).</a:t>
+            </a:r>
+          </a:p>
+          <a:p>
+            <a:pPr>
+              <a:spcAft>
+                <a:spcPts val="0"/>
+              </a:spcAft>
+            </a:pPr>
+            <a:r>
+              <a:rPr sz="800">
+                <a:solidFill>
+                  <a:srgbClr val="0F172A"/>
+                </a:solidFill>
+                <a:ea typeface="Consolas"/>
+                <a:cs typeface="Consolas"/>
+                <a:latin typeface="Consolas"/>
+              </a:rPr>
+              <a:t>- ტონი: პროფესიონალური, მარტივი და დამაჯერებელი.</a:t>
             </a:r>
           </a:p>
         </p:txBody>
@@ -46215,7 +46377,7 @@
               </a:spcAft>
             </a:pPr>
             <a:r>
-              <a:rPr sz="1000">
+              <a:rPr sz="800">
                 <a:solidFill>
                   <a:srgbClr val="0F172A"/>
                 </a:solidFill>
@@ -46223,7 +46385,7 @@
                 <a:cs typeface="Consolas"/>
                 <a:latin typeface="Consolas"/>
               </a:rPr>
-              <a:t>მე ვარ ჯანდაცვის სპეციალისტი. ჩემი იდეაა აფთიაქი-დელივერი.</a:t>
+              <a:t>შენ ხარ სტარტაპ მენტორი და კოპირაიტერი.</a:t>
             </a:r>
           </a:p>
           <a:p>
@@ -46233,7 +46395,7 @@
               </a:spcAft>
             </a:pPr>
             <a:r>
-              <a:rPr sz="1000">
+              <a:rPr sz="800">
                 <a:solidFill>
                   <a:srgbClr val="0F172A"/>
                 </a:solidFill>
@@ -46241,7 +46403,7 @@
                 <a:cs typeface="Consolas"/>
                 <a:latin typeface="Consolas"/>
               </a:rPr>
-              <a:t>დამიწერე 30-წამიანი პრეზენტაციის ტექსტი ქართულად, რომელიც</a:t>
+              <a:t>მე ვარ ჯანდაცვის სპეციალისტი. ჩემი იდეაა "აფთიაქი-დელივერი"</a:t>
             </a:r>
           </a:p>
           <a:p>
@@ -46251,7 +46413,7 @@
               </a:spcAft>
             </a:pPr>
             <a:r>
-              <a:rPr sz="1000">
+              <a:rPr sz="800">
                 <a:solidFill>
                   <a:srgbClr val="0F172A"/>
                 </a:solidFill>
@@ -46259,7 +46421,133 @@
                 <a:cs typeface="Consolas"/>
                 <a:latin typeface="Consolas"/>
               </a:rPr>
-              <a:t>ხაზს უსვამს სოციალურ პასუხისმგებლობასა და ოპერატიულობას.</a:t>
+              <a:t>(წამლების მიწოდება სპეციალური ტემპერატურული რეჟიმის დაცვით,</a:t>
+            </a:r>
+          </a:p>
+          <a:p>
+            <a:pPr>
+              <a:spcAft>
+                <a:spcPts val="0"/>
+              </a:spcAft>
+            </a:pPr>
+            <a:r>
+              <a:rPr sz="800">
+                <a:solidFill>
+                  <a:srgbClr val="0F172A"/>
+                </a:solidFill>
+                <a:ea typeface="Consolas"/>
+                <a:cs typeface="Consolas"/>
+                <a:latin typeface="Consolas"/>
+              </a:rPr>
+              <a:t>განსაკუთრებით ქრონიკული პაციენტებისთვის).</a:t>
+            </a:r>
+          </a:p>
+          <a:p>
+            <a:pPr>
+              <a:spcAft>
+                <a:spcPts val="0"/>
+              </a:spcAft>
+            </a:pPr>
+            <a:r>
+              <a:rPr sz="800">
+                <a:solidFill>
+                  <a:srgbClr val="0F172A"/>
+                </a:solidFill>
+                <a:ea typeface="Consolas"/>
+                <a:cs typeface="Consolas"/>
+                <a:latin typeface="Consolas"/>
+              </a:rPr>
+              <a:t>დამიწერე 30-წამიანი Elevator Pitch ქართულად:</a:t>
+            </a:r>
+          </a:p>
+          <a:p>
+            <a:pPr>
+              <a:spcAft>
+                <a:spcPts val="0"/>
+              </a:spcAft>
+            </a:pPr>
+            <a:r>
+              <a:rPr sz="800">
+                <a:solidFill>
+                  <a:srgbClr val="0F172A"/>
+                </a:solidFill>
+                <a:ea typeface="Consolas"/>
+                <a:cs typeface="Consolas"/>
+                <a:latin typeface="Consolas"/>
+              </a:rPr>
+              <a:t>- სტრუქტურა: Hook (წამლების რიგები ხანდაზმულებისთვის) -&gt;</a:t>
+            </a:r>
+          </a:p>
+          <a:p>
+            <a:pPr>
+              <a:spcAft>
+                <a:spcPts val="0"/>
+              </a:spcAft>
+            </a:pPr>
+            <a:r>
+              <a:rPr sz="800">
+                <a:solidFill>
+                  <a:srgbClr val="0F172A"/>
+                </a:solidFill>
+                <a:ea typeface="Consolas"/>
+                <a:cs typeface="Consolas"/>
+                <a:latin typeface="Consolas"/>
+              </a:rPr>
+              <a:t>Solution (რეცეპტების ავტო-გამოწერა + მიწოდება 1 საათში) -&gt;</a:t>
+            </a:r>
+          </a:p>
+          <a:p>
+            <a:pPr>
+              <a:spcAft>
+                <a:spcPts val="0"/>
+              </a:spcAft>
+            </a:pPr>
+            <a:r>
+              <a:rPr sz="800">
+                <a:solidFill>
+                  <a:srgbClr val="0F172A"/>
+                </a:solidFill>
+                <a:ea typeface="Consolas"/>
+                <a:cs typeface="Consolas"/>
+                <a:latin typeface="Consolas"/>
+              </a:rPr>
+              <a:t>Value/Ask (სოციალური პასუხისმგებლობა და ოპერატიულობა).</a:t>
+            </a:r>
+          </a:p>
+          <a:p>
+            <a:pPr>
+              <a:spcAft>
+                <a:spcPts val="0"/>
+              </a:spcAft>
+            </a:pPr>
+            <a:r>
+              <a:rPr sz="800">
+                <a:solidFill>
+                  <a:srgbClr val="0F172A"/>
+                </a:solidFill>
+                <a:ea typeface="Consolas"/>
+                <a:cs typeface="Consolas"/>
+                <a:latin typeface="Consolas"/>
+              </a:rPr>
+              <a:t>- შეზღუდვა: მაქსიმუმ 70-80 სიტყვა (რათა 30 წამში ჩაეტიოს).</a:t>
+            </a:r>
+          </a:p>
+          <a:p>
+            <a:pPr>
+              <a:spcAft>
+                <a:spcPts val="0"/>
+              </a:spcAft>
+            </a:pPr>
+            <a:r>
+              <a:rPr sz="800">
+                <a:solidFill>
+                  <a:srgbClr val="0F172A"/>
+                </a:solidFill>
+                <a:ea typeface="Consolas"/>
+                <a:cs typeface="Consolas"/>
+                <a:latin typeface="Consolas"/>
+              </a:rPr>
+              <a:t>- ტონი: ემპათიური, პროფესიონალური და დამაჯერებელი.</a:t>
             </a:r>
           </a:p>
         </p:txBody>

</xml_diff>

<commit_message>
update Fri 07/17/2026 13:01:38.11
</commit_message>
<xml_diff>
--- a/GITA/Pre-Acceleration/2026-5h-AI-for-Startups/day1-slides.pptx
+++ b/GITA/Pre-Acceleration/2026-5h-AI-for-Startups/day1-slides.pptx
@@ -13480,7 +13480,7 @@
                 <a:cs typeface="Sylfaen"/>
                 <a:latin typeface="Sylfaen"/>
               </a:rPr>
-              <a:t>3:05 - 4:00: Lean Canvas &amp; VPC Validation</a:t>
+              <a:t>3:05 - 4:25: Lean Canvas &amp; VPC Validation</a:t>
             </a:r>
           </a:p>
           <a:p>
@@ -13509,7 +13509,7 @@
                 <a:cs typeface="Sylfaen"/>
                 <a:latin typeface="Sylfaen"/>
               </a:rPr>
-              <a:t>4:00 - 5:00: Wrap-up + Homework Setup</a:t>
+              <a:t>4:25 - 5:00: Wrap-up + Homework Setup</a:t>
             </a:r>
           </a:p>
         </p:txBody>

</xml_diff>

<commit_message>
update Fri 07/17/2026 20:23:16.68
</commit_message>
<xml_diff>
--- a/GITA/Pre-Acceleration/2026-5h-AI-for-Startups/day1-slides.pptx
+++ b/GITA/Pre-Acceleration/2026-5h-AI-for-Startups/day1-slides.pptx
@@ -9794,7 +9794,7 @@
                 <a:cs typeface="Sylfaen"/>
                 <a:latin typeface="Sylfaen"/>
               </a:rPr>
-              <a:t>Day 1: Goals &amp; Deliverables</a:t>
+              <a:t>Day 1: Goals &amp; Deliverables / დღე 1: მიზნები და შედეგები</a:t>
             </a:r>
           </a:p>
         </p:txBody>
@@ -10583,7 +10583,7 @@
                 <a:cs typeface="Sylfaen"/>
                 <a:latin typeface="Sylfaen"/>
               </a:rPr>
-              <a:t>Myth 1: Innovation requires uniqueness</a:t>
+              <a:t>Myth 1: Innovation requires uniqueness / მითი 1: ინოვაცია მოითხოვს უნიკალურობას</a:t>
             </a:r>
           </a:p>
         </p:txBody>
@@ -11395,7 +11395,7 @@
                 <a:cs typeface="Sylfaen"/>
                 <a:latin typeface="Sylfaen"/>
               </a:rPr>
-              <a:t>Myth 2: MVP requires developers</a:t>
+              <a:t>Myth 2: MVP requires developers / მითი 2: MVP მოითხოვს დეველოპერებს</a:t>
             </a:r>
           </a:p>
         </p:txBody>
@@ -12207,7 +12207,7 @@
                 <a:cs typeface="Sylfaen"/>
                 <a:latin typeface="Sylfaen"/>
               </a:rPr>
-              <a:t>Myth 3: High budget is essential</a:t>
+              <a:t>Myth 3: High budget is essential / მითი 3: მაღალი ბიუჯეტი აუცილებელია</a:t>
             </a:r>
           </a:p>
         </p:txBody>
@@ -13019,7 +13019,7 @@
                 <a:cs typeface="Sylfaen"/>
                 <a:latin typeface="Sylfaen"/>
               </a:rPr>
-              <a:t>Welcome &amp; Agenda</a:t>
+              <a:t>Welcome &amp; Agenda / მისალმება და დღის წესრიგი</a:t>
             </a:r>
           </a:p>
         </p:txBody>
@@ -14052,7 +14052,7 @@
                 <a:cs typeface="Sylfaen"/>
                 <a:latin typeface="Sylfaen"/>
               </a:rPr>
-              <a:t>AI Strategy: 10x Experimentation Speed</a:t>
+              <a:t>AI Strategy: 10x Experimentation Speed / AI სტრატეგია: 10x ექსპერიმენტების სიჩქარე</a:t>
             </a:r>
           </a:p>
         </p:txBody>
@@ -15009,7 +15009,7 @@
                 <a:cs typeface="Sylfaen"/>
                 <a:latin typeface="Sylfaen"/>
               </a:rPr>
-              <a:t>AI Strategy: Cost Minimization</a:t>
+              <a:t>AI Strategy: Cost Minimization / AI სტრატეგია: ხარჯების მინიმიზაცია</a:t>
             </a:r>
           </a:p>
         </p:txBody>
@@ -15985,7 +15985,7 @@
                 <a:cs typeface="Sylfaen"/>
                 <a:latin typeface="Sylfaen"/>
               </a:rPr>
-              <a:t>AI Tools: Safety Ratings Matrix</a:t>
+              <a:t>AI Tools: Safety Ratings Matrix / AI ინსტრუმენტების უსაფრთხოების რეიტინგი</a:t>
             </a:r>
           </a:p>
         </p:txBody>
@@ -16834,7 +16834,7 @@
                 <a:cs typeface="Sylfaen"/>
                 <a:latin typeface="Sylfaen"/>
               </a:rPr>
-              <a:t>AI Tools: Data Leakage Protection</a:t>
+              <a:t>AI Tools: Data Leakage Protection / AI ინსტრუმენტები: გაჟონვისგან დაცვა</a:t>
             </a:r>
           </a:p>
         </p:txBody>
@@ -17490,7 +17490,7 @@
                 <a:cs typeface="Sylfaen"/>
                 <a:latin typeface="Sylfaen"/>
               </a:rPr>
-              <a:t>Divergent Thinking: Ideation Flow</a:t>
+              <a:t>Divergent Thinking: Ideation Flow / დივერგენტული აზროვნება: იდეების გენერაცია</a:t>
             </a:r>
           </a:p>
         </p:txBody>
@@ -18369,7 +18369,7 @@
                 <a:cs typeface="Sylfaen"/>
                 <a:latin typeface="Sylfaen"/>
               </a:rPr>
-              <a:t>Convergent Thinking: Pruning &amp; Selection</a:t>
+              <a:t>Convergent Thinking: Pruning &amp; Selection / კონვერგენტული აზროვნება: იდეების შერჩევა</a:t>
             </a:r>
           </a:p>
         </p:txBody>
@@ -23086,7 +23086,7 @@
                 <a:cs typeface="Sylfaen"/>
                 <a:latin typeface="Sylfaen"/>
               </a:rPr>
-              <a:t>5 Whys: Deep Root-Cause Analysis</a:t>
+              <a:t>5 Whys: Deep Root-Cause Analysis / 5 რატომ: ფესვური მიზეზების ანალიზი</a:t>
             </a:r>
           </a:p>
         </p:txBody>
@@ -23841,7 +23841,7 @@
                 <a:cs typeface="Sylfaen"/>
                 <a:latin typeface="Sylfaen"/>
               </a:rPr>
-              <a:t>Welcome Showcase - AgriTech Focus</a:t>
+              <a:t>Welcome Showcase / AgriTech პროექტები</a:t>
             </a:r>
           </a:p>
         </p:txBody>
@@ -24833,7 +24833,7 @@
                 <a:cs typeface="Sylfaen"/>
                 <a:latin typeface="Sylfaen"/>
               </a:rPr>
-              <a:t>What If: Blue Ocean Opportunity Prompts</a:t>
+              <a:t>What If: Blue Ocean Opportunity Prompts / What If: ლურჯი ოკეანის პრომპტები</a:t>
             </a:r>
           </a:p>
         </p:txBody>
@@ -27648,7 +27648,7 @@
                 <a:cs typeface="Sylfaen"/>
                 <a:latin typeface="Sylfaen"/>
               </a:rPr>
-              <a:t>Jobs-to-be-Done (JTBD): Milkshake Story</a:t>
+              <a:t>Jobs-to-be-Done (JTBD): Milkshake Story / JTBD მეთოდოლოგია: Milkshake-ის ქეისი</a:t>
             </a:r>
           </a:p>
         </p:txBody>
@@ -28450,7 +28450,7 @@
                 <a:cs typeface="Sylfaen"/>
                 <a:latin typeface="Sylfaen"/>
               </a:rPr>
-              <a:t>Jobs-to-be-Done (JTBD): Formula &amp; Examples</a:t>
+              <a:t>Jobs-to-be-Done (JTBD): Formula &amp; Examples / JTBD ფორმულა და მაგალითები</a:t>
             </a:r>
           </a:p>
         </p:txBody>
@@ -35874,7 +35874,7 @@
                 <a:cs typeface="Sylfaen"/>
                 <a:latin typeface="Sylfaen"/>
               </a:rPr>
-              <a:t>Welcome Showcase - FinTech Focus</a:t>
+              <a:t>Welcome Showcase / FinTech პროექტები</a:t>
             </a:r>
           </a:p>
         </p:txBody>
@@ -41249,7 +41249,7 @@
                 <a:cs typeface="Sylfaen"/>
                 <a:latin typeface="Sylfaen"/>
               </a:rPr>
-              <a:t>Value Proposition Canvas: Customer Profile</a:t>
+              <a:t>Value Proposition Canvas: Customer Profile / მომხმარებლის პროფილი</a:t>
             </a:r>
           </a:p>
         </p:txBody>
@@ -42920,7 +42920,7 @@
                 <a:cs typeface="Sylfaen"/>
                 <a:latin typeface="Sylfaen"/>
               </a:rPr>
-              <a:t>The Mom Test: Do's vs. Don'ts</a:t>
+              <a:t>The Mom Test: Do's vs. Don'ts / The Mom Test: კარგი და ცუდი კითხვები</a:t>
             </a:r>
           </a:p>
         </p:txBody>
@@ -45007,7 +45007,7 @@
                 <a:cs typeface="Sylfaen"/>
                 <a:latin typeface="Sylfaen"/>
               </a:rPr>
-              <a:t>Value Proposition Canvas: Value Map Alignment</a:t>
+              <a:t>Value Proposition Canvas: Value Map Alignment / ღირებულების რუკის შესაბამისობა</a:t>
             </a:r>
           </a:p>
         </p:txBody>
@@ -46814,7 +46814,7 @@
                 <a:cs typeface="Sylfaen"/>
                 <a:latin typeface="Sylfaen"/>
               </a:rPr>
-              <a:t>Welcome Showcase - HealthTech Focus</a:t>
+              <a:t>Welcome Showcase / HealthTech პროექტები</a:t>
             </a:r>
           </a:p>
         </p:txBody>
@@ -47824,7 +47824,7 @@
                 <a:cs typeface="Sylfaen"/>
                 <a:latin typeface="Sylfaen"/>
               </a:rPr>
-              <a:t>Lean Canvas: Blocks 1-3 &amp; The Golden Thread</a:t>
+              <a:t>Lean Canvas: Blocks 1-3 &amp; The Golden Thread / Lean Canvas-ის პირველი 3 ბლოკი</a:t>
             </a:r>
           </a:p>
         </p:txBody>
@@ -48759,7 +48759,7 @@
                 <a:cs typeface="Sylfaen"/>
                 <a:latin typeface="Sylfaen"/>
               </a:rPr>
-              <a:t>Lean Canvas: Blocks 4-6</a:t>
+              <a:t>Lean Canvas: Blocks 4-6 / Lean Canvas-ის 4-6 ბლოკები</a:t>
             </a:r>
           </a:p>
         </p:txBody>
@@ -49694,7 +49694,7 @@
                 <a:cs typeface="Sylfaen"/>
                 <a:latin typeface="Sylfaen"/>
               </a:rPr>
-              <a:t>Lean Canvas: Blocks 7-9</a:t>
+              <a:t>Lean Canvas: Blocks 7-9 / Lean Canvas-ის 7-9 ბლოკები</a:t>
             </a:r>
           </a:p>
         </p:txBody>
@@ -56827,7 +56827,7 @@
                 <a:cs typeface="Sylfaen"/>
                 <a:latin typeface="Sylfaen"/>
               </a:rPr>
-              <a:t>AI-Powered Smoke Testing &amp; UVP ვალიდაცია</a:t>
+              <a:t>AI-Powered Smoke Testing &amp; UVP ვალიდაცია / Smoke ტესტირება და UVP-ის შემოწმება</a:t>
             </a:r>
           </a:p>
         </p:txBody>
@@ -62133,7 +62133,7 @@
                 <a:cs typeface="Sylfaen"/>
                 <a:latin typeface="Sylfaen"/>
               </a:rPr>
-              <a:t>Homework Part A Guidelines</a:t>
+              <a:t>Homework Part A Guidelines / საშინაო დავალება: ნაწილი A</a:t>
             </a:r>
           </a:p>
         </p:txBody>
@@ -62830,7 +62830,7 @@
                 <a:cs typeface="Sylfaen"/>
                 <a:latin typeface="Sylfaen"/>
               </a:rPr>
-              <a:t>Day 1 Wrap-up &amp; Checklist</a:t>
+              <a:t>Day 1 Wrap-up &amp; Checklist / დღე 1: შეჯამება და საკონტროლო სია</a:t>
             </a:r>
           </a:p>
         </p:txBody>
@@ -63806,7 +63806,7 @@
                 <a:cs typeface="Sylfaen"/>
                 <a:latin typeface="Sylfaen"/>
               </a:rPr>
-              <a:t>30-30-30 Pitch Rules</a:t>
+              <a:t>30-30-30 Pitch Rules / პრეზენტაციის წესები</a:t>
             </a:r>
           </a:p>
         </p:txBody>
@@ -64705,7 +64705,7 @@
                 <a:cs typeface="Sylfaen"/>
                 <a:latin typeface="Sylfaen"/>
               </a:rPr>
-              <a:t>Elevator Pitch Formula</a:t>
+              <a:t>Elevator Pitch Formula / ლიფტის პრეზენტაციის ფორმულა</a:t>
             </a:r>
           </a:p>
         </p:txBody>
@@ -65538,7 +65538,7 @@
                 <a:cs typeface="Sylfaen"/>
                 <a:latin typeface="Sylfaen"/>
               </a:rPr>
-              <a:t>Elevator Pitch Sector Examples</a:t>
+              <a:t>Elevator Pitch Sector Examples / ლიფტის პრეზენტაცია: მაგალითები</a:t>
             </a:r>
           </a:p>
         </p:txBody>

</xml_diff>

<commit_message>
update Fri 07/17/2026 20:26:13.28
</commit_message>
<xml_diff>
--- a/GITA/Pre-Acceleration/2026-5h-AI-for-Startups/day1-slides.pptx
+++ b/GITA/Pre-Acceleration/2026-5h-AI-for-Startups/day1-slides.pptx
@@ -8436,7 +8436,7 @@
                 <a:cs typeface="Sylfaen"/>
                 <a:latin typeface="Sylfaen"/>
               </a:rPr>
-              <a:t>გახსენით Claude ან ChatGPT ;</a:t>
+              <a:t>გახსენით Claude , ChatGPT ან Gemini ;</a:t>
             </a:r>
           </a:p>
           <a:p>
@@ -12748,7 +12748,7 @@
                 <a:cs typeface="Sylfaen"/>
                 <a:latin typeface="Sylfaen"/>
               </a:rPr>
-              <a:t>AI ხელსაწყოების (Claude, Perplexity, Gamma, Make) უფასო ვერსიებით შეგიძლიათ სრულიად უფასოდ ჩაატაროთ კვლევა, შექმნათ ვიზუალური ბრენდი და მოიზიდოთ პირველი მომხმარებლები.</a:t>
+              <a:t>AI ხელსაწყოების (Claude, Gemini, Perplexity, Gamma, Make) უფასო ვერსიებით შეგიძლიათ სრულიად უფასოდ ჩაატაროთ კვლევა, შექმნათ ვიზუალური ბრენდი და მოიზიდოთ პირველი მომხმარებლები.</a:t>
             </a:r>
           </a:p>
         </p:txBody>
@@ -14208,7 +14208,7 @@
         <p:spPr>
           <a:xfrm>
             <a:off x="457200" y="1737360"/>
-            <a:ext cx="54864" cy="2734056"/>
+            <a:ext cx="54864" cy="3008375"/>
           </a:xfrm>
           <a:prstGeom prst="rect">
             <a:avLst/>
@@ -14252,7 +14252,7 @@
         <p:spPr>
           <a:xfrm>
             <a:off x="512064" y="1737360"/>
-            <a:ext cx="3991356" cy="2734056"/>
+            <a:ext cx="3991356" cy="3008375"/>
           </a:xfrm>
           <a:prstGeom prst="roundRect">
             <a:avLst>
@@ -14480,7 +14480,7 @@
         <p:spPr>
           <a:xfrm>
             <a:off x="4640580" y="1737360"/>
-            <a:ext cx="54864" cy="2734056"/>
+            <a:ext cx="54864" cy="3008375"/>
           </a:xfrm>
           <a:prstGeom prst="rect">
             <a:avLst/>
@@ -14524,7 +14524,7 @@
         <p:spPr>
           <a:xfrm>
             <a:off x="4695444" y="1737360"/>
-            <a:ext cx="3991356" cy="2734056"/>
+            <a:ext cx="3991356" cy="3008375"/>
           </a:xfrm>
           <a:prstGeom prst="roundRect">
             <a:avLst>
@@ -14613,7 +14613,7 @@
         <p:spPr>
           <a:xfrm>
             <a:off x="4805172" y="2203704"/>
-            <a:ext cx="3771900" cy="1865376"/>
+            <a:ext cx="3771900" cy="2139696"/>
           </a:xfrm>
           <a:prstGeom prst="rect">
             <a:avLst/>
@@ -14709,7 +14709,7 @@
                 <a:cs typeface="Sylfaen"/>
                 <a:latin typeface="Sylfaen"/>
               </a:rPr>
-              <a:t>კოპირაითინგი Claude-ით (10 წუთი);</a:t>
+              <a:t>კოპირაითინგი Claude-ით/Gemini-ით (10 წუთი);</a:t>
             </a:r>
           </a:p>
           <a:p>
@@ -16376,7 +16376,7 @@
                           <a:cs typeface="Sylfaen"/>
                           <a:latin typeface="Sylfaen"/>
                         </a:rPr>
-                        <a:t>Claude / Perplexity</a:t>
+                        <a:t>Claude / Gemini / Perplexity</a:t>
                       </a:r>
                     </a:p>
                   </a:txBody>
@@ -17161,7 +17161,7 @@
                 <a:cs typeface="Sylfaen"/>
                 <a:latin typeface="Sylfaen"/>
               </a:rPr>
-              <a:t>გათიშეთ Training პარამეტრი: ChatGPT-ისა და Claude-ის პარამეტრებში გათიშეთ „Improve model for everyone“;</a:t>
+              <a:t>გათიშეთ Training პარამეტრი: ChatGPT-ის, Claude-ისა და Gemini-ს პარამეტრებში გათიშეთ „Improve model for everyone“;</a:t>
             </a:r>
           </a:p>
           <a:p>
@@ -21786,7 +21786,7 @@
                 <a:cs typeface="Sylfaen"/>
                 <a:latin typeface="Sylfaen"/>
               </a:rPr>
-              <a:t>გახსენით Claude ან ChatGPT და შეიყვანეთ ქვემოთ მოცემული პრომპტი;</a:t>
+              <a:t>გახსენით Claude , ChatGPT ან Gemini და შეიყვანეთ ქვემოთ მოცემული პრომპტი;</a:t>
             </a:r>
           </a:p>
           <a:p>
@@ -22420,6 +22420,330 @@
                 <a:latin typeface="Consolas"/>
               </a:rPr>
               <a:t>იდეა].</a:t>
+            </a:r>
+          </a:p>
+          <a:p>
+            <a:pPr>
+              <a:spcAft>
+                <a:spcPts val="0"/>
+              </a:spcAft>
+            </a:pPr>
+            <a:r>
+              <a:rPr sz="1000">
+                <a:solidFill>
+                  <a:srgbClr val="0F172A"/>
+                </a:solidFill>
+                <a:ea typeface="Consolas"/>
+                <a:cs typeface="Consolas"/>
+                <a:latin typeface="Consolas"/>
+              </a:rPr>
+              <a:t>*(მაგალითად:</a:t>
+            </a:r>
+          </a:p>
+          <a:p>
+            <a:pPr>
+              <a:spcAft>
+                <a:spcPts val="0"/>
+              </a:spcAft>
+            </a:pPr>
+            <a:r>
+              <a:rPr sz="1000">
+                <a:solidFill>
+                  <a:srgbClr val="0F172A"/>
+                </a:solidFill>
+                <a:ea typeface="Consolas"/>
+                <a:cs typeface="Consolas"/>
+                <a:latin typeface="Consolas"/>
+              </a:rPr>
+              <a:t>- 🏥 Team 1 (მედიკამენტების</a:t>
+            </a:r>
+          </a:p>
+          <a:p>
+            <a:pPr>
+              <a:spcAft>
+                <a:spcPts val="0"/>
+              </a:spcAft>
+            </a:pPr>
+            <a:r>
+              <a:rPr sz="1000">
+                <a:solidFill>
+                  <a:srgbClr val="0F172A"/>
+                </a:solidFill>
+                <a:ea typeface="Consolas"/>
+                <a:cs typeface="Consolas"/>
+                <a:latin typeface="Consolas"/>
+              </a:rPr>
+              <a:t>მიტანა): "Substitute -</a:t>
+            </a:r>
+          </a:p>
+          <a:p>
+            <a:pPr>
+              <a:spcAft>
+                <a:spcPts val="0"/>
+              </a:spcAft>
+            </a:pPr>
+            <a:r>
+              <a:rPr sz="1000">
+                <a:solidFill>
+                  <a:srgbClr val="0F172A"/>
+                </a:solidFill>
+                <a:ea typeface="Consolas"/>
+                <a:cs typeface="Consolas"/>
+                <a:latin typeface="Consolas"/>
+              </a:rPr>
+              <a:t>დისტრიბუტორების ჩანაცვლება</a:t>
+            </a:r>
+          </a:p>
+          <a:p>
+            <a:pPr>
+              <a:spcAft>
+                <a:spcPts val="0"/>
+              </a:spcAft>
+            </a:pPr>
+            <a:r>
+              <a:rPr sz="1000">
+                <a:solidFill>
+                  <a:srgbClr val="0F172A"/>
+                </a:solidFill>
+                <a:ea typeface="Consolas"/>
+                <a:cs typeface="Consolas"/>
+                <a:latin typeface="Consolas"/>
+              </a:rPr>
+              <a:t>ლოკალური აფთიაქების</a:t>
+            </a:r>
+          </a:p>
+          <a:p>
+            <a:pPr>
+              <a:spcAft>
+                <a:spcPts val="0"/>
+              </a:spcAft>
+            </a:pPr>
+            <a:r>
+              <a:rPr sz="1000">
+                <a:solidFill>
+                  <a:srgbClr val="0F172A"/>
+                </a:solidFill>
+                <a:ea typeface="Consolas"/>
+                <a:cs typeface="Consolas"/>
+                <a:latin typeface="Consolas"/>
+              </a:rPr>
+              <a:t>ქსელით"</a:t>
+            </a:r>
+          </a:p>
+          <a:p>
+            <a:pPr>
+              <a:spcAft>
+                <a:spcPts val="0"/>
+              </a:spcAft>
+            </a:pPr>
+            <a:r>
+              <a:rPr sz="1000">
+                <a:solidFill>
+                  <a:srgbClr val="0F172A"/>
+                </a:solidFill>
+                <a:ea typeface="Consolas"/>
+                <a:cs typeface="Consolas"/>
+                <a:latin typeface="Consolas"/>
+              </a:rPr>
+              <a:t>- 🎒 Team 6 (SPARK AI</a:t>
+            </a:r>
+          </a:p>
+          <a:p>
+            <a:pPr>
+              <a:spcAft>
+                <a:spcPts val="0"/>
+              </a:spcAft>
+            </a:pPr>
+            <a:r>
+              <a:rPr sz="1000">
+                <a:solidFill>
+                  <a:srgbClr val="0F172A"/>
+                </a:solidFill>
+                <a:ea typeface="Consolas"/>
+                <a:cs typeface="Consolas"/>
+                <a:latin typeface="Consolas"/>
+              </a:rPr>
+              <a:t>საზღვარგარეთ სწავლა):</a:t>
+            </a:r>
+          </a:p>
+          <a:p>
+            <a:pPr>
+              <a:spcAft>
+                <a:spcPts val="0"/>
+              </a:spcAft>
+            </a:pPr>
+            <a:r>
+              <a:rPr sz="1000">
+                <a:solidFill>
+                  <a:srgbClr val="0F172A"/>
+                </a:solidFill>
+                <a:ea typeface="Consolas"/>
+                <a:cs typeface="Consolas"/>
+                <a:latin typeface="Consolas"/>
+              </a:rPr>
+              <a:t>"Combine - საუნივერსიტეტო</a:t>
+            </a:r>
+          </a:p>
+          <a:p>
+            <a:pPr>
+              <a:spcAft>
+                <a:spcPts val="0"/>
+              </a:spcAft>
+            </a:pPr>
+            <a:r>
+              <a:rPr sz="1000">
+                <a:solidFill>
+                  <a:srgbClr val="0F172A"/>
+                </a:solidFill>
+                <a:ea typeface="Consolas"/>
+                <a:cs typeface="Consolas"/>
+                <a:latin typeface="Consolas"/>
+              </a:rPr>
+              <a:t>გზამკვლევისა და ფინანსური</a:t>
+            </a:r>
+          </a:p>
+          <a:p>
+            <a:pPr>
+              <a:spcAft>
+                <a:spcPts val="0"/>
+              </a:spcAft>
+            </a:pPr>
+            <a:r>
+              <a:rPr sz="1000">
+                <a:solidFill>
+                  <a:srgbClr val="0F172A"/>
+                </a:solidFill>
+                <a:ea typeface="Consolas"/>
+                <a:cs typeface="Consolas"/>
+                <a:latin typeface="Consolas"/>
+              </a:rPr>
+              <a:t>გრანტების კალკულატორის</a:t>
+            </a:r>
+          </a:p>
+          <a:p>
+            <a:pPr>
+              <a:spcAft>
+                <a:spcPts val="0"/>
+              </a:spcAft>
+            </a:pPr>
+            <a:r>
+              <a:rPr sz="1000">
+                <a:solidFill>
+                  <a:srgbClr val="0F172A"/>
+                </a:solidFill>
+                <a:ea typeface="Consolas"/>
+                <a:cs typeface="Consolas"/>
+                <a:latin typeface="Consolas"/>
+              </a:rPr>
+              <a:t>გაერთიანება"</a:t>
+            </a:r>
+          </a:p>
+          <a:p>
+            <a:pPr>
+              <a:spcAft>
+                <a:spcPts val="0"/>
+              </a:spcAft>
+            </a:pPr>
+            <a:r>
+              <a:rPr sz="1000">
+                <a:solidFill>
+                  <a:srgbClr val="0F172A"/>
+                </a:solidFill>
+                <a:ea typeface="Consolas"/>
+                <a:cs typeface="Consolas"/>
+                <a:latin typeface="Consolas"/>
+              </a:rPr>
+              <a:t>- 🛡️ Team 9 (Scutum</a:t>
+            </a:r>
+          </a:p>
+          <a:p>
+            <a:pPr>
+              <a:spcAft>
+                <a:spcPts val="0"/>
+              </a:spcAft>
+            </a:pPr>
+            <a:r>
+              <a:rPr sz="1000">
+                <a:solidFill>
+                  <a:srgbClr val="0F172A"/>
+                </a:solidFill>
+                <a:ea typeface="Consolas"/>
+                <a:cs typeface="Consolas"/>
+                <a:latin typeface="Consolas"/>
+              </a:rPr>
+              <a:t>სამოგზაურო ასისტენტი):</a:t>
+            </a:r>
+          </a:p>
+          <a:p>
+            <a:pPr>
+              <a:spcAft>
+                <a:spcPts val="0"/>
+              </a:spcAft>
+            </a:pPr>
+            <a:r>
+              <a:rPr sz="1000">
+                <a:solidFill>
+                  <a:srgbClr val="0F172A"/>
+                </a:solidFill>
+                <a:ea typeface="Consolas"/>
+                <a:cs typeface="Consolas"/>
+                <a:latin typeface="Consolas"/>
+              </a:rPr>
+              <a:t>"Adapt - Tinder-ის Swipe</a:t>
+            </a:r>
+          </a:p>
+          <a:p>
+            <a:pPr>
+              <a:spcAft>
+                <a:spcPts val="0"/>
+              </a:spcAft>
+            </a:pPr>
+            <a:r>
+              <a:rPr sz="1000">
+                <a:solidFill>
+                  <a:srgbClr val="0F172A"/>
+                </a:solidFill>
+                <a:ea typeface="Consolas"/>
+                <a:cs typeface="Consolas"/>
+                <a:latin typeface="Consolas"/>
+              </a:rPr>
+              <a:t>ლოგიკის მორგება უსაფრთხო</a:t>
+            </a:r>
+          </a:p>
+          <a:p>
+            <a:pPr>
+              <a:spcAft>
+                <a:spcPts val="0"/>
+              </a:spcAft>
+            </a:pPr>
+            <a:r>
+              <a:rPr sz="1000">
+                <a:solidFill>
+                  <a:srgbClr val="0F172A"/>
+                </a:solidFill>
+                <a:ea typeface="Consolas"/>
+                <a:cs typeface="Consolas"/>
+                <a:latin typeface="Consolas"/>
+              </a:rPr>
+              <a:t>მარშრუტების შერჩევაზე")*</a:t>
+            </a:r>
+          </a:p>
+          <a:p>
+            <a:pPr>
+              <a:spcAft>
+                <a:spcPts val="0"/>
+              </a:spcAft>
+            </a:pPr>
+            <a:r>
+              <a:rPr sz="1000">
+                <a:solidFill>
+                  <a:srgbClr val="0F172A"/>
+                </a:solidFill>
+                <a:ea typeface="Consolas"/>
+                <a:cs typeface="Consolas"/>
+                <a:latin typeface="Consolas"/>
+              </a:rPr>
+              <a:t> </a:t>
             </a:r>
           </a:p>
           <a:p>
@@ -29712,7 +30036,7 @@
                 <a:cs typeface="Sylfaen"/>
                 <a:latin typeface="Sylfaen"/>
               </a:rPr>
-              <a:t>გახსენით Claude ან ChatGPT ;</a:t>
+              <a:t>გახსენით Claude , ChatGPT ან Gemini ;</a:t>
             </a:r>
           </a:p>
           <a:p>
@@ -38373,7 +38697,7 @@
                 <a:cs typeface="Sylfaen"/>
                 <a:latin typeface="Sylfaen"/>
               </a:rPr>
-              <a:t>🚀 საცდელი პრომპტი ChatGPT/Claude-ისთვის:</a:t>
+              <a:t>🚀 საცდელი პრომპტი ChatGPT/Claude/Gemini-სთვის:</a:t>
             </a:r>
           </a:p>
         </p:txBody>
@@ -43894,7 +44218,7 @@
                 <a:cs typeface="Sylfaen"/>
                 <a:latin typeface="Sylfaen"/>
               </a:rPr>
-              <a:t>გახსენით Claude ან ChatGPT ;</a:t>
+              <a:t>გახსენით Claude , ChatGPT ან Gemini ;</a:t>
             </a:r>
           </a:p>
           <a:p>
@@ -50956,7 +51280,7 @@
                 <a:cs typeface="Sylfaen"/>
                 <a:latin typeface="Sylfaen"/>
               </a:rPr>
-              <a:t>აირჩიეთ საუკეთესო იდეა და გახსენით Claude ან ChatGPT ;</a:t>
+              <a:t>აირჩიეთ საუკეთესო იდეა და გახსენით Claude , ChatGPT ან Gemini ;</a:t>
             </a:r>
           </a:p>
           <a:p>
@@ -52342,7 +52666,7 @@
                 <a:cs typeface="Sylfaen"/>
                 <a:latin typeface="Sylfaen"/>
               </a:rPr>
-              <a:t>გახსენით Claude ან ChatGPT ;</a:t>
+              <a:t>გახსენით Claude , ChatGPT ან Gemini ;</a:t>
             </a:r>
           </a:p>
           <a:p>
@@ -52971,6 +53295,186 @@
                 <a:latin typeface="Consolas"/>
               </a:rPr>
               <a:t>და სამიზნე აუდიტორია].</a:t>
+            </a:r>
+          </a:p>
+          <a:p>
+            <a:pPr>
+              <a:spcAft>
+                <a:spcPts val="0"/>
+              </a:spcAft>
+            </a:pPr>
+            <a:r>
+              <a:rPr sz="1000">
+                <a:solidFill>
+                  <a:srgbClr val="0F172A"/>
+                </a:solidFill>
+                <a:ea typeface="Consolas"/>
+                <a:cs typeface="Consolas"/>
+                <a:latin typeface="Consolas"/>
+              </a:rPr>
+              <a:t>*(მაგალითად:</a:t>
+            </a:r>
+          </a:p>
+          <a:p>
+            <a:pPr>
+              <a:spcAft>
+                <a:spcPts val="0"/>
+              </a:spcAft>
+            </a:pPr>
+            <a:r>
+              <a:rPr sz="1000">
+                <a:solidFill>
+                  <a:srgbClr val="0F172A"/>
+                </a:solidFill>
+                <a:ea typeface="Consolas"/>
+                <a:cs typeface="Consolas"/>
+                <a:latin typeface="Consolas"/>
+              </a:rPr>
+              <a:t>- ⚖️ Team 4 (Legal AI):</a:t>
+            </a:r>
+          </a:p>
+          <a:p>
+            <a:pPr>
+              <a:spcAft>
+                <a:spcPts val="0"/>
+              </a:spcAft>
+            </a:pPr>
+            <a:r>
+              <a:rPr sz="1000">
+                <a:solidFill>
+                  <a:srgbClr val="0F172A"/>
+                </a:solidFill>
+                <a:ea typeface="Consolas"/>
+                <a:cs typeface="Consolas"/>
+                <a:latin typeface="Consolas"/>
+              </a:rPr>
+              <a:t>"იურიდიული ასისტენტი,</a:t>
+            </a:r>
+          </a:p>
+          <a:p>
+            <a:pPr>
+              <a:spcAft>
+                <a:spcPts val="0"/>
+              </a:spcAft>
+            </a:pPr>
+            <a:r>
+              <a:rPr sz="1000">
+                <a:solidFill>
+                  <a:srgbClr val="0F172A"/>
+                </a:solidFill>
+                <a:ea typeface="Consolas"/>
+                <a:cs typeface="Consolas"/>
+                <a:latin typeface="Consolas"/>
+              </a:rPr>
+              <a:t>რომელიც ქმნის კონტრაქტებს</a:t>
+            </a:r>
+          </a:p>
+          <a:p>
+            <a:pPr>
+              <a:spcAft>
+                <a:spcPts val="0"/>
+              </a:spcAft>
+            </a:pPr>
+            <a:r>
+              <a:rPr sz="1000">
+                <a:solidFill>
+                  <a:srgbClr val="0F172A"/>
+                </a:solidFill>
+                <a:ea typeface="Consolas"/>
+                <a:cs typeface="Consolas"/>
+                <a:latin typeface="Consolas"/>
+              </a:rPr>
+              <a:t>ქართულ ენაზე"</a:t>
+            </a:r>
+          </a:p>
+          <a:p>
+            <a:pPr>
+              <a:spcAft>
+                <a:spcPts val="0"/>
+              </a:spcAft>
+            </a:pPr>
+            <a:r>
+              <a:rPr sz="1000">
+                <a:solidFill>
+                  <a:srgbClr val="0F172A"/>
+                </a:solidFill>
+                <a:ea typeface="Consolas"/>
+                <a:cs typeface="Consolas"/>
+                <a:latin typeface="Consolas"/>
+              </a:rPr>
+              <a:t>- 🛡️ Team 5 (Compliance</a:t>
+            </a:r>
+          </a:p>
+          <a:p>
+            <a:pPr>
+              <a:spcAft>
+                <a:spcPts val="0"/>
+              </a:spcAft>
+            </a:pPr>
+            <a:r>
+              <a:rPr sz="1000">
+                <a:solidFill>
+                  <a:srgbClr val="0F172A"/>
+                </a:solidFill>
+                <a:ea typeface="Consolas"/>
+                <a:cs typeface="Consolas"/>
+                <a:latin typeface="Consolas"/>
+              </a:rPr>
+              <a:t>Copilot): "AI პლატფორმა</a:t>
+            </a:r>
+          </a:p>
+          <a:p>
+            <a:pPr>
+              <a:spcAft>
+                <a:spcPts val="0"/>
+              </a:spcAft>
+            </a:pPr>
+            <a:r>
+              <a:rPr sz="1000">
+                <a:solidFill>
+                  <a:srgbClr val="0F172A"/>
+                </a:solidFill>
+                <a:ea typeface="Consolas"/>
+                <a:cs typeface="Consolas"/>
+                <a:latin typeface="Consolas"/>
+              </a:rPr>
+              <a:t>ფინანსური კომპლაენსის</a:t>
+            </a:r>
+          </a:p>
+          <a:p>
+            <a:pPr>
+              <a:spcAft>
+                <a:spcPts val="0"/>
+              </a:spcAft>
+            </a:pPr>
+            <a:r>
+              <a:rPr sz="1000">
+                <a:solidFill>
+                  <a:srgbClr val="0F172A"/>
+                </a:solidFill>
+                <a:ea typeface="Consolas"/>
+                <a:cs typeface="Consolas"/>
+                <a:latin typeface="Consolas"/>
+              </a:rPr>
+              <a:t>AML/CFT რეგულაციებისთვის</a:t>
+            </a:r>
+          </a:p>
+          <a:p>
+            <a:pPr>
+              <a:spcAft>
+                <a:spcPts val="0"/>
+              </a:spcAft>
+            </a:pPr>
+            <a:r>
+              <a:rPr sz="1000">
+                <a:solidFill>
+                  <a:srgbClr val="0F172A"/>
+                </a:solidFill>
+                <a:ea typeface="Consolas"/>
+                <a:cs typeface="Consolas"/>
+                <a:latin typeface="Consolas"/>
+              </a:rPr>
+              <a:t>VASP-ებისთვის")*</a:t>
             </a:r>
           </a:p>
           <a:p>
@@ -55381,7 +55885,7 @@
                 <a:cs typeface="Sylfaen"/>
                 <a:latin typeface="Sylfaen"/>
               </a:rPr>
-              <a:t>გაუშვით ქვემოთ მოცემული პრომპტი Claude -ში;</a:t>
+              <a:t>გაუშვით ქვემოთ მოცემული პრომპტი Claude , ChatGPT ან Gemini -ში;</a:t>
             </a:r>
           </a:p>
           <a:p>
@@ -56017,6 +56521,222 @@
                 <a:latin typeface="Consolas"/>
               </a:rPr>
               <a:t>ჩემი იდეაა: [ჩაწერე იდეა].</a:t>
+            </a:r>
+          </a:p>
+          <a:p>
+            <a:pPr>
+              <a:spcAft>
+                <a:spcPts val="0"/>
+              </a:spcAft>
+            </a:pPr>
+            <a:r>
+              <a:rPr sz="1000">
+                <a:solidFill>
+                  <a:srgbClr val="0F172A"/>
+                </a:solidFill>
+                <a:ea typeface="Consolas"/>
+                <a:cs typeface="Consolas"/>
+                <a:latin typeface="Consolas"/>
+              </a:rPr>
+              <a:t>*(მაგალითად:</a:t>
+            </a:r>
+          </a:p>
+          <a:p>
+            <a:pPr>
+              <a:spcAft>
+                <a:spcPts val="0"/>
+              </a:spcAft>
+            </a:pPr>
+            <a:r>
+              <a:rPr sz="1000">
+                <a:solidFill>
+                  <a:srgbClr val="0F172A"/>
+                </a:solidFill>
+                <a:ea typeface="Consolas"/>
+                <a:cs typeface="Consolas"/>
+                <a:latin typeface="Consolas"/>
+              </a:rPr>
+              <a:t>- 🤟 Team 3 (AI ასისტენტი</a:t>
+            </a:r>
+          </a:p>
+          <a:p>
+            <a:pPr>
+              <a:spcAft>
+                <a:spcPts val="0"/>
+              </a:spcAft>
+            </a:pPr>
+            <a:r>
+              <a:rPr sz="1000">
+                <a:solidFill>
+                  <a:srgbClr val="0F172A"/>
+                </a:solidFill>
+                <a:ea typeface="Consolas"/>
+                <a:cs typeface="Consolas"/>
+                <a:latin typeface="Consolas"/>
+              </a:rPr>
+              <a:t>შშმ პირებისთვის): "ხმის</a:t>
+            </a:r>
+          </a:p>
+          <a:p>
+            <a:pPr>
+              <a:spcAft>
+                <a:spcPts val="0"/>
+              </a:spcAft>
+            </a:pPr>
+            <a:r>
+              <a:rPr sz="1000">
+                <a:solidFill>
+                  <a:srgbClr val="0F172A"/>
+                </a:solidFill>
+                <a:ea typeface="Consolas"/>
+                <a:cs typeface="Consolas"/>
+                <a:latin typeface="Consolas"/>
+              </a:rPr>
+              <a:t>ტექსტად და ტექსტის ხმად</a:t>
+            </a:r>
+          </a:p>
+          <a:p>
+            <a:pPr>
+              <a:spcAft>
+                <a:spcPts val="0"/>
+              </a:spcAft>
+            </a:pPr>
+            <a:r>
+              <a:rPr sz="1000">
+                <a:solidFill>
+                  <a:srgbClr val="0F172A"/>
+                </a:solidFill>
+                <a:ea typeface="Consolas"/>
+                <a:cs typeface="Consolas"/>
+                <a:latin typeface="Consolas"/>
+              </a:rPr>
+              <a:t>გარდამქმნელი ქართულენოვანი</a:t>
+            </a:r>
+          </a:p>
+          <a:p>
+            <a:pPr>
+              <a:spcAft>
+                <a:spcPts val="0"/>
+              </a:spcAft>
+            </a:pPr>
+            <a:r>
+              <a:rPr sz="1000">
+                <a:solidFill>
+                  <a:srgbClr val="0F172A"/>
+                </a:solidFill>
+                <a:ea typeface="Consolas"/>
+                <a:cs typeface="Consolas"/>
+                <a:latin typeface="Consolas"/>
+              </a:rPr>
+              <a:t>AI აპლიკაცია"</a:t>
+            </a:r>
+          </a:p>
+          <a:p>
+            <a:pPr>
+              <a:spcAft>
+                <a:spcPts val="0"/>
+              </a:spcAft>
+            </a:pPr>
+            <a:r>
+              <a:rPr sz="1000">
+                <a:solidFill>
+                  <a:srgbClr val="0F172A"/>
+                </a:solidFill>
+                <a:ea typeface="Consolas"/>
+                <a:cs typeface="Consolas"/>
+                <a:latin typeface="Consolas"/>
+              </a:rPr>
+              <a:t>- 🧭 Team 10 (GidAI</a:t>
+            </a:r>
+          </a:p>
+          <a:p>
+            <a:pPr>
+              <a:spcAft>
+                <a:spcPts val="0"/>
+              </a:spcAft>
+            </a:pPr>
+            <a:r>
+              <a:rPr sz="1000">
+                <a:solidFill>
+                  <a:srgbClr val="0F172A"/>
+                </a:solidFill>
+                <a:ea typeface="Consolas"/>
+                <a:cs typeface="Consolas"/>
+                <a:latin typeface="Consolas"/>
+              </a:rPr>
+              <a:t>ოკუპირებულ მხარეებში): "AI</a:t>
+            </a:r>
+          </a:p>
+          <a:p>
+            <a:pPr>
+              <a:spcAft>
+                <a:spcPts val="0"/>
+              </a:spcAft>
+            </a:pPr>
+            <a:r>
+              <a:rPr sz="1000">
+                <a:solidFill>
+                  <a:srgbClr val="0F172A"/>
+                </a:solidFill>
+                <a:ea typeface="Consolas"/>
+                <a:cs typeface="Consolas"/>
+                <a:latin typeface="Consolas"/>
+              </a:rPr>
+              <a:t>ტურისტული გზამკვლევი</a:t>
+            </a:r>
+          </a:p>
+          <a:p>
+            <a:pPr>
+              <a:spcAft>
+                <a:spcPts val="0"/>
+              </a:spcAft>
+            </a:pPr>
+            <a:r>
+              <a:rPr sz="1000">
+                <a:solidFill>
+                  <a:srgbClr val="0F172A"/>
+                </a:solidFill>
+                <a:ea typeface="Consolas"/>
+                <a:cs typeface="Consolas"/>
+                <a:latin typeface="Consolas"/>
+              </a:rPr>
+              <a:t>სამაჩაბლოსა და ოკუპირებულ</a:t>
+            </a:r>
+          </a:p>
+          <a:p>
+            <a:pPr>
+              <a:spcAft>
+                <a:spcPts val="0"/>
+              </a:spcAft>
+            </a:pPr>
+            <a:r>
+              <a:rPr sz="1000">
+                <a:solidFill>
+                  <a:srgbClr val="0F172A"/>
+                </a:solidFill>
+                <a:ea typeface="Consolas"/>
+                <a:cs typeface="Consolas"/>
+                <a:latin typeface="Consolas"/>
+              </a:rPr>
+              <a:t>რეგიონებში ისტორიული</a:t>
+            </a:r>
+          </a:p>
+          <a:p>
+            <a:pPr>
+              <a:spcAft>
+                <a:spcPts val="0"/>
+              </a:spcAft>
+            </a:pPr>
+            <a:r>
+              <a:rPr sz="1000">
+                <a:solidFill>
+                  <a:srgbClr val="0F172A"/>
+                </a:solidFill>
+                <a:ea typeface="Consolas"/>
+                <a:cs typeface="Consolas"/>
+                <a:latin typeface="Consolas"/>
+              </a:rPr>
+              <a:t>ბაზით")*</a:t>
             </a:r>
           </a:p>
           <a:p>

</xml_diff>

<commit_message>
update Fri 07/17/2026 20:29:54.80
</commit_message>
<xml_diff>
--- a/GITA/Pre-Acceleration/2026-5h-AI-for-Startups/day1-slides.pptx
+++ b/GITA/Pre-Acceleration/2026-5h-AI-for-Startups/day1-slides.pptx
@@ -31113,7 +31113,7 @@
                 <a:cs typeface="Sylfaen"/>
                 <a:latin typeface="Sylfaen"/>
               </a:rPr>
-              <a:t>⚖️ იდეების შეფასება და პრიორიტეტიზაცია</a:t>
+              <a:t>🎨 ChatGPT Canvas — ინტერაქტიული ბრეინშტორმინგი</a:t>
             </a:r>
           </a:p>
         </p:txBody>
@@ -31347,7 +31347,7 @@
                 <a:cs typeface="Sylfaen"/>
                 <a:latin typeface="Sylfaen"/>
               </a:rPr>
-              <a:t>📊 შეფასების კრიტერიუმები (1-10 ბალით):</a:t>
+              <a:t>💡 რა შეუძლია Canvas-ს ბრეინშტორმინგში:</a:t>
             </a:r>
           </a:p>
         </p:txBody>
@@ -31399,7 +31399,7 @@
                 <a:cs typeface="Sylfaen"/>
                 <a:latin typeface="Sylfaen"/>
               </a:rPr>
-              <a:t>გავლენა (Impact): რამხელა ეფექტი ექნება ბაზარზე?</a:t>
+              <a:t>📝 ინლაინ რედაქტირება: შეცვალეთ ტექსტი უშუალოდ სამუშაო დაფაზე;</a:t>
             </a:r>
           </a:p>
           <a:p>
@@ -31428,7 +31428,7 @@
                 <a:cs typeface="Sylfaen"/>
                 <a:latin typeface="Sylfaen"/>
               </a:rPr>
-              <a:t>განხორციელებადობა (Feasibility): რამდენად ადვილია MVP-ის აწყობა?</a:t>
+              <a:t>🎯 კონკრეტული უკუკავშირი: მონიშნეთ აბზაცი და სთხოვეთ ალტერნატივები;</a:t>
             </a:r>
           </a:p>
           <a:p>
@@ -31457,7 +31457,7 @@
                 <a:cs typeface="Sylfaen"/>
                 <a:latin typeface="Sylfaen"/>
               </a:rPr>
-              <a:t>დანახარჯი (Cost): რა რესურსებს მოითხოვს? (10 = ძალიან იაფი);</a:t>
+              <a:t>🔄 ვერსიების კონტროლი: დააბრუნეთ წინა წარმატებული იდეები;</a:t>
             </a:r>
           </a:p>
           <a:p>
@@ -31486,7 +31486,7 @@
                 <a:cs typeface="Sylfaen"/>
                 <a:latin typeface="Sylfaen"/>
               </a:rPr>
-              <a:t>დრო (Time): რა დრო დასჭირდება გაშვებას? (10 = უსწრაფესი).</a:t>
+              <a:t>✨ სწრაფი ქმედებები: ერთი კლიკით შეცვალეთ ტონის ფორმატები.</a:t>
             </a:r>
           </a:p>
         </p:txBody>
@@ -31556,98 +31556,6 @@
           </a:solidFill>
           <a:ln w="6350">
             <a:solidFill>
-              <a:srgbClr val="3730A3"/>
-            </a:solidFill>
-          </a:ln>
-          <a:effectLst/>
-        </p:spPr>
-        <p:style>
-          <a:lnRef idx="1">
-            <a:schemeClr val="accent1"/>
-          </a:lnRef>
-          <a:fillRef idx="3">
-            <a:schemeClr val="accent1"/>
-          </a:fillRef>
-          <a:effectRef idx="2">
-            <a:schemeClr val="accent1"/>
-          </a:effectRef>
-          <a:fontRef idx="minor">
-            <a:schemeClr val="lt1"/>
-          </a:fontRef>
-        </p:style>
-        <p:txBody>
-          <a:bodyPr rtlCol="0" anchor="ctr"/>
-          <a:lstStyle/>
-          <a:p>
-            <a:pPr algn="ctr"/>
-          </a:p>
-        </p:txBody>
-      </p:sp>
-      <p:sp>
-        <p:nvSpPr>
-          <p:cNvPr id="14" name="Rectangle 13"/>
-          <p:cNvSpPr/>
-          <p:nvPr/>
-        </p:nvSpPr>
-        <p:spPr>
-          <a:xfrm>
-            <a:off x="4805172" y="1261872"/>
-            <a:ext cx="54864" cy="292608"/>
-          </a:xfrm>
-          <a:prstGeom prst="rect">
-            <a:avLst/>
-          </a:prstGeom>
-          <a:solidFill>
-            <a:srgbClr val="3730A3"/>
-          </a:solidFill>
-          <a:ln>
-            <a:noFill/>
-          </a:ln>
-          <a:effectLst/>
-        </p:spPr>
-        <p:style>
-          <a:lnRef idx="1">
-            <a:schemeClr val="accent1"/>
-          </a:lnRef>
-          <a:fillRef idx="3">
-            <a:schemeClr val="accent1"/>
-          </a:fillRef>
-          <a:effectRef idx="2">
-            <a:schemeClr val="accent1"/>
-          </a:effectRef>
-          <a:fontRef idx="minor">
-            <a:schemeClr val="lt1"/>
-          </a:fontRef>
-        </p:style>
-        <p:txBody>
-          <a:bodyPr rtlCol="0" anchor="ctr"/>
-          <a:lstStyle/>
-          <a:p>
-            <a:pPr algn="ctr"/>
-          </a:p>
-        </p:txBody>
-      </p:sp>
-      <p:sp>
-        <p:nvSpPr>
-          <p:cNvPr id="15" name="Rounded Rectangle 14"/>
-          <p:cNvSpPr/>
-          <p:nvPr/>
-        </p:nvSpPr>
-        <p:spPr>
-          <a:xfrm>
-            <a:off x="4860036" y="1261872"/>
-            <a:ext cx="3717036" cy="292608"/>
-          </a:xfrm>
-          <a:prstGeom prst="roundRect">
-            <a:avLst>
-              <a:gd name="adj" fmla="val 4000"/>
-            </a:avLst>
-          </a:prstGeom>
-          <a:solidFill>
-            <a:srgbClr val="F8FAFC"/>
-          </a:solidFill>
-          <a:ln w="9525">
-            <a:solidFill>
               <a:srgbClr val="E2E8F0"/>
             </a:solidFill>
           </a:ln>
@@ -31677,60 +31585,14 @@
       </p:sp>
       <p:sp>
         <p:nvSpPr>
-          <p:cNvPr id="16" name="Rectangle 15"/>
-          <p:cNvSpPr/>
-          <p:nvPr/>
-        </p:nvSpPr>
-        <p:spPr>
-          <a:xfrm>
-            <a:off x="4914900" y="1316736"/>
-            <a:ext cx="3552444" cy="201168"/>
-          </a:xfrm>
-          <a:prstGeom prst="rect">
-            <a:avLst/>
-          </a:prstGeom>
-          <a:solidFill>
-            <a:srgbClr val="FFFFFF"/>
-          </a:solidFill>
-          <a:ln w="6350">
-            <a:solidFill>
-              <a:srgbClr val="E2E8F0"/>
-            </a:solidFill>
-          </a:ln>
-          <a:effectLst/>
-        </p:spPr>
-        <p:style>
-          <a:lnRef idx="1">
-            <a:schemeClr val="accent1"/>
-          </a:lnRef>
-          <a:fillRef idx="3">
-            <a:schemeClr val="accent1"/>
-          </a:fillRef>
-          <a:effectRef idx="2">
-            <a:schemeClr val="accent1"/>
-          </a:effectRef>
-          <a:fontRef idx="minor">
-            <a:schemeClr val="lt1"/>
-          </a:fontRef>
-        </p:style>
-        <p:txBody>
-          <a:bodyPr rtlCol="0" anchor="ctr"/>
-          <a:lstStyle/>
-          <a:p>
-            <a:pPr algn="ctr"/>
-          </a:p>
-        </p:txBody>
-      </p:sp>
-      <p:sp>
-        <p:nvSpPr>
-          <p:cNvPr id="17" name="TextBox 16"/>
+          <p:cNvPr id="14" name="TextBox 13"/>
           <p:cNvSpPr txBox="1"/>
           <p:nvPr/>
         </p:nvSpPr>
         <p:spPr>
           <a:xfrm>
-            <a:off x="4969764" y="1344168"/>
-            <a:ext cx="3442716" cy="146304"/>
+            <a:off x="4805172" y="1261872"/>
+            <a:ext cx="3771900" cy="320040"/>
           </a:xfrm>
           <a:prstGeom prst="rect">
             <a:avLst/>
@@ -31745,127 +31607,33 @@
           <a:p>
             <a:pPr>
               <a:spcAft>
-                <a:spcPts val="0"/>
-              </a:spcAft>
-            </a:pPr>
-            <a:r>
-              <a:rPr sz="1200">
-                <a:solidFill>
-                  <a:srgbClr val="0F172A"/>
-                </a:solidFill>
-                <a:ea typeface="Consolas"/>
-                <a:cs typeface="Consolas"/>
-                <a:latin typeface="Consolas"/>
-              </a:rPr>
-              <a:t>Idea Evaluation Prompt:</a:t>
-            </a:r>
-          </a:p>
-        </p:txBody>
-      </p:sp>
-      <p:sp>
-        <p:nvSpPr>
-          <p:cNvPr id="18" name="Rounded Rectangle 17"/>
-          <p:cNvSpPr/>
-          <p:nvPr/>
-        </p:nvSpPr>
-        <p:spPr>
-          <a:xfrm>
-            <a:off x="4805172" y="1627632"/>
-            <a:ext cx="3771900" cy="3150108"/>
-          </a:xfrm>
-          <a:prstGeom prst="roundRect">
-            <a:avLst>
-              <a:gd name="adj" fmla="val 4000"/>
-            </a:avLst>
-          </a:prstGeom>
-          <a:solidFill>
-            <a:srgbClr val="F8FAFC"/>
-          </a:solidFill>
-          <a:ln w="9525">
-            <a:solidFill>
-              <a:srgbClr val="E2E8F0"/>
-            </a:solidFill>
-          </a:ln>
-          <a:effectLst/>
-        </p:spPr>
-        <p:style>
-          <a:lnRef idx="1">
-            <a:schemeClr val="accent1"/>
-          </a:lnRef>
-          <a:fillRef idx="3">
-            <a:schemeClr val="accent1"/>
-          </a:fillRef>
-          <a:effectRef idx="2">
-            <a:schemeClr val="accent1"/>
-          </a:effectRef>
-          <a:fontRef idx="minor">
-            <a:schemeClr val="lt1"/>
-          </a:fontRef>
-        </p:style>
-        <p:txBody>
-          <a:bodyPr rtlCol="0" anchor="ctr"/>
-          <a:lstStyle/>
-          <a:p>
-            <a:pPr algn="ctr"/>
-          </a:p>
-        </p:txBody>
-      </p:sp>
-      <p:sp>
-        <p:nvSpPr>
-          <p:cNvPr id="19" name="Rectangle 18"/>
-          <p:cNvSpPr/>
-          <p:nvPr/>
-        </p:nvSpPr>
-        <p:spPr>
-          <a:xfrm>
-            <a:off x="4860036" y="1673352"/>
-            <a:ext cx="3662172" cy="3058668"/>
-          </a:xfrm>
-          <a:prstGeom prst="rect">
-            <a:avLst/>
-          </a:prstGeom>
-          <a:solidFill>
-            <a:srgbClr val="FFFFFF"/>
-          </a:solidFill>
-          <a:ln w="6350">
-            <a:solidFill>
-              <a:srgbClr val="E2E8F0"/>
-            </a:solidFill>
-          </a:ln>
-          <a:effectLst/>
-        </p:spPr>
-        <p:style>
-          <a:lnRef idx="1">
-            <a:schemeClr val="accent1"/>
-          </a:lnRef>
-          <a:fillRef idx="3">
-            <a:schemeClr val="accent1"/>
-          </a:fillRef>
-          <a:effectRef idx="2">
-            <a:schemeClr val="accent1"/>
-          </a:effectRef>
-          <a:fontRef idx="minor">
-            <a:schemeClr val="lt1"/>
-          </a:fontRef>
-        </p:style>
-        <p:txBody>
-          <a:bodyPr rtlCol="0" anchor="ctr"/>
-          <a:lstStyle/>
-          <a:p>
-            <a:pPr algn="ctr"/>
-          </a:p>
-        </p:txBody>
-      </p:sp>
-      <p:sp>
-        <p:nvSpPr>
-          <p:cNvPr id="20" name="TextBox 19"/>
+                <a:spcPts val="400"/>
+              </a:spcAft>
+            </a:pPr>
+            <a:r>
+              <a:rPr sz="1400" b="1" i="0">
+                <a:solidFill>
+                  <a:srgbClr val="0F172A"/>
+                </a:solidFill>
+                <a:ea typeface="Sylfaen"/>
+                <a:cs typeface="Sylfaen"/>
+                <a:latin typeface="Sylfaen"/>
+              </a:rPr>
+              <a:t>🚀 როგორ გამოვიყენოთ პრაქტიკაში:</a:t>
+            </a:r>
+          </a:p>
+        </p:txBody>
+      </p:sp>
+      <p:sp>
+        <p:nvSpPr>
+          <p:cNvPr id="15" name="TextBox 14"/>
           <p:cNvSpPr txBox="1"/>
           <p:nvPr/>
         </p:nvSpPr>
         <p:spPr>
           <a:xfrm>
-            <a:off x="4914900" y="1691640"/>
-            <a:ext cx="3552444" cy="3022091"/>
+            <a:off x="4805172" y="1655064"/>
+            <a:ext cx="3771900" cy="3122675"/>
           </a:xfrm>
           <a:prstGeom prst="rect">
             <a:avLst/>
@@ -31878,442 +31646,126 @@
           </a:bodyPr>
           <a:lstStyle/>
           <a:p>
-            <a:pPr>
-              <a:spcAft>
-                <a:spcPts val="0"/>
-              </a:spcAft>
-            </a:pPr>
-            <a:r>
-              <a:rPr sz="1000">
-                <a:solidFill>
-                  <a:srgbClr val="0F172A"/>
-                </a:solidFill>
-                <a:ea typeface="Consolas"/>
-                <a:cs typeface="Consolas"/>
-                <a:latin typeface="Consolas"/>
-              </a:rPr>
-              <a:t>შეაფასე ეს იდეები:</a:t>
-            </a:r>
-          </a:p>
-          <a:p>
-            <a:pPr>
-              <a:spcAft>
-                <a:spcPts val="0"/>
-              </a:spcAft>
-            </a:pPr>
-            <a:r>
-              <a:rPr sz="1000">
-                <a:solidFill>
-                  <a:srgbClr val="0F172A"/>
-                </a:solidFill>
-                <a:ea typeface="Consolas"/>
-                <a:cs typeface="Consolas"/>
-                <a:latin typeface="Consolas"/>
-              </a:rPr>
-              <a:t>[იდეების სია] შემდეგი</a:t>
-            </a:r>
-          </a:p>
-          <a:p>
-            <a:pPr>
-              <a:spcAft>
-                <a:spcPts val="0"/>
-              </a:spcAft>
-            </a:pPr>
-            <a:r>
-              <a:rPr sz="1000">
-                <a:solidFill>
-                  <a:srgbClr val="0F172A"/>
-                </a:solidFill>
-                <a:ea typeface="Consolas"/>
-                <a:cs typeface="Consolas"/>
-                <a:latin typeface="Consolas"/>
-              </a:rPr>
-              <a:t>კრიტერიუმებით (1-10</a:t>
-            </a:r>
-          </a:p>
-          <a:p>
-            <a:pPr>
-              <a:spcAft>
-                <a:spcPts val="0"/>
-              </a:spcAft>
-            </a:pPr>
-            <a:r>
-              <a:rPr sz="1000">
-                <a:solidFill>
-                  <a:srgbClr val="0F172A"/>
-                </a:solidFill>
-                <a:ea typeface="Consolas"/>
-                <a:cs typeface="Consolas"/>
-                <a:latin typeface="Consolas"/>
-              </a:rPr>
-              <a:t>ბალით): Impact,</a:t>
-            </a:r>
-          </a:p>
-          <a:p>
-            <a:pPr>
-              <a:spcAft>
-                <a:spcPts val="0"/>
-              </a:spcAft>
-            </a:pPr>
-            <a:r>
-              <a:rPr sz="1000">
-                <a:solidFill>
-                  <a:srgbClr val="0F172A"/>
-                </a:solidFill>
-                <a:ea typeface="Consolas"/>
-                <a:cs typeface="Consolas"/>
-                <a:latin typeface="Consolas"/>
-              </a:rPr>
-              <a:t>Feasibility, Cost, Time და</a:t>
-            </a:r>
-          </a:p>
-          <a:p>
-            <a:pPr>
-              <a:spcAft>
-                <a:spcPts val="0"/>
-              </a:spcAft>
-            </a:pPr>
-            <a:r>
-              <a:rPr sz="1000">
-                <a:solidFill>
-                  <a:srgbClr val="0F172A"/>
-                </a:solidFill>
-                <a:ea typeface="Consolas"/>
-                <a:cs typeface="Consolas"/>
-                <a:latin typeface="Consolas"/>
-              </a:rPr>
-              <a:t>Market Fit.</a:t>
-            </a:r>
-          </a:p>
-          <a:p>
-            <a:pPr>
-              <a:spcAft>
-                <a:spcPts val="0"/>
-              </a:spcAft>
-            </a:pPr>
-            <a:r>
-              <a:rPr sz="1000">
-                <a:solidFill>
-                  <a:srgbClr val="0F172A"/>
-                </a:solidFill>
-                <a:ea typeface="Consolas"/>
-                <a:cs typeface="Consolas"/>
-                <a:latin typeface="Consolas"/>
-              </a:rPr>
-              <a:t>წარმოადგინე შედეგები</a:t>
-            </a:r>
-          </a:p>
-          <a:p>
-            <a:pPr>
-              <a:spcAft>
-                <a:spcPts val="0"/>
-              </a:spcAft>
-            </a:pPr>
-            <a:r>
-              <a:rPr sz="1000">
-                <a:solidFill>
-                  <a:srgbClr val="0F172A"/>
-                </a:solidFill>
-                <a:ea typeface="Consolas"/>
-                <a:cs typeface="Consolas"/>
-                <a:latin typeface="Consolas"/>
-              </a:rPr>
-              <a:t>Markdown ცხრილის სახით.</a:t>
-            </a:r>
-          </a:p>
-          <a:p>
-            <a:pPr>
-              <a:spcAft>
-                <a:spcPts val="0"/>
-              </a:spcAft>
-            </a:pPr>
-            <a:r>
-              <a:rPr sz="1000">
-                <a:solidFill>
-                  <a:srgbClr val="0F172A"/>
-                </a:solidFill>
-                <a:ea typeface="Consolas"/>
-                <a:cs typeface="Consolas"/>
-                <a:latin typeface="Consolas"/>
-              </a:rPr>
-              <a:t>დააჯგუფე ისინი 4</a:t>
-            </a:r>
-          </a:p>
-          <a:p>
-            <a:pPr>
-              <a:spcAft>
-                <a:spcPts val="0"/>
-              </a:spcAft>
-            </a:pPr>
-            <a:r>
-              <a:rPr sz="1000">
-                <a:solidFill>
-                  <a:srgbClr val="0F172A"/>
-                </a:solidFill>
-                <a:ea typeface="Consolas"/>
-                <a:cs typeface="Consolas"/>
-                <a:latin typeface="Consolas"/>
-              </a:rPr>
-              <a:t>კატეგორიად:</a:t>
-            </a:r>
-          </a:p>
-          <a:p>
-            <a:pPr>
-              <a:spcAft>
-                <a:spcPts val="0"/>
-              </a:spcAft>
-            </a:pPr>
-            <a:r>
-              <a:rPr sz="1000">
-                <a:solidFill>
-                  <a:srgbClr val="0F172A"/>
-                </a:solidFill>
-                <a:ea typeface="Consolas"/>
-                <a:cs typeface="Consolas"/>
-                <a:latin typeface="Consolas"/>
-              </a:rPr>
-              <a:t>1. სწრაფი გამარჯვებები</a:t>
-            </a:r>
-          </a:p>
-          <a:p>
-            <a:pPr>
-              <a:spcAft>
-                <a:spcPts val="0"/>
-              </a:spcAft>
-            </a:pPr>
-            <a:r>
-              <a:rPr sz="1000">
-                <a:solidFill>
-                  <a:srgbClr val="0F172A"/>
-                </a:solidFill>
-                <a:ea typeface="Consolas"/>
-                <a:cs typeface="Consolas"/>
-                <a:latin typeface="Consolas"/>
-              </a:rPr>
-              <a:t>(Quick Wins - მაღალი</a:t>
-            </a:r>
-          </a:p>
-          <a:p>
-            <a:pPr>
-              <a:spcAft>
-                <a:spcPts val="0"/>
-              </a:spcAft>
-            </a:pPr>
-            <a:r>
-              <a:rPr sz="1000">
-                <a:solidFill>
-                  <a:srgbClr val="0F172A"/>
-                </a:solidFill>
-                <a:ea typeface="Consolas"/>
-                <a:cs typeface="Consolas"/>
-                <a:latin typeface="Consolas"/>
-              </a:rPr>
-              <a:t>Impact, დაბალი</a:t>
-            </a:r>
-          </a:p>
-          <a:p>
-            <a:pPr>
-              <a:spcAft>
-                <a:spcPts val="0"/>
-              </a:spcAft>
-            </a:pPr>
-            <a:r>
-              <a:rPr sz="1000">
-                <a:solidFill>
-                  <a:srgbClr val="0F172A"/>
-                </a:solidFill>
-                <a:ea typeface="Consolas"/>
-                <a:cs typeface="Consolas"/>
-                <a:latin typeface="Consolas"/>
-              </a:rPr>
-              <a:t>ძალისხმევა);</a:t>
-            </a:r>
-          </a:p>
-          <a:p>
-            <a:pPr>
-              <a:spcAft>
-                <a:spcPts val="0"/>
-              </a:spcAft>
-            </a:pPr>
-            <a:r>
-              <a:rPr sz="1000">
-                <a:solidFill>
-                  <a:srgbClr val="0F172A"/>
-                </a:solidFill>
-                <a:ea typeface="Consolas"/>
-                <a:cs typeface="Consolas"/>
-                <a:latin typeface="Consolas"/>
-              </a:rPr>
-              <a:t>2. სტრატეგიული</a:t>
-            </a:r>
-          </a:p>
-          <a:p>
-            <a:pPr>
-              <a:spcAft>
-                <a:spcPts val="0"/>
-              </a:spcAft>
-            </a:pPr>
-            <a:r>
-              <a:rPr sz="1000">
-                <a:solidFill>
-                  <a:srgbClr val="0F172A"/>
-                </a:solidFill>
-                <a:ea typeface="Consolas"/>
-                <a:cs typeface="Consolas"/>
-                <a:latin typeface="Consolas"/>
-              </a:rPr>
-              <a:t>ინიციატივები (დიდი</a:t>
-            </a:r>
-          </a:p>
-          <a:p>
-            <a:pPr>
-              <a:spcAft>
-                <a:spcPts val="0"/>
-              </a:spcAft>
-            </a:pPr>
-            <a:r>
-              <a:rPr sz="1000">
-                <a:solidFill>
-                  <a:srgbClr val="0F172A"/>
-                </a:solidFill>
-                <a:ea typeface="Consolas"/>
-                <a:cs typeface="Consolas"/>
-                <a:latin typeface="Consolas"/>
-              </a:rPr>
-              <a:t>გავლენა, მაღალი</a:t>
-            </a:r>
-          </a:p>
-          <a:p>
-            <a:pPr>
-              <a:spcAft>
-                <a:spcPts val="0"/>
-              </a:spcAft>
-            </a:pPr>
-            <a:r>
-              <a:rPr sz="1000">
-                <a:solidFill>
-                  <a:srgbClr val="0F172A"/>
-                </a:solidFill>
-                <a:ea typeface="Consolas"/>
-                <a:cs typeface="Consolas"/>
-                <a:latin typeface="Consolas"/>
-              </a:rPr>
-              <a:t>ძალისხმევა);</a:t>
-            </a:r>
-          </a:p>
-          <a:p>
-            <a:pPr>
-              <a:spcAft>
-                <a:spcPts val="0"/>
-              </a:spcAft>
-            </a:pPr>
-            <a:r>
-              <a:rPr sz="1000">
-                <a:solidFill>
-                  <a:srgbClr val="0F172A"/>
-                </a:solidFill>
-                <a:ea typeface="Consolas"/>
-                <a:cs typeface="Consolas"/>
-                <a:latin typeface="Consolas"/>
-              </a:rPr>
-              <a:t>3. შემავსებლები (დაბალი</a:t>
-            </a:r>
-          </a:p>
-          <a:p>
-            <a:pPr>
-              <a:spcAft>
-                <a:spcPts val="0"/>
-              </a:spcAft>
-            </a:pPr>
-            <a:r>
-              <a:rPr sz="1000">
-                <a:solidFill>
-                  <a:srgbClr val="0F172A"/>
-                </a:solidFill>
-                <a:ea typeface="Consolas"/>
-                <a:cs typeface="Consolas"/>
-                <a:latin typeface="Consolas"/>
-              </a:rPr>
-              <a:t>გავლენა, დაბალი</a:t>
-            </a:r>
-          </a:p>
-          <a:p>
-            <a:pPr>
-              <a:spcAft>
-                <a:spcPts val="0"/>
-              </a:spcAft>
-            </a:pPr>
-            <a:r>
-              <a:rPr sz="1000">
-                <a:solidFill>
-                  <a:srgbClr val="0F172A"/>
-                </a:solidFill>
-                <a:ea typeface="Consolas"/>
-                <a:cs typeface="Consolas"/>
-                <a:latin typeface="Consolas"/>
-              </a:rPr>
-              <a:t>ძალისხმევა);</a:t>
-            </a:r>
-          </a:p>
-          <a:p>
-            <a:pPr>
-              <a:spcAft>
-                <a:spcPts val="0"/>
-              </a:spcAft>
-            </a:pPr>
-            <a:r>
-              <a:rPr sz="1000">
-                <a:solidFill>
-                  <a:srgbClr val="0F172A"/>
-                </a:solidFill>
-                <a:ea typeface="Consolas"/>
-                <a:cs typeface="Consolas"/>
-                <a:latin typeface="Consolas"/>
-              </a:rPr>
-              <a:t>4. დროის მჭამელები (დაბალი</a:t>
-            </a:r>
-          </a:p>
-          <a:p>
-            <a:pPr>
-              <a:spcAft>
-                <a:spcPts val="0"/>
-              </a:spcAft>
-            </a:pPr>
-            <a:r>
-              <a:rPr sz="1000">
-                <a:solidFill>
-                  <a:srgbClr val="0F172A"/>
-                </a:solidFill>
-                <a:ea typeface="Consolas"/>
-                <a:cs typeface="Consolas"/>
-                <a:latin typeface="Consolas"/>
-              </a:rPr>
-              <a:t>გავლენა, მაღალი</a:t>
-            </a:r>
-          </a:p>
-          <a:p>
-            <a:pPr>
-              <a:spcAft>
-                <a:spcPts val="0"/>
-              </a:spcAft>
-            </a:pPr>
-            <a:r>
-              <a:rPr sz="1000">
-                <a:solidFill>
-                  <a:srgbClr val="0F172A"/>
-                </a:solidFill>
-                <a:ea typeface="Consolas"/>
-                <a:cs typeface="Consolas"/>
-                <a:latin typeface="Consolas"/>
-              </a:rPr>
-              <a:t>ძალისხმევა).</a:t>
-            </a:r>
-          </a:p>
-        </p:txBody>
-      </p:sp>
-      <p:sp>
-        <p:nvSpPr>
-          <p:cNvPr id="21" name="Rectangle 20"/>
+            <a:pPr algn="l">
+              <a:spcAft>
+                <a:spcPts val="300"/>
+              </a:spcAft>
+            </a:pPr>
+            <a:r>
+              <a:rPr sz="1300" b="1">
+                <a:solidFill>
+                  <a:srgbClr val="3730A3"/>
+                </a:solidFill>
+                <a:ea typeface="Sylfaen"/>
+                <a:cs typeface="Sylfaen"/>
+                <a:latin typeface="Sylfaen"/>
+              </a:rPr>
+              <a:t>1.  </a:t>
+            </a:r>
+            <a:r>
+              <a:rPr sz="1300">
+                <a:solidFill>
+                  <a:srgbClr val="0F172A"/>
+                </a:solidFill>
+                <a:ea typeface="Sylfaen"/>
+                <a:cs typeface="Sylfaen"/>
+                <a:latin typeface="Sylfaen"/>
+              </a:rPr>
+              <a:t>დაიწყეთ იდეების გენერაცია ჩვეულებრივ ჩატში;</a:t>
+            </a:r>
+          </a:p>
+          <a:p>
+            <a:pPr algn="l">
+              <a:spcAft>
+                <a:spcPts val="300"/>
+              </a:spcAft>
+            </a:pPr>
+            <a:r>
+              <a:rPr sz="1300" b="1">
+                <a:solidFill>
+                  <a:srgbClr val="3730A3"/>
+                </a:solidFill>
+                <a:ea typeface="Sylfaen"/>
+                <a:cs typeface="Sylfaen"/>
+                <a:latin typeface="Sylfaen"/>
+              </a:rPr>
+              <a:t>2.  </a:t>
+            </a:r>
+            <a:r>
+              <a:rPr sz="1300">
+                <a:solidFill>
+                  <a:srgbClr val="0F172A"/>
+                </a:solidFill>
+                <a:ea typeface="Sylfaen"/>
+                <a:cs typeface="Sylfaen"/>
+                <a:latin typeface="Sylfaen"/>
+              </a:rPr>
+              <a:t>სთხოვეთ AI-ს: „გახსენი ეს ტექსტი Canvas-ში“ ან გამოიყენეთ ბრძანება „use canvas“ ;</a:t>
+            </a:r>
+          </a:p>
+          <a:p>
+            <a:pPr algn="l">
+              <a:spcAft>
+                <a:spcPts val="300"/>
+              </a:spcAft>
+            </a:pPr>
+            <a:r>
+              <a:rPr sz="1300" b="1">
+                <a:solidFill>
+                  <a:srgbClr val="3730A3"/>
+                </a:solidFill>
+                <a:ea typeface="Sylfaen"/>
+                <a:cs typeface="Sylfaen"/>
+                <a:latin typeface="Sylfaen"/>
+              </a:rPr>
+              <a:t>3.  </a:t>
+            </a:r>
+            <a:r>
+              <a:rPr sz="1300">
+                <a:solidFill>
+                  <a:srgbClr val="0F172A"/>
+                </a:solidFill>
+                <a:ea typeface="Sylfaen"/>
+                <a:cs typeface="Sylfaen"/>
+                <a:latin typeface="Sylfaen"/>
+              </a:rPr>
+              <a:t>მონიშნეთ სუსტი იდეები და სთხოვეთ მათი გაუმჯობესება;</a:t>
+            </a:r>
+          </a:p>
+          <a:p>
+            <a:pPr algn="l">
+              <a:spcAft>
+                <a:spcPts val="300"/>
+              </a:spcAft>
+            </a:pPr>
+            <a:r>
+              <a:rPr sz="1300" b="1">
+                <a:solidFill>
+                  <a:srgbClr val="3730A3"/>
+                </a:solidFill>
+                <a:ea typeface="Sylfaen"/>
+                <a:cs typeface="Sylfaen"/>
+                <a:latin typeface="Sylfaen"/>
+              </a:rPr>
+              <a:t>4.  </a:t>
+            </a:r>
+            <a:r>
+              <a:rPr sz="1300">
+                <a:solidFill>
+                  <a:srgbClr val="0F172A"/>
+                </a:solidFill>
+                <a:ea typeface="Sylfaen"/>
+                <a:cs typeface="Sylfaen"/>
+                <a:latin typeface="Sylfaen"/>
+              </a:rPr>
+              <a:t>გააკეთეთ ექსპორტი ან გაუზიარეთ გუნდის წევრებს ბმულით.</a:t>
+            </a:r>
+          </a:p>
+        </p:txBody>
+      </p:sp>
+      <p:sp>
+        <p:nvSpPr>
+          <p:cNvPr id="16" name="Rectangle 15"/>
           <p:cNvSpPr/>
           <p:nvPr/>
         </p:nvSpPr>
@@ -32357,7 +31809,7 @@
       </p:sp>
       <p:sp>
         <p:nvSpPr>
-          <p:cNvPr id="22" name="TextBox 21"/>
+          <p:cNvPr id="17" name="TextBox 16"/>
           <p:cNvSpPr txBox="1"/>
           <p:nvPr/>
         </p:nvSpPr>
@@ -32577,7 +32029,7 @@
                 <a:cs typeface="Sylfaen"/>
                 <a:latin typeface="Sylfaen"/>
               </a:rPr>
-              <a:t>⚡ სწრაფი პროტოტიპირების იდეაცია (Rapid Prototyping)</a:t>
+              <a:t>🔮 ტენდენციების შემჩნევა და მომავლის პროგნოზირება</a:t>
             </a:r>
           </a:p>
         </p:txBody>
@@ -32811,7 +32263,7 @@
                 <a:cs typeface="Sylfaen"/>
                 <a:latin typeface="Sylfaen"/>
               </a:rPr>
-              <a:t>📋 სწრაფი პროტოტიპის გეგმის ელემენტები:</a:t>
+              <a:t>🔍 AI-ს გამოყენება პროგნოზირებისთვის:</a:t>
             </a:r>
           </a:p>
         </p:txBody>
@@ -32825,7 +32277,7 @@
         <p:spPr>
           <a:xfrm>
             <a:off x="621792" y="1655064"/>
-            <a:ext cx="3771900" cy="3122675"/>
+            <a:ext cx="3771900" cy="2542032"/>
           </a:xfrm>
           <a:prstGeom prst="rect">
             <a:avLst/>
@@ -32863,7 +32315,7 @@
                 <a:cs typeface="Sylfaen"/>
                 <a:latin typeface="Sylfaen"/>
               </a:rPr>
-              <a:t>🎯 ძირითადი ფუნქციონალი: მხოლოდ აუცილებელი Core ფუნქციები;</a:t>
+              <a:t>📊 ტენდენციების ანალიზი: მიმდინარე და აღმოცენებადი ტენდენციების შედარება;</a:t>
             </a:r>
           </a:p>
           <a:p>
@@ -32892,7 +32344,7 @@
                 <a:cs typeface="Sylfaen"/>
                 <a:latin typeface="Sylfaen"/>
               </a:rPr>
-              <a:t>🛠️ ტექნოლოგიური სტეკი: No-Code/Low-Code ხელსაწყოების შერჩევა (Lovable, Supabase, Make);</a:t>
+              <a:t>🚀 სცენარების დაგეგმვა: ოპტიმისტური, პესიმისტური და ყველაზე მოსალოდნელი მომავლის მოდელირება;</a:t>
             </a:r>
           </a:p>
           <a:p>
@@ -32921,36 +32373,7 @@
                 <a:cs typeface="Sylfaen"/>
                 <a:latin typeface="Sylfaen"/>
               </a:rPr>
-              <a:t>📅 2-კვირიანი სპრინტი: დროში გაწერილი ნაბიჯ-ნაბიჯ გეგმა;</a:t>
-            </a:r>
-          </a:p>
-          <a:p>
-            <a:pPr algn="l">
-              <a:spcAft>
-                <a:spcPts val="300"/>
-              </a:spcAft>
-            </a:pPr>
-            <a:r>
-              <a:rPr sz="1300" b="1">
-                <a:solidFill>
-                  <a:srgbClr val="3730A3"/>
-                </a:solidFill>
-                <a:ea typeface="Sylfaen"/>
-                <a:cs typeface="Sylfaen"/>
-                <a:latin typeface="Sylfaen"/>
-              </a:rPr>
-              <a:t>▸  </a:t>
-            </a:r>
-            <a:r>
-              <a:rPr sz="1300">
-                <a:solidFill>
-                  <a:srgbClr val="0F172A"/>
-                </a:solidFill>
-                <a:ea typeface="Sylfaen"/>
-                <a:cs typeface="Sylfaen"/>
-                <a:latin typeface="Sylfaen"/>
-              </a:rPr>
-              <a:t>📈 წარმატების მეტრიკა: როგორ მივხვდებით, რომ ტესტმა წარმატებით ჩაიარა?</a:t>
+              <a:t>💡 ახალი ნიშები: ბაზარზე გამოჩენილი ვაკუუმების იდენტიფიკაცია.</a:t>
             </a:r>
           </a:p>
         </p:txBody>
@@ -33221,7 +32644,7 @@
                 <a:cs typeface="Consolas"/>
                 <a:latin typeface="Consolas"/>
               </a:rPr>
-              <a:t>Rapid MVP Prototyping</a:t>
+              <a:t>Trend Spotting &amp;</a:t>
             </a:r>
           </a:p>
           <a:p>
@@ -33239,7 +32662,7 @@
                 <a:cs typeface="Consolas"/>
                 <a:latin typeface="Consolas"/>
               </a:rPr>
-              <a:t>Prompt:</a:t>
+              <a:t>Forecasting Prompt:</a:t>
             </a:r>
           </a:p>
         </p:txBody>
@@ -33374,7 +32797,7 @@
                 <a:cs typeface="Consolas"/>
                 <a:latin typeface="Consolas"/>
               </a:rPr>
-              <a:t>ჩემი სტარტაპ იდეაა:</a:t>
+              <a:t>გააანალიზე მიმდინარე</a:t>
             </a:r>
           </a:p>
           <a:p>
@@ -33392,7 +32815,7 @@
                 <a:cs typeface="Consolas"/>
                 <a:latin typeface="Consolas"/>
               </a:rPr>
-              <a:t>[ჩაწერე იდეა].</a:t>
+              <a:t>ტენდენციები [თქვენი</a:t>
             </a:r>
           </a:p>
           <a:p>
@@ -33410,7 +32833,7 @@
                 <a:cs typeface="Consolas"/>
                 <a:latin typeface="Consolas"/>
               </a:rPr>
-              <a:t>შემომთავაზე 2-კვირაში</a:t>
+              <a:t>ინდუსტრია]-ში და</a:t>
             </a:r>
           </a:p>
           <a:p>
@@ -33428,7 +32851,7 @@
                 <a:cs typeface="Consolas"/>
                 <a:latin typeface="Consolas"/>
               </a:rPr>
-              <a:t>ასაშენებელი MVP-ის გეგმა:</a:t>
+              <a:t>დააგენერირე:</a:t>
             </a:r>
           </a:p>
           <a:p>
@@ -33446,7 +32869,7 @@
                 <a:cs typeface="Consolas"/>
                 <a:latin typeface="Consolas"/>
               </a:rPr>
-              <a:t>1. ფუნქციების სია</a:t>
+              <a:t>1. მიმდინარე ტენდენციები</a:t>
             </a:r>
           </a:p>
           <a:p>
@@ -33464,7 +32887,7 @@
                 <a:cs typeface="Consolas"/>
                 <a:latin typeface="Consolas"/>
               </a:rPr>
-              <a:t>(აუცილებელი Core vs</a:t>
+              <a:t>(5 ტენდენცია);</a:t>
             </a:r>
           </a:p>
           <a:p>
@@ -33482,7 +32905,7 @@
                 <a:cs typeface="Consolas"/>
                 <a:latin typeface="Consolas"/>
               </a:rPr>
-              <a:t>სასურველი);</a:t>
+              <a:t>2. აღმოცენებადი</a:t>
             </a:r>
           </a:p>
           <a:p>
@@ -33500,7 +32923,7 @@
                 <a:cs typeface="Consolas"/>
                 <a:latin typeface="Consolas"/>
               </a:rPr>
-              <a:t>2. ტექნოლოგიური სტეკი</a:t>
+              <a:t>ტენდენციები / სუსტი</a:t>
             </a:r>
           </a:p>
           <a:p>
@@ -33518,7 +32941,7 @@
                 <a:cs typeface="Consolas"/>
                 <a:latin typeface="Consolas"/>
               </a:rPr>
-              <a:t>(Lovable, Supabase,</a:t>
+              <a:t>სიგნალები (5 ტენდენცია);</a:t>
             </a:r>
           </a:p>
           <a:p>
@@ -33536,7 +32959,7 @@
                 <a:cs typeface="Consolas"/>
                 <a:latin typeface="Consolas"/>
               </a:rPr>
-              <a:t>Make-ის გამოყენებით);</a:t>
+              <a:t>3. სამომავლო 3-წლიანი</a:t>
             </a:r>
           </a:p>
           <a:p>
@@ -33554,7 +32977,7 @@
                 <a:cs typeface="Consolas"/>
                 <a:latin typeface="Consolas"/>
               </a:rPr>
-              <a:t>3. 2-კვირიანი ნაბიჯ-ნაბიჯ</a:t>
+              <a:t>სცენარები: ოპტიმისტური,</a:t>
             </a:r>
           </a:p>
           <a:p>
@@ -33572,7 +32995,7 @@
                 <a:cs typeface="Consolas"/>
                 <a:latin typeface="Consolas"/>
               </a:rPr>
-              <a:t>სპრინტის გეგმა;</a:t>
+              <a:t>პესიმისტური და ყველაზე</a:t>
             </a:r>
           </a:p>
           <a:p>
@@ -33590,7 +33013,7 @@
                 <a:cs typeface="Consolas"/>
                 <a:latin typeface="Consolas"/>
               </a:rPr>
-              <a:t>4. ტესტირების სტრატეგია და</a:t>
+              <a:t>მოსალოდნელი სცენარი;</a:t>
             </a:r>
           </a:p>
           <a:p>
@@ -33608,7 +33031,7 @@
                 <a:cs typeface="Consolas"/>
                 <a:latin typeface="Consolas"/>
               </a:rPr>
-              <a:t>წარმატების კონკრეტული</a:t>
+              <a:t>4. 5 კონკრეტული ბიზნეს</a:t>
             </a:r>
           </a:p>
           <a:p>
@@ -33626,7 +33049,25 @@
                 <a:cs typeface="Consolas"/>
                 <a:latin typeface="Consolas"/>
               </a:rPr>
-              <a:t>მეტრიკები.</a:t>
+              <a:t>შესაძლებლობა, რომელიც ამ</a:t>
+            </a:r>
+          </a:p>
+          <a:p>
+            <a:pPr>
+              <a:spcAft>
+                <a:spcPts val="0"/>
+              </a:spcAft>
+            </a:pPr>
+            <a:r>
+              <a:rPr sz="1000">
+                <a:solidFill>
+                  <a:srgbClr val="0F172A"/>
+                </a:solidFill>
+                <a:ea typeface="Consolas"/>
+                <a:cs typeface="Consolas"/>
+                <a:latin typeface="Consolas"/>
+              </a:rPr>
+              <a:t>ტენდენციებს ეფუძნება.</a:t>
             </a:r>
           </a:p>
         </p:txBody>
@@ -33897,7 +33338,7 @@
                 <a:cs typeface="Sylfaen"/>
                 <a:latin typeface="Sylfaen"/>
               </a:rPr>
-              <a:t>✨ იდეის დახვეწა და სრულყოფა (Refinement)</a:t>
+              <a:t>⚖️ იდეების შეფასება და პრიორიტეტიზაცია</a:t>
             </a:r>
           </a:p>
         </p:txBody>
@@ -34131,7 +33572,7 @@
                 <a:cs typeface="Sylfaen"/>
                 <a:latin typeface="Sylfaen"/>
               </a:rPr>
-              <a:t>🛠️ იდეის ფილტრაცია 5 მიმართულებით:</a:t>
+              <a:t>📊 შეფასების კრიტერიუმები (1-10 ბალით):</a:t>
             </a:r>
           </a:p>
         </p:txBody>
@@ -34145,7 +33586,7 @@
         <p:spPr>
           <a:xfrm>
             <a:off x="621792" y="1655064"/>
-            <a:ext cx="3771900" cy="3122675"/>
+            <a:ext cx="3771900" cy="2962656"/>
           </a:xfrm>
           <a:prstGeom prst="rect">
             <a:avLst/>
@@ -34183,7 +33624,7 @@
                 <a:cs typeface="Sylfaen"/>
                 <a:latin typeface="Sylfaen"/>
               </a:rPr>
-              <a:t>კრიტიკა (Critique): რა სუსტი მხარეები აქვს იდეას? რა შეიძლება ჩაიშალოს?</a:t>
+              <a:t>გავლენა (Impact): რამხელა ეფექტი ექნება ბაზარზე?</a:t>
             </a:r>
           </a:p>
           <a:p>
@@ -34212,7 +33653,7 @@
                 <a:cs typeface="Sylfaen"/>
                 <a:latin typeface="Sylfaen"/>
               </a:rPr>
-              <a:t>გაძლიერება (Enhance): როგორ გავზარდოთ მისი ძირითადი სარგებელი?</a:t>
+              <a:t>განხორციელებადობა (Feasibility): რამდენად ადვილია MVP-ის აწყობა?</a:t>
             </a:r>
           </a:p>
           <a:p>
@@ -34241,7 +33682,7 @@
                 <a:cs typeface="Sylfaen"/>
                 <a:latin typeface="Sylfaen"/>
               </a:rPr>
-              <a:t>გამორჩევა (Differentiate): რით განსხვავდება არსებული გადაწყვეტებისგან?</a:t>
+              <a:t>დანახარჯი (Cost): რა რესურსებს მოითხოვს? (10 = ძალიან იაფი);</a:t>
             </a:r>
           </a:p>
           <a:p>
@@ -34270,36 +33711,7 @@
                 <a:cs typeface="Sylfaen"/>
                 <a:latin typeface="Sylfaen"/>
               </a:rPr>
-              <a:t>გამარტივება (Simplify): როგორ მოვაშოროთ ზედმეტი სირთულეები?</a:t>
-            </a:r>
-          </a:p>
-          <a:p>
-            <a:pPr algn="l">
-              <a:spcAft>
-                <a:spcPts val="300"/>
-              </a:spcAft>
-            </a:pPr>
-            <a:r>
-              <a:rPr sz="1300" b="1">
-                <a:solidFill>
-                  <a:srgbClr val="3730A3"/>
-                </a:solidFill>
-                <a:ea typeface="Sylfaen"/>
-                <a:cs typeface="Sylfaen"/>
-                <a:latin typeface="Sylfaen"/>
-              </a:rPr>
-              <a:t>▸  </a:t>
-            </a:r>
-            <a:r>
-              <a:rPr sz="1300">
-                <a:solidFill>
-                  <a:srgbClr val="0F172A"/>
-                </a:solidFill>
-                <a:ea typeface="Sylfaen"/>
-                <a:cs typeface="Sylfaen"/>
-                <a:latin typeface="Sylfaen"/>
-              </a:rPr>
-              <a:t>მასშტაბირება (Scale): როგორ გაიზრდება ბიზნესი მომავალში?</a:t>
+              <a:t>დრო (Time): რა დრო დასჭირდება გაშვებას? (10 = უსწრაფესი).</a:t>
             </a:r>
           </a:p>
         </p:txBody>
@@ -34570,7 +33982,7 @@
                 <a:cs typeface="Consolas"/>
                 <a:latin typeface="Consolas"/>
               </a:rPr>
-              <a:t>Idea Refinement Prompt:</a:t>
+              <a:t>Idea Evaluation Prompt:</a:t>
             </a:r>
           </a:p>
         </p:txBody>
@@ -34705,7 +34117,7 @@
                 <a:cs typeface="Consolas"/>
                 <a:latin typeface="Consolas"/>
               </a:rPr>
-              <a:t>ჩემი საწყისი იდეაა:</a:t>
+              <a:t>შეაფასე ეს იდეები:</a:t>
             </a:r>
           </a:p>
           <a:p>
@@ -34723,7 +34135,7 @@
                 <a:cs typeface="Consolas"/>
                 <a:latin typeface="Consolas"/>
               </a:rPr>
-              <a:t>[ჩაწერე იდეა].</a:t>
+              <a:t>[იდეების სია] შემდეგი</a:t>
             </a:r>
           </a:p>
           <a:p>
@@ -34741,7 +34153,7 @@
                 <a:cs typeface="Consolas"/>
                 <a:latin typeface="Consolas"/>
               </a:rPr>
-              <a:t>დამეხმარე მის დახვეწაში.</a:t>
+              <a:t>კრიტერიუმებით (1-10</a:t>
             </a:r>
           </a:p>
           <a:p>
@@ -34759,7 +34171,7 @@
                 <a:cs typeface="Consolas"/>
                 <a:latin typeface="Consolas"/>
               </a:rPr>
-              <a:t>გააკეთე ანალიზი 5</a:t>
+              <a:t>ბალით): Impact,</a:t>
             </a:r>
           </a:p>
           <a:p>
@@ -34777,7 +34189,7 @@
                 <a:cs typeface="Consolas"/>
                 <a:latin typeface="Consolas"/>
               </a:rPr>
-              <a:t>მიმართულებით:</a:t>
+              <a:t>Feasibility, Cost, Time და</a:t>
             </a:r>
           </a:p>
           <a:p>
@@ -34795,7 +34207,7 @@
                 <a:cs typeface="Consolas"/>
                 <a:latin typeface="Consolas"/>
               </a:rPr>
-              <a:t>1. კრიტიკა (რა არის სუსტი</a:t>
+              <a:t>Market Fit.</a:t>
             </a:r>
           </a:p>
           <a:p>
@@ -34813,7 +34225,7 @@
                 <a:cs typeface="Consolas"/>
                 <a:latin typeface="Consolas"/>
               </a:rPr>
-              <a:t>წერტილი?);</a:t>
+              <a:t>წარმოადგინე შედეგები</a:t>
             </a:r>
           </a:p>
           <a:p>
@@ -34831,7 +34243,7 @@
                 <a:cs typeface="Consolas"/>
                 <a:latin typeface="Consolas"/>
               </a:rPr>
-              <a:t>2. გაძლიერება (როგორ</a:t>
+              <a:t>Markdown ცხრილის სახით.</a:t>
             </a:r>
           </a:p>
           <a:p>
@@ -34849,7 +34261,7 @@
                 <a:cs typeface="Consolas"/>
                 <a:latin typeface="Consolas"/>
               </a:rPr>
-              <a:t>გავხადო უკეთესი?);</a:t>
+              <a:t>დააჯგუფე ისინი 4</a:t>
             </a:r>
           </a:p>
           <a:p>
@@ -34867,7 +34279,7 @@
                 <a:cs typeface="Consolas"/>
                 <a:latin typeface="Consolas"/>
               </a:rPr>
-              <a:t>3. გამორჩევა (როგორ</a:t>
+              <a:t>კატეგორიად:</a:t>
             </a:r>
           </a:p>
           <a:p>
@@ -34885,7 +34297,7 @@
                 <a:cs typeface="Consolas"/>
                 <a:latin typeface="Consolas"/>
               </a:rPr>
-              <a:t>შევუქმნა უნიკალურობა?);</a:t>
+              <a:t>1. სწრაფი გამარჯვებები</a:t>
             </a:r>
           </a:p>
           <a:p>
@@ -34903,7 +34315,7 @@
                 <a:cs typeface="Consolas"/>
                 <a:latin typeface="Consolas"/>
               </a:rPr>
-              <a:t>4. გამარტივება (როგორ</a:t>
+              <a:t>(Quick Wins - მაღალი</a:t>
             </a:r>
           </a:p>
           <a:p>
@@ -34921,7 +34333,7 @@
                 <a:cs typeface="Consolas"/>
                 <a:latin typeface="Consolas"/>
               </a:rPr>
-              <a:t>მივიღო მარტივი MVP</a:t>
+              <a:t>Impact, დაბალი</a:t>
             </a:r>
           </a:p>
           <a:p>
@@ -34939,7 +34351,7 @@
                 <a:cs typeface="Consolas"/>
                 <a:latin typeface="Consolas"/>
               </a:rPr>
-              <a:t>ვერსია?);</a:t>
+              <a:t>ძალისხმევა);</a:t>
             </a:r>
           </a:p>
           <a:p>
@@ -34957,7 +34369,7 @@
                 <a:cs typeface="Consolas"/>
                 <a:latin typeface="Consolas"/>
               </a:rPr>
-              <a:t>5. მასშტაბირება (როგორ</a:t>
+              <a:t>2. სტრატეგიული</a:t>
             </a:r>
           </a:p>
           <a:p>
@@ -34975,7 +34387,7 @@
                 <a:cs typeface="Consolas"/>
                 <a:latin typeface="Consolas"/>
               </a:rPr>
-              <a:t>გაიზრდება მომავალში?).</a:t>
+              <a:t>ინიციატივები (დიდი</a:t>
             </a:r>
           </a:p>
           <a:p>
@@ -34993,7 +34405,7 @@
                 <a:cs typeface="Consolas"/>
                 <a:latin typeface="Consolas"/>
               </a:rPr>
-              <a:t>ბოლოს შემომთავაზე იდეის</a:t>
+              <a:t>გავლენა, მაღალი</a:t>
             </a:r>
           </a:p>
           <a:p>
@@ -35011,7 +34423,115 @@
                 <a:cs typeface="Consolas"/>
                 <a:latin typeface="Consolas"/>
               </a:rPr>
-              <a:t>საბოლოო, დახვეწილი ვერსია.</a:t>
+              <a:t>ძალისხმევა);</a:t>
+            </a:r>
+          </a:p>
+          <a:p>
+            <a:pPr>
+              <a:spcAft>
+                <a:spcPts val="0"/>
+              </a:spcAft>
+            </a:pPr>
+            <a:r>
+              <a:rPr sz="1000">
+                <a:solidFill>
+                  <a:srgbClr val="0F172A"/>
+                </a:solidFill>
+                <a:ea typeface="Consolas"/>
+                <a:cs typeface="Consolas"/>
+                <a:latin typeface="Consolas"/>
+              </a:rPr>
+              <a:t>3. შემავსებლები (დაბალი</a:t>
+            </a:r>
+          </a:p>
+          <a:p>
+            <a:pPr>
+              <a:spcAft>
+                <a:spcPts val="0"/>
+              </a:spcAft>
+            </a:pPr>
+            <a:r>
+              <a:rPr sz="1000">
+                <a:solidFill>
+                  <a:srgbClr val="0F172A"/>
+                </a:solidFill>
+                <a:ea typeface="Consolas"/>
+                <a:cs typeface="Consolas"/>
+                <a:latin typeface="Consolas"/>
+              </a:rPr>
+              <a:t>გავლენა, დაბალი</a:t>
+            </a:r>
+          </a:p>
+          <a:p>
+            <a:pPr>
+              <a:spcAft>
+                <a:spcPts val="0"/>
+              </a:spcAft>
+            </a:pPr>
+            <a:r>
+              <a:rPr sz="1000">
+                <a:solidFill>
+                  <a:srgbClr val="0F172A"/>
+                </a:solidFill>
+                <a:ea typeface="Consolas"/>
+                <a:cs typeface="Consolas"/>
+                <a:latin typeface="Consolas"/>
+              </a:rPr>
+              <a:t>ძალისხმევა);</a:t>
+            </a:r>
+          </a:p>
+          <a:p>
+            <a:pPr>
+              <a:spcAft>
+                <a:spcPts val="0"/>
+              </a:spcAft>
+            </a:pPr>
+            <a:r>
+              <a:rPr sz="1000">
+                <a:solidFill>
+                  <a:srgbClr val="0F172A"/>
+                </a:solidFill>
+                <a:ea typeface="Consolas"/>
+                <a:cs typeface="Consolas"/>
+                <a:latin typeface="Consolas"/>
+              </a:rPr>
+              <a:t>4. დროის მჭამელები (დაბალი</a:t>
+            </a:r>
+          </a:p>
+          <a:p>
+            <a:pPr>
+              <a:spcAft>
+                <a:spcPts val="0"/>
+              </a:spcAft>
+            </a:pPr>
+            <a:r>
+              <a:rPr sz="1000">
+                <a:solidFill>
+                  <a:srgbClr val="0F172A"/>
+                </a:solidFill>
+                <a:ea typeface="Consolas"/>
+                <a:cs typeface="Consolas"/>
+                <a:latin typeface="Consolas"/>
+              </a:rPr>
+              <a:t>გავლენა, მაღალი</a:t>
+            </a:r>
+          </a:p>
+          <a:p>
+            <a:pPr>
+              <a:spcAft>
+                <a:spcPts val="0"/>
+              </a:spcAft>
+            </a:pPr>
+            <a:r>
+              <a:rPr sz="1000">
+                <a:solidFill>
+                  <a:srgbClr val="0F172A"/>
+                </a:solidFill>
+                <a:ea typeface="Consolas"/>
+                <a:cs typeface="Consolas"/>
+                <a:latin typeface="Consolas"/>
+              </a:rPr>
+              <a:t>ძალისხმევა).</a:t>
             </a:r>
           </a:p>
         </p:txBody>
@@ -35282,7 +34802,7 @@
                 <a:cs typeface="Sylfaen"/>
                 <a:latin typeface="Sylfaen"/>
               </a:rPr>
-              <a:t>🎨 ChatGPT Canvas — ინტერაქტიული ბრეინშტორმინგი</a:t>
+              <a:t>✨ იდეის დახვეწა და სრულყოფა (Refinement)</a:t>
             </a:r>
           </a:p>
         </p:txBody>
@@ -35516,7 +35036,7 @@
                 <a:cs typeface="Sylfaen"/>
                 <a:latin typeface="Sylfaen"/>
               </a:rPr>
-              <a:t>💡 რა შეუძლია Canvas-ს ბრეინშტორმინგში:</a:t>
+              <a:t>🛠️ იდეის ფილტრაცია 5 მიმართულებით:</a:t>
             </a:r>
           </a:p>
         </p:txBody>
@@ -35530,7 +35050,7 @@
         <p:spPr>
           <a:xfrm>
             <a:off x="621792" y="1655064"/>
-            <a:ext cx="3771900" cy="2962656"/>
+            <a:ext cx="3771900" cy="3122675"/>
           </a:xfrm>
           <a:prstGeom prst="rect">
             <a:avLst/>
@@ -35568,7 +35088,7 @@
                 <a:cs typeface="Sylfaen"/>
                 <a:latin typeface="Sylfaen"/>
               </a:rPr>
-              <a:t>📝 ინლაინ რედაქტირება: შეცვალეთ ტექსტი უშუალოდ სამუშაო დაფაზე;</a:t>
+              <a:t>კრიტიკა (Critique): რა სუსტი მხარეები აქვს იდეას? რა შეიძლება ჩაიშალოს?</a:t>
             </a:r>
           </a:p>
           <a:p>
@@ -35597,7 +35117,7 @@
                 <a:cs typeface="Sylfaen"/>
                 <a:latin typeface="Sylfaen"/>
               </a:rPr>
-              <a:t>🎯 კონკრეტული უკუკავშირი: მონიშნეთ აბზაცი და სთხოვეთ ალტერნატივები;</a:t>
+              <a:t>გაძლიერება (Enhance): როგორ გავზარდოთ მისი ძირითადი სარგებელი?</a:t>
             </a:r>
           </a:p>
           <a:p>
@@ -35626,7 +35146,7 @@
                 <a:cs typeface="Sylfaen"/>
                 <a:latin typeface="Sylfaen"/>
               </a:rPr>
-              <a:t>🔄 ვერსიების კონტროლი: დააბრუნეთ წინა წარმატებული იდეები;</a:t>
+              <a:t>გამორჩევა (Differentiate): რით განსხვავდება არსებული გადაწყვეტებისგან?</a:t>
             </a:r>
           </a:p>
           <a:p>
@@ -35655,7 +35175,36 @@
                 <a:cs typeface="Sylfaen"/>
                 <a:latin typeface="Sylfaen"/>
               </a:rPr>
-              <a:t>✨ სწრაფი ქმედებები: ერთი კლიკით შეცვალეთ ტონის ფორმატები.</a:t>
+              <a:t>გამარტივება (Simplify): როგორ მოვაშოროთ ზედმეტი სირთულეები?</a:t>
+            </a:r>
+          </a:p>
+          <a:p>
+            <a:pPr algn="l">
+              <a:spcAft>
+                <a:spcPts val="300"/>
+              </a:spcAft>
+            </a:pPr>
+            <a:r>
+              <a:rPr sz="1300" b="1">
+                <a:solidFill>
+                  <a:srgbClr val="3730A3"/>
+                </a:solidFill>
+                <a:ea typeface="Sylfaen"/>
+                <a:cs typeface="Sylfaen"/>
+                <a:latin typeface="Sylfaen"/>
+              </a:rPr>
+              <a:t>▸  </a:t>
+            </a:r>
+            <a:r>
+              <a:rPr sz="1300">
+                <a:solidFill>
+                  <a:srgbClr val="0F172A"/>
+                </a:solidFill>
+                <a:ea typeface="Sylfaen"/>
+                <a:cs typeface="Sylfaen"/>
+                <a:latin typeface="Sylfaen"/>
+              </a:rPr>
+              <a:t>მასშტაბირება (Scale): როგორ გაიზრდება ბიზნესი მომავალში?</a:t>
             </a:r>
           </a:p>
         </p:txBody>
@@ -35725,6 +35274,98 @@
           </a:solidFill>
           <a:ln w="6350">
             <a:solidFill>
+              <a:srgbClr val="3730A3"/>
+            </a:solidFill>
+          </a:ln>
+          <a:effectLst/>
+        </p:spPr>
+        <p:style>
+          <a:lnRef idx="1">
+            <a:schemeClr val="accent1"/>
+          </a:lnRef>
+          <a:fillRef idx="3">
+            <a:schemeClr val="accent1"/>
+          </a:fillRef>
+          <a:effectRef idx="2">
+            <a:schemeClr val="accent1"/>
+          </a:effectRef>
+          <a:fontRef idx="minor">
+            <a:schemeClr val="lt1"/>
+          </a:fontRef>
+        </p:style>
+        <p:txBody>
+          <a:bodyPr rtlCol="0" anchor="ctr"/>
+          <a:lstStyle/>
+          <a:p>
+            <a:pPr algn="ctr"/>
+          </a:p>
+        </p:txBody>
+      </p:sp>
+      <p:sp>
+        <p:nvSpPr>
+          <p:cNvPr id="14" name="Rectangle 13"/>
+          <p:cNvSpPr/>
+          <p:nvPr/>
+        </p:nvSpPr>
+        <p:spPr>
+          <a:xfrm>
+            <a:off x="4805172" y="1261872"/>
+            <a:ext cx="54864" cy="292608"/>
+          </a:xfrm>
+          <a:prstGeom prst="rect">
+            <a:avLst/>
+          </a:prstGeom>
+          <a:solidFill>
+            <a:srgbClr val="3730A3"/>
+          </a:solidFill>
+          <a:ln>
+            <a:noFill/>
+          </a:ln>
+          <a:effectLst/>
+        </p:spPr>
+        <p:style>
+          <a:lnRef idx="1">
+            <a:schemeClr val="accent1"/>
+          </a:lnRef>
+          <a:fillRef idx="3">
+            <a:schemeClr val="accent1"/>
+          </a:fillRef>
+          <a:effectRef idx="2">
+            <a:schemeClr val="accent1"/>
+          </a:effectRef>
+          <a:fontRef idx="minor">
+            <a:schemeClr val="lt1"/>
+          </a:fontRef>
+        </p:style>
+        <p:txBody>
+          <a:bodyPr rtlCol="0" anchor="ctr"/>
+          <a:lstStyle/>
+          <a:p>
+            <a:pPr algn="ctr"/>
+          </a:p>
+        </p:txBody>
+      </p:sp>
+      <p:sp>
+        <p:nvSpPr>
+          <p:cNvPr id="15" name="Rounded Rectangle 14"/>
+          <p:cNvSpPr/>
+          <p:nvPr/>
+        </p:nvSpPr>
+        <p:spPr>
+          <a:xfrm>
+            <a:off x="4860036" y="1261872"/>
+            <a:ext cx="3717036" cy="292608"/>
+          </a:xfrm>
+          <a:prstGeom prst="roundRect">
+            <a:avLst>
+              <a:gd name="adj" fmla="val 4000"/>
+            </a:avLst>
+          </a:prstGeom>
+          <a:solidFill>
+            <a:srgbClr val="F8FAFC"/>
+          </a:solidFill>
+          <a:ln w="9525">
+            <a:solidFill>
               <a:srgbClr val="E2E8F0"/>
             </a:solidFill>
           </a:ln>
@@ -35754,14 +35395,60 @@
       </p:sp>
       <p:sp>
         <p:nvSpPr>
-          <p:cNvPr id="14" name="TextBox 13"/>
+          <p:cNvPr id="16" name="Rectangle 15"/>
+          <p:cNvSpPr/>
+          <p:nvPr/>
+        </p:nvSpPr>
+        <p:spPr>
+          <a:xfrm>
+            <a:off x="4914900" y="1316736"/>
+            <a:ext cx="3552444" cy="201168"/>
+          </a:xfrm>
+          <a:prstGeom prst="rect">
+            <a:avLst/>
+          </a:prstGeom>
+          <a:solidFill>
+            <a:srgbClr val="FFFFFF"/>
+          </a:solidFill>
+          <a:ln w="6350">
+            <a:solidFill>
+              <a:srgbClr val="E2E8F0"/>
+            </a:solidFill>
+          </a:ln>
+          <a:effectLst/>
+        </p:spPr>
+        <p:style>
+          <a:lnRef idx="1">
+            <a:schemeClr val="accent1"/>
+          </a:lnRef>
+          <a:fillRef idx="3">
+            <a:schemeClr val="accent1"/>
+          </a:fillRef>
+          <a:effectRef idx="2">
+            <a:schemeClr val="accent1"/>
+          </a:effectRef>
+          <a:fontRef idx="minor">
+            <a:schemeClr val="lt1"/>
+          </a:fontRef>
+        </p:style>
+        <p:txBody>
+          <a:bodyPr rtlCol="0" anchor="ctr"/>
+          <a:lstStyle/>
+          <a:p>
+            <a:pPr algn="ctr"/>
+          </a:p>
+        </p:txBody>
+      </p:sp>
+      <p:sp>
+        <p:nvSpPr>
+          <p:cNvPr id="17" name="TextBox 16"/>
           <p:cNvSpPr txBox="1"/>
           <p:nvPr/>
         </p:nvSpPr>
         <p:spPr>
           <a:xfrm>
-            <a:off x="4805172" y="1261872"/>
-            <a:ext cx="3771900" cy="320040"/>
+            <a:off x="4969764" y="1344168"/>
+            <a:ext cx="3442716" cy="146304"/>
           </a:xfrm>
           <a:prstGeom prst="rect">
             <a:avLst/>
@@ -35776,33 +35463,127 @@
           <a:p>
             <a:pPr>
               <a:spcAft>
-                <a:spcPts val="400"/>
-              </a:spcAft>
-            </a:pPr>
-            <a:r>
-              <a:rPr sz="1400" b="1" i="0">
-                <a:solidFill>
-                  <a:srgbClr val="0F172A"/>
-                </a:solidFill>
-                <a:ea typeface="Sylfaen"/>
-                <a:cs typeface="Sylfaen"/>
-                <a:latin typeface="Sylfaen"/>
-              </a:rPr>
-              <a:t>🚀 როგორ გამოვიყენოთ პრაქტიკაში:</a:t>
-            </a:r>
-          </a:p>
-        </p:txBody>
-      </p:sp>
-      <p:sp>
-        <p:nvSpPr>
-          <p:cNvPr id="15" name="TextBox 14"/>
+                <a:spcPts val="0"/>
+              </a:spcAft>
+            </a:pPr>
+            <a:r>
+              <a:rPr sz="1200">
+                <a:solidFill>
+                  <a:srgbClr val="0F172A"/>
+                </a:solidFill>
+                <a:ea typeface="Consolas"/>
+                <a:cs typeface="Consolas"/>
+                <a:latin typeface="Consolas"/>
+              </a:rPr>
+              <a:t>Idea Refinement Prompt:</a:t>
+            </a:r>
+          </a:p>
+        </p:txBody>
+      </p:sp>
+      <p:sp>
+        <p:nvSpPr>
+          <p:cNvPr id="18" name="Rounded Rectangle 17"/>
+          <p:cNvSpPr/>
+          <p:nvPr/>
+        </p:nvSpPr>
+        <p:spPr>
+          <a:xfrm>
+            <a:off x="4805172" y="1627632"/>
+            <a:ext cx="3771900" cy="3150108"/>
+          </a:xfrm>
+          <a:prstGeom prst="roundRect">
+            <a:avLst>
+              <a:gd name="adj" fmla="val 4000"/>
+            </a:avLst>
+          </a:prstGeom>
+          <a:solidFill>
+            <a:srgbClr val="F8FAFC"/>
+          </a:solidFill>
+          <a:ln w="9525">
+            <a:solidFill>
+              <a:srgbClr val="E2E8F0"/>
+            </a:solidFill>
+          </a:ln>
+          <a:effectLst/>
+        </p:spPr>
+        <p:style>
+          <a:lnRef idx="1">
+            <a:schemeClr val="accent1"/>
+          </a:lnRef>
+          <a:fillRef idx="3">
+            <a:schemeClr val="accent1"/>
+          </a:fillRef>
+          <a:effectRef idx="2">
+            <a:schemeClr val="accent1"/>
+          </a:effectRef>
+          <a:fontRef idx="minor">
+            <a:schemeClr val="lt1"/>
+          </a:fontRef>
+        </p:style>
+        <p:txBody>
+          <a:bodyPr rtlCol="0" anchor="ctr"/>
+          <a:lstStyle/>
+          <a:p>
+            <a:pPr algn="ctr"/>
+          </a:p>
+        </p:txBody>
+      </p:sp>
+      <p:sp>
+        <p:nvSpPr>
+          <p:cNvPr id="19" name="Rectangle 18"/>
+          <p:cNvSpPr/>
+          <p:nvPr/>
+        </p:nvSpPr>
+        <p:spPr>
+          <a:xfrm>
+            <a:off x="4860036" y="1673352"/>
+            <a:ext cx="3662172" cy="3058668"/>
+          </a:xfrm>
+          <a:prstGeom prst="rect">
+            <a:avLst/>
+          </a:prstGeom>
+          <a:solidFill>
+            <a:srgbClr val="FFFFFF"/>
+          </a:solidFill>
+          <a:ln w="6350">
+            <a:solidFill>
+              <a:srgbClr val="E2E8F0"/>
+            </a:solidFill>
+          </a:ln>
+          <a:effectLst/>
+        </p:spPr>
+        <p:style>
+          <a:lnRef idx="1">
+            <a:schemeClr val="accent1"/>
+          </a:lnRef>
+          <a:fillRef idx="3">
+            <a:schemeClr val="accent1"/>
+          </a:fillRef>
+          <a:effectRef idx="2">
+            <a:schemeClr val="accent1"/>
+          </a:effectRef>
+          <a:fontRef idx="minor">
+            <a:schemeClr val="lt1"/>
+          </a:fontRef>
+        </p:style>
+        <p:txBody>
+          <a:bodyPr rtlCol="0" anchor="ctr"/>
+          <a:lstStyle/>
+          <a:p>
+            <a:pPr algn="ctr"/>
+          </a:p>
+        </p:txBody>
+      </p:sp>
+      <p:sp>
+        <p:nvSpPr>
+          <p:cNvPr id="20" name="TextBox 19"/>
           <p:cNvSpPr txBox="1"/>
           <p:nvPr/>
         </p:nvSpPr>
         <p:spPr>
           <a:xfrm>
-            <a:off x="4805172" y="1655064"/>
-            <a:ext cx="3771900" cy="3122675"/>
+            <a:off x="4914900" y="1691640"/>
+            <a:ext cx="3552444" cy="3022091"/>
           </a:xfrm>
           <a:prstGeom prst="rect">
             <a:avLst/>
@@ -35815,126 +35596,334 @@
           </a:bodyPr>
           <a:lstStyle/>
           <a:p>
-            <a:pPr algn="l">
-              <a:spcAft>
-                <a:spcPts val="300"/>
-              </a:spcAft>
-            </a:pPr>
-            <a:r>
-              <a:rPr sz="1300" b="1">
-                <a:solidFill>
-                  <a:srgbClr val="3730A3"/>
-                </a:solidFill>
-                <a:ea typeface="Sylfaen"/>
-                <a:cs typeface="Sylfaen"/>
-                <a:latin typeface="Sylfaen"/>
-              </a:rPr>
-              <a:t>1.  </a:t>
-            </a:r>
-            <a:r>
-              <a:rPr sz="1300">
-                <a:solidFill>
-                  <a:srgbClr val="0F172A"/>
-                </a:solidFill>
-                <a:ea typeface="Sylfaen"/>
-                <a:cs typeface="Sylfaen"/>
-                <a:latin typeface="Sylfaen"/>
-              </a:rPr>
-              <a:t>დაიწყეთ იდეების გენერაცია ჩვეულებრივ ჩატში;</a:t>
-            </a:r>
-          </a:p>
-          <a:p>
-            <a:pPr algn="l">
-              <a:spcAft>
-                <a:spcPts val="300"/>
-              </a:spcAft>
-            </a:pPr>
-            <a:r>
-              <a:rPr sz="1300" b="1">
-                <a:solidFill>
-                  <a:srgbClr val="3730A3"/>
-                </a:solidFill>
-                <a:ea typeface="Sylfaen"/>
-                <a:cs typeface="Sylfaen"/>
-                <a:latin typeface="Sylfaen"/>
-              </a:rPr>
-              <a:t>2.  </a:t>
-            </a:r>
-            <a:r>
-              <a:rPr sz="1300">
-                <a:solidFill>
-                  <a:srgbClr val="0F172A"/>
-                </a:solidFill>
-                <a:ea typeface="Sylfaen"/>
-                <a:cs typeface="Sylfaen"/>
-                <a:latin typeface="Sylfaen"/>
-              </a:rPr>
-              <a:t>სთხოვეთ AI-ს: „გახსენი ეს ტექსტი Canvas-ში“ ან გამოიყენეთ ბრძანება „use canvas“ ;</a:t>
-            </a:r>
-          </a:p>
-          <a:p>
-            <a:pPr algn="l">
-              <a:spcAft>
-                <a:spcPts val="300"/>
-              </a:spcAft>
-            </a:pPr>
-            <a:r>
-              <a:rPr sz="1300" b="1">
-                <a:solidFill>
-                  <a:srgbClr val="3730A3"/>
-                </a:solidFill>
-                <a:ea typeface="Sylfaen"/>
-                <a:cs typeface="Sylfaen"/>
-                <a:latin typeface="Sylfaen"/>
-              </a:rPr>
-              <a:t>3.  </a:t>
-            </a:r>
-            <a:r>
-              <a:rPr sz="1300">
-                <a:solidFill>
-                  <a:srgbClr val="0F172A"/>
-                </a:solidFill>
-                <a:ea typeface="Sylfaen"/>
-                <a:cs typeface="Sylfaen"/>
-                <a:latin typeface="Sylfaen"/>
-              </a:rPr>
-              <a:t>მონიშნეთ სუსტი იდეები და სთხოვეთ მათი გაუმჯობესება;</a:t>
-            </a:r>
-          </a:p>
-          <a:p>
-            <a:pPr algn="l">
-              <a:spcAft>
-                <a:spcPts val="300"/>
-              </a:spcAft>
-            </a:pPr>
-            <a:r>
-              <a:rPr sz="1300" b="1">
-                <a:solidFill>
-                  <a:srgbClr val="3730A3"/>
-                </a:solidFill>
-                <a:ea typeface="Sylfaen"/>
-                <a:cs typeface="Sylfaen"/>
-                <a:latin typeface="Sylfaen"/>
-              </a:rPr>
-              <a:t>4.  </a:t>
-            </a:r>
-            <a:r>
-              <a:rPr sz="1300">
-                <a:solidFill>
-                  <a:srgbClr val="0F172A"/>
-                </a:solidFill>
-                <a:ea typeface="Sylfaen"/>
-                <a:cs typeface="Sylfaen"/>
-                <a:latin typeface="Sylfaen"/>
-              </a:rPr>
-              <a:t>გააკეთეთ ექსპორტი ან გაუზიარეთ გუნდის წევრებს ბმულით.</a:t>
-            </a:r>
-          </a:p>
-        </p:txBody>
-      </p:sp>
-      <p:sp>
-        <p:nvSpPr>
-          <p:cNvPr id="16" name="Rectangle 15"/>
+            <a:pPr>
+              <a:spcAft>
+                <a:spcPts val="0"/>
+              </a:spcAft>
+            </a:pPr>
+            <a:r>
+              <a:rPr sz="1000">
+                <a:solidFill>
+                  <a:srgbClr val="0F172A"/>
+                </a:solidFill>
+                <a:ea typeface="Consolas"/>
+                <a:cs typeface="Consolas"/>
+                <a:latin typeface="Consolas"/>
+              </a:rPr>
+              <a:t>ჩემი საწყისი იდეაა:</a:t>
+            </a:r>
+          </a:p>
+          <a:p>
+            <a:pPr>
+              <a:spcAft>
+                <a:spcPts val="0"/>
+              </a:spcAft>
+            </a:pPr>
+            <a:r>
+              <a:rPr sz="1000">
+                <a:solidFill>
+                  <a:srgbClr val="0F172A"/>
+                </a:solidFill>
+                <a:ea typeface="Consolas"/>
+                <a:cs typeface="Consolas"/>
+                <a:latin typeface="Consolas"/>
+              </a:rPr>
+              <a:t>[ჩაწერე იდეა].</a:t>
+            </a:r>
+          </a:p>
+          <a:p>
+            <a:pPr>
+              <a:spcAft>
+                <a:spcPts val="0"/>
+              </a:spcAft>
+            </a:pPr>
+            <a:r>
+              <a:rPr sz="1000">
+                <a:solidFill>
+                  <a:srgbClr val="0F172A"/>
+                </a:solidFill>
+                <a:ea typeface="Consolas"/>
+                <a:cs typeface="Consolas"/>
+                <a:latin typeface="Consolas"/>
+              </a:rPr>
+              <a:t>დამეხმარე მის დახვეწაში.</a:t>
+            </a:r>
+          </a:p>
+          <a:p>
+            <a:pPr>
+              <a:spcAft>
+                <a:spcPts val="0"/>
+              </a:spcAft>
+            </a:pPr>
+            <a:r>
+              <a:rPr sz="1000">
+                <a:solidFill>
+                  <a:srgbClr val="0F172A"/>
+                </a:solidFill>
+                <a:ea typeface="Consolas"/>
+                <a:cs typeface="Consolas"/>
+                <a:latin typeface="Consolas"/>
+              </a:rPr>
+              <a:t>გააკეთე ანალიზი 5</a:t>
+            </a:r>
+          </a:p>
+          <a:p>
+            <a:pPr>
+              <a:spcAft>
+                <a:spcPts val="0"/>
+              </a:spcAft>
+            </a:pPr>
+            <a:r>
+              <a:rPr sz="1000">
+                <a:solidFill>
+                  <a:srgbClr val="0F172A"/>
+                </a:solidFill>
+                <a:ea typeface="Consolas"/>
+                <a:cs typeface="Consolas"/>
+                <a:latin typeface="Consolas"/>
+              </a:rPr>
+              <a:t>მიმართულებით:</a:t>
+            </a:r>
+          </a:p>
+          <a:p>
+            <a:pPr>
+              <a:spcAft>
+                <a:spcPts val="0"/>
+              </a:spcAft>
+            </a:pPr>
+            <a:r>
+              <a:rPr sz="1000">
+                <a:solidFill>
+                  <a:srgbClr val="0F172A"/>
+                </a:solidFill>
+                <a:ea typeface="Consolas"/>
+                <a:cs typeface="Consolas"/>
+                <a:latin typeface="Consolas"/>
+              </a:rPr>
+              <a:t>1. კრიტიკა (რა არის სუსტი</a:t>
+            </a:r>
+          </a:p>
+          <a:p>
+            <a:pPr>
+              <a:spcAft>
+                <a:spcPts val="0"/>
+              </a:spcAft>
+            </a:pPr>
+            <a:r>
+              <a:rPr sz="1000">
+                <a:solidFill>
+                  <a:srgbClr val="0F172A"/>
+                </a:solidFill>
+                <a:ea typeface="Consolas"/>
+                <a:cs typeface="Consolas"/>
+                <a:latin typeface="Consolas"/>
+              </a:rPr>
+              <a:t>წერტილი?);</a:t>
+            </a:r>
+          </a:p>
+          <a:p>
+            <a:pPr>
+              <a:spcAft>
+                <a:spcPts val="0"/>
+              </a:spcAft>
+            </a:pPr>
+            <a:r>
+              <a:rPr sz="1000">
+                <a:solidFill>
+                  <a:srgbClr val="0F172A"/>
+                </a:solidFill>
+                <a:ea typeface="Consolas"/>
+                <a:cs typeface="Consolas"/>
+                <a:latin typeface="Consolas"/>
+              </a:rPr>
+              <a:t>2. გაძლიერება (როგორ</a:t>
+            </a:r>
+          </a:p>
+          <a:p>
+            <a:pPr>
+              <a:spcAft>
+                <a:spcPts val="0"/>
+              </a:spcAft>
+            </a:pPr>
+            <a:r>
+              <a:rPr sz="1000">
+                <a:solidFill>
+                  <a:srgbClr val="0F172A"/>
+                </a:solidFill>
+                <a:ea typeface="Consolas"/>
+                <a:cs typeface="Consolas"/>
+                <a:latin typeface="Consolas"/>
+              </a:rPr>
+              <a:t>გავხადო უკეთესი?);</a:t>
+            </a:r>
+          </a:p>
+          <a:p>
+            <a:pPr>
+              <a:spcAft>
+                <a:spcPts val="0"/>
+              </a:spcAft>
+            </a:pPr>
+            <a:r>
+              <a:rPr sz="1000">
+                <a:solidFill>
+                  <a:srgbClr val="0F172A"/>
+                </a:solidFill>
+                <a:ea typeface="Consolas"/>
+                <a:cs typeface="Consolas"/>
+                <a:latin typeface="Consolas"/>
+              </a:rPr>
+              <a:t>3. გამორჩევა (როგორ</a:t>
+            </a:r>
+          </a:p>
+          <a:p>
+            <a:pPr>
+              <a:spcAft>
+                <a:spcPts val="0"/>
+              </a:spcAft>
+            </a:pPr>
+            <a:r>
+              <a:rPr sz="1000">
+                <a:solidFill>
+                  <a:srgbClr val="0F172A"/>
+                </a:solidFill>
+                <a:ea typeface="Consolas"/>
+                <a:cs typeface="Consolas"/>
+                <a:latin typeface="Consolas"/>
+              </a:rPr>
+              <a:t>შევუქმნა უნიკალურობა?);</a:t>
+            </a:r>
+          </a:p>
+          <a:p>
+            <a:pPr>
+              <a:spcAft>
+                <a:spcPts val="0"/>
+              </a:spcAft>
+            </a:pPr>
+            <a:r>
+              <a:rPr sz="1000">
+                <a:solidFill>
+                  <a:srgbClr val="0F172A"/>
+                </a:solidFill>
+                <a:ea typeface="Consolas"/>
+                <a:cs typeface="Consolas"/>
+                <a:latin typeface="Consolas"/>
+              </a:rPr>
+              <a:t>4. გამარტივება (როგორ</a:t>
+            </a:r>
+          </a:p>
+          <a:p>
+            <a:pPr>
+              <a:spcAft>
+                <a:spcPts val="0"/>
+              </a:spcAft>
+            </a:pPr>
+            <a:r>
+              <a:rPr sz="1000">
+                <a:solidFill>
+                  <a:srgbClr val="0F172A"/>
+                </a:solidFill>
+                <a:ea typeface="Consolas"/>
+                <a:cs typeface="Consolas"/>
+                <a:latin typeface="Consolas"/>
+              </a:rPr>
+              <a:t>მივიღო მარტივი MVP</a:t>
+            </a:r>
+          </a:p>
+          <a:p>
+            <a:pPr>
+              <a:spcAft>
+                <a:spcPts val="0"/>
+              </a:spcAft>
+            </a:pPr>
+            <a:r>
+              <a:rPr sz="1000">
+                <a:solidFill>
+                  <a:srgbClr val="0F172A"/>
+                </a:solidFill>
+                <a:ea typeface="Consolas"/>
+                <a:cs typeface="Consolas"/>
+                <a:latin typeface="Consolas"/>
+              </a:rPr>
+              <a:t>ვერსია?);</a:t>
+            </a:r>
+          </a:p>
+          <a:p>
+            <a:pPr>
+              <a:spcAft>
+                <a:spcPts val="0"/>
+              </a:spcAft>
+            </a:pPr>
+            <a:r>
+              <a:rPr sz="1000">
+                <a:solidFill>
+                  <a:srgbClr val="0F172A"/>
+                </a:solidFill>
+                <a:ea typeface="Consolas"/>
+                <a:cs typeface="Consolas"/>
+                <a:latin typeface="Consolas"/>
+              </a:rPr>
+              <a:t>5. მასშტაბირება (როგორ</a:t>
+            </a:r>
+          </a:p>
+          <a:p>
+            <a:pPr>
+              <a:spcAft>
+                <a:spcPts val="0"/>
+              </a:spcAft>
+            </a:pPr>
+            <a:r>
+              <a:rPr sz="1000">
+                <a:solidFill>
+                  <a:srgbClr val="0F172A"/>
+                </a:solidFill>
+                <a:ea typeface="Consolas"/>
+                <a:cs typeface="Consolas"/>
+                <a:latin typeface="Consolas"/>
+              </a:rPr>
+              <a:t>გაიზრდება მომავალში?).</a:t>
+            </a:r>
+          </a:p>
+          <a:p>
+            <a:pPr>
+              <a:spcAft>
+                <a:spcPts val="0"/>
+              </a:spcAft>
+            </a:pPr>
+            <a:r>
+              <a:rPr sz="1000">
+                <a:solidFill>
+                  <a:srgbClr val="0F172A"/>
+                </a:solidFill>
+                <a:ea typeface="Consolas"/>
+                <a:cs typeface="Consolas"/>
+                <a:latin typeface="Consolas"/>
+              </a:rPr>
+              <a:t>ბოლოს შემომთავაზე იდეის</a:t>
+            </a:r>
+          </a:p>
+          <a:p>
+            <a:pPr>
+              <a:spcAft>
+                <a:spcPts val="0"/>
+              </a:spcAft>
+            </a:pPr>
+            <a:r>
+              <a:rPr sz="1000">
+                <a:solidFill>
+                  <a:srgbClr val="0F172A"/>
+                </a:solidFill>
+                <a:ea typeface="Consolas"/>
+                <a:cs typeface="Consolas"/>
+                <a:latin typeface="Consolas"/>
+              </a:rPr>
+              <a:t>საბოლოო, დახვეწილი ვერსია.</a:t>
+            </a:r>
+          </a:p>
+        </p:txBody>
+      </p:sp>
+      <p:sp>
+        <p:nvSpPr>
+          <p:cNvPr id="21" name="Rectangle 20"/>
           <p:cNvSpPr/>
           <p:nvPr/>
         </p:nvSpPr>
@@ -35978,7 +35967,7 @@
       </p:sp>
       <p:sp>
         <p:nvSpPr>
-          <p:cNvPr id="17" name="TextBox 16"/>
+          <p:cNvPr id="22" name="TextBox 21"/>
           <p:cNvSpPr txBox="1"/>
           <p:nvPr/>
         </p:nvSpPr>
@@ -37208,7 +37197,7 @@
                 <a:cs typeface="Sylfaen"/>
                 <a:latin typeface="Sylfaen"/>
               </a:rPr>
-              <a:t>🎨 ბრენდინგის იდეები &amp; შეჯამება</a:t>
+              <a:t>⚡ სწრაფი პროტოტიპირების იდეაცია (Rapid Prototyping)</a:t>
             </a:r>
           </a:p>
         </p:txBody>
@@ -37442,7 +37431,7 @@
                 <a:cs typeface="Sylfaen"/>
                 <a:latin typeface="Sylfaen"/>
               </a:rPr>
-              <a:t>🏷️ სახელების 3 ძირითადი კატეგორია:</a:t>
+              <a:t>📋 სწრაფი პროტოტიპის გეგმის ელემენტები:</a:t>
             </a:r>
           </a:p>
         </p:txBody>
@@ -37456,7 +37445,7 @@
         <p:spPr>
           <a:xfrm>
             <a:off x="621792" y="1655064"/>
-            <a:ext cx="3771900" cy="2816352"/>
+            <a:ext cx="3771900" cy="3122675"/>
           </a:xfrm>
           <a:prstGeom prst="rect">
             <a:avLst/>
@@ -37494,7 +37483,7 @@
                 <a:cs typeface="Sylfaen"/>
                 <a:latin typeface="Sylfaen"/>
               </a:rPr>
-              <a:t>აღწერითი: რაც პირდაპირ გამოხატავს საქმიანობას (მაგ: HomeChef, LocalKitchen);</a:t>
+              <a:t>🎯 ძირითადი ფუნქციონალი: მხოლოდ აუცილებელი Core ფუნქციები;</a:t>
             </a:r>
           </a:p>
           <a:p>
@@ -37523,7 +37512,7 @@
                 <a:cs typeface="Sylfaen"/>
                 <a:latin typeface="Sylfaen"/>
               </a:rPr>
-              <a:t>აბსტრაქტული / გამოგონილი: ჟღერადი, ახალი სიტყვები (მაგ: Foodly, Tastora);</a:t>
+              <a:t>🛠️ ტექნოლოგიური სტეკი: No-Code/Low-Code ხელსაწყოების შერჩევა (Lovable, Supabase, Make);</a:t>
             </a:r>
           </a:p>
           <a:p>
@@ -37552,7 +37541,36 @@
                 <a:cs typeface="Sylfaen"/>
                 <a:latin typeface="Sylfaen"/>
               </a:rPr>
-              <a:t>ქართული ინსპირაცია / ავთენტური: ლათინურად ნაწარმოები ქართული სიტყვებიდან (მაგ: Supra [სუფრა], Kera [კერა]).</a:t>
+              <a:t>📅 2-კვირიანი სპრინტი: დროში გაწერილი ნაბიჯ-ნაბიჯ გეგმა;</a:t>
+            </a:r>
+          </a:p>
+          <a:p>
+            <a:pPr algn="l">
+              <a:spcAft>
+                <a:spcPts val="300"/>
+              </a:spcAft>
+            </a:pPr>
+            <a:r>
+              <a:rPr sz="1300" b="1">
+                <a:solidFill>
+                  <a:srgbClr val="3730A3"/>
+                </a:solidFill>
+                <a:ea typeface="Sylfaen"/>
+                <a:cs typeface="Sylfaen"/>
+                <a:latin typeface="Sylfaen"/>
+              </a:rPr>
+              <a:t>▸  </a:t>
+            </a:r>
+            <a:r>
+              <a:rPr sz="1300">
+                <a:solidFill>
+                  <a:srgbClr val="0F172A"/>
+                </a:solidFill>
+                <a:ea typeface="Sylfaen"/>
+                <a:cs typeface="Sylfaen"/>
+                <a:latin typeface="Sylfaen"/>
+              </a:rPr>
+              <a:t>📈 წარმატების მეტრიკა: როგორ მივხვდებით, რომ ტესტმა წარმატებით ჩაიარა?</a:t>
             </a:r>
           </a:p>
         </p:txBody>
@@ -37815,7 +37833,7 @@
               </a:spcAft>
             </a:pPr>
             <a:r>
-              <a:rPr sz="1200">
+              <a:rPr sz="800">
                 <a:solidFill>
                   <a:srgbClr val="0F172A"/>
                 </a:solidFill>
@@ -37823,7 +37841,25 @@
                 <a:cs typeface="Consolas"/>
                 <a:latin typeface="Consolas"/>
               </a:rPr>
-              <a:t>Brand Naming Prompt:</a:t>
+              <a:t>Rapid MVP Prototyping</a:t>
+            </a:r>
+          </a:p>
+          <a:p>
+            <a:pPr>
+              <a:spcAft>
+                <a:spcPts val="0"/>
+              </a:spcAft>
+            </a:pPr>
+            <a:r>
+              <a:rPr sz="800">
+                <a:solidFill>
+                  <a:srgbClr val="0F172A"/>
+                </a:solidFill>
+                <a:ea typeface="Consolas"/>
+                <a:cs typeface="Consolas"/>
+                <a:latin typeface="Consolas"/>
+              </a:rPr>
+              <a:t>Prompt:</a:t>
             </a:r>
           </a:p>
         </p:txBody>
@@ -37837,7 +37873,7 @@
         <p:spPr>
           <a:xfrm>
             <a:off x="4805172" y="1627632"/>
-            <a:ext cx="3771900" cy="2779776"/>
+            <a:ext cx="3771900" cy="3150108"/>
           </a:xfrm>
           <a:prstGeom prst="roundRect">
             <a:avLst>
@@ -37885,7 +37921,7 @@
         <p:spPr>
           <a:xfrm>
             <a:off x="4860036" y="1673352"/>
-            <a:ext cx="3662172" cy="2688336"/>
+            <a:ext cx="3662172" cy="3058668"/>
           </a:xfrm>
           <a:prstGeom prst="rect">
             <a:avLst/>
@@ -37931,7 +37967,7 @@
         <p:spPr>
           <a:xfrm>
             <a:off x="4914900" y="1691640"/>
-            <a:ext cx="3552444" cy="2651760"/>
+            <a:ext cx="3552444" cy="3022091"/>
           </a:xfrm>
           <a:prstGeom prst="rect">
             <a:avLst/>
@@ -37958,7 +37994,7 @@
                 <a:cs typeface="Consolas"/>
                 <a:latin typeface="Consolas"/>
               </a:rPr>
-              <a:t>დააგენერირე 15 სახელი ჩემი</a:t>
+              <a:t>ჩემი სტარტაპ იდეაა:</a:t>
             </a:r>
           </a:p>
           <a:p>
@@ -37976,7 +38012,7 @@
                 <a:cs typeface="Consolas"/>
                 <a:latin typeface="Consolas"/>
               </a:rPr>
-              <a:t>პროდუქტისთვის.</a:t>
+              <a:t>[ჩაწერე იდეა].</a:t>
             </a:r>
           </a:p>
           <a:p>
@@ -37994,7 +38030,7 @@
                 <a:cs typeface="Consolas"/>
                 <a:latin typeface="Consolas"/>
               </a:rPr>
-              <a:t>კონტექსტი: ინდუსტრია</a:t>
+              <a:t>შემომთავაზე 2-კვირაში</a:t>
             </a:r>
           </a:p>
           <a:p>
@@ -38012,7 +38048,7 @@
                 <a:cs typeface="Consolas"/>
                 <a:latin typeface="Consolas"/>
               </a:rPr>
-              <a:t>[სფერო], სამიზნე [ICP],</a:t>
+              <a:t>ასაშენებელი MVP-ის გეგმა:</a:t>
             </a:r>
           </a:p>
           <a:p>
@@ -38030,7 +38066,7 @@
                 <a:cs typeface="Consolas"/>
                 <a:latin typeface="Consolas"/>
               </a:rPr>
-              <a:t>ბრენდის პერსონა [ხასიათი,</a:t>
+              <a:t>1. ფუნქციების სია</a:t>
             </a:r>
           </a:p>
           <a:p>
@@ -38048,7 +38084,7 @@
                 <a:cs typeface="Consolas"/>
                 <a:latin typeface="Consolas"/>
               </a:rPr>
-              <a:t>მაგ: მეგობრული].</a:t>
+              <a:t>(აუცილებელი Core vs</a:t>
             </a:r>
           </a:p>
           <a:p>
@@ -38066,7 +38102,7 @@
                 <a:cs typeface="Consolas"/>
                 <a:latin typeface="Consolas"/>
               </a:rPr>
-              <a:t>სახელები დაყავი 3 ჯგუფად:</a:t>
+              <a:t>სასურველი);</a:t>
             </a:r>
           </a:p>
           <a:p>
@@ -38084,7 +38120,7 @@
                 <a:cs typeface="Consolas"/>
                 <a:latin typeface="Consolas"/>
               </a:rPr>
-              <a:t>1) აღწერითი, 2)</a:t>
+              <a:t>2. ტექნოლოგიური სტეკი</a:t>
             </a:r>
           </a:p>
           <a:p>
@@ -38102,7 +38138,7 @@
                 <a:cs typeface="Consolas"/>
                 <a:latin typeface="Consolas"/>
               </a:rPr>
-              <a:t>აბსტრაქტული, 3)</a:t>
+              <a:t>(Lovable, Supabase,</a:t>
             </a:r>
           </a:p>
           <a:p>
@@ -38120,7 +38156,7 @@
                 <a:cs typeface="Consolas"/>
                 <a:latin typeface="Consolas"/>
               </a:rPr>
-              <a:t>ლოკალური/ავთენტური.</a:t>
+              <a:t>Make-ის გამოყენებით);</a:t>
             </a:r>
           </a:p>
           <a:p>
@@ -38138,7 +38174,7 @@
                 <a:cs typeface="Consolas"/>
                 <a:latin typeface="Consolas"/>
               </a:rPr>
-              <a:t>თითოეულს დაურთე სლოგანი</a:t>
+              <a:t>3. 2-კვირიანი ნაბიჯ-ნაბიჯ</a:t>
             </a:r>
           </a:p>
           <a:p>
@@ -38156,7 +38192,7 @@
                 <a:cs typeface="Consolas"/>
                 <a:latin typeface="Consolas"/>
               </a:rPr>
-              <a:t>(Tagline) და</a:t>
+              <a:t>სპრინტის გეგმა;</a:t>
             </a:r>
           </a:p>
           <a:p>
@@ -38174,7 +38210,7 @@
                 <a:cs typeface="Consolas"/>
                 <a:latin typeface="Consolas"/>
               </a:rPr>
-              <a:t>1-წინადადებიანი ბრენდის</a:t>
+              <a:t>4. ტესტირების სტრატეგია და</a:t>
             </a:r>
           </a:p>
           <a:p>
@@ -38192,7 +38228,25 @@
                 <a:cs typeface="Consolas"/>
                 <a:latin typeface="Consolas"/>
               </a:rPr>
-              <a:t>ისტორია.</a:t>
+              <a:t>წარმატების კონკრეტული</a:t>
+            </a:r>
+          </a:p>
+          <a:p>
+            <a:pPr>
+              <a:spcAft>
+                <a:spcPts val="0"/>
+              </a:spcAft>
+            </a:pPr>
+            <a:r>
+              <a:rPr sz="1000">
+                <a:solidFill>
+                  <a:srgbClr val="0F172A"/>
+                </a:solidFill>
+                <a:ea typeface="Consolas"/>
+                <a:cs typeface="Consolas"/>
+                <a:latin typeface="Consolas"/>
+              </a:rPr>
+              <a:t>მეტრიკები.</a:t>
             </a:r>
           </a:p>
         </p:txBody>
@@ -38463,7 +38517,7 @@
                 <a:cs typeface="Sylfaen"/>
                 <a:latin typeface="Sylfaen"/>
               </a:rPr>
-              <a:t>🎬 LIVE DEMO პრომპტი: ბრენდინგის გენერაცია</a:t>
+              <a:t>🔀 ინდუსტრიებს შორის ინოვაცია (Cross-Industry Innovation)</a:t>
             </a:r>
           </a:p>
         </p:txBody>
@@ -38578,7 +38632,7 @@
         <p:spPr>
           <a:xfrm>
             <a:off x="457200" y="1188720"/>
-            <a:ext cx="54864" cy="1965960"/>
+            <a:ext cx="54864" cy="3662172"/>
           </a:xfrm>
           <a:prstGeom prst="rect">
             <a:avLst/>
@@ -38622,7 +38676,7 @@
         <p:spPr>
           <a:xfrm>
             <a:off x="512064" y="1188720"/>
-            <a:ext cx="8174736" cy="1965960"/>
+            <a:ext cx="3991356" cy="3662172"/>
           </a:xfrm>
           <a:prstGeom prst="roundRect">
             <a:avLst>
@@ -38632,6 +38686,341 @@
           <a:solidFill>
             <a:srgbClr val="F8FAFC"/>
           </a:solidFill>
+          <a:ln w="6350">
+            <a:solidFill>
+              <a:srgbClr val="E2E8F0"/>
+            </a:solidFill>
+          </a:ln>
+          <a:effectLst/>
+        </p:spPr>
+        <p:style>
+          <a:lnRef idx="1">
+            <a:schemeClr val="accent1"/>
+          </a:lnRef>
+          <a:fillRef idx="3">
+            <a:schemeClr val="accent1"/>
+          </a:fillRef>
+          <a:effectRef idx="2">
+            <a:schemeClr val="accent1"/>
+          </a:effectRef>
+          <a:fontRef idx="minor">
+            <a:schemeClr val="lt1"/>
+          </a:fontRef>
+        </p:style>
+        <p:txBody>
+          <a:bodyPr rtlCol="0" anchor="ctr"/>
+          <a:lstStyle/>
+          <a:p>
+            <a:pPr algn="ctr"/>
+          </a:p>
+        </p:txBody>
+      </p:sp>
+      <p:sp>
+        <p:nvSpPr>
+          <p:cNvPr id="10" name="TextBox 9"/>
+          <p:cNvSpPr txBox="1"/>
+          <p:nvPr/>
+        </p:nvSpPr>
+        <p:spPr>
+          <a:xfrm>
+            <a:off x="621792" y="1261872"/>
+            <a:ext cx="3771900" cy="320040"/>
+          </a:xfrm>
+          <a:prstGeom prst="rect">
+            <a:avLst/>
+          </a:prstGeom>
+          <a:noFill/>
+        </p:spPr>
+        <p:txBody>
+          <a:bodyPr wrap="square" anchor="t" lIns="54864" rIns="54864" tIns="54864" bIns="54864">
+            <a:spAutoFit/>
+          </a:bodyPr>
+          <a:lstStyle/>
+          <a:p>
+            <a:pPr>
+              <a:spcAft>
+                <a:spcPts val="400"/>
+              </a:spcAft>
+            </a:pPr>
+            <a:r>
+              <a:rPr sz="1400" b="1" i="0">
+                <a:solidFill>
+                  <a:srgbClr val="0F172A"/>
+                </a:solidFill>
+                <a:ea typeface="Sylfaen"/>
+                <a:cs typeface="Sylfaen"/>
+                <a:latin typeface="Sylfaen"/>
+              </a:rPr>
+              <a:t>🔗 გადაკვეთის პრინციპი (მაგალითები):</a:t>
+            </a:r>
+          </a:p>
+        </p:txBody>
+      </p:sp>
+      <p:sp>
+        <p:nvSpPr>
+          <p:cNvPr id="11" name="TextBox 10"/>
+          <p:cNvSpPr txBox="1"/>
+          <p:nvPr/>
+        </p:nvSpPr>
+        <p:spPr>
+          <a:xfrm>
+            <a:off x="621792" y="1655064"/>
+            <a:ext cx="3771900" cy="2816352"/>
+          </a:xfrm>
+          <a:prstGeom prst="rect">
+            <a:avLst/>
+          </a:prstGeom>
+          <a:noFill/>
+        </p:spPr>
+        <p:txBody>
+          <a:bodyPr wrap="square" anchor="t" lIns="54864" rIns="54864" tIns="54864" bIns="54864">
+            <a:spAutoFit/>
+          </a:bodyPr>
+          <a:lstStyle/>
+          <a:p>
+            <a:pPr algn="l">
+              <a:spcAft>
+                <a:spcPts val="300"/>
+              </a:spcAft>
+            </a:pPr>
+            <a:r>
+              <a:rPr sz="1300" b="1">
+                <a:solidFill>
+                  <a:srgbClr val="3730A3"/>
+                </a:solidFill>
+                <a:ea typeface="Sylfaen"/>
+                <a:cs typeface="Sylfaen"/>
+                <a:latin typeface="Sylfaen"/>
+              </a:rPr>
+              <a:t>▸  </a:t>
+            </a:r>
+            <a:r>
+              <a:rPr sz="1300">
+                <a:solidFill>
+                  <a:srgbClr val="0F172A"/>
+                </a:solidFill>
+                <a:ea typeface="Sylfaen"/>
+                <a:cs typeface="Sylfaen"/>
+                <a:latin typeface="Sylfaen"/>
+              </a:rPr>
+              <a:t>🚗 Uber-ის მოდელი: On-Demand სერვისის გადმოტანა სამედიცინო მომსახურებაზე;</a:t>
+            </a:r>
+          </a:p>
+          <a:p>
+            <a:pPr algn="l">
+              <a:spcAft>
+                <a:spcPts val="300"/>
+              </a:spcAft>
+            </a:pPr>
+            <a:r>
+              <a:rPr sz="1300" b="1">
+                <a:solidFill>
+                  <a:srgbClr val="3730A3"/>
+                </a:solidFill>
+                <a:ea typeface="Sylfaen"/>
+                <a:cs typeface="Sylfaen"/>
+                <a:latin typeface="Sylfaen"/>
+              </a:rPr>
+              <a:t>▸  </a:t>
+            </a:r>
+            <a:r>
+              <a:rPr sz="1300">
+                <a:solidFill>
+                  <a:srgbClr val="0F172A"/>
+                </a:solidFill>
+                <a:ea typeface="Sylfaen"/>
+                <a:cs typeface="Sylfaen"/>
+                <a:latin typeface="Sylfaen"/>
+              </a:rPr>
+              <a:t>📺 Netflix-ის მოდელი: ყოველთვიური გამოწერის (Subscription) გამოყენება სარეცხ საშუალებებზე;</a:t>
+            </a:r>
+          </a:p>
+          <a:p>
+            <a:pPr algn="l">
+              <a:spcAft>
+                <a:spcPts val="300"/>
+              </a:spcAft>
+            </a:pPr>
+            <a:r>
+              <a:rPr sz="1300" b="1">
+                <a:solidFill>
+                  <a:srgbClr val="3730A3"/>
+                </a:solidFill>
+                <a:ea typeface="Sylfaen"/>
+                <a:cs typeface="Sylfaen"/>
+                <a:latin typeface="Sylfaen"/>
+              </a:rPr>
+              <a:t>▸  </a:t>
+            </a:r>
+            <a:r>
+              <a:rPr sz="1300">
+                <a:solidFill>
+                  <a:srgbClr val="0F172A"/>
+                </a:solidFill>
+                <a:ea typeface="Sylfaen"/>
+                <a:cs typeface="Sylfaen"/>
+                <a:latin typeface="Sylfaen"/>
+              </a:rPr>
+              <a:t>🕹️ გეიმიფიკაცია: თამაშის მექანიზმების (ქულები, ლიდერბორდი) მორგება ფინანსების დაზოგვაზე.</a:t>
+            </a:r>
+          </a:p>
+        </p:txBody>
+      </p:sp>
+      <p:sp>
+        <p:nvSpPr>
+          <p:cNvPr id="12" name="Rectangle 11"/>
+          <p:cNvSpPr/>
+          <p:nvPr/>
+        </p:nvSpPr>
+        <p:spPr>
+          <a:xfrm>
+            <a:off x="4640580" y="1188720"/>
+            <a:ext cx="54864" cy="3662172"/>
+          </a:xfrm>
+          <a:prstGeom prst="rect">
+            <a:avLst/>
+          </a:prstGeom>
+          <a:solidFill>
+            <a:srgbClr val="3730A3"/>
+          </a:solidFill>
+          <a:ln>
+            <a:noFill/>
+          </a:ln>
+          <a:effectLst/>
+        </p:spPr>
+        <p:style>
+          <a:lnRef idx="1">
+            <a:schemeClr val="accent1"/>
+          </a:lnRef>
+          <a:fillRef idx="3">
+            <a:schemeClr val="accent1"/>
+          </a:fillRef>
+          <a:effectRef idx="2">
+            <a:schemeClr val="accent1"/>
+          </a:effectRef>
+          <a:fontRef idx="minor">
+            <a:schemeClr val="lt1"/>
+          </a:fontRef>
+        </p:style>
+        <p:txBody>
+          <a:bodyPr rtlCol="0" anchor="ctr"/>
+          <a:lstStyle/>
+          <a:p>
+            <a:pPr algn="ctr"/>
+          </a:p>
+        </p:txBody>
+      </p:sp>
+      <p:sp>
+        <p:nvSpPr>
+          <p:cNvPr id="13" name="Rounded Rectangle 12"/>
+          <p:cNvSpPr/>
+          <p:nvPr/>
+        </p:nvSpPr>
+        <p:spPr>
+          <a:xfrm>
+            <a:off x="4695444" y="1188720"/>
+            <a:ext cx="3991356" cy="3662172"/>
+          </a:xfrm>
+          <a:prstGeom prst="roundRect">
+            <a:avLst>
+              <a:gd name="adj" fmla="val 4000"/>
+            </a:avLst>
+          </a:prstGeom>
+          <a:solidFill>
+            <a:srgbClr val="F8FAFC"/>
+          </a:solidFill>
+          <a:ln w="6350">
+            <a:solidFill>
+              <a:srgbClr val="3730A3"/>
+            </a:solidFill>
+          </a:ln>
+          <a:effectLst/>
+        </p:spPr>
+        <p:style>
+          <a:lnRef idx="1">
+            <a:schemeClr val="accent1"/>
+          </a:lnRef>
+          <a:fillRef idx="3">
+            <a:schemeClr val="accent1"/>
+          </a:fillRef>
+          <a:effectRef idx="2">
+            <a:schemeClr val="accent1"/>
+          </a:effectRef>
+          <a:fontRef idx="minor">
+            <a:schemeClr val="lt1"/>
+          </a:fontRef>
+        </p:style>
+        <p:txBody>
+          <a:bodyPr rtlCol="0" anchor="ctr"/>
+          <a:lstStyle/>
+          <a:p>
+            <a:pPr algn="ctr"/>
+          </a:p>
+        </p:txBody>
+      </p:sp>
+      <p:sp>
+        <p:nvSpPr>
+          <p:cNvPr id="14" name="Rectangle 13"/>
+          <p:cNvSpPr/>
+          <p:nvPr/>
+        </p:nvSpPr>
+        <p:spPr>
+          <a:xfrm>
+            <a:off x="4805172" y="1261872"/>
+            <a:ext cx="54864" cy="292608"/>
+          </a:xfrm>
+          <a:prstGeom prst="rect">
+            <a:avLst/>
+          </a:prstGeom>
+          <a:solidFill>
+            <a:srgbClr val="3730A3"/>
+          </a:solidFill>
+          <a:ln>
+            <a:noFill/>
+          </a:ln>
+          <a:effectLst/>
+        </p:spPr>
+        <p:style>
+          <a:lnRef idx="1">
+            <a:schemeClr val="accent1"/>
+          </a:lnRef>
+          <a:fillRef idx="3">
+            <a:schemeClr val="accent1"/>
+          </a:fillRef>
+          <a:effectRef idx="2">
+            <a:schemeClr val="accent1"/>
+          </a:effectRef>
+          <a:fontRef idx="minor">
+            <a:schemeClr val="lt1"/>
+          </a:fontRef>
+        </p:style>
+        <p:txBody>
+          <a:bodyPr rtlCol="0" anchor="ctr"/>
+          <a:lstStyle/>
+          <a:p>
+            <a:pPr algn="ctr"/>
+          </a:p>
+        </p:txBody>
+      </p:sp>
+      <p:sp>
+        <p:nvSpPr>
+          <p:cNvPr id="15" name="Rounded Rectangle 14"/>
+          <p:cNvSpPr/>
+          <p:nvPr/>
+        </p:nvSpPr>
+        <p:spPr>
+          <a:xfrm>
+            <a:off x="4860036" y="1261872"/>
+            <a:ext cx="3717036" cy="292608"/>
+          </a:xfrm>
+          <a:prstGeom prst="roundRect">
+            <a:avLst>
+              <a:gd name="adj" fmla="val 4000"/>
+            </a:avLst>
+          </a:prstGeom>
+          <a:solidFill>
+            <a:srgbClr val="F8FAFC"/>
+          </a:solidFill>
           <a:ln w="9525">
             <a:solidFill>
               <a:srgbClr val="E2E8F0"/>
@@ -38663,14 +39052,60 @@
       </p:sp>
       <p:sp>
         <p:nvSpPr>
-          <p:cNvPr id="10" name="TextBox 9"/>
+          <p:cNvPr id="16" name="Rectangle 15"/>
+          <p:cNvSpPr/>
+          <p:nvPr/>
+        </p:nvSpPr>
+        <p:spPr>
+          <a:xfrm>
+            <a:off x="4914900" y="1316736"/>
+            <a:ext cx="3552444" cy="201168"/>
+          </a:xfrm>
+          <a:prstGeom prst="rect">
+            <a:avLst/>
+          </a:prstGeom>
+          <a:solidFill>
+            <a:srgbClr val="FFFFFF"/>
+          </a:solidFill>
+          <a:ln w="6350">
+            <a:solidFill>
+              <a:srgbClr val="E2E8F0"/>
+            </a:solidFill>
+          </a:ln>
+          <a:effectLst/>
+        </p:spPr>
+        <p:style>
+          <a:lnRef idx="1">
+            <a:schemeClr val="accent1"/>
+          </a:lnRef>
+          <a:fillRef idx="3">
+            <a:schemeClr val="accent1"/>
+          </a:fillRef>
+          <a:effectRef idx="2">
+            <a:schemeClr val="accent1"/>
+          </a:effectRef>
+          <a:fontRef idx="minor">
+            <a:schemeClr val="lt1"/>
+          </a:fontRef>
+        </p:style>
+        <p:txBody>
+          <a:bodyPr rtlCol="0" anchor="ctr"/>
+          <a:lstStyle/>
+          <a:p>
+            <a:pPr algn="ctr"/>
+          </a:p>
+        </p:txBody>
+      </p:sp>
+      <p:sp>
+        <p:nvSpPr>
+          <p:cNvPr id="17" name="TextBox 16"/>
           <p:cNvSpPr txBox="1"/>
           <p:nvPr/>
         </p:nvSpPr>
         <p:spPr>
           <a:xfrm>
-            <a:off x="621792" y="1261872"/>
-            <a:ext cx="7955279" cy="320040"/>
+            <a:off x="4969764" y="1344168"/>
+            <a:ext cx="3442716" cy="146304"/>
           </a:xfrm>
           <a:prstGeom prst="rect">
             <a:avLst/>
@@ -38685,33 +39120,145 @@
           <a:p>
             <a:pPr>
               <a:spcAft>
-                <a:spcPts val="400"/>
-              </a:spcAft>
-            </a:pPr>
-            <a:r>
-              <a:rPr sz="1400" b="1" i="0">
-                <a:solidFill>
-                  <a:srgbClr val="0F172A"/>
-                </a:solidFill>
-                <a:ea typeface="Sylfaen"/>
-                <a:cs typeface="Sylfaen"/>
-                <a:latin typeface="Sylfaen"/>
-              </a:rPr>
-              <a:t>🚀 საცდელი პრომპტი ChatGPT/Claude/Gemini-სთვის:</a:t>
-            </a:r>
-          </a:p>
-        </p:txBody>
-      </p:sp>
-      <p:sp>
-        <p:nvSpPr>
-          <p:cNvPr id="11" name="TextBox 10"/>
+                <a:spcPts val="0"/>
+              </a:spcAft>
+            </a:pPr>
+            <a:r>
+              <a:rPr sz="800">
+                <a:solidFill>
+                  <a:srgbClr val="0F172A"/>
+                </a:solidFill>
+                <a:ea typeface="Consolas"/>
+                <a:cs typeface="Consolas"/>
+                <a:latin typeface="Consolas"/>
+              </a:rPr>
+              <a:t>Cross-Industry Innovation</a:t>
+            </a:r>
+          </a:p>
+          <a:p>
+            <a:pPr>
+              <a:spcAft>
+                <a:spcPts val="0"/>
+              </a:spcAft>
+            </a:pPr>
+            <a:r>
+              <a:rPr sz="800">
+                <a:solidFill>
+                  <a:srgbClr val="0F172A"/>
+                </a:solidFill>
+                <a:ea typeface="Consolas"/>
+                <a:cs typeface="Consolas"/>
+                <a:latin typeface="Consolas"/>
+              </a:rPr>
+              <a:t>Prompt:</a:t>
+            </a:r>
+          </a:p>
+        </p:txBody>
+      </p:sp>
+      <p:sp>
+        <p:nvSpPr>
+          <p:cNvPr id="18" name="Rounded Rectangle 17"/>
+          <p:cNvSpPr/>
+          <p:nvPr/>
+        </p:nvSpPr>
+        <p:spPr>
+          <a:xfrm>
+            <a:off x="4805172" y="1627632"/>
+            <a:ext cx="3771900" cy="2779776"/>
+          </a:xfrm>
+          <a:prstGeom prst="roundRect">
+            <a:avLst>
+              <a:gd name="adj" fmla="val 4000"/>
+            </a:avLst>
+          </a:prstGeom>
+          <a:solidFill>
+            <a:srgbClr val="F8FAFC"/>
+          </a:solidFill>
+          <a:ln w="9525">
+            <a:solidFill>
+              <a:srgbClr val="E2E8F0"/>
+            </a:solidFill>
+          </a:ln>
+          <a:effectLst/>
+        </p:spPr>
+        <p:style>
+          <a:lnRef idx="1">
+            <a:schemeClr val="accent1"/>
+          </a:lnRef>
+          <a:fillRef idx="3">
+            <a:schemeClr val="accent1"/>
+          </a:fillRef>
+          <a:effectRef idx="2">
+            <a:schemeClr val="accent1"/>
+          </a:effectRef>
+          <a:fontRef idx="minor">
+            <a:schemeClr val="lt1"/>
+          </a:fontRef>
+        </p:style>
+        <p:txBody>
+          <a:bodyPr rtlCol="0" anchor="ctr"/>
+          <a:lstStyle/>
+          <a:p>
+            <a:pPr algn="ctr"/>
+          </a:p>
+        </p:txBody>
+      </p:sp>
+      <p:sp>
+        <p:nvSpPr>
+          <p:cNvPr id="19" name="Rectangle 18"/>
+          <p:cNvSpPr/>
+          <p:nvPr/>
+        </p:nvSpPr>
+        <p:spPr>
+          <a:xfrm>
+            <a:off x="4860036" y="1673352"/>
+            <a:ext cx="3662172" cy="2688336"/>
+          </a:xfrm>
+          <a:prstGeom prst="rect">
+            <a:avLst/>
+          </a:prstGeom>
+          <a:solidFill>
+            <a:srgbClr val="FFFFFF"/>
+          </a:solidFill>
+          <a:ln w="6350">
+            <a:solidFill>
+              <a:srgbClr val="E2E8F0"/>
+            </a:solidFill>
+          </a:ln>
+          <a:effectLst/>
+        </p:spPr>
+        <p:style>
+          <a:lnRef idx="1">
+            <a:schemeClr val="accent1"/>
+          </a:lnRef>
+          <a:fillRef idx="3">
+            <a:schemeClr val="accent1"/>
+          </a:fillRef>
+          <a:effectRef idx="2">
+            <a:schemeClr val="accent1"/>
+          </a:effectRef>
+          <a:fontRef idx="minor">
+            <a:schemeClr val="lt1"/>
+          </a:fontRef>
+        </p:style>
+        <p:txBody>
+          <a:bodyPr rtlCol="0" anchor="ctr"/>
+          <a:lstStyle/>
+          <a:p>
+            <a:pPr algn="ctr"/>
+          </a:p>
+        </p:txBody>
+      </p:sp>
+      <p:sp>
+        <p:nvSpPr>
+          <p:cNvPr id="20" name="TextBox 19"/>
           <p:cNvSpPr txBox="1"/>
           <p:nvPr/>
         </p:nvSpPr>
         <p:spPr>
           <a:xfrm>
-            <a:off x="621792" y="1655064"/>
-            <a:ext cx="7955279" cy="1371600"/>
+            <a:off x="4914900" y="1691640"/>
+            <a:ext cx="3552444" cy="2651760"/>
           </a:xfrm>
           <a:prstGeom prst="rect">
             <a:avLst/>
@@ -38726,26 +39273,242 @@
           <a:p>
             <a:pPr>
               <a:spcAft>
-                <a:spcPts val="400"/>
-              </a:spcAft>
-            </a:pPr>
-            <a:r>
-              <a:rPr sz="1300" b="0" i="0">
-                <a:solidFill>
-                  <a:srgbClr val="0F172A"/>
-                </a:solidFill>
-                <a:ea typeface="Sylfaen"/>
-                <a:cs typeface="Sylfaen"/>
-                <a:latin typeface="Sylfaen"/>
-              </a:rPr>
-              <a:t>დააგენერირე 18 სახელი ახალი პროდუქტისთვის: 1. ინდუსტრია: Food Delivery / სწრაფი კვება საქართველოში. 2. პროდუქტი: მობილური აპლიკაცია, რომელიც ადგილობრივ მზარეულებს მომხმარებლებთან აკავშირებს - სახლში მომზადებული საკვების მიტანის სისტემა. 3. სამიზნე აუდიტორია: 25-45 წლის ურბანული პროფესიონალები, რომლებიც ეძებენ ჯანსაღ, ხარისხიან საკვებს (არა Fast Food). 4. ბრენდის პერსონა: თბილი, ოჯახური, ავთენტური, მაგრამ თანამედროვე. 5. ქართული ხაზგასმა: სახელი უნდა იყოს საერთაშორისო (ლათინური), მაგრამ ასახავდეს ქართულ კულტურას. სახელები დაყავი 3 კატეგორიად (თითოში 6): 1. აღწერითი (მაგ: HomeChef, LocalKitchen); 2. აბსტრაქტული (მაგ: Foodly, Tastora); 3. ქართული ინსპირაცია (მაგ: Supra [სუფრა], Kera [კერა]). თითოეულისთვის მომეცი: სახელი, .ge/.com დომენის ლოგიკა, tagline (ქართულად და ინგლისურად), ბრენდის ისტორია (1 წინადადება).</a:t>
-            </a:r>
-          </a:p>
-        </p:txBody>
-      </p:sp>
-      <p:sp>
-        <p:nvSpPr>
-          <p:cNvPr id="12" name="Rectangle 11"/>
+                <a:spcPts val="0"/>
+              </a:spcAft>
+            </a:pPr>
+            <a:r>
+              <a:rPr sz="1000">
+                <a:solidFill>
+                  <a:srgbClr val="0F172A"/>
+                </a:solidFill>
+                <a:ea typeface="Consolas"/>
+                <a:cs typeface="Consolas"/>
+                <a:latin typeface="Consolas"/>
+              </a:rPr>
+              <a:t>გააანალიზე წამყვანი</a:t>
+            </a:r>
+          </a:p>
+          <a:p>
+            <a:pPr>
+              <a:spcAft>
+                <a:spcPts val="0"/>
+              </a:spcAft>
+            </a:pPr>
+            <a:r>
+              <a:rPr sz="1000">
+                <a:solidFill>
+                  <a:srgbClr val="0F172A"/>
+                </a:solidFill>
+                <a:ea typeface="Consolas"/>
+                <a:cs typeface="Consolas"/>
+                <a:latin typeface="Consolas"/>
+              </a:rPr>
+              <a:t>ინოვაციები და ბიზნეს</a:t>
+            </a:r>
+          </a:p>
+          <a:p>
+            <a:pPr>
+              <a:spcAft>
+                <a:spcPts val="0"/>
+              </a:spcAft>
+            </a:pPr>
+            <a:r>
+              <a:rPr sz="1000">
+                <a:solidFill>
+                  <a:srgbClr val="0F172A"/>
+                </a:solidFill>
+                <a:ea typeface="Consolas"/>
+                <a:cs typeface="Consolas"/>
+                <a:latin typeface="Consolas"/>
+              </a:rPr>
+              <a:t>მოდელები [ინდუსტრია A]-ში</a:t>
+            </a:r>
+          </a:p>
+          <a:p>
+            <a:pPr>
+              <a:spcAft>
+                <a:spcPts val="0"/>
+              </a:spcAft>
+            </a:pPr>
+            <a:r>
+              <a:rPr sz="1000">
+                <a:solidFill>
+                  <a:srgbClr val="0F172A"/>
+                </a:solidFill>
+                <a:ea typeface="Consolas"/>
+                <a:cs typeface="Consolas"/>
+                <a:latin typeface="Consolas"/>
+              </a:rPr>
+              <a:t>(მაგ: სათამაშო ინდუსტრია).</a:t>
+            </a:r>
+          </a:p>
+          <a:p>
+            <a:pPr>
+              <a:spcAft>
+                <a:spcPts val="0"/>
+              </a:spcAft>
+            </a:pPr>
+            <a:r>
+              <a:rPr sz="1000">
+                <a:solidFill>
+                  <a:srgbClr val="0F172A"/>
+                </a:solidFill>
+                <a:ea typeface="Consolas"/>
+                <a:cs typeface="Consolas"/>
+                <a:latin typeface="Consolas"/>
+              </a:rPr>
+              <a:t>შემომთავაზე 3 გზა, როგორ</a:t>
+            </a:r>
+          </a:p>
+          <a:p>
+            <a:pPr>
+              <a:spcAft>
+                <a:spcPts val="0"/>
+              </a:spcAft>
+            </a:pPr>
+            <a:r>
+              <a:rPr sz="1000">
+                <a:solidFill>
+                  <a:srgbClr val="0F172A"/>
+                </a:solidFill>
+                <a:ea typeface="Consolas"/>
+                <a:cs typeface="Consolas"/>
+                <a:latin typeface="Consolas"/>
+              </a:rPr>
+              <a:t>შეიძლება ამ</a:t>
+            </a:r>
+          </a:p>
+          <a:p>
+            <a:pPr>
+              <a:spcAft>
+                <a:spcPts val="0"/>
+              </a:spcAft>
+            </a:pPr>
+            <a:r>
+              <a:rPr sz="1000">
+                <a:solidFill>
+                  <a:srgbClr val="0F172A"/>
+                </a:solidFill>
+                <a:ea typeface="Consolas"/>
+                <a:cs typeface="Consolas"/>
+                <a:latin typeface="Consolas"/>
+              </a:rPr>
+              <a:t>მექანიზმების/პრინციპების</a:t>
+            </a:r>
+          </a:p>
+          <a:p>
+            <a:pPr>
+              <a:spcAft>
+                <a:spcPts val="0"/>
+              </a:spcAft>
+            </a:pPr>
+            <a:r>
+              <a:rPr sz="1000">
+                <a:solidFill>
+                  <a:srgbClr val="0F172A"/>
+                </a:solidFill>
+                <a:ea typeface="Consolas"/>
+                <a:cs typeface="Consolas"/>
+                <a:latin typeface="Consolas"/>
+              </a:rPr>
+              <a:t>გადატანა და გამოყენება</a:t>
+            </a:r>
+          </a:p>
+          <a:p>
+            <a:pPr>
+              <a:spcAft>
+                <a:spcPts val="0"/>
+              </a:spcAft>
+            </a:pPr>
+            <a:r>
+              <a:rPr sz="1000">
+                <a:solidFill>
+                  <a:srgbClr val="0F172A"/>
+                </a:solidFill>
+                <a:ea typeface="Consolas"/>
+                <a:cs typeface="Consolas"/>
+                <a:latin typeface="Consolas"/>
+              </a:rPr>
+              <a:t>[ინდუსტრია B]-ში (მაგ:</a:t>
+            </a:r>
+          </a:p>
+          <a:p>
+            <a:pPr>
+              <a:spcAft>
+                <a:spcPts val="0"/>
+              </a:spcAft>
+            </a:pPr>
+            <a:r>
+              <a:rPr sz="1000">
+                <a:solidFill>
+                  <a:srgbClr val="0F172A"/>
+                </a:solidFill>
+                <a:ea typeface="Consolas"/>
+                <a:cs typeface="Consolas"/>
+                <a:latin typeface="Consolas"/>
+              </a:rPr>
+              <a:t>EdTech საგანმანათლებლო</a:t>
+            </a:r>
+          </a:p>
+          <a:p>
+            <a:pPr>
+              <a:spcAft>
+                <a:spcPts val="0"/>
+              </a:spcAft>
+            </a:pPr>
+            <a:r>
+              <a:rPr sz="1000">
+                <a:solidFill>
+                  <a:srgbClr val="0F172A"/>
+                </a:solidFill>
+                <a:ea typeface="Consolas"/>
+                <a:cs typeface="Consolas"/>
+                <a:latin typeface="Consolas"/>
+              </a:rPr>
+              <a:t>ტექნოლოგიები საქართველოში)</a:t>
+            </a:r>
+          </a:p>
+          <a:p>
+            <a:pPr>
+              <a:spcAft>
+                <a:spcPts val="0"/>
+              </a:spcAft>
+            </a:pPr>
+            <a:r>
+              <a:rPr sz="1000">
+                <a:solidFill>
+                  <a:srgbClr val="0F172A"/>
+                </a:solidFill>
+                <a:ea typeface="Consolas"/>
+                <a:cs typeface="Consolas"/>
+                <a:latin typeface="Consolas"/>
+              </a:rPr>
+              <a:t>ახალი სტარტაპის</a:t>
+            </a:r>
+          </a:p>
+          <a:p>
+            <a:pPr>
+              <a:spcAft>
+                <a:spcPts val="0"/>
+              </a:spcAft>
+            </a:pPr>
+            <a:r>
+              <a:rPr sz="1000">
+                <a:solidFill>
+                  <a:srgbClr val="0F172A"/>
+                </a:solidFill>
+                <a:ea typeface="Consolas"/>
+                <a:cs typeface="Consolas"/>
+                <a:latin typeface="Consolas"/>
+              </a:rPr>
+              <a:t>შესაქმნელად.</a:t>
+            </a:r>
+          </a:p>
+        </p:txBody>
+      </p:sp>
+      <p:sp>
+        <p:nvSpPr>
+          <p:cNvPr id="21" name="Rectangle 20"/>
           <p:cNvSpPr/>
           <p:nvPr/>
         </p:nvSpPr>
@@ -38789,7 +39552,7 @@
       </p:sp>
       <p:sp>
         <p:nvSpPr>
-          <p:cNvPr id="13" name="TextBox 12"/>
+          <p:cNvPr id="22" name="TextBox 21"/>
           <p:cNvSpPr txBox="1"/>
           <p:nvPr/>
         </p:nvSpPr>
@@ -39009,7 +39772,7 @@
                 <a:cs typeface="Sylfaen"/>
                 <a:latin typeface="Sylfaen"/>
               </a:rPr>
-              <a:t>🔀 ინდუსტრიებს შორის ინოვაცია (Cross-Industry Innovation)</a:t>
+              <a:t>🎨 ბრენდინგის იდეები &amp; შეჯამება</a:t>
             </a:r>
           </a:p>
         </p:txBody>
@@ -39243,7 +40006,7 @@
                 <a:cs typeface="Sylfaen"/>
                 <a:latin typeface="Sylfaen"/>
               </a:rPr>
-              <a:t>🔗 გადაკვეთის პრინციპი (მაგალითები):</a:t>
+              <a:t>🏷️ სახელების 3 ძირითადი კატეგორია:</a:t>
             </a:r>
           </a:p>
         </p:txBody>
@@ -39295,7 +40058,7 @@
                 <a:cs typeface="Sylfaen"/>
                 <a:latin typeface="Sylfaen"/>
               </a:rPr>
-              <a:t>🚗 Uber-ის მოდელი: On-Demand სერვისის გადმოტანა სამედიცინო მომსახურებაზე;</a:t>
+              <a:t>აღწერითი: რაც პირდაპირ გამოხატავს საქმიანობას (მაგ: HomeChef, LocalKitchen);</a:t>
             </a:r>
           </a:p>
           <a:p>
@@ -39324,7 +40087,7 @@
                 <a:cs typeface="Sylfaen"/>
                 <a:latin typeface="Sylfaen"/>
               </a:rPr>
-              <a:t>📺 Netflix-ის მოდელი: ყოველთვიური გამოწერის (Subscription) გამოყენება სარეცხ საშუალებებზე;</a:t>
+              <a:t>აბსტრაქტული / გამოგონილი: ჟღერადი, ახალი სიტყვები (მაგ: Foodly, Tastora);</a:t>
             </a:r>
           </a:p>
           <a:p>
@@ -39353,7 +40116,7 @@
                 <a:cs typeface="Sylfaen"/>
                 <a:latin typeface="Sylfaen"/>
               </a:rPr>
-              <a:t>🕹️ გეიმიფიკაცია: თამაშის მექანიზმების (ქულები, ლიდერბორდი) მორგება ფინანსების დაზოგვაზე.</a:t>
+              <a:t>ქართული ინსპირაცია / ავთენტური: ლათინურად ნაწარმოები ქართული სიტყვებიდან (მაგ: Supra [სუფრა], Kera [კერა]).</a:t>
             </a:r>
           </a:p>
         </p:txBody>
@@ -39616,7 +40379,7 @@
               </a:spcAft>
             </a:pPr>
             <a:r>
-              <a:rPr sz="800">
+              <a:rPr sz="1200">
                 <a:solidFill>
                   <a:srgbClr val="0F172A"/>
                 </a:solidFill>
@@ -39624,25 +40387,7 @@
                 <a:cs typeface="Consolas"/>
                 <a:latin typeface="Consolas"/>
               </a:rPr>
-              <a:t>Cross-Industry Innovation</a:t>
-            </a:r>
-          </a:p>
-          <a:p>
-            <a:pPr>
-              <a:spcAft>
-                <a:spcPts val="0"/>
-              </a:spcAft>
-            </a:pPr>
-            <a:r>
-              <a:rPr sz="800">
-                <a:solidFill>
-                  <a:srgbClr val="0F172A"/>
-                </a:solidFill>
-                <a:ea typeface="Consolas"/>
-                <a:cs typeface="Consolas"/>
-                <a:latin typeface="Consolas"/>
-              </a:rPr>
-              <a:t>Prompt:</a:t>
+              <a:t>Brand Naming Prompt:</a:t>
             </a:r>
           </a:p>
         </p:txBody>
@@ -39777,7 +40522,7 @@
                 <a:cs typeface="Consolas"/>
                 <a:latin typeface="Consolas"/>
               </a:rPr>
-              <a:t>გააანალიზე წამყვანი</a:t>
+              <a:t>დააგენერირე 15 სახელი ჩემი</a:t>
             </a:r>
           </a:p>
           <a:p>
@@ -39795,7 +40540,7 @@
                 <a:cs typeface="Consolas"/>
                 <a:latin typeface="Consolas"/>
               </a:rPr>
-              <a:t>ინოვაციები და ბიზნეს</a:t>
+              <a:t>პროდუქტისთვის.</a:t>
             </a:r>
           </a:p>
           <a:p>
@@ -39813,7 +40558,7 @@
                 <a:cs typeface="Consolas"/>
                 <a:latin typeface="Consolas"/>
               </a:rPr>
-              <a:t>მოდელები [ინდუსტრია A]-ში</a:t>
+              <a:t>კონტექსტი: ინდუსტრია</a:t>
             </a:r>
           </a:p>
           <a:p>
@@ -39831,7 +40576,7 @@
                 <a:cs typeface="Consolas"/>
                 <a:latin typeface="Consolas"/>
               </a:rPr>
-              <a:t>(მაგ: სათამაშო ინდუსტრია).</a:t>
+              <a:t>[სფერო], სამიზნე [ICP],</a:t>
             </a:r>
           </a:p>
           <a:p>
@@ -39849,7 +40594,7 @@
                 <a:cs typeface="Consolas"/>
                 <a:latin typeface="Consolas"/>
               </a:rPr>
-              <a:t>შემომთავაზე 3 გზა, როგორ</a:t>
+              <a:t>ბრენდის პერსონა [ხასიათი,</a:t>
             </a:r>
           </a:p>
           <a:p>
@@ -39867,7 +40612,7 @@
                 <a:cs typeface="Consolas"/>
                 <a:latin typeface="Consolas"/>
               </a:rPr>
-              <a:t>შეიძლება ამ</a:t>
+              <a:t>მაგ: მეგობრული].</a:t>
             </a:r>
           </a:p>
           <a:p>
@@ -39885,7 +40630,7 @@
                 <a:cs typeface="Consolas"/>
                 <a:latin typeface="Consolas"/>
               </a:rPr>
-              <a:t>მექანიზმების/პრინციპების</a:t>
+              <a:t>სახელები დაყავი 3 ჯგუფად:</a:t>
             </a:r>
           </a:p>
           <a:p>
@@ -39903,7 +40648,7 @@
                 <a:cs typeface="Consolas"/>
                 <a:latin typeface="Consolas"/>
               </a:rPr>
-              <a:t>გადატანა და გამოყენება</a:t>
+              <a:t>1) აღწერითი, 2)</a:t>
             </a:r>
           </a:p>
           <a:p>
@@ -39921,7 +40666,7 @@
                 <a:cs typeface="Consolas"/>
                 <a:latin typeface="Consolas"/>
               </a:rPr>
-              <a:t>[ინდუსტრია B]-ში (მაგ:</a:t>
+              <a:t>აბსტრაქტული, 3)</a:t>
             </a:r>
           </a:p>
           <a:p>
@@ -39939,7 +40684,7 @@
                 <a:cs typeface="Consolas"/>
                 <a:latin typeface="Consolas"/>
               </a:rPr>
-              <a:t>EdTech საგანმანათლებლო</a:t>
+              <a:t>ლოკალური/ავთენტური.</a:t>
             </a:r>
           </a:p>
           <a:p>
@@ -39957,7 +40702,7 @@
                 <a:cs typeface="Consolas"/>
                 <a:latin typeface="Consolas"/>
               </a:rPr>
-              <a:t>ტექნოლოგიები საქართველოში)</a:t>
+              <a:t>თითოეულს დაურთე სლოგანი</a:t>
             </a:r>
           </a:p>
           <a:p>
@@ -39975,7 +40720,7 @@
                 <a:cs typeface="Consolas"/>
                 <a:latin typeface="Consolas"/>
               </a:rPr>
-              <a:t>ახალი სტარტაპის</a:t>
+              <a:t>(Tagline) და</a:t>
             </a:r>
           </a:p>
           <a:p>
@@ -39993,7 +40738,25 @@
                 <a:cs typeface="Consolas"/>
                 <a:latin typeface="Consolas"/>
               </a:rPr>
-              <a:t>შესაქმნელად.</a:t>
+              <a:t>1-წინადადებიანი ბრენდის</a:t>
+            </a:r>
+          </a:p>
+          <a:p>
+            <a:pPr>
+              <a:spcAft>
+                <a:spcPts val="0"/>
+              </a:spcAft>
+            </a:pPr>
+            <a:r>
+              <a:rPr sz="1000">
+                <a:solidFill>
+                  <a:srgbClr val="0F172A"/>
+                </a:solidFill>
+                <a:ea typeface="Consolas"/>
+                <a:cs typeface="Consolas"/>
+                <a:latin typeface="Consolas"/>
+              </a:rPr>
+              <a:t>ისტორია.</a:t>
             </a:r>
           </a:p>
         </p:txBody>
@@ -40264,7 +41027,7 @@
                 <a:cs typeface="Sylfaen"/>
                 <a:latin typeface="Sylfaen"/>
               </a:rPr>
-              <a:t>🔮 ტენდენციების შემჩნევა და მომავლის პროგნოზირება</a:t>
+              <a:t>🎬 LIVE DEMO პრომპტი: ბრენდინგის გენერაცია</a:t>
             </a:r>
           </a:p>
         </p:txBody>
@@ -40379,7 +41142,7 @@
         <p:spPr>
           <a:xfrm>
             <a:off x="457200" y="1188720"/>
-            <a:ext cx="54864" cy="3662172"/>
+            <a:ext cx="54864" cy="1965960"/>
           </a:xfrm>
           <a:prstGeom prst="rect">
             <a:avLst/>
@@ -40423,7 +41186,7 @@
         <p:spPr>
           <a:xfrm>
             <a:off x="512064" y="1188720"/>
-            <a:ext cx="3991356" cy="3662172"/>
+            <a:ext cx="8174736" cy="1965960"/>
           </a:xfrm>
           <a:prstGeom prst="roundRect">
             <a:avLst>
@@ -40433,341 +41196,6 @@
           <a:solidFill>
             <a:srgbClr val="F8FAFC"/>
           </a:solidFill>
-          <a:ln w="6350">
-            <a:solidFill>
-              <a:srgbClr val="E2E8F0"/>
-            </a:solidFill>
-          </a:ln>
-          <a:effectLst/>
-        </p:spPr>
-        <p:style>
-          <a:lnRef idx="1">
-            <a:schemeClr val="accent1"/>
-          </a:lnRef>
-          <a:fillRef idx="3">
-            <a:schemeClr val="accent1"/>
-          </a:fillRef>
-          <a:effectRef idx="2">
-            <a:schemeClr val="accent1"/>
-          </a:effectRef>
-          <a:fontRef idx="minor">
-            <a:schemeClr val="lt1"/>
-          </a:fontRef>
-        </p:style>
-        <p:txBody>
-          <a:bodyPr rtlCol="0" anchor="ctr"/>
-          <a:lstStyle/>
-          <a:p>
-            <a:pPr algn="ctr"/>
-          </a:p>
-        </p:txBody>
-      </p:sp>
-      <p:sp>
-        <p:nvSpPr>
-          <p:cNvPr id="10" name="TextBox 9"/>
-          <p:cNvSpPr txBox="1"/>
-          <p:nvPr/>
-        </p:nvSpPr>
-        <p:spPr>
-          <a:xfrm>
-            <a:off x="621792" y="1261872"/>
-            <a:ext cx="3771900" cy="320040"/>
-          </a:xfrm>
-          <a:prstGeom prst="rect">
-            <a:avLst/>
-          </a:prstGeom>
-          <a:noFill/>
-        </p:spPr>
-        <p:txBody>
-          <a:bodyPr wrap="square" anchor="t" lIns="54864" rIns="54864" tIns="54864" bIns="54864">
-            <a:spAutoFit/>
-          </a:bodyPr>
-          <a:lstStyle/>
-          <a:p>
-            <a:pPr>
-              <a:spcAft>
-                <a:spcPts val="400"/>
-              </a:spcAft>
-            </a:pPr>
-            <a:r>
-              <a:rPr sz="1400" b="1" i="0">
-                <a:solidFill>
-                  <a:srgbClr val="0F172A"/>
-                </a:solidFill>
-                <a:ea typeface="Sylfaen"/>
-                <a:cs typeface="Sylfaen"/>
-                <a:latin typeface="Sylfaen"/>
-              </a:rPr>
-              <a:t>🔍 AI-ს გამოყენება პროგნოზირებისთვის:</a:t>
-            </a:r>
-          </a:p>
-        </p:txBody>
-      </p:sp>
-      <p:sp>
-        <p:nvSpPr>
-          <p:cNvPr id="11" name="TextBox 10"/>
-          <p:cNvSpPr txBox="1"/>
-          <p:nvPr/>
-        </p:nvSpPr>
-        <p:spPr>
-          <a:xfrm>
-            <a:off x="621792" y="1655064"/>
-            <a:ext cx="3771900" cy="2542032"/>
-          </a:xfrm>
-          <a:prstGeom prst="rect">
-            <a:avLst/>
-          </a:prstGeom>
-          <a:noFill/>
-        </p:spPr>
-        <p:txBody>
-          <a:bodyPr wrap="square" anchor="t" lIns="54864" rIns="54864" tIns="54864" bIns="54864">
-            <a:spAutoFit/>
-          </a:bodyPr>
-          <a:lstStyle/>
-          <a:p>
-            <a:pPr algn="l">
-              <a:spcAft>
-                <a:spcPts val="300"/>
-              </a:spcAft>
-            </a:pPr>
-            <a:r>
-              <a:rPr sz="1300" b="1">
-                <a:solidFill>
-                  <a:srgbClr val="3730A3"/>
-                </a:solidFill>
-                <a:ea typeface="Sylfaen"/>
-                <a:cs typeface="Sylfaen"/>
-                <a:latin typeface="Sylfaen"/>
-              </a:rPr>
-              <a:t>▸  </a:t>
-            </a:r>
-            <a:r>
-              <a:rPr sz="1300">
-                <a:solidFill>
-                  <a:srgbClr val="0F172A"/>
-                </a:solidFill>
-                <a:ea typeface="Sylfaen"/>
-                <a:cs typeface="Sylfaen"/>
-                <a:latin typeface="Sylfaen"/>
-              </a:rPr>
-              <a:t>📊 ტენდენციების ანალიზი: მიმდინარე და აღმოცენებადი ტენდენციების შედარება;</a:t>
-            </a:r>
-          </a:p>
-          <a:p>
-            <a:pPr algn="l">
-              <a:spcAft>
-                <a:spcPts val="300"/>
-              </a:spcAft>
-            </a:pPr>
-            <a:r>
-              <a:rPr sz="1300" b="1">
-                <a:solidFill>
-                  <a:srgbClr val="3730A3"/>
-                </a:solidFill>
-                <a:ea typeface="Sylfaen"/>
-                <a:cs typeface="Sylfaen"/>
-                <a:latin typeface="Sylfaen"/>
-              </a:rPr>
-              <a:t>▸  </a:t>
-            </a:r>
-            <a:r>
-              <a:rPr sz="1300">
-                <a:solidFill>
-                  <a:srgbClr val="0F172A"/>
-                </a:solidFill>
-                <a:ea typeface="Sylfaen"/>
-                <a:cs typeface="Sylfaen"/>
-                <a:latin typeface="Sylfaen"/>
-              </a:rPr>
-              <a:t>🚀 სცენარების დაგეგმვა: ოპტიმისტური, პესიმისტური და ყველაზე მოსალოდნელი მომავლის მოდელირება;</a:t>
-            </a:r>
-          </a:p>
-          <a:p>
-            <a:pPr algn="l">
-              <a:spcAft>
-                <a:spcPts val="300"/>
-              </a:spcAft>
-            </a:pPr>
-            <a:r>
-              <a:rPr sz="1300" b="1">
-                <a:solidFill>
-                  <a:srgbClr val="3730A3"/>
-                </a:solidFill>
-                <a:ea typeface="Sylfaen"/>
-                <a:cs typeface="Sylfaen"/>
-                <a:latin typeface="Sylfaen"/>
-              </a:rPr>
-              <a:t>▸  </a:t>
-            </a:r>
-            <a:r>
-              <a:rPr sz="1300">
-                <a:solidFill>
-                  <a:srgbClr val="0F172A"/>
-                </a:solidFill>
-                <a:ea typeface="Sylfaen"/>
-                <a:cs typeface="Sylfaen"/>
-                <a:latin typeface="Sylfaen"/>
-              </a:rPr>
-              <a:t>💡 ახალი ნიშები: ბაზარზე გამოჩენილი ვაკუუმების იდენტიფიკაცია.</a:t>
-            </a:r>
-          </a:p>
-        </p:txBody>
-      </p:sp>
-      <p:sp>
-        <p:nvSpPr>
-          <p:cNvPr id="12" name="Rectangle 11"/>
-          <p:cNvSpPr/>
-          <p:nvPr/>
-        </p:nvSpPr>
-        <p:spPr>
-          <a:xfrm>
-            <a:off x="4640580" y="1188720"/>
-            <a:ext cx="54864" cy="3662172"/>
-          </a:xfrm>
-          <a:prstGeom prst="rect">
-            <a:avLst/>
-          </a:prstGeom>
-          <a:solidFill>
-            <a:srgbClr val="3730A3"/>
-          </a:solidFill>
-          <a:ln>
-            <a:noFill/>
-          </a:ln>
-          <a:effectLst/>
-        </p:spPr>
-        <p:style>
-          <a:lnRef idx="1">
-            <a:schemeClr val="accent1"/>
-          </a:lnRef>
-          <a:fillRef idx="3">
-            <a:schemeClr val="accent1"/>
-          </a:fillRef>
-          <a:effectRef idx="2">
-            <a:schemeClr val="accent1"/>
-          </a:effectRef>
-          <a:fontRef idx="minor">
-            <a:schemeClr val="lt1"/>
-          </a:fontRef>
-        </p:style>
-        <p:txBody>
-          <a:bodyPr rtlCol="0" anchor="ctr"/>
-          <a:lstStyle/>
-          <a:p>
-            <a:pPr algn="ctr"/>
-          </a:p>
-        </p:txBody>
-      </p:sp>
-      <p:sp>
-        <p:nvSpPr>
-          <p:cNvPr id="13" name="Rounded Rectangle 12"/>
-          <p:cNvSpPr/>
-          <p:nvPr/>
-        </p:nvSpPr>
-        <p:spPr>
-          <a:xfrm>
-            <a:off x="4695444" y="1188720"/>
-            <a:ext cx="3991356" cy="3662172"/>
-          </a:xfrm>
-          <a:prstGeom prst="roundRect">
-            <a:avLst>
-              <a:gd name="adj" fmla="val 4000"/>
-            </a:avLst>
-          </a:prstGeom>
-          <a:solidFill>
-            <a:srgbClr val="F8FAFC"/>
-          </a:solidFill>
-          <a:ln w="6350">
-            <a:solidFill>
-              <a:srgbClr val="3730A3"/>
-            </a:solidFill>
-          </a:ln>
-          <a:effectLst/>
-        </p:spPr>
-        <p:style>
-          <a:lnRef idx="1">
-            <a:schemeClr val="accent1"/>
-          </a:lnRef>
-          <a:fillRef idx="3">
-            <a:schemeClr val="accent1"/>
-          </a:fillRef>
-          <a:effectRef idx="2">
-            <a:schemeClr val="accent1"/>
-          </a:effectRef>
-          <a:fontRef idx="minor">
-            <a:schemeClr val="lt1"/>
-          </a:fontRef>
-        </p:style>
-        <p:txBody>
-          <a:bodyPr rtlCol="0" anchor="ctr"/>
-          <a:lstStyle/>
-          <a:p>
-            <a:pPr algn="ctr"/>
-          </a:p>
-        </p:txBody>
-      </p:sp>
-      <p:sp>
-        <p:nvSpPr>
-          <p:cNvPr id="14" name="Rectangle 13"/>
-          <p:cNvSpPr/>
-          <p:nvPr/>
-        </p:nvSpPr>
-        <p:spPr>
-          <a:xfrm>
-            <a:off x="4805172" y="1261872"/>
-            <a:ext cx="54864" cy="292608"/>
-          </a:xfrm>
-          <a:prstGeom prst="rect">
-            <a:avLst/>
-          </a:prstGeom>
-          <a:solidFill>
-            <a:srgbClr val="3730A3"/>
-          </a:solidFill>
-          <a:ln>
-            <a:noFill/>
-          </a:ln>
-          <a:effectLst/>
-        </p:spPr>
-        <p:style>
-          <a:lnRef idx="1">
-            <a:schemeClr val="accent1"/>
-          </a:lnRef>
-          <a:fillRef idx="3">
-            <a:schemeClr val="accent1"/>
-          </a:fillRef>
-          <a:effectRef idx="2">
-            <a:schemeClr val="accent1"/>
-          </a:effectRef>
-          <a:fontRef idx="minor">
-            <a:schemeClr val="lt1"/>
-          </a:fontRef>
-        </p:style>
-        <p:txBody>
-          <a:bodyPr rtlCol="0" anchor="ctr"/>
-          <a:lstStyle/>
-          <a:p>
-            <a:pPr algn="ctr"/>
-          </a:p>
-        </p:txBody>
-      </p:sp>
-      <p:sp>
-        <p:nvSpPr>
-          <p:cNvPr id="15" name="Rounded Rectangle 14"/>
-          <p:cNvSpPr/>
-          <p:nvPr/>
-        </p:nvSpPr>
-        <p:spPr>
-          <a:xfrm>
-            <a:off x="4860036" y="1261872"/>
-            <a:ext cx="3717036" cy="292608"/>
-          </a:xfrm>
-          <a:prstGeom prst="roundRect">
-            <a:avLst>
-              <a:gd name="adj" fmla="val 4000"/>
-            </a:avLst>
-          </a:prstGeom>
-          <a:solidFill>
-            <a:srgbClr val="F8FAFC"/>
-          </a:solidFill>
           <a:ln w="9525">
             <a:solidFill>
               <a:srgbClr val="E2E8F0"/>
@@ -40799,60 +41227,14 @@
       </p:sp>
       <p:sp>
         <p:nvSpPr>
-          <p:cNvPr id="16" name="Rectangle 15"/>
-          <p:cNvSpPr/>
-          <p:nvPr/>
-        </p:nvSpPr>
-        <p:spPr>
-          <a:xfrm>
-            <a:off x="4914900" y="1316736"/>
-            <a:ext cx="3552444" cy="201168"/>
-          </a:xfrm>
-          <a:prstGeom prst="rect">
-            <a:avLst/>
-          </a:prstGeom>
-          <a:solidFill>
-            <a:srgbClr val="FFFFFF"/>
-          </a:solidFill>
-          <a:ln w="6350">
-            <a:solidFill>
-              <a:srgbClr val="E2E8F0"/>
-            </a:solidFill>
-          </a:ln>
-          <a:effectLst/>
-        </p:spPr>
-        <p:style>
-          <a:lnRef idx="1">
-            <a:schemeClr val="accent1"/>
-          </a:lnRef>
-          <a:fillRef idx="3">
-            <a:schemeClr val="accent1"/>
-          </a:fillRef>
-          <a:effectRef idx="2">
-            <a:schemeClr val="accent1"/>
-          </a:effectRef>
-          <a:fontRef idx="minor">
-            <a:schemeClr val="lt1"/>
-          </a:fontRef>
-        </p:style>
-        <p:txBody>
-          <a:bodyPr rtlCol="0" anchor="ctr"/>
-          <a:lstStyle/>
-          <a:p>
-            <a:pPr algn="ctr"/>
-          </a:p>
-        </p:txBody>
-      </p:sp>
-      <p:sp>
-        <p:nvSpPr>
-          <p:cNvPr id="17" name="TextBox 16"/>
+          <p:cNvPr id="10" name="TextBox 9"/>
           <p:cNvSpPr txBox="1"/>
           <p:nvPr/>
         </p:nvSpPr>
         <p:spPr>
           <a:xfrm>
-            <a:off x="4969764" y="1344168"/>
-            <a:ext cx="3442716" cy="146304"/>
+            <a:off x="621792" y="1261872"/>
+            <a:ext cx="7955279" cy="320040"/>
           </a:xfrm>
           <a:prstGeom prst="rect">
             <a:avLst/>
@@ -40867,145 +41249,33 @@
           <a:p>
             <a:pPr>
               <a:spcAft>
-                <a:spcPts val="0"/>
-              </a:spcAft>
-            </a:pPr>
-            <a:r>
-              <a:rPr sz="800">
-                <a:solidFill>
-                  <a:srgbClr val="0F172A"/>
-                </a:solidFill>
-                <a:ea typeface="Consolas"/>
-                <a:cs typeface="Consolas"/>
-                <a:latin typeface="Consolas"/>
-              </a:rPr>
-              <a:t>Trend Spotting &amp;</a:t>
-            </a:r>
-          </a:p>
-          <a:p>
-            <a:pPr>
-              <a:spcAft>
-                <a:spcPts val="0"/>
-              </a:spcAft>
-            </a:pPr>
-            <a:r>
-              <a:rPr sz="800">
-                <a:solidFill>
-                  <a:srgbClr val="0F172A"/>
-                </a:solidFill>
-                <a:ea typeface="Consolas"/>
-                <a:cs typeface="Consolas"/>
-                <a:latin typeface="Consolas"/>
-              </a:rPr>
-              <a:t>Forecasting Prompt:</a:t>
-            </a:r>
-          </a:p>
-        </p:txBody>
-      </p:sp>
-      <p:sp>
-        <p:nvSpPr>
-          <p:cNvPr id="18" name="Rounded Rectangle 17"/>
-          <p:cNvSpPr/>
-          <p:nvPr/>
-        </p:nvSpPr>
-        <p:spPr>
-          <a:xfrm>
-            <a:off x="4805172" y="1627632"/>
-            <a:ext cx="3771900" cy="3150108"/>
-          </a:xfrm>
-          <a:prstGeom prst="roundRect">
-            <a:avLst>
-              <a:gd name="adj" fmla="val 4000"/>
-            </a:avLst>
-          </a:prstGeom>
-          <a:solidFill>
-            <a:srgbClr val="F8FAFC"/>
-          </a:solidFill>
-          <a:ln w="9525">
-            <a:solidFill>
-              <a:srgbClr val="E2E8F0"/>
-            </a:solidFill>
-          </a:ln>
-          <a:effectLst/>
-        </p:spPr>
-        <p:style>
-          <a:lnRef idx="1">
-            <a:schemeClr val="accent1"/>
-          </a:lnRef>
-          <a:fillRef idx="3">
-            <a:schemeClr val="accent1"/>
-          </a:fillRef>
-          <a:effectRef idx="2">
-            <a:schemeClr val="accent1"/>
-          </a:effectRef>
-          <a:fontRef idx="minor">
-            <a:schemeClr val="lt1"/>
-          </a:fontRef>
-        </p:style>
-        <p:txBody>
-          <a:bodyPr rtlCol="0" anchor="ctr"/>
-          <a:lstStyle/>
-          <a:p>
-            <a:pPr algn="ctr"/>
-          </a:p>
-        </p:txBody>
-      </p:sp>
-      <p:sp>
-        <p:nvSpPr>
-          <p:cNvPr id="19" name="Rectangle 18"/>
-          <p:cNvSpPr/>
-          <p:nvPr/>
-        </p:nvSpPr>
-        <p:spPr>
-          <a:xfrm>
-            <a:off x="4860036" y="1673352"/>
-            <a:ext cx="3662172" cy="3058668"/>
-          </a:xfrm>
-          <a:prstGeom prst="rect">
-            <a:avLst/>
-          </a:prstGeom>
-          <a:solidFill>
-            <a:srgbClr val="FFFFFF"/>
-          </a:solidFill>
-          <a:ln w="6350">
-            <a:solidFill>
-              <a:srgbClr val="E2E8F0"/>
-            </a:solidFill>
-          </a:ln>
-          <a:effectLst/>
-        </p:spPr>
-        <p:style>
-          <a:lnRef idx="1">
-            <a:schemeClr val="accent1"/>
-          </a:lnRef>
-          <a:fillRef idx="3">
-            <a:schemeClr val="accent1"/>
-          </a:fillRef>
-          <a:effectRef idx="2">
-            <a:schemeClr val="accent1"/>
-          </a:effectRef>
-          <a:fontRef idx="minor">
-            <a:schemeClr val="lt1"/>
-          </a:fontRef>
-        </p:style>
-        <p:txBody>
-          <a:bodyPr rtlCol="0" anchor="ctr"/>
-          <a:lstStyle/>
-          <a:p>
-            <a:pPr algn="ctr"/>
-          </a:p>
-        </p:txBody>
-      </p:sp>
-      <p:sp>
-        <p:nvSpPr>
-          <p:cNvPr id="20" name="TextBox 19"/>
+                <a:spcPts val="400"/>
+              </a:spcAft>
+            </a:pPr>
+            <a:r>
+              <a:rPr sz="1400" b="1" i="0">
+                <a:solidFill>
+                  <a:srgbClr val="0F172A"/>
+                </a:solidFill>
+                <a:ea typeface="Sylfaen"/>
+                <a:cs typeface="Sylfaen"/>
+                <a:latin typeface="Sylfaen"/>
+              </a:rPr>
+              <a:t>🚀 საცდელი პრომპტი ChatGPT/Claude/Gemini-სთვის:</a:t>
+            </a:r>
+          </a:p>
+        </p:txBody>
+      </p:sp>
+      <p:sp>
+        <p:nvSpPr>
+          <p:cNvPr id="11" name="TextBox 10"/>
           <p:cNvSpPr txBox="1"/>
           <p:nvPr/>
         </p:nvSpPr>
         <p:spPr>
           <a:xfrm>
-            <a:off x="4914900" y="1691640"/>
-            <a:ext cx="3552444" cy="3022091"/>
+            <a:off x="621792" y="1655064"/>
+            <a:ext cx="7955279" cy="1371600"/>
           </a:xfrm>
           <a:prstGeom prst="rect">
             <a:avLst/>
@@ -41020,296 +41290,26 @@
           <a:p>
             <a:pPr>
               <a:spcAft>
-                <a:spcPts val="0"/>
-              </a:spcAft>
-            </a:pPr>
-            <a:r>
-              <a:rPr sz="1000">
-                <a:solidFill>
-                  <a:srgbClr val="0F172A"/>
-                </a:solidFill>
-                <a:ea typeface="Consolas"/>
-                <a:cs typeface="Consolas"/>
-                <a:latin typeface="Consolas"/>
-              </a:rPr>
-              <a:t>გააანალიზე მიმდინარე</a:t>
-            </a:r>
-          </a:p>
-          <a:p>
-            <a:pPr>
-              <a:spcAft>
-                <a:spcPts val="0"/>
-              </a:spcAft>
-            </a:pPr>
-            <a:r>
-              <a:rPr sz="1000">
-                <a:solidFill>
-                  <a:srgbClr val="0F172A"/>
-                </a:solidFill>
-                <a:ea typeface="Consolas"/>
-                <a:cs typeface="Consolas"/>
-                <a:latin typeface="Consolas"/>
-              </a:rPr>
-              <a:t>ტენდენციები [თქვენი</a:t>
-            </a:r>
-          </a:p>
-          <a:p>
-            <a:pPr>
-              <a:spcAft>
-                <a:spcPts val="0"/>
-              </a:spcAft>
-            </a:pPr>
-            <a:r>
-              <a:rPr sz="1000">
-                <a:solidFill>
-                  <a:srgbClr val="0F172A"/>
-                </a:solidFill>
-                <a:ea typeface="Consolas"/>
-                <a:cs typeface="Consolas"/>
-                <a:latin typeface="Consolas"/>
-              </a:rPr>
-              <a:t>ინდუსტრია]-ში და</a:t>
-            </a:r>
-          </a:p>
-          <a:p>
-            <a:pPr>
-              <a:spcAft>
-                <a:spcPts val="0"/>
-              </a:spcAft>
-            </a:pPr>
-            <a:r>
-              <a:rPr sz="1000">
-                <a:solidFill>
-                  <a:srgbClr val="0F172A"/>
-                </a:solidFill>
-                <a:ea typeface="Consolas"/>
-                <a:cs typeface="Consolas"/>
-                <a:latin typeface="Consolas"/>
-              </a:rPr>
-              <a:t>დააგენერირე:</a:t>
-            </a:r>
-          </a:p>
-          <a:p>
-            <a:pPr>
-              <a:spcAft>
-                <a:spcPts val="0"/>
-              </a:spcAft>
-            </a:pPr>
-            <a:r>
-              <a:rPr sz="1000">
-                <a:solidFill>
-                  <a:srgbClr val="0F172A"/>
-                </a:solidFill>
-                <a:ea typeface="Consolas"/>
-                <a:cs typeface="Consolas"/>
-                <a:latin typeface="Consolas"/>
-              </a:rPr>
-              <a:t>1. მიმდინარე ტენდენციები</a:t>
-            </a:r>
-          </a:p>
-          <a:p>
-            <a:pPr>
-              <a:spcAft>
-                <a:spcPts val="0"/>
-              </a:spcAft>
-            </a:pPr>
-            <a:r>
-              <a:rPr sz="1000">
-                <a:solidFill>
-                  <a:srgbClr val="0F172A"/>
-                </a:solidFill>
-                <a:ea typeface="Consolas"/>
-                <a:cs typeface="Consolas"/>
-                <a:latin typeface="Consolas"/>
-              </a:rPr>
-              <a:t>(5 ტენდენცია);</a:t>
-            </a:r>
-          </a:p>
-          <a:p>
-            <a:pPr>
-              <a:spcAft>
-                <a:spcPts val="0"/>
-              </a:spcAft>
-            </a:pPr>
-            <a:r>
-              <a:rPr sz="1000">
-                <a:solidFill>
-                  <a:srgbClr val="0F172A"/>
-                </a:solidFill>
-                <a:ea typeface="Consolas"/>
-                <a:cs typeface="Consolas"/>
-                <a:latin typeface="Consolas"/>
-              </a:rPr>
-              <a:t>2. აღმოცენებადი</a:t>
-            </a:r>
-          </a:p>
-          <a:p>
-            <a:pPr>
-              <a:spcAft>
-                <a:spcPts val="0"/>
-              </a:spcAft>
-            </a:pPr>
-            <a:r>
-              <a:rPr sz="1000">
-                <a:solidFill>
-                  <a:srgbClr val="0F172A"/>
-                </a:solidFill>
-                <a:ea typeface="Consolas"/>
-                <a:cs typeface="Consolas"/>
-                <a:latin typeface="Consolas"/>
-              </a:rPr>
-              <a:t>ტენდენციები / სუსტი</a:t>
-            </a:r>
-          </a:p>
-          <a:p>
-            <a:pPr>
-              <a:spcAft>
-                <a:spcPts val="0"/>
-              </a:spcAft>
-            </a:pPr>
-            <a:r>
-              <a:rPr sz="1000">
-                <a:solidFill>
-                  <a:srgbClr val="0F172A"/>
-                </a:solidFill>
-                <a:ea typeface="Consolas"/>
-                <a:cs typeface="Consolas"/>
-                <a:latin typeface="Consolas"/>
-              </a:rPr>
-              <a:t>სიგნალები (5 ტენდენცია);</a:t>
-            </a:r>
-          </a:p>
-          <a:p>
-            <a:pPr>
-              <a:spcAft>
-                <a:spcPts val="0"/>
-              </a:spcAft>
-            </a:pPr>
-            <a:r>
-              <a:rPr sz="1000">
-                <a:solidFill>
-                  <a:srgbClr val="0F172A"/>
-                </a:solidFill>
-                <a:ea typeface="Consolas"/>
-                <a:cs typeface="Consolas"/>
-                <a:latin typeface="Consolas"/>
-              </a:rPr>
-              <a:t>3. სამომავლო 3-წლიანი</a:t>
-            </a:r>
-          </a:p>
-          <a:p>
-            <a:pPr>
-              <a:spcAft>
-                <a:spcPts val="0"/>
-              </a:spcAft>
-            </a:pPr>
-            <a:r>
-              <a:rPr sz="1000">
-                <a:solidFill>
-                  <a:srgbClr val="0F172A"/>
-                </a:solidFill>
-                <a:ea typeface="Consolas"/>
-                <a:cs typeface="Consolas"/>
-                <a:latin typeface="Consolas"/>
-              </a:rPr>
-              <a:t>სცენარები: ოპტიმისტური,</a:t>
-            </a:r>
-          </a:p>
-          <a:p>
-            <a:pPr>
-              <a:spcAft>
-                <a:spcPts val="0"/>
-              </a:spcAft>
-            </a:pPr>
-            <a:r>
-              <a:rPr sz="1000">
-                <a:solidFill>
-                  <a:srgbClr val="0F172A"/>
-                </a:solidFill>
-                <a:ea typeface="Consolas"/>
-                <a:cs typeface="Consolas"/>
-                <a:latin typeface="Consolas"/>
-              </a:rPr>
-              <a:t>პესიმისტური და ყველაზე</a:t>
-            </a:r>
-          </a:p>
-          <a:p>
-            <a:pPr>
-              <a:spcAft>
-                <a:spcPts val="0"/>
-              </a:spcAft>
-            </a:pPr>
-            <a:r>
-              <a:rPr sz="1000">
-                <a:solidFill>
-                  <a:srgbClr val="0F172A"/>
-                </a:solidFill>
-                <a:ea typeface="Consolas"/>
-                <a:cs typeface="Consolas"/>
-                <a:latin typeface="Consolas"/>
-              </a:rPr>
-              <a:t>მოსალოდნელი სცენარი;</a:t>
-            </a:r>
-          </a:p>
-          <a:p>
-            <a:pPr>
-              <a:spcAft>
-                <a:spcPts val="0"/>
-              </a:spcAft>
-            </a:pPr>
-            <a:r>
-              <a:rPr sz="1000">
-                <a:solidFill>
-                  <a:srgbClr val="0F172A"/>
-                </a:solidFill>
-                <a:ea typeface="Consolas"/>
-                <a:cs typeface="Consolas"/>
-                <a:latin typeface="Consolas"/>
-              </a:rPr>
-              <a:t>4. 5 კონკრეტული ბიზნეს</a:t>
-            </a:r>
-          </a:p>
-          <a:p>
-            <a:pPr>
-              <a:spcAft>
-                <a:spcPts val="0"/>
-              </a:spcAft>
-            </a:pPr>
-            <a:r>
-              <a:rPr sz="1000">
-                <a:solidFill>
-                  <a:srgbClr val="0F172A"/>
-                </a:solidFill>
-                <a:ea typeface="Consolas"/>
-                <a:cs typeface="Consolas"/>
-                <a:latin typeface="Consolas"/>
-              </a:rPr>
-              <a:t>შესაძლებლობა, რომელიც ამ</a:t>
-            </a:r>
-          </a:p>
-          <a:p>
-            <a:pPr>
-              <a:spcAft>
-                <a:spcPts val="0"/>
-              </a:spcAft>
-            </a:pPr>
-            <a:r>
-              <a:rPr sz="1000">
-                <a:solidFill>
-                  <a:srgbClr val="0F172A"/>
-                </a:solidFill>
-                <a:ea typeface="Consolas"/>
-                <a:cs typeface="Consolas"/>
-                <a:latin typeface="Consolas"/>
-              </a:rPr>
-              <a:t>ტენდენციებს ეფუძნება.</a:t>
-            </a:r>
-          </a:p>
-        </p:txBody>
-      </p:sp>
-      <p:sp>
-        <p:nvSpPr>
-          <p:cNvPr id="21" name="Rectangle 20"/>
+                <a:spcPts val="400"/>
+              </a:spcAft>
+            </a:pPr>
+            <a:r>
+              <a:rPr sz="1300" b="0" i="0">
+                <a:solidFill>
+                  <a:srgbClr val="0F172A"/>
+                </a:solidFill>
+                <a:ea typeface="Sylfaen"/>
+                <a:cs typeface="Sylfaen"/>
+                <a:latin typeface="Sylfaen"/>
+              </a:rPr>
+              <a:t>დააგენერირე 18 სახელი ახალი პროდუქტისთვის: 1. ინდუსტრია: Food Delivery / სწრაფი კვება საქართველოში. 2. პროდუქტი: მობილური აპლიკაცია, რომელიც ადგილობრივ მზარეულებს მომხმარებლებთან აკავშირებს - სახლში მომზადებული საკვების მიტანის სისტემა. 3. სამიზნე აუდიტორია: 25-45 წლის ურბანული პროფესიონალები, რომლებიც ეძებენ ჯანსაღ, ხარისხიან საკვებს (არა Fast Food). 4. ბრენდის პერსონა: თბილი, ოჯახური, ავთენტური, მაგრამ თანამედროვე. 5. ქართული ხაზგასმა: სახელი უნდა იყოს საერთაშორისო (ლათინური), მაგრამ ასახავდეს ქართულ კულტურას. სახელები დაყავი 3 კატეგორიად (თითოში 6): 1. აღწერითი (მაგ: HomeChef, LocalKitchen); 2. აბსტრაქტული (მაგ: Foodly, Tastora); 3. ქართული ინსპირაცია (მაგ: Supra [სუფრა], Kera [კერა]). თითოეულისთვის მომეცი: სახელი, .ge/.com დომენის ლოგიკა, tagline (ქართულად და ინგლისურად), ბრენდის ისტორია (1 წინადადება).</a:t>
+            </a:r>
+          </a:p>
+        </p:txBody>
+      </p:sp>
+      <p:sp>
+        <p:nvSpPr>
+          <p:cNvPr id="12" name="Rectangle 11"/>
           <p:cNvSpPr/>
           <p:nvPr/>
         </p:nvSpPr>
@@ -41353,7 +41353,7 @@
       </p:sp>
       <p:sp>
         <p:nvSpPr>
-          <p:cNvPr id="22" name="TextBox 21"/>
+          <p:cNvPr id="13" name="TextBox 12"/>
           <p:cNvSpPr txBox="1"/>
           <p:nvPr/>
         </p:nvSpPr>

</xml_diff>

<commit_message>
update Sat 07/18/2026  0:22:45.51
</commit_message>
<xml_diff>
--- a/GITA/Pre-Acceleration/2026-5h-AI-for-Startups/day1-slides.pptx
+++ b/GITA/Pre-Acceleration/2026-5h-AI-for-Startups/day1-slides.pptx
@@ -57985,7 +57985,7 @@
                 <a:cs typeface="Sylfaen"/>
                 <a:latin typeface="Sylfaen"/>
               </a:rPr>
-              <a:t>საუკეთესო სადესანტო გვერდის სტრუქტურის განსაზღვრაში;</a:t>
+              <a:t>საუკეთესო Landing Page-ის სტრუქტურის განსაზღვრაში;</a:t>
             </a:r>
           </a:p>
           <a:p>
@@ -58654,7 +58654,7 @@
                 <a:cs typeface="Consolas"/>
                 <a:latin typeface="Consolas"/>
               </a:rPr>
-              <a:t>Forms, ან Lovable</a:t>
+              <a:t>Forms, ან Lovable Landing</a:t>
             </a:r>
           </a:p>
           <a:p>
@@ -58672,7 +58672,7 @@
                 <a:cs typeface="Consolas"/>
                 <a:latin typeface="Consolas"/>
               </a:rPr>
-              <a:t>სადესანტო გვერდი).</a:t>
+              <a:t>Page).</a:t>
             </a:r>
           </a:p>
           <a:p>

</xml_diff>